<commit_message>
Contextualisation du projet pour la structure d'accueil OPEN MOISE
- Mémoire : section « Présentation de la structure d'accueil : OPEN MOISE »
  (présentation générale, missions, organisation, justification du projet),
  page de garde, remerciements et méthodologie mis à jour
- Présentation (md + .pptx) : diapo dédiée à OPEN MOISE + titre actualisé
- PowerPoint régénéré : 23 diapositives

Les données chiffrées précises (effectif, année, ville) restent en [...]
à compléter avec les informations officielles de l'entreprise.
</commit_message>
<xml_diff>
--- a/soutenance/presentation-projet.pptx
+++ b/soutenance/presentation-projet.pptx
@@ -27,6 +27,7 @@
     <p:sldId id="275" r:id="rId27"/>
     <p:sldId id="276" r:id="rId28"/>
     <p:sldId id="277" r:id="rId29"/>
+    <p:sldId id="278" r:id="rId30"/>
   </p:sldIdLst>
   <p:sldSz cx="12191695" cy="6858000" type="screen4x3"/>
   <p:notesSz cx="6858000" cy="9144000"/>
@@ -593,7 +594,7 @@
           <a:lstStyle/>
           <a:p>
             <a:r>
-              <a:t>Mon innovation ne réside pas dans un protocole nouveau, mais dans un positionnement unique : combiner simplicité, gratuité, alerte mobile instantanée et ouverture vers l'IA. Là où chaque concurrent impose un sacrifice, ma solution réunit ces atouts. Telegram natif est mon marqueur.</a:t>
+              <a:t>Ma réponse à ce vide : une solution complète mais légère. Elle découvre, surveille, confirme, journalise, alerte et affiche - le tout assemblé à partir de briques open-source éprouvées.</a:t>
             </a:r>
           </a:p>
         </p:txBody>
@@ -663,7 +664,7 @@
           <a:lstStyle/>
           <a:p>
             <a:r>
-              <a:t>Le projet est faisable sur les trois plans : technique - le prototype fonctionne -, économique - coût quasi nul - et organisationnel. J'ai rigoureusement conçu le système en UML et MERISE, sur une architecture en cinq couches.</a:t>
+              <a:t>Mon innovation ne réside pas dans un protocole nouveau, mais dans un positionnement unique : combiner simplicité, gratuité, alerte mobile instantanée et ouverture vers l'IA. Là où chaque concurrent impose un sacrifice, ma solution réunit ces atouts. Telegram natif est mon marqueur.</a:t>
             </a:r>
           </a:p>
         </p:txBody>
@@ -733,7 +734,7 @@
           <a:lstStyle/>
           <a:p>
             <a:r>
-              <a:t>Voici l'architecture en cinq couches. Le choix d'ingénierie le plus important est le découplage entre la collecte et l'affichage : ils communiquent uniquement par la base, ce qui rend le système robuste.</a:t>
+              <a:t>Le projet est faisable sur les trois plans : technique - le prototype fonctionne -, économique - coût quasi nul - et organisationnel. J'ai rigoureusement conçu le système en UML et MERISE, sur une architecture en cinq couches.</a:t>
             </a:r>
           </a:p>
         </p:txBody>
@@ -803,7 +804,7 @@
           <a:lstStyle/>
           <a:p>
             <a:r>
-              <a:t>Techniquement : toutes les deux minutes, Cron lance le moteur qui teste chaque équipement. Une panne n'est confirmée qu'après plusieurs échecs - pour éviter les fausses alertes - et une seule notification est envoyée par panne. Tout est parallélisé pour rester rapide.</a:t>
+              <a:t>Voici l'architecture en cinq couches. Le choix d'ingénierie le plus important est le découplage entre la collecte et l'affichage : ils communiquent uniquement par la base, ce qui rend le système robuste.</a:t>
             </a:r>
           </a:p>
         </p:txBody>
@@ -873,7 +874,7 @@
           <a:lstStyle/>
           <a:p>
             <a:r>
-              <a:t>La sécurité a été pensée dès la conception, pas ajoutée après : secrets hors du code, mots de passe hachés, requêtes paramétrées contre l'injection SQL, communications chiffrées et moindre privilège sur la base.</a:t>
+              <a:t>Techniquement : toutes les deux minutes, Cron lance le moteur qui teste chaque équipement. Une panne n'est confirmée qu'après plusieurs échecs - pour éviter les fausses alertes - et une seule notification est envoyée par panne. Tout est parallélisé pour rester rapide.</a:t>
             </a:r>
           </a:p>
         </p:txBody>
@@ -943,7 +944,7 @@
           <a:lstStyle/>
           <a:p>
             <a:r>
-              <a:t>Pour la démonstration, je propose un scénario vivant : je montre le tableau de bord, j'éteins un équipement devant vous, et vous verrez l'alerte Telegram arriver sur mon téléphone en temps réel. Puis je le rallume pour montrer le rétablissement. J'ai un plan B en captures et vidéo.</a:t>
+              <a:t>La sécurité a été pensée dès la conception, pas ajoutée après : secrets hors du code, mots de passe hachés, requêtes paramétrées contre l'injection SQL, communications chiffrées et moindre privilège sur la base.</a:t>
             </a:r>
           </a:p>
         </p:txBody>
@@ -1013,7 +1014,7 @@
           <a:lstStyle/>
           <a:p>
             <a:r>
-              <a:t>Ces captures matérialisent chaque fonctionnalité clé. La plus parlante est la notification Telegram reçue sur le téléphone : la preuve concrète de la valeur ajoutée pour l'administrateur.</a:t>
+              <a:t>Pour la démonstration, je propose un scénario vivant : je montre le tableau de bord, j'éteins un équipement devant vous, et vous verrez l'alerte Telegram arriver sur mon téléphone en temps réel. Puis je le rallume pour montrer le rétablissement. J'ai un plan B en captures et vidéo.</a:t>
             </a:r>
           </a:p>
         </p:txBody>
@@ -1083,7 +1084,7 @@
           <a:lstStyle/>
           <a:p>
             <a:r>
-              <a:t>Côté business, je vise les structures sans gros budget IT et les infogérants. Mon modèle est l'open-core : le cœur est gratuit pour créer l'adoption, et je monétise les services et une édition Pro avec SNMP et IA.</a:t>
+              <a:t>Ces captures matérialisent chaque fonctionnalité clé. La plus parlante est la notification Telegram reçue sur le téléphone : la preuve concrète de la valeur ajoutée pour l'administrateur.</a:t>
             </a:r>
           </a:p>
         </p:txBody>
@@ -1153,7 +1154,7 @@
           <a:lstStyle/>
           <a:p>
             <a:r>
-              <a:t>Je ne prétends pas battre Zabbix sur les très grandes infrastructures. Ma stratégie est celle de l'océan bleu : occuper le segment que les géants négligent - les petites structures - avec un produit simple et gratuit.</a:t>
+              <a:t>Côté business, je vise les structures sans gros budget IT et les infogérants. Mon modèle est l'open-core : le cœur est gratuit pour créer l'adoption, et je monétise les services et une édition Pro avec SNMP et IA.</a:t>
             </a:r>
           </a:p>
         </p:txBody>
@@ -1223,7 +1224,7 @@
           <a:lstStyle/>
           <a:p>
             <a:r>
-              <a:t>Financièrement, l'entrée est quasi nulle : pas de licence, juste un petit serveur. Côté revenus, même avec des hypothèses prudentes, on dépasse 9 000 € la première année. Pour le client, le retour vient de la réduction des coûts d'indisponibilité : la solution est rentabilisée dès le premier incident majeur évité.</a:t>
+              <a:t>Je ne prétends pas battre Zabbix sur les très grandes infrastructures. Ma stratégie est celle de l'océan bleu : occuper le segment que les géants négligent - les petites structures - avec un produit simple et gratuit.</a:t>
             </a:r>
           </a:p>
         </p:txBody>
@@ -1363,7 +1364,7 @@
           <a:lstStyle/>
           <a:p>
             <a:r>
-              <a:t>Je reste lucide sur les limites : pas encore de SNMP, réactivité bornée à deux minutes, et la question du superviseur lui-même. Mais ces limites tracent ma feuille de route : SNMP, puis l'IA pour passer d'une supervision réactive à une supervision prédictive.</a:t>
+              <a:t>Financièrement, l'entrée est quasi nulle : pas de licence, juste un petit serveur. Côté revenus, même avec des hypothèses prudentes, on dépasse 9 000 € la première année. Pour le client, le retour vient de la réduction des coûts d'indisponibilité : la solution est rentabilisée dès le premier incident majeur évité.</a:t>
             </a:r>
           </a:p>
         </p:txBody>
@@ -1433,7 +1434,7 @@
           <a:lstStyle/>
           <a:p>
             <a:r>
-              <a:t>En conclusion, ce projet livre un produit réel et performant, doublé d'un modèle économique crédible, et ouvert vers l'avenir de la supervision : le prédictif. J'ai montré qu'on pouvait rendre la haute disponibilité accessible à tous.</a:t>
+              <a:t>Je reste lucide sur les limites : pas encore de SNMP, réactivité bornée à deux minutes, et la question du superviseur lui-même. Mais ces limites tracent ma feuille de route : SNMP, puis l'IA pour passer d'une supervision réactive à une supervision prédictive.</a:t>
             </a:r>
           </a:p>
         </p:txBody>
@@ -1503,6 +1504,76 @@
           <a:lstStyle/>
           <a:p>
             <a:r>
+              <a:t>En conclusion, ce projet livre un produit réel et performant, doublé d'un modèle économique crédible, et ouvert vers l'avenir de la supervision : le prédictif. J'ai montré qu'on pouvait rendre la haute disponibilité accessible à tous.</a:t>
+            </a:r>
+          </a:p>
+        </p:txBody>
+      </p:sp>
+      <p:sp>
+        <p:nvSpPr>
+          <p:cNvPr id="4" name="Slide Number Placeholder 3"/>
+          <p:cNvSpPr>
+            <a:spLocks noGrp="1"/>
+          </p:cNvSpPr>
+          <p:nvPr>
+            <p:ph type="sldNum" idx="5" sz="quarter"/>
+          </p:nvPr>
+        </p:nvSpPr>
+        <p:spPr/>
+      </p:sp>
+    </p:spTree>
+  </p:cSld>
+  <p:clrMapOvr>
+    <a:masterClrMapping/>
+  </p:clrMapOvr>
+</p:notes>
+</file>
+
+<file path=ppt/notesSlides/notesSlide23.xml><?xml version="1.0" encoding="utf-8"?>
+<p:notes xmlns:a="http://schemas.openxmlformats.org/drawingml/2006/main" xmlns:p="http://schemas.openxmlformats.org/presentationml/2006/main" xmlns:r="http://schemas.openxmlformats.org/officeDocument/2006/relationships">
+  <p:cSld>
+    <p:spTree>
+      <p:nvGrpSpPr>
+        <p:cNvPr id="1" name=""/>
+        <p:cNvGrpSpPr/>
+        <p:nvPr/>
+      </p:nvGrpSpPr>
+      <p:grpSpPr>
+        <a:xfrm>
+          <a:off x="0" y="0"/>
+          <a:ext cx="0" cy="0"/>
+          <a:chOff x="0" y="0"/>
+          <a:chExt cx="0" cy="0"/>
+        </a:xfrm>
+      </p:grpSpPr>
+      <p:sp>
+        <p:nvSpPr>
+          <p:cNvPr id="2" name="Slide Image Placeholder 1"/>
+          <p:cNvSpPr>
+            <a:spLocks noGrp="1"/>
+          </p:cNvSpPr>
+          <p:nvPr>
+            <p:ph type="sldImg" idx="2"/>
+          </p:nvPr>
+        </p:nvSpPr>
+        <p:spPr/>
+      </p:sp>
+      <p:sp>
+        <p:nvSpPr>
+          <p:cNvPr id="3" name="Notes Placeholder 2"/>
+          <p:cNvSpPr>
+            <a:spLocks noGrp="1"/>
+          </p:cNvSpPr>
+          <p:nvPr>
+            <p:ph type="body" idx="3" sz="quarter"/>
+          </p:nvPr>
+        </p:nvSpPr>
+        <p:spPr/>
+        <p:txBody>
+          <a:bodyPr/>
+          <a:lstStyle/>
+          <a:p>
+            <a:r>
               <a:t>Je vous remercie de votre attention et je suis prêt à répondre à toutes vos questions, qu'elles soient techniques ou sur le volet économique.</a:t>
             </a:r>
           </a:p>
@@ -1643,7 +1714,7 @@
           <a:lstStyle/>
           <a:p>
             <a:r>
-              <a:t>Le contexte : des réseaux toujours plus complexes et critiques. Pourtant, sur le terrain, beaucoup surveillent encore à la main. Résultat : on apprend la panne par les plaintes, sans aucune trace, et les outils du marché paraissent inaccessibles.</a:t>
+              <a:t>Quelques mots sur mon entreprise d'accueil, OPEN MOISE : une ESN qui assure notamment l'infogérance et la supervision des réseaux de ses clients. Mon projet répond donc à un besoin direct de l'entreprise : détecter plus vite les pannes des parcs qu'elle exploite et respecter ses engagements de service.</a:t>
             </a:r>
           </a:p>
         </p:txBody>
@@ -1713,7 +1784,7 @@
           <a:lstStyle/>
           <a:p>
             <a:r>
-              <a:t>Tout le projet répond à cette question centrale, que je formule clairement : détecter en temps réel et réduire le temps d'intervention, avec une solution automatisée, fiable ET accessible financièrement. Les trois sous-questions guident ma conception.</a:t>
+              <a:t>Le contexte : des réseaux toujours plus complexes et critiques. Pourtant, sur le terrain, beaucoup surveillent encore à la main. Résultat : on apprend la panne par les plaintes, sans aucune trace, et les outils du marché paraissent inaccessibles.</a:t>
             </a:r>
           </a:p>
         </p:txBody>
@@ -1783,7 +1854,7 @@
           <a:lstStyle/>
           <a:p>
             <a:r>
-              <a:t>Mes objectifs sont chiffrés, donc vérifiables. Le cœur : faire chuter le temps de détection de l'ordre de l'heure à moins de deux minutes, et le temps de réaction à moins de cinq minutes, sans coût de licence.</a:t>
+              <a:t>Tout le projet répond à cette question centrale, que je formule clairement : détecter en temps réel et réduire le temps d'intervention, avec une solution automatisée, fiable ET accessible financièrement. Les trois sous-questions guident ma conception.</a:t>
             </a:r>
           </a:p>
         </p:txBody>
@@ -1853,7 +1924,7 @@
           <a:lstStyle/>
           <a:p>
             <a:r>
-              <a:t>Ma démarche est celle de l'ingénieur-chercheur : je conçois un système réel et je prouve sa valeur par la mesure. J'ai travaillé en cycles itératifs, à la DevOps, et j'évalue par comparaison avant/après sur des indicateurs objectifs.</a:t>
+              <a:t>Mes objectifs sont chiffrés, donc vérifiables. Le cœur : faire chuter le temps de détection de l'ordre de l'heure à moins de deux minutes, et le temps de réaction à moins de cinq minutes, sans coût de licence.</a:t>
             </a:r>
           </a:p>
         </p:txBody>
@@ -1923,7 +1994,7 @@
           <a:lstStyle/>
           <a:p>
             <a:r>
-              <a:t>J'ai analysé les références du marché : soit des usines à gaz puissantes mais complexes, soit des produits simples mais propriétaires et chers. Il existe un vide pour une solution légère, gratuite et sur mesure.</a:t>
+              <a:t>Ma démarche est celle de l'ingénieur-chercheur : je conçois un système réel et je prouve sa valeur par la mesure. J'ai travaillé en cycles itératifs, à la DevOps, et j'évalue par comparaison avant/après sur des indicateurs objectifs.</a:t>
             </a:r>
           </a:p>
         </p:txBody>
@@ -1993,7 +2064,7 @@
           <a:lstStyle/>
           <a:p>
             <a:r>
-              <a:t>Ma réponse à ce vide : une solution complète mais légère. Elle découvre, surveille, confirme, journalise, alerte et affiche - le tout assemblé à partir de briques open-source éprouvées.</a:t>
+              <a:t>J'ai analysé les références du marché : soit des usines à gaz puissantes mais complexes, soit des produits simples mais propriétaires et chers. Il existe un vide pour une solution légère, gratuite et sur mesure.</a:t>
             </a:r>
           </a:p>
         </p:txBody>
@@ -5153,7 +5224,7 @@
                 </a:solidFill>
                 <a:latin typeface="Calibri"/>
               </a:rPr>
-              <a:t>Structure d'accueil : [Entreprise]  •  Année académique 2025–2026</a:t>
+              <a:t>Structure d'accueil : OPEN MOISE  •  Année académique 2025–2026</a:t>
             </a:r>
           </a:p>
         </p:txBody>
@@ -5167,6 +5238,379 @@
 </file>
 
 <file path=ppt/slides/slide10.xml><?xml version="1.0" encoding="utf-8"?>
+<p:sld xmlns:a="http://schemas.openxmlformats.org/drawingml/2006/main" xmlns:p="http://schemas.openxmlformats.org/presentationml/2006/main" xmlns:r="http://schemas.openxmlformats.org/officeDocument/2006/relationships">
+  <p:cSld>
+    <p:bg>
+      <p:bgPr>
+        <a:solidFill>
+          <a:srgbClr val="FFFFFF"/>
+        </a:solidFill>
+        <a:effectLst/>
+      </p:bgPr>
+    </p:bg>
+    <p:spTree>
+      <p:nvGrpSpPr>
+        <p:cNvPr id="1" name=""/>
+        <p:cNvGrpSpPr/>
+        <p:nvPr/>
+      </p:nvGrpSpPr>
+      <p:grpSpPr/>
+      <p:sp>
+        <p:nvSpPr>
+          <p:cNvPr id="2" name="Rectangle 1"/>
+          <p:cNvSpPr/>
+          <p:nvPr/>
+        </p:nvSpPr>
+        <p:spPr>
+          <a:xfrm>
+            <a:off x="0" y="0"/>
+            <a:ext cx="12191695" cy="1051560"/>
+          </a:xfrm>
+          <a:prstGeom prst="rect">
+            <a:avLst/>
+          </a:prstGeom>
+          <a:solidFill>
+            <a:srgbClr val="0D3B66"/>
+          </a:solidFill>
+          <a:ln>
+            <a:noFill/>
+          </a:ln>
+          <a:effectLst/>
+        </p:spPr>
+        <p:style>
+          <a:lnRef idx="1">
+            <a:schemeClr val="accent1"/>
+          </a:lnRef>
+          <a:fillRef idx="3">
+            <a:schemeClr val="accent1"/>
+          </a:fillRef>
+          <a:effectRef idx="2">
+            <a:schemeClr val="accent1"/>
+          </a:effectRef>
+          <a:fontRef idx="minor">
+            <a:schemeClr val="lt1"/>
+          </a:fontRef>
+        </p:style>
+        <p:txBody>
+          <a:bodyPr rtlCol="0" anchor="ctr"/>
+          <a:lstStyle/>
+          <a:p>
+            <a:pPr algn="ctr"/>
+          </a:p>
+        </p:txBody>
+      </p:sp>
+      <p:sp>
+        <p:nvSpPr>
+          <p:cNvPr id="3" name="Oval 2"/>
+          <p:cNvSpPr/>
+          <p:nvPr/>
+        </p:nvSpPr>
+        <p:spPr>
+          <a:xfrm>
+            <a:off x="320040" y="201168"/>
+            <a:ext cx="658368" cy="658368"/>
+          </a:xfrm>
+          <a:prstGeom prst="ellipse">
+            <a:avLst/>
+          </a:prstGeom>
+          <a:solidFill>
+            <a:srgbClr val="0D6EFD"/>
+          </a:solidFill>
+          <a:ln>
+            <a:noFill/>
+          </a:ln>
+          <a:effectLst/>
+        </p:spPr>
+        <p:style>
+          <a:lnRef idx="1">
+            <a:schemeClr val="accent1"/>
+          </a:lnRef>
+          <a:fillRef idx="3">
+            <a:schemeClr val="accent1"/>
+          </a:fillRef>
+          <a:effectRef idx="2">
+            <a:schemeClr val="accent1"/>
+          </a:effectRef>
+          <a:fontRef idx="minor">
+            <a:schemeClr val="lt1"/>
+          </a:fontRef>
+        </p:style>
+        <p:txBody>
+          <a:bodyPr rtlCol="0" anchor="ctr" wrap="none"/>
+          <a:lstStyle/>
+          <a:p>
+            <a:pPr algn="ctr"/>
+            <a:r>
+              <a:rPr sz="2600" b="1" i="0">
+                <a:solidFill>
+                  <a:srgbClr val="FFFFFF"/>
+                </a:solidFill>
+                <a:latin typeface="Calibri"/>
+              </a:rPr>
+              <a:t>4</a:t>
+            </a:r>
+          </a:p>
+        </p:txBody>
+      </p:sp>
+      <p:sp>
+        <p:nvSpPr>
+          <p:cNvPr id="4" name="TextBox 3"/>
+          <p:cNvSpPr txBox="1"/>
+          <p:nvPr/>
+        </p:nvSpPr>
+        <p:spPr>
+          <a:xfrm>
+            <a:off x="1143000" y="164592"/>
+            <a:ext cx="10774375" cy="731520"/>
+          </a:xfrm>
+          <a:prstGeom prst="rect">
+            <a:avLst/>
+          </a:prstGeom>
+          <a:noFill/>
+        </p:spPr>
+        <p:txBody>
+          <a:bodyPr wrap="square" anchor="ctr">
+            <a:spAutoFit/>
+          </a:bodyPr>
+          <a:lstStyle/>
+          <a:p>
+            <a:r>
+              <a:rPr sz="3000" b="1" i="0">
+                <a:solidFill>
+                  <a:srgbClr val="FFFFFF"/>
+                </a:solidFill>
+                <a:latin typeface="Calibri"/>
+              </a:rPr>
+              <a:t>Solution proposée</a:t>
+            </a:r>
+          </a:p>
+        </p:txBody>
+      </p:sp>
+      <p:sp>
+        <p:nvSpPr>
+          <p:cNvPr id="5" name="TextBox 4"/>
+          <p:cNvSpPr txBox="1"/>
+          <p:nvPr/>
+        </p:nvSpPr>
+        <p:spPr>
+          <a:xfrm>
+            <a:off x="640080" y="1371600"/>
+            <a:ext cx="10881360" cy="3291840"/>
+          </a:xfrm>
+          <a:prstGeom prst="rect">
+            <a:avLst/>
+          </a:prstGeom>
+          <a:noFill/>
+        </p:spPr>
+        <p:txBody>
+          <a:bodyPr wrap="square">
+            <a:spAutoFit/>
+          </a:bodyPr>
+          <a:lstStyle/>
+          <a:p>
+            <a:pPr>
+              <a:spcAft>
+                <a:spcPts val="800"/>
+              </a:spcAft>
+            </a:pPr>
+            <a:r>
+              <a:rPr sz="2000" b="1" i="0">
+                <a:solidFill>
+                  <a:srgbClr val="0D3B66"/>
+                </a:solidFill>
+                <a:latin typeface="Calibri"/>
+              </a:rPr>
+              <a:t>•  Un système automatisé, modulaire et 100 % open-source qui :</a:t>
+            </a:r>
+          </a:p>
+          <a:p>
+            <a:pPr lvl="1">
+              <a:spcAft>
+                <a:spcPts val="800"/>
+              </a:spcAft>
+            </a:pPr>
+            <a:r>
+              <a:rPr sz="1800" b="0" i="0">
+                <a:solidFill>
+                  <a:srgbClr val="333333"/>
+                </a:solidFill>
+                <a:latin typeface="Calibri"/>
+              </a:rPr>
+              <a:t>–  découvre automatiquement les équipements du réseau</a:t>
+            </a:r>
+          </a:p>
+          <a:p>
+            <a:pPr lvl="1">
+              <a:spcAft>
+                <a:spcPts val="800"/>
+              </a:spcAft>
+            </a:pPr>
+            <a:r>
+              <a:rPr sz="1800" b="0" i="0">
+                <a:solidFill>
+                  <a:srgbClr val="333333"/>
+                </a:solidFill>
+                <a:latin typeface="Calibri"/>
+              </a:rPr>
+              <a:t>–  sonde en continu la disponibilité (ICMP) et les services (TCP)</a:t>
+            </a:r>
+          </a:p>
+          <a:p>
+            <a:pPr lvl="1">
+              <a:spcAft>
+                <a:spcPts val="800"/>
+              </a:spcAft>
+            </a:pPr>
+            <a:r>
+              <a:rPr sz="1800" b="0" i="0">
+                <a:solidFill>
+                  <a:srgbClr val="333333"/>
+                </a:solidFill>
+                <a:latin typeface="Calibri"/>
+              </a:rPr>
+              <a:t>–  confirme la panne (anti-faux positif) et journalise tout</a:t>
+            </a:r>
+          </a:p>
+          <a:p>
+            <a:pPr lvl="1">
+              <a:spcAft>
+                <a:spcPts val="800"/>
+              </a:spcAft>
+            </a:pPr>
+            <a:r>
+              <a:rPr sz="1800" b="0" i="0">
+                <a:solidFill>
+                  <a:srgbClr val="333333"/>
+                </a:solidFill>
+                <a:latin typeface="Calibri"/>
+              </a:rPr>
+              <a:t>–  alerte en temps réel par e-mail ET Telegram (push mobile)</a:t>
+            </a:r>
+          </a:p>
+          <a:p>
+            <a:pPr lvl="1">
+              <a:spcAft>
+                <a:spcPts val="800"/>
+              </a:spcAft>
+            </a:pPr>
+            <a:r>
+              <a:rPr sz="1800" b="0" i="0">
+                <a:solidFill>
+                  <a:srgbClr val="333333"/>
+                </a:solidFill>
+                <a:latin typeface="Calibri"/>
+              </a:rPr>
+              <a:t>–  offre un tableau de bord web temps réel + rapports</a:t>
+            </a:r>
+          </a:p>
+        </p:txBody>
+      </p:sp>
+      <p:sp>
+        <p:nvSpPr>
+          <p:cNvPr id="6" name="Rectangle 5"/>
+          <p:cNvSpPr/>
+          <p:nvPr/>
+        </p:nvSpPr>
+        <p:spPr>
+          <a:xfrm>
+            <a:off x="640080" y="5120640"/>
+            <a:ext cx="109728" cy="914400"/>
+          </a:xfrm>
+          <a:prstGeom prst="rect">
+            <a:avLst/>
+          </a:prstGeom>
+          <a:solidFill>
+            <a:srgbClr val="0D6EFD"/>
+          </a:solidFill>
+          <a:ln>
+            <a:noFill/>
+          </a:ln>
+          <a:effectLst/>
+        </p:spPr>
+        <p:style>
+          <a:lnRef idx="1">
+            <a:schemeClr val="accent1"/>
+          </a:lnRef>
+          <a:fillRef idx="3">
+            <a:schemeClr val="accent1"/>
+          </a:fillRef>
+          <a:effectRef idx="2">
+            <a:schemeClr val="accent1"/>
+          </a:effectRef>
+          <a:fontRef idx="minor">
+            <a:schemeClr val="lt1"/>
+          </a:fontRef>
+        </p:style>
+        <p:txBody>
+          <a:bodyPr rtlCol="0" anchor="ctr"/>
+          <a:lstStyle/>
+          <a:p>
+            <a:pPr algn="ctr"/>
+          </a:p>
+        </p:txBody>
+      </p:sp>
+      <p:sp>
+        <p:nvSpPr>
+          <p:cNvPr id="7" name="Rectangle 6"/>
+          <p:cNvSpPr/>
+          <p:nvPr/>
+        </p:nvSpPr>
+        <p:spPr>
+          <a:xfrm>
+            <a:off x="749808" y="5120640"/>
+            <a:ext cx="10771632" cy="914400"/>
+          </a:xfrm>
+          <a:prstGeom prst="rect">
+            <a:avLst/>
+          </a:prstGeom>
+          <a:solidFill>
+            <a:srgbClr val="0D3B66"/>
+          </a:solidFill>
+          <a:ln>
+            <a:noFill/>
+          </a:ln>
+          <a:effectLst/>
+        </p:spPr>
+        <p:style>
+          <a:lnRef idx="1">
+            <a:schemeClr val="accent1"/>
+          </a:lnRef>
+          <a:fillRef idx="3">
+            <a:schemeClr val="accent1"/>
+          </a:fillRef>
+          <a:effectRef idx="2">
+            <a:schemeClr val="accent1"/>
+          </a:effectRef>
+          <a:fontRef idx="minor">
+            <a:schemeClr val="lt1"/>
+          </a:fontRef>
+        </p:style>
+        <p:txBody>
+          <a:bodyPr rtlCol="0" anchor="ctr" wrap="square" lIns="182880"/>
+          <a:lstStyle/>
+          <a:p>
+            <a:pPr algn="ctr"/>
+            <a:r>
+              <a:rPr sz="1700" b="1" i="1">
+                <a:solidFill>
+                  <a:srgbClr val="0D3B66"/>
+                </a:solidFill>
+                <a:latin typeface="Calibri"/>
+              </a:rPr>
+              <a:t>Stack : Ubuntu · Python · Cron · MySQL · Flask · Bootstrap · Bot Telegram</a:t>
+            </a:r>
+          </a:p>
+        </p:txBody>
+      </p:sp>
+    </p:spTree>
+  </p:cSld>
+  <p:clrMapOvr>
+    <a:masterClrMapping/>
+  </p:clrMapOvr>
+</p:sld>
+</file>
+
+<file path=ppt/slides/slide11.xml><?xml version="1.0" encoding="utf-8"?>
 <p:sld xmlns:a="http://schemas.openxmlformats.org/drawingml/2006/main" xmlns:p="http://schemas.openxmlformats.org/presentationml/2006/main" xmlns:r="http://schemas.openxmlformats.org/officeDocument/2006/relationships">
   <p:cSld>
     <p:bg>
@@ -5734,7 +6178,7 @@
 </p:sld>
 </file>
 
-<file path=ppt/slides/slide11.xml><?xml version="1.0" encoding="utf-8"?>
+<file path=ppt/slides/slide12.xml><?xml version="1.0" encoding="utf-8"?>
 <p:sld xmlns:a="http://schemas.openxmlformats.org/drawingml/2006/main" xmlns:p="http://schemas.openxmlformats.org/presentationml/2006/main" xmlns:r="http://schemas.openxmlformats.org/officeDocument/2006/relationships">
   <p:cSld>
     <p:bg>
@@ -6030,570 +6474,6 @@
                 <a:latin typeface="Calibri"/>
               </a:rPr>
               <a:t>–  Architecture en 5 couches</a:t>
-            </a:r>
-          </a:p>
-        </p:txBody>
-      </p:sp>
-    </p:spTree>
-  </p:cSld>
-  <p:clrMapOvr>
-    <a:masterClrMapping/>
-  </p:clrMapOvr>
-</p:sld>
-</file>
-
-<file path=ppt/slides/slide12.xml><?xml version="1.0" encoding="utf-8"?>
-<p:sld xmlns:a="http://schemas.openxmlformats.org/drawingml/2006/main" xmlns:p="http://schemas.openxmlformats.org/presentationml/2006/main" xmlns:r="http://schemas.openxmlformats.org/officeDocument/2006/relationships">
-  <p:cSld>
-    <p:bg>
-      <p:bgPr>
-        <a:solidFill>
-          <a:srgbClr val="FFFFFF"/>
-        </a:solidFill>
-        <a:effectLst/>
-      </p:bgPr>
-    </p:bg>
-    <p:spTree>
-      <p:nvGrpSpPr>
-        <p:cNvPr id="1" name=""/>
-        <p:cNvGrpSpPr/>
-        <p:nvPr/>
-      </p:nvGrpSpPr>
-      <p:grpSpPr/>
-      <p:sp>
-        <p:nvSpPr>
-          <p:cNvPr id="2" name="Rectangle 1"/>
-          <p:cNvSpPr/>
-          <p:nvPr/>
-        </p:nvSpPr>
-        <p:spPr>
-          <a:xfrm>
-            <a:off x="0" y="0"/>
-            <a:ext cx="12191695" cy="1051560"/>
-          </a:xfrm>
-          <a:prstGeom prst="rect">
-            <a:avLst/>
-          </a:prstGeom>
-          <a:solidFill>
-            <a:srgbClr val="0D3B66"/>
-          </a:solidFill>
-          <a:ln>
-            <a:noFill/>
-          </a:ln>
-          <a:effectLst/>
-        </p:spPr>
-        <p:style>
-          <a:lnRef idx="1">
-            <a:schemeClr val="accent1"/>
-          </a:lnRef>
-          <a:fillRef idx="3">
-            <a:schemeClr val="accent1"/>
-          </a:fillRef>
-          <a:effectRef idx="2">
-            <a:schemeClr val="accent1"/>
-          </a:effectRef>
-          <a:fontRef idx="minor">
-            <a:schemeClr val="lt1"/>
-          </a:fontRef>
-        </p:style>
-        <p:txBody>
-          <a:bodyPr rtlCol="0" anchor="ctr"/>
-          <a:lstStyle/>
-          <a:p>
-            <a:pPr algn="ctr"/>
-          </a:p>
-        </p:txBody>
-      </p:sp>
-      <p:sp>
-        <p:nvSpPr>
-          <p:cNvPr id="3" name="Oval 2"/>
-          <p:cNvSpPr/>
-          <p:nvPr/>
-        </p:nvSpPr>
-        <p:spPr>
-          <a:xfrm>
-            <a:off x="320040" y="201168"/>
-            <a:ext cx="658368" cy="658368"/>
-          </a:xfrm>
-          <a:prstGeom prst="ellipse">
-            <a:avLst/>
-          </a:prstGeom>
-          <a:solidFill>
-            <a:srgbClr val="0D6EFD"/>
-          </a:solidFill>
-          <a:ln>
-            <a:noFill/>
-          </a:ln>
-          <a:effectLst/>
-        </p:spPr>
-        <p:style>
-          <a:lnRef idx="1">
-            <a:schemeClr val="accent1"/>
-          </a:lnRef>
-          <a:fillRef idx="3">
-            <a:schemeClr val="accent1"/>
-          </a:fillRef>
-          <a:effectRef idx="2">
-            <a:schemeClr val="accent1"/>
-          </a:effectRef>
-          <a:fontRef idx="minor">
-            <a:schemeClr val="lt1"/>
-          </a:fontRef>
-        </p:style>
-        <p:txBody>
-          <a:bodyPr rtlCol="0" anchor="ctr" wrap="none"/>
-          <a:lstStyle/>
-          <a:p>
-            <a:pPr algn="ctr"/>
-            <a:r>
-              <a:rPr sz="2600" b="1" i="0">
-                <a:solidFill>
-                  <a:srgbClr val="FFFFFF"/>
-                </a:solidFill>
-                <a:latin typeface="Calibri"/>
-              </a:rPr>
-              <a:t>6</a:t>
-            </a:r>
-          </a:p>
-        </p:txBody>
-      </p:sp>
-      <p:sp>
-        <p:nvSpPr>
-          <p:cNvPr id="4" name="TextBox 3"/>
-          <p:cNvSpPr txBox="1"/>
-          <p:nvPr/>
-        </p:nvSpPr>
-        <p:spPr>
-          <a:xfrm>
-            <a:off x="1143000" y="164592"/>
-            <a:ext cx="10774375" cy="731520"/>
-          </a:xfrm>
-          <a:prstGeom prst="rect">
-            <a:avLst/>
-          </a:prstGeom>
-          <a:noFill/>
-        </p:spPr>
-        <p:txBody>
-          <a:bodyPr wrap="square" anchor="ctr">
-            <a:spAutoFit/>
-          </a:bodyPr>
-          <a:lstStyle/>
-          <a:p>
-            <a:r>
-              <a:rPr sz="3000" b="1" i="0">
-                <a:solidFill>
-                  <a:srgbClr val="FFFFFF"/>
-                </a:solidFill>
-                <a:latin typeface="Calibri"/>
-              </a:rPr>
-              <a:t>Architecture de la solution</a:t>
-            </a:r>
-          </a:p>
-        </p:txBody>
-      </p:sp>
-      <p:sp>
-        <p:nvSpPr>
-          <p:cNvPr id="5" name="Rectangle 4"/>
-          <p:cNvSpPr/>
-          <p:nvPr/>
-        </p:nvSpPr>
-        <p:spPr>
-          <a:xfrm>
-            <a:off x="1097280" y="1417320"/>
-            <a:ext cx="9966960" cy="749808"/>
-          </a:xfrm>
-          <a:prstGeom prst="rect">
-            <a:avLst/>
-          </a:prstGeom>
-          <a:solidFill>
-            <a:srgbClr val="0D6EFD"/>
-          </a:solidFill>
-          <a:ln>
-            <a:noFill/>
-          </a:ln>
-          <a:effectLst/>
-        </p:spPr>
-        <p:style>
-          <a:lnRef idx="1">
-            <a:schemeClr val="accent1"/>
-          </a:lnRef>
-          <a:fillRef idx="3">
-            <a:schemeClr val="accent1"/>
-          </a:fillRef>
-          <a:effectRef idx="2">
-            <a:schemeClr val="accent1"/>
-          </a:effectRef>
-          <a:fontRef idx="minor">
-            <a:schemeClr val="lt1"/>
-          </a:fontRef>
-        </p:style>
-        <p:txBody>
-          <a:bodyPr rtlCol="0" anchor="ctr" lIns="274320"/>
-          <a:lstStyle/>
-          <a:p>
-            <a:pPr algn="ctr"/>
-            <a:r>
-              <a:rPr sz="1600" b="1" i="0">
-                <a:solidFill>
-                  <a:srgbClr val="FFFFFF"/>
-                </a:solidFill>
-                <a:latin typeface="Calibri"/>
-              </a:rPr>
-              <a:t>PRÉSENTATION   </a:t>
-            </a:r>
-            <a:r>
-              <a:rPr sz="1500" b="0" i="0">
-                <a:solidFill>
-                  <a:srgbClr val="E8EEF4"/>
-                </a:solidFill>
-                <a:latin typeface="Calibri"/>
-              </a:rPr>
-              <a:t>— Tableau de bord Flask + Bootstrap + Chart.js</a:t>
-            </a:r>
-          </a:p>
-        </p:txBody>
-      </p:sp>
-      <p:sp>
-        <p:nvSpPr>
-          <p:cNvPr id="6" name="Rectangle 5"/>
-          <p:cNvSpPr/>
-          <p:nvPr/>
-        </p:nvSpPr>
-        <p:spPr>
-          <a:xfrm>
-            <a:off x="1097280" y="2286000"/>
-            <a:ext cx="9966960" cy="749808"/>
-          </a:xfrm>
-          <a:prstGeom prst="rect">
-            <a:avLst/>
-          </a:prstGeom>
-          <a:solidFill>
-            <a:srgbClr val="398AC8"/>
-          </a:solidFill>
-          <a:ln>
-            <a:noFill/>
-          </a:ln>
-          <a:effectLst/>
-        </p:spPr>
-        <p:style>
-          <a:lnRef idx="1">
-            <a:schemeClr val="accent1"/>
-          </a:lnRef>
-          <a:fillRef idx="3">
-            <a:schemeClr val="accent1"/>
-          </a:fillRef>
-          <a:effectRef idx="2">
-            <a:schemeClr val="accent1"/>
-          </a:effectRef>
-          <a:fontRef idx="minor">
-            <a:schemeClr val="lt1"/>
-          </a:fontRef>
-        </p:style>
-        <p:txBody>
-          <a:bodyPr rtlCol="0" anchor="ctr" lIns="274320"/>
-          <a:lstStyle/>
-          <a:p>
-            <a:pPr algn="ctr"/>
-            <a:r>
-              <a:rPr sz="1600" b="1" i="0">
-                <a:solidFill>
-                  <a:srgbClr val="FFFFFF"/>
-                </a:solidFill>
-                <a:latin typeface="Calibri"/>
-              </a:rPr>
-              <a:t>NOTIFICATION   </a:t>
-            </a:r>
-            <a:r>
-              <a:rPr sz="1500" b="0" i="0">
-                <a:solidFill>
-                  <a:srgbClr val="E8EEF4"/>
-                </a:solidFill>
-                <a:latin typeface="Calibri"/>
-              </a:rPr>
-              <a:t>— E-mail (SMTP)  +  Telegram (push mobile)</a:t>
-            </a:r>
-          </a:p>
-        </p:txBody>
-      </p:sp>
-      <p:sp>
-        <p:nvSpPr>
-          <p:cNvPr id="7" name="Rectangle 6"/>
-          <p:cNvSpPr/>
-          <p:nvPr/>
-        </p:nvSpPr>
-        <p:spPr>
-          <a:xfrm>
-            <a:off x="1097280" y="3154680"/>
-            <a:ext cx="9966960" cy="749808"/>
-          </a:xfrm>
-          <a:prstGeom prst="rect">
-            <a:avLst/>
-          </a:prstGeom>
-          <a:solidFill>
-            <a:srgbClr val="2A6F97"/>
-          </a:solidFill>
-          <a:ln>
-            <a:noFill/>
-          </a:ln>
-          <a:effectLst/>
-        </p:spPr>
-        <p:style>
-          <a:lnRef idx="1">
-            <a:schemeClr val="accent1"/>
-          </a:lnRef>
-          <a:fillRef idx="3">
-            <a:schemeClr val="accent1"/>
-          </a:fillRef>
-          <a:effectRef idx="2">
-            <a:schemeClr val="accent1"/>
-          </a:effectRef>
-          <a:fontRef idx="minor">
-            <a:schemeClr val="lt1"/>
-          </a:fontRef>
-        </p:style>
-        <p:txBody>
-          <a:bodyPr rtlCol="0" anchor="ctr" lIns="274320"/>
-          <a:lstStyle/>
-          <a:p>
-            <a:pPr algn="ctr"/>
-            <a:r>
-              <a:rPr sz="1600" b="1" i="0">
-                <a:solidFill>
-                  <a:srgbClr val="FFFFFF"/>
-                </a:solidFill>
-                <a:latin typeface="Calibri"/>
-              </a:rPr>
-              <a:t>TRAITEMENT   </a:t>
-            </a:r>
-            <a:r>
-              <a:rPr sz="1500" b="0" i="0">
-                <a:solidFill>
-                  <a:srgbClr val="E8EEF4"/>
-                </a:solidFill>
-                <a:latin typeface="Calibri"/>
-              </a:rPr>
-              <a:t>— Moteur Python + Cron (sondes ICMP / TCP)</a:t>
-            </a:r>
-          </a:p>
-        </p:txBody>
-      </p:sp>
-      <p:sp>
-        <p:nvSpPr>
-          <p:cNvPr id="8" name="Rectangle 7"/>
-          <p:cNvSpPr/>
-          <p:nvPr/>
-        </p:nvSpPr>
-        <p:spPr>
-          <a:xfrm>
-            <a:off x="1097280" y="4023360"/>
-            <a:ext cx="9966960" cy="749808"/>
-          </a:xfrm>
-          <a:prstGeom prst="rect">
-            <a:avLst/>
-          </a:prstGeom>
-          <a:solidFill>
-            <a:srgbClr val="1B4F72"/>
-          </a:solidFill>
-          <a:ln>
-            <a:noFill/>
-          </a:ln>
-          <a:effectLst/>
-        </p:spPr>
-        <p:style>
-          <a:lnRef idx="1">
-            <a:schemeClr val="accent1"/>
-          </a:lnRef>
-          <a:fillRef idx="3">
-            <a:schemeClr val="accent1"/>
-          </a:fillRef>
-          <a:effectRef idx="2">
-            <a:schemeClr val="accent1"/>
-          </a:effectRef>
-          <a:fontRef idx="minor">
-            <a:schemeClr val="lt1"/>
-          </a:fontRef>
-        </p:style>
-        <p:txBody>
-          <a:bodyPr rtlCol="0" anchor="ctr" lIns="274320"/>
-          <a:lstStyle/>
-          <a:p>
-            <a:pPr algn="ctr"/>
-            <a:r>
-              <a:rPr sz="1600" b="1" i="0">
-                <a:solidFill>
-                  <a:srgbClr val="FFFFFF"/>
-                </a:solidFill>
-                <a:latin typeface="Calibri"/>
-              </a:rPr>
-              <a:t>DONNÉES   </a:t>
-            </a:r>
-            <a:r>
-              <a:rPr sz="1500" b="0" i="0">
-                <a:solidFill>
-                  <a:srgbClr val="E8EEF4"/>
-                </a:solidFill>
-                <a:latin typeface="Calibri"/>
-              </a:rPr>
-              <a:t>— Base MySQL (historique, alertes, configuration)</a:t>
-            </a:r>
-          </a:p>
-        </p:txBody>
-      </p:sp>
-      <p:sp>
-        <p:nvSpPr>
-          <p:cNvPr id="9" name="Rectangle 8"/>
-          <p:cNvSpPr/>
-          <p:nvPr/>
-        </p:nvSpPr>
-        <p:spPr>
-          <a:xfrm>
-            <a:off x="1097280" y="4892040"/>
-            <a:ext cx="9966960" cy="749808"/>
-          </a:xfrm>
-          <a:prstGeom prst="rect">
-            <a:avLst/>
-          </a:prstGeom>
-          <a:solidFill>
-            <a:srgbClr val="0D3B66"/>
-          </a:solidFill>
-          <a:ln>
-            <a:noFill/>
-          </a:ln>
-          <a:effectLst/>
-        </p:spPr>
-        <p:style>
-          <a:lnRef idx="1">
-            <a:schemeClr val="accent1"/>
-          </a:lnRef>
-          <a:fillRef idx="3">
-            <a:schemeClr val="accent1"/>
-          </a:fillRef>
-          <a:effectRef idx="2">
-            <a:schemeClr val="accent1"/>
-          </a:effectRef>
-          <a:fontRef idx="minor">
-            <a:schemeClr val="lt1"/>
-          </a:fontRef>
-        </p:style>
-        <p:txBody>
-          <a:bodyPr rtlCol="0" anchor="ctr" lIns="274320"/>
-          <a:lstStyle/>
-          <a:p>
-            <a:pPr algn="ctr"/>
-            <a:r>
-              <a:rPr sz="1600" b="1" i="0">
-                <a:solidFill>
-                  <a:srgbClr val="FFFFFF"/>
-                </a:solidFill>
-                <a:latin typeface="Calibri"/>
-              </a:rPr>
-              <a:t>SYSTÈME   </a:t>
-            </a:r>
-            <a:r>
-              <a:rPr sz="1500" b="0" i="0">
-                <a:solidFill>
-                  <a:srgbClr val="E8EEF4"/>
-                </a:solidFill>
-                <a:latin typeface="Calibri"/>
-              </a:rPr>
-              <a:t>— Serveur Linux Ubuntu</a:t>
-            </a:r>
-          </a:p>
-        </p:txBody>
-      </p:sp>
-      <p:sp>
-        <p:nvSpPr>
-          <p:cNvPr id="10" name="Rectangle 9"/>
-          <p:cNvSpPr/>
-          <p:nvPr/>
-        </p:nvSpPr>
-        <p:spPr>
-          <a:xfrm>
-            <a:off x="640080" y="5806440"/>
-            <a:ext cx="109728" cy="868680"/>
-          </a:xfrm>
-          <a:prstGeom prst="rect">
-            <a:avLst/>
-          </a:prstGeom>
-          <a:solidFill>
-            <a:srgbClr val="0D6EFD"/>
-          </a:solidFill>
-          <a:ln>
-            <a:noFill/>
-          </a:ln>
-          <a:effectLst/>
-        </p:spPr>
-        <p:style>
-          <a:lnRef idx="1">
-            <a:schemeClr val="accent1"/>
-          </a:lnRef>
-          <a:fillRef idx="3">
-            <a:schemeClr val="accent1"/>
-          </a:fillRef>
-          <a:effectRef idx="2">
-            <a:schemeClr val="accent1"/>
-          </a:effectRef>
-          <a:fontRef idx="minor">
-            <a:schemeClr val="lt1"/>
-          </a:fontRef>
-        </p:style>
-        <p:txBody>
-          <a:bodyPr rtlCol="0" anchor="ctr"/>
-          <a:lstStyle/>
-          <a:p>
-            <a:pPr algn="ctr"/>
-          </a:p>
-        </p:txBody>
-      </p:sp>
-      <p:sp>
-        <p:nvSpPr>
-          <p:cNvPr id="11" name="Rectangle 10"/>
-          <p:cNvSpPr/>
-          <p:nvPr/>
-        </p:nvSpPr>
-        <p:spPr>
-          <a:xfrm>
-            <a:off x="749808" y="5806440"/>
-            <a:ext cx="10771632" cy="868680"/>
-          </a:xfrm>
-          <a:prstGeom prst="rect">
-            <a:avLst/>
-          </a:prstGeom>
-          <a:solidFill>
-            <a:srgbClr val="F1F3F5"/>
-          </a:solidFill>
-          <a:ln>
-            <a:noFill/>
-          </a:ln>
-          <a:effectLst/>
-        </p:spPr>
-        <p:style>
-          <a:lnRef idx="1">
-            <a:schemeClr val="accent1"/>
-          </a:lnRef>
-          <a:fillRef idx="3">
-            <a:schemeClr val="accent1"/>
-          </a:fillRef>
-          <a:effectRef idx="2">
-            <a:schemeClr val="accent1"/>
-          </a:effectRef>
-          <a:fontRef idx="minor">
-            <a:schemeClr val="lt1"/>
-          </a:fontRef>
-        </p:style>
-        <p:txBody>
-          <a:bodyPr rtlCol="0" anchor="ctr" wrap="square" lIns="182880"/>
-          <a:lstStyle/>
-          <a:p>
-            <a:pPr algn="ctr"/>
-            <a:r>
-              <a:rPr sz="1700" b="1" i="1">
-                <a:solidFill>
-                  <a:srgbClr val="0D3B66"/>
-                </a:solidFill>
-                <a:latin typeface="Calibri"/>
-              </a:rPr>
-              <a:t>Choix clé : découplage moteur de collecte (Cron) ↔ interface (Flask) → la surveillance continue même si le tableau de bord est arrêté.</a:t>
             </a:r>
           </a:p>
         </p:txBody>
@@ -6716,6 +6596,570 @@
                 </a:solidFill>
                 <a:latin typeface="Calibri"/>
               </a:rPr>
+              <a:t>6</a:t>
+            </a:r>
+          </a:p>
+        </p:txBody>
+      </p:sp>
+      <p:sp>
+        <p:nvSpPr>
+          <p:cNvPr id="4" name="TextBox 3"/>
+          <p:cNvSpPr txBox="1"/>
+          <p:nvPr/>
+        </p:nvSpPr>
+        <p:spPr>
+          <a:xfrm>
+            <a:off x="1143000" y="164592"/>
+            <a:ext cx="10774375" cy="731520"/>
+          </a:xfrm>
+          <a:prstGeom prst="rect">
+            <a:avLst/>
+          </a:prstGeom>
+          <a:noFill/>
+        </p:spPr>
+        <p:txBody>
+          <a:bodyPr wrap="square" anchor="ctr">
+            <a:spAutoFit/>
+          </a:bodyPr>
+          <a:lstStyle/>
+          <a:p>
+            <a:r>
+              <a:rPr sz="3000" b="1" i="0">
+                <a:solidFill>
+                  <a:srgbClr val="FFFFFF"/>
+                </a:solidFill>
+                <a:latin typeface="Calibri"/>
+              </a:rPr>
+              <a:t>Architecture de la solution</a:t>
+            </a:r>
+          </a:p>
+        </p:txBody>
+      </p:sp>
+      <p:sp>
+        <p:nvSpPr>
+          <p:cNvPr id="5" name="Rectangle 4"/>
+          <p:cNvSpPr/>
+          <p:nvPr/>
+        </p:nvSpPr>
+        <p:spPr>
+          <a:xfrm>
+            <a:off x="1097280" y="1417320"/>
+            <a:ext cx="9966960" cy="749808"/>
+          </a:xfrm>
+          <a:prstGeom prst="rect">
+            <a:avLst/>
+          </a:prstGeom>
+          <a:solidFill>
+            <a:srgbClr val="0D6EFD"/>
+          </a:solidFill>
+          <a:ln>
+            <a:noFill/>
+          </a:ln>
+          <a:effectLst/>
+        </p:spPr>
+        <p:style>
+          <a:lnRef idx="1">
+            <a:schemeClr val="accent1"/>
+          </a:lnRef>
+          <a:fillRef idx="3">
+            <a:schemeClr val="accent1"/>
+          </a:fillRef>
+          <a:effectRef idx="2">
+            <a:schemeClr val="accent1"/>
+          </a:effectRef>
+          <a:fontRef idx="minor">
+            <a:schemeClr val="lt1"/>
+          </a:fontRef>
+        </p:style>
+        <p:txBody>
+          <a:bodyPr rtlCol="0" anchor="ctr" lIns="274320"/>
+          <a:lstStyle/>
+          <a:p>
+            <a:pPr algn="ctr"/>
+            <a:r>
+              <a:rPr sz="1600" b="1" i="0">
+                <a:solidFill>
+                  <a:srgbClr val="FFFFFF"/>
+                </a:solidFill>
+                <a:latin typeface="Calibri"/>
+              </a:rPr>
+              <a:t>PRÉSENTATION   </a:t>
+            </a:r>
+            <a:r>
+              <a:rPr sz="1500" b="0" i="0">
+                <a:solidFill>
+                  <a:srgbClr val="E8EEF4"/>
+                </a:solidFill>
+                <a:latin typeface="Calibri"/>
+              </a:rPr>
+              <a:t>— Tableau de bord Flask + Bootstrap + Chart.js</a:t>
+            </a:r>
+          </a:p>
+        </p:txBody>
+      </p:sp>
+      <p:sp>
+        <p:nvSpPr>
+          <p:cNvPr id="6" name="Rectangle 5"/>
+          <p:cNvSpPr/>
+          <p:nvPr/>
+        </p:nvSpPr>
+        <p:spPr>
+          <a:xfrm>
+            <a:off x="1097280" y="2286000"/>
+            <a:ext cx="9966960" cy="749808"/>
+          </a:xfrm>
+          <a:prstGeom prst="rect">
+            <a:avLst/>
+          </a:prstGeom>
+          <a:solidFill>
+            <a:srgbClr val="398AC8"/>
+          </a:solidFill>
+          <a:ln>
+            <a:noFill/>
+          </a:ln>
+          <a:effectLst/>
+        </p:spPr>
+        <p:style>
+          <a:lnRef idx="1">
+            <a:schemeClr val="accent1"/>
+          </a:lnRef>
+          <a:fillRef idx="3">
+            <a:schemeClr val="accent1"/>
+          </a:fillRef>
+          <a:effectRef idx="2">
+            <a:schemeClr val="accent1"/>
+          </a:effectRef>
+          <a:fontRef idx="minor">
+            <a:schemeClr val="lt1"/>
+          </a:fontRef>
+        </p:style>
+        <p:txBody>
+          <a:bodyPr rtlCol="0" anchor="ctr" lIns="274320"/>
+          <a:lstStyle/>
+          <a:p>
+            <a:pPr algn="ctr"/>
+            <a:r>
+              <a:rPr sz="1600" b="1" i="0">
+                <a:solidFill>
+                  <a:srgbClr val="FFFFFF"/>
+                </a:solidFill>
+                <a:latin typeface="Calibri"/>
+              </a:rPr>
+              <a:t>NOTIFICATION   </a:t>
+            </a:r>
+            <a:r>
+              <a:rPr sz="1500" b="0" i="0">
+                <a:solidFill>
+                  <a:srgbClr val="E8EEF4"/>
+                </a:solidFill>
+                <a:latin typeface="Calibri"/>
+              </a:rPr>
+              <a:t>— E-mail (SMTP)  +  Telegram (push mobile)</a:t>
+            </a:r>
+          </a:p>
+        </p:txBody>
+      </p:sp>
+      <p:sp>
+        <p:nvSpPr>
+          <p:cNvPr id="7" name="Rectangle 6"/>
+          <p:cNvSpPr/>
+          <p:nvPr/>
+        </p:nvSpPr>
+        <p:spPr>
+          <a:xfrm>
+            <a:off x="1097280" y="3154680"/>
+            <a:ext cx="9966960" cy="749808"/>
+          </a:xfrm>
+          <a:prstGeom prst="rect">
+            <a:avLst/>
+          </a:prstGeom>
+          <a:solidFill>
+            <a:srgbClr val="2A6F97"/>
+          </a:solidFill>
+          <a:ln>
+            <a:noFill/>
+          </a:ln>
+          <a:effectLst/>
+        </p:spPr>
+        <p:style>
+          <a:lnRef idx="1">
+            <a:schemeClr val="accent1"/>
+          </a:lnRef>
+          <a:fillRef idx="3">
+            <a:schemeClr val="accent1"/>
+          </a:fillRef>
+          <a:effectRef idx="2">
+            <a:schemeClr val="accent1"/>
+          </a:effectRef>
+          <a:fontRef idx="minor">
+            <a:schemeClr val="lt1"/>
+          </a:fontRef>
+        </p:style>
+        <p:txBody>
+          <a:bodyPr rtlCol="0" anchor="ctr" lIns="274320"/>
+          <a:lstStyle/>
+          <a:p>
+            <a:pPr algn="ctr"/>
+            <a:r>
+              <a:rPr sz="1600" b="1" i="0">
+                <a:solidFill>
+                  <a:srgbClr val="FFFFFF"/>
+                </a:solidFill>
+                <a:latin typeface="Calibri"/>
+              </a:rPr>
+              <a:t>TRAITEMENT   </a:t>
+            </a:r>
+            <a:r>
+              <a:rPr sz="1500" b="0" i="0">
+                <a:solidFill>
+                  <a:srgbClr val="E8EEF4"/>
+                </a:solidFill>
+                <a:latin typeface="Calibri"/>
+              </a:rPr>
+              <a:t>— Moteur Python + Cron (sondes ICMP / TCP)</a:t>
+            </a:r>
+          </a:p>
+        </p:txBody>
+      </p:sp>
+      <p:sp>
+        <p:nvSpPr>
+          <p:cNvPr id="8" name="Rectangle 7"/>
+          <p:cNvSpPr/>
+          <p:nvPr/>
+        </p:nvSpPr>
+        <p:spPr>
+          <a:xfrm>
+            <a:off x="1097280" y="4023360"/>
+            <a:ext cx="9966960" cy="749808"/>
+          </a:xfrm>
+          <a:prstGeom prst="rect">
+            <a:avLst/>
+          </a:prstGeom>
+          <a:solidFill>
+            <a:srgbClr val="1B4F72"/>
+          </a:solidFill>
+          <a:ln>
+            <a:noFill/>
+          </a:ln>
+          <a:effectLst/>
+        </p:spPr>
+        <p:style>
+          <a:lnRef idx="1">
+            <a:schemeClr val="accent1"/>
+          </a:lnRef>
+          <a:fillRef idx="3">
+            <a:schemeClr val="accent1"/>
+          </a:fillRef>
+          <a:effectRef idx="2">
+            <a:schemeClr val="accent1"/>
+          </a:effectRef>
+          <a:fontRef idx="minor">
+            <a:schemeClr val="lt1"/>
+          </a:fontRef>
+        </p:style>
+        <p:txBody>
+          <a:bodyPr rtlCol="0" anchor="ctr" lIns="274320"/>
+          <a:lstStyle/>
+          <a:p>
+            <a:pPr algn="ctr"/>
+            <a:r>
+              <a:rPr sz="1600" b="1" i="0">
+                <a:solidFill>
+                  <a:srgbClr val="FFFFFF"/>
+                </a:solidFill>
+                <a:latin typeface="Calibri"/>
+              </a:rPr>
+              <a:t>DONNÉES   </a:t>
+            </a:r>
+            <a:r>
+              <a:rPr sz="1500" b="0" i="0">
+                <a:solidFill>
+                  <a:srgbClr val="E8EEF4"/>
+                </a:solidFill>
+                <a:latin typeface="Calibri"/>
+              </a:rPr>
+              <a:t>— Base MySQL (historique, alertes, configuration)</a:t>
+            </a:r>
+          </a:p>
+        </p:txBody>
+      </p:sp>
+      <p:sp>
+        <p:nvSpPr>
+          <p:cNvPr id="9" name="Rectangle 8"/>
+          <p:cNvSpPr/>
+          <p:nvPr/>
+        </p:nvSpPr>
+        <p:spPr>
+          <a:xfrm>
+            <a:off x="1097280" y="4892040"/>
+            <a:ext cx="9966960" cy="749808"/>
+          </a:xfrm>
+          <a:prstGeom prst="rect">
+            <a:avLst/>
+          </a:prstGeom>
+          <a:solidFill>
+            <a:srgbClr val="0D3B66"/>
+          </a:solidFill>
+          <a:ln>
+            <a:noFill/>
+          </a:ln>
+          <a:effectLst/>
+        </p:spPr>
+        <p:style>
+          <a:lnRef idx="1">
+            <a:schemeClr val="accent1"/>
+          </a:lnRef>
+          <a:fillRef idx="3">
+            <a:schemeClr val="accent1"/>
+          </a:fillRef>
+          <a:effectRef idx="2">
+            <a:schemeClr val="accent1"/>
+          </a:effectRef>
+          <a:fontRef idx="minor">
+            <a:schemeClr val="lt1"/>
+          </a:fontRef>
+        </p:style>
+        <p:txBody>
+          <a:bodyPr rtlCol="0" anchor="ctr" lIns="274320"/>
+          <a:lstStyle/>
+          <a:p>
+            <a:pPr algn="ctr"/>
+            <a:r>
+              <a:rPr sz="1600" b="1" i="0">
+                <a:solidFill>
+                  <a:srgbClr val="FFFFFF"/>
+                </a:solidFill>
+                <a:latin typeface="Calibri"/>
+              </a:rPr>
+              <a:t>SYSTÈME   </a:t>
+            </a:r>
+            <a:r>
+              <a:rPr sz="1500" b="0" i="0">
+                <a:solidFill>
+                  <a:srgbClr val="E8EEF4"/>
+                </a:solidFill>
+                <a:latin typeface="Calibri"/>
+              </a:rPr>
+              <a:t>— Serveur Linux Ubuntu</a:t>
+            </a:r>
+          </a:p>
+        </p:txBody>
+      </p:sp>
+      <p:sp>
+        <p:nvSpPr>
+          <p:cNvPr id="10" name="Rectangle 9"/>
+          <p:cNvSpPr/>
+          <p:nvPr/>
+        </p:nvSpPr>
+        <p:spPr>
+          <a:xfrm>
+            <a:off x="640080" y="5806440"/>
+            <a:ext cx="109728" cy="868680"/>
+          </a:xfrm>
+          <a:prstGeom prst="rect">
+            <a:avLst/>
+          </a:prstGeom>
+          <a:solidFill>
+            <a:srgbClr val="0D6EFD"/>
+          </a:solidFill>
+          <a:ln>
+            <a:noFill/>
+          </a:ln>
+          <a:effectLst/>
+        </p:spPr>
+        <p:style>
+          <a:lnRef idx="1">
+            <a:schemeClr val="accent1"/>
+          </a:lnRef>
+          <a:fillRef idx="3">
+            <a:schemeClr val="accent1"/>
+          </a:fillRef>
+          <a:effectRef idx="2">
+            <a:schemeClr val="accent1"/>
+          </a:effectRef>
+          <a:fontRef idx="minor">
+            <a:schemeClr val="lt1"/>
+          </a:fontRef>
+        </p:style>
+        <p:txBody>
+          <a:bodyPr rtlCol="0" anchor="ctr"/>
+          <a:lstStyle/>
+          <a:p>
+            <a:pPr algn="ctr"/>
+          </a:p>
+        </p:txBody>
+      </p:sp>
+      <p:sp>
+        <p:nvSpPr>
+          <p:cNvPr id="11" name="Rectangle 10"/>
+          <p:cNvSpPr/>
+          <p:nvPr/>
+        </p:nvSpPr>
+        <p:spPr>
+          <a:xfrm>
+            <a:off x="749808" y="5806440"/>
+            <a:ext cx="10771632" cy="868680"/>
+          </a:xfrm>
+          <a:prstGeom prst="rect">
+            <a:avLst/>
+          </a:prstGeom>
+          <a:solidFill>
+            <a:srgbClr val="F1F3F5"/>
+          </a:solidFill>
+          <a:ln>
+            <a:noFill/>
+          </a:ln>
+          <a:effectLst/>
+        </p:spPr>
+        <p:style>
+          <a:lnRef idx="1">
+            <a:schemeClr val="accent1"/>
+          </a:lnRef>
+          <a:fillRef idx="3">
+            <a:schemeClr val="accent1"/>
+          </a:fillRef>
+          <a:effectRef idx="2">
+            <a:schemeClr val="accent1"/>
+          </a:effectRef>
+          <a:fontRef idx="minor">
+            <a:schemeClr val="lt1"/>
+          </a:fontRef>
+        </p:style>
+        <p:txBody>
+          <a:bodyPr rtlCol="0" anchor="ctr" wrap="square" lIns="182880"/>
+          <a:lstStyle/>
+          <a:p>
+            <a:pPr algn="ctr"/>
+            <a:r>
+              <a:rPr sz="1700" b="1" i="1">
+                <a:solidFill>
+                  <a:srgbClr val="0D3B66"/>
+                </a:solidFill>
+                <a:latin typeface="Calibri"/>
+              </a:rPr>
+              <a:t>Choix clé : découplage moteur de collecte (Cron) ↔ interface (Flask) → la surveillance continue même si le tableau de bord est arrêté.</a:t>
+            </a:r>
+          </a:p>
+        </p:txBody>
+      </p:sp>
+    </p:spTree>
+  </p:cSld>
+  <p:clrMapOvr>
+    <a:masterClrMapping/>
+  </p:clrMapOvr>
+</p:sld>
+</file>
+
+<file path=ppt/slides/slide14.xml><?xml version="1.0" encoding="utf-8"?>
+<p:sld xmlns:a="http://schemas.openxmlformats.org/drawingml/2006/main" xmlns:p="http://schemas.openxmlformats.org/presentationml/2006/main" xmlns:r="http://schemas.openxmlformats.org/officeDocument/2006/relationships">
+  <p:cSld>
+    <p:bg>
+      <p:bgPr>
+        <a:solidFill>
+          <a:srgbClr val="FFFFFF"/>
+        </a:solidFill>
+        <a:effectLst/>
+      </p:bgPr>
+    </p:bg>
+    <p:spTree>
+      <p:nvGrpSpPr>
+        <p:cNvPr id="1" name=""/>
+        <p:cNvGrpSpPr/>
+        <p:nvPr/>
+      </p:nvGrpSpPr>
+      <p:grpSpPr/>
+      <p:sp>
+        <p:nvSpPr>
+          <p:cNvPr id="2" name="Rectangle 1"/>
+          <p:cNvSpPr/>
+          <p:nvPr/>
+        </p:nvSpPr>
+        <p:spPr>
+          <a:xfrm>
+            <a:off x="0" y="0"/>
+            <a:ext cx="12191695" cy="1051560"/>
+          </a:xfrm>
+          <a:prstGeom prst="rect">
+            <a:avLst/>
+          </a:prstGeom>
+          <a:solidFill>
+            <a:srgbClr val="0D3B66"/>
+          </a:solidFill>
+          <a:ln>
+            <a:noFill/>
+          </a:ln>
+          <a:effectLst/>
+        </p:spPr>
+        <p:style>
+          <a:lnRef idx="1">
+            <a:schemeClr val="accent1"/>
+          </a:lnRef>
+          <a:fillRef idx="3">
+            <a:schemeClr val="accent1"/>
+          </a:fillRef>
+          <a:effectRef idx="2">
+            <a:schemeClr val="accent1"/>
+          </a:effectRef>
+          <a:fontRef idx="minor">
+            <a:schemeClr val="lt1"/>
+          </a:fontRef>
+        </p:style>
+        <p:txBody>
+          <a:bodyPr rtlCol="0" anchor="ctr"/>
+          <a:lstStyle/>
+          <a:p>
+            <a:pPr algn="ctr"/>
+          </a:p>
+        </p:txBody>
+      </p:sp>
+      <p:sp>
+        <p:nvSpPr>
+          <p:cNvPr id="3" name="Oval 2"/>
+          <p:cNvSpPr/>
+          <p:nvPr/>
+        </p:nvSpPr>
+        <p:spPr>
+          <a:xfrm>
+            <a:off x="320040" y="201168"/>
+            <a:ext cx="658368" cy="658368"/>
+          </a:xfrm>
+          <a:prstGeom prst="ellipse">
+            <a:avLst/>
+          </a:prstGeom>
+          <a:solidFill>
+            <a:srgbClr val="0D6EFD"/>
+          </a:solidFill>
+          <a:ln>
+            <a:noFill/>
+          </a:ln>
+          <a:effectLst/>
+        </p:spPr>
+        <p:style>
+          <a:lnRef idx="1">
+            <a:schemeClr val="accent1"/>
+          </a:lnRef>
+          <a:fillRef idx="3">
+            <a:schemeClr val="accent1"/>
+          </a:fillRef>
+          <a:effectRef idx="2">
+            <a:schemeClr val="accent1"/>
+          </a:effectRef>
+          <a:fontRef idx="minor">
+            <a:schemeClr val="lt1"/>
+          </a:fontRef>
+        </p:style>
+        <p:txBody>
+          <a:bodyPr rtlCol="0" anchor="ctr" wrap="none"/>
+          <a:lstStyle/>
+          <a:p>
+            <a:pPr algn="ctr"/>
+            <a:r>
+              <a:rPr sz="2600" b="1" i="0">
+                <a:solidFill>
+                  <a:srgbClr val="FFFFFF"/>
+                </a:solidFill>
+                <a:latin typeface="Calibri"/>
+              </a:rPr>
               <a:t>7</a:t>
             </a:r>
           </a:p>
@@ -6979,7 +7423,7 @@
 </p:sld>
 </file>
 
-<file path=ppt/slides/slide14.xml><?xml version="1.0" encoding="utf-8"?>
+<file path=ppt/slides/slide15.xml><?xml version="1.0" encoding="utf-8"?>
 <p:sld xmlns:a="http://schemas.openxmlformats.org/drawingml/2006/main" xmlns:p="http://schemas.openxmlformats.org/presentationml/2006/main" xmlns:r="http://schemas.openxmlformats.org/officeDocument/2006/relationships">
   <p:cSld>
     <p:bg>
@@ -7498,7 +7942,7 @@
 </p:sld>
 </file>
 
-<file path=ppt/slides/slide15.xml><?xml version="1.0" encoding="utf-8"?>
+<file path=ppt/slides/slide16.xml><?xml version="1.0" encoding="utf-8"?>
 <p:sld xmlns:a="http://schemas.openxmlformats.org/drawingml/2006/main" xmlns:p="http://schemas.openxmlformats.org/presentationml/2006/main" xmlns:r="http://schemas.openxmlformats.org/officeDocument/2006/relationships">
   <p:cSld>
     <p:bg>
@@ -7819,7 +8263,7 @@
 </p:sld>
 </file>
 
-<file path=ppt/slides/slide16.xml><?xml version="1.0" encoding="utf-8"?>
+<file path=ppt/slides/slide17.xml><?xml version="1.0" encoding="utf-8"?>
 <p:sld xmlns:a="http://schemas.openxmlformats.org/drawingml/2006/main" xmlns:p="http://schemas.openxmlformats.org/presentationml/2006/main" xmlns:r="http://schemas.openxmlformats.org/officeDocument/2006/relationships">
   <p:cSld>
     <p:bg>
@@ -8435,7 +8879,7 @@
 </p:sld>
 </file>
 
-<file path=ppt/slides/slide17.xml><?xml version="1.0" encoding="utf-8"?>
+<file path=ppt/slides/slide18.xml><?xml version="1.0" encoding="utf-8"?>
 <p:sld xmlns:a="http://schemas.openxmlformats.org/drawingml/2006/main" xmlns:p="http://schemas.openxmlformats.org/presentationml/2006/main" xmlns:r="http://schemas.openxmlformats.org/officeDocument/2006/relationships">
   <p:cSld>
     <p:bg>
@@ -8759,7 +9203,7 @@
 </p:sld>
 </file>
 
-<file path=ppt/slides/slide18.xml><?xml version="1.0" encoding="utf-8"?>
+<file path=ppt/slides/slide19.xml><?xml version="1.0" encoding="utf-8"?>
 <p:sld xmlns:a="http://schemas.openxmlformats.org/drawingml/2006/main" xmlns:p="http://schemas.openxmlformats.org/presentationml/2006/main" xmlns:r="http://schemas.openxmlformats.org/officeDocument/2006/relationships">
   <p:cSld>
     <p:bg>
@@ -9605,7 +10049,381 @@
 </p:sld>
 </file>
 
-<file path=ppt/slides/slide19.xml><?xml version="1.0" encoding="utf-8"?>
+<file path=ppt/slides/slide2.xml><?xml version="1.0" encoding="utf-8"?>
+<p:sld xmlns:a="http://schemas.openxmlformats.org/drawingml/2006/main" xmlns:p="http://schemas.openxmlformats.org/presentationml/2006/main" xmlns:r="http://schemas.openxmlformats.org/officeDocument/2006/relationships">
+  <p:cSld>
+    <p:bg>
+      <p:bgPr>
+        <a:solidFill>
+          <a:srgbClr val="FFFFFF"/>
+        </a:solidFill>
+        <a:effectLst/>
+      </p:bgPr>
+    </p:bg>
+    <p:spTree>
+      <p:nvGrpSpPr>
+        <p:cNvPr id="1" name=""/>
+        <p:cNvGrpSpPr/>
+        <p:nvPr/>
+      </p:nvGrpSpPr>
+      <p:grpSpPr/>
+      <p:sp>
+        <p:nvSpPr>
+          <p:cNvPr id="2" name="Rectangle 1"/>
+          <p:cNvSpPr/>
+          <p:nvPr/>
+        </p:nvSpPr>
+        <p:spPr>
+          <a:xfrm>
+            <a:off x="0" y="0"/>
+            <a:ext cx="12191695" cy="1051560"/>
+          </a:xfrm>
+          <a:prstGeom prst="rect">
+            <a:avLst/>
+          </a:prstGeom>
+          <a:solidFill>
+            <a:srgbClr val="0D3B66"/>
+          </a:solidFill>
+          <a:ln>
+            <a:noFill/>
+          </a:ln>
+          <a:effectLst/>
+        </p:spPr>
+        <p:style>
+          <a:lnRef idx="1">
+            <a:schemeClr val="accent1"/>
+          </a:lnRef>
+          <a:fillRef idx="3">
+            <a:schemeClr val="accent1"/>
+          </a:fillRef>
+          <a:effectRef idx="2">
+            <a:schemeClr val="accent1"/>
+          </a:effectRef>
+          <a:fontRef idx="minor">
+            <a:schemeClr val="lt1"/>
+          </a:fontRef>
+        </p:style>
+        <p:txBody>
+          <a:bodyPr rtlCol="0" anchor="ctr"/>
+          <a:lstStyle/>
+          <a:p>
+            <a:pPr algn="ctr"/>
+          </a:p>
+        </p:txBody>
+      </p:sp>
+      <p:sp>
+        <p:nvSpPr>
+          <p:cNvPr id="3" name="TextBox 2"/>
+          <p:cNvSpPr txBox="1"/>
+          <p:nvPr/>
+        </p:nvSpPr>
+        <p:spPr>
+          <a:xfrm>
+            <a:off x="457200" y="164592"/>
+            <a:ext cx="11460175" cy="731520"/>
+          </a:xfrm>
+          <a:prstGeom prst="rect">
+            <a:avLst/>
+          </a:prstGeom>
+          <a:noFill/>
+        </p:spPr>
+        <p:txBody>
+          <a:bodyPr wrap="square" anchor="ctr">
+            <a:spAutoFit/>
+          </a:bodyPr>
+          <a:lstStyle/>
+          <a:p>
+            <a:r>
+              <a:rPr sz="3000" b="1" i="0">
+                <a:solidFill>
+                  <a:srgbClr val="FFFFFF"/>
+                </a:solidFill>
+                <a:latin typeface="Calibri"/>
+              </a:rPr>
+              <a:t>Plan de la présentation</a:t>
+            </a:r>
+          </a:p>
+        </p:txBody>
+      </p:sp>
+      <p:sp>
+        <p:nvSpPr>
+          <p:cNvPr id="4" name="TextBox 3"/>
+          <p:cNvSpPr txBox="1"/>
+          <p:nvPr/>
+        </p:nvSpPr>
+        <p:spPr>
+          <a:xfrm>
+            <a:off x="640080" y="1463040"/>
+            <a:ext cx="5486400" cy="4937760"/>
+          </a:xfrm>
+          <a:prstGeom prst="rect">
+            <a:avLst/>
+          </a:prstGeom>
+          <a:noFill/>
+        </p:spPr>
+        <p:txBody>
+          <a:bodyPr wrap="square">
+            <a:spAutoFit/>
+          </a:bodyPr>
+          <a:lstStyle/>
+          <a:p>
+            <a:pPr>
+              <a:spcAft>
+                <a:spcPts val="1200"/>
+              </a:spcAft>
+            </a:pPr>
+            <a:r>
+              <a:rPr sz="2000" b="1" i="0">
+                <a:solidFill>
+                  <a:srgbClr val="0D3B66"/>
+                </a:solidFill>
+                <a:latin typeface="Calibri"/>
+              </a:rPr>
+              <a:t>•  Introduction — L'annonce du sujet</a:t>
+            </a:r>
+          </a:p>
+          <a:p>
+            <a:pPr>
+              <a:spcAft>
+                <a:spcPts val="1200"/>
+              </a:spcAft>
+            </a:pPr>
+            <a:r>
+              <a:rPr sz="2000" b="0" i="0">
+                <a:solidFill>
+                  <a:srgbClr val="333333"/>
+                </a:solidFill>
+                <a:latin typeface="Calibri"/>
+              </a:rPr>
+              <a:t>•  1.  Contexte et identification du problème</a:t>
+            </a:r>
+          </a:p>
+          <a:p>
+            <a:pPr>
+              <a:spcAft>
+                <a:spcPts val="1200"/>
+              </a:spcAft>
+            </a:pPr>
+            <a:r>
+              <a:rPr sz="2000" b="0" i="0">
+                <a:solidFill>
+                  <a:srgbClr val="333333"/>
+                </a:solidFill>
+                <a:latin typeface="Calibri"/>
+              </a:rPr>
+              <a:t>•  2.  Objectifs et résultats attendus</a:t>
+            </a:r>
+          </a:p>
+          <a:p>
+            <a:pPr>
+              <a:spcAft>
+                <a:spcPts val="1200"/>
+              </a:spcAft>
+            </a:pPr>
+            <a:r>
+              <a:rPr sz="2000" b="0" i="0">
+                <a:solidFill>
+                  <a:srgbClr val="333333"/>
+                </a:solidFill>
+                <a:latin typeface="Calibri"/>
+              </a:rPr>
+              <a:t>•  3.  Démarche méthodologique</a:t>
+            </a:r>
+          </a:p>
+          <a:p>
+            <a:pPr>
+              <a:spcAft>
+                <a:spcPts val="1200"/>
+              </a:spcAft>
+            </a:pPr>
+            <a:r>
+              <a:rPr sz="2000" b="0" i="0">
+                <a:solidFill>
+                  <a:srgbClr val="333333"/>
+                </a:solidFill>
+                <a:latin typeface="Calibri"/>
+              </a:rPr>
+              <a:t>•  4.  État des lieux &amp; solution proposée</a:t>
+            </a:r>
+          </a:p>
+          <a:p>
+            <a:pPr>
+              <a:spcAft>
+                <a:spcPts val="1200"/>
+              </a:spcAft>
+            </a:pPr>
+            <a:r>
+              <a:rPr sz="2000" b="0" i="0">
+                <a:solidFill>
+                  <a:srgbClr val="333333"/>
+                </a:solidFill>
+                <a:latin typeface="Calibri"/>
+              </a:rPr>
+              <a:t>•  5.  Axe de différenciation (innovation)</a:t>
+            </a:r>
+          </a:p>
+          <a:p>
+            <a:pPr>
+              <a:spcAft>
+                <a:spcPts val="1200"/>
+              </a:spcAft>
+            </a:pPr>
+            <a:r>
+              <a:rPr sz="2000" b="0" i="0">
+                <a:solidFill>
+                  <a:srgbClr val="333333"/>
+                </a:solidFill>
+                <a:latin typeface="Calibri"/>
+              </a:rPr>
+              <a:t>•  6.  Étude de faisabilité &amp; conception</a:t>
+            </a:r>
+          </a:p>
+        </p:txBody>
+      </p:sp>
+      <p:sp>
+        <p:nvSpPr>
+          <p:cNvPr id="5" name="TextBox 4"/>
+          <p:cNvSpPr txBox="1"/>
+          <p:nvPr/>
+        </p:nvSpPr>
+        <p:spPr>
+          <a:xfrm>
+            <a:off x="6309360" y="1463040"/>
+            <a:ext cx="5486400" cy="4937760"/>
+          </a:xfrm>
+          <a:prstGeom prst="rect">
+            <a:avLst/>
+          </a:prstGeom>
+          <a:noFill/>
+        </p:spPr>
+        <p:txBody>
+          <a:bodyPr wrap="square">
+            <a:spAutoFit/>
+          </a:bodyPr>
+          <a:lstStyle/>
+          <a:p>
+            <a:pPr>
+              <a:spcAft>
+                <a:spcPts val="1200"/>
+              </a:spcAft>
+            </a:pPr>
+            <a:r>
+              <a:rPr sz="2000" b="0" i="0">
+                <a:solidFill>
+                  <a:srgbClr val="333333"/>
+                </a:solidFill>
+                <a:latin typeface="Calibri"/>
+              </a:rPr>
+              <a:t>•  7.  Fonctionnement technique</a:t>
+            </a:r>
+          </a:p>
+          <a:p>
+            <a:pPr>
+              <a:spcAft>
+                <a:spcPts val="1200"/>
+              </a:spcAft>
+            </a:pPr>
+            <a:r>
+              <a:rPr sz="2000" b="1" i="0">
+                <a:solidFill>
+                  <a:srgbClr val="D62828"/>
+                </a:solidFill>
+                <a:latin typeface="Calibri"/>
+              </a:rPr>
+              <a:t>•  8.  Démonstration</a:t>
+            </a:r>
+          </a:p>
+          <a:p>
+            <a:pPr>
+              <a:spcAft>
+                <a:spcPts val="1200"/>
+              </a:spcAft>
+            </a:pPr>
+            <a:r>
+              <a:rPr sz="2000" b="0" i="0">
+                <a:solidFill>
+                  <a:srgbClr val="333333"/>
+                </a:solidFill>
+                <a:latin typeface="Calibri"/>
+              </a:rPr>
+              <a:t>•  9.  Marketing, vente &amp; concurrence</a:t>
+            </a:r>
+          </a:p>
+          <a:p>
+            <a:pPr>
+              <a:spcAft>
+                <a:spcPts val="1200"/>
+              </a:spcAft>
+            </a:pPr>
+            <a:r>
+              <a:rPr sz="2000" b="0" i="0">
+                <a:solidFill>
+                  <a:srgbClr val="333333"/>
+                </a:solidFill>
+                <a:latin typeface="Calibri"/>
+              </a:rPr>
+              <a:t>•  10. Prévisions financières</a:t>
+            </a:r>
+          </a:p>
+          <a:p>
+            <a:pPr>
+              <a:spcAft>
+                <a:spcPts val="1200"/>
+              </a:spcAft>
+            </a:pPr>
+            <a:r>
+              <a:rPr sz="2000" b="0" i="0">
+                <a:solidFill>
+                  <a:srgbClr val="333333"/>
+                </a:solidFill>
+                <a:latin typeface="Calibri"/>
+              </a:rPr>
+              <a:t>•  11. Limites &amp; perspectives</a:t>
+            </a:r>
+          </a:p>
+          <a:p>
+            <a:pPr>
+              <a:spcAft>
+                <a:spcPts val="1200"/>
+              </a:spcAft>
+            </a:pPr>
+            <a:r>
+              <a:rPr sz="2000" b="0" i="0">
+                <a:solidFill>
+                  <a:srgbClr val="333333"/>
+                </a:solidFill>
+                <a:latin typeface="Calibri"/>
+              </a:rPr>
+              <a:t/>
+            </a:r>
+          </a:p>
+          <a:p>
+            <a:pPr>
+              <a:spcAft>
+                <a:spcPts val="1200"/>
+              </a:spcAft>
+            </a:pPr>
+            <a:r>
+              <a:rPr sz="2000" b="1" i="0">
+                <a:solidFill>
+                  <a:srgbClr val="0D3B66"/>
+                </a:solidFill>
+                <a:latin typeface="Calibri"/>
+              </a:rPr>
+              <a:t>•  Conclusion</a:t>
+            </a:r>
+          </a:p>
+        </p:txBody>
+      </p:sp>
+    </p:spTree>
+  </p:cSld>
+  <p:clrMapOvr>
+    <a:masterClrMapping/>
+  </p:clrMapOvr>
+</p:sld>
+</file>
+
+<file path=ppt/slides/slide20.xml><?xml version="1.0" encoding="utf-8"?>
 <p:sld xmlns:a="http://schemas.openxmlformats.org/drawingml/2006/main" xmlns:p="http://schemas.openxmlformats.org/presentationml/2006/main" xmlns:r="http://schemas.openxmlformats.org/officeDocument/2006/relationships">
   <p:cSld>
     <p:bg>
@@ -10575,7 +11393,7 @@
 </p:sld>
 </file>
 
-<file path=ppt/slides/slide2.xml><?xml version="1.0" encoding="utf-8"?>
+<file path=ppt/slides/slide21.xml><?xml version="1.0" encoding="utf-8"?>
 <p:sld xmlns:a="http://schemas.openxmlformats.org/drawingml/2006/main" xmlns:p="http://schemas.openxmlformats.org/presentationml/2006/main" xmlns:r="http://schemas.openxmlformats.org/officeDocument/2006/relationships">
   <p:cSld>
     <p:bg>
@@ -10639,14 +11457,67 @@
       </p:sp>
       <p:sp>
         <p:nvSpPr>
-          <p:cNvPr id="3" name="TextBox 2"/>
+          <p:cNvPr id="3" name="Oval 2"/>
+          <p:cNvSpPr/>
+          <p:nvPr/>
+        </p:nvSpPr>
+        <p:spPr>
+          <a:xfrm>
+            <a:off x="320040" y="201168"/>
+            <a:ext cx="658368" cy="658368"/>
+          </a:xfrm>
+          <a:prstGeom prst="ellipse">
+            <a:avLst/>
+          </a:prstGeom>
+          <a:solidFill>
+            <a:srgbClr val="0D6EFD"/>
+          </a:solidFill>
+          <a:ln>
+            <a:noFill/>
+          </a:ln>
+          <a:effectLst/>
+        </p:spPr>
+        <p:style>
+          <a:lnRef idx="1">
+            <a:schemeClr val="accent1"/>
+          </a:lnRef>
+          <a:fillRef idx="3">
+            <a:schemeClr val="accent1"/>
+          </a:fillRef>
+          <a:effectRef idx="2">
+            <a:schemeClr val="accent1"/>
+          </a:effectRef>
+          <a:fontRef idx="minor">
+            <a:schemeClr val="lt1"/>
+          </a:fontRef>
+        </p:style>
+        <p:txBody>
+          <a:bodyPr rtlCol="0" anchor="ctr" wrap="none"/>
+          <a:lstStyle/>
+          <a:p>
+            <a:pPr algn="ctr"/>
+            <a:r>
+              <a:rPr sz="2600" b="1" i="0">
+                <a:solidFill>
+                  <a:srgbClr val="FFFFFF"/>
+                </a:solidFill>
+                <a:latin typeface="Calibri"/>
+              </a:rPr>
+              <a:t>11</a:t>
+            </a:r>
+          </a:p>
+        </p:txBody>
+      </p:sp>
+      <p:sp>
+        <p:nvSpPr>
+          <p:cNvPr id="4" name="TextBox 3"/>
           <p:cNvSpPr txBox="1"/>
           <p:nvPr/>
         </p:nvSpPr>
         <p:spPr>
           <a:xfrm>
-            <a:off x="457200" y="164592"/>
-            <a:ext cx="11460175" cy="731520"/>
+            <a:off x="1143000" y="164592"/>
+            <a:ext cx="10774375" cy="731520"/>
           </a:xfrm>
           <a:prstGeom prst="rect">
             <a:avLst/>
@@ -10666,21 +11537,21 @@
                 </a:solidFill>
                 <a:latin typeface="Calibri"/>
               </a:rPr>
-              <a:t>Plan de la présentation</a:t>
-            </a:r>
-          </a:p>
-        </p:txBody>
-      </p:sp>
-      <p:sp>
-        <p:nvSpPr>
-          <p:cNvPr id="4" name="TextBox 3"/>
+              <a:t>Limites du projet et perspectives</a:t>
+            </a:r>
+          </a:p>
+        </p:txBody>
+      </p:sp>
+      <p:sp>
+        <p:nvSpPr>
+          <p:cNvPr id="5" name="TextBox 4"/>
           <p:cNvSpPr txBox="1"/>
           <p:nvPr/>
         </p:nvSpPr>
         <p:spPr>
           <a:xfrm>
-            <a:off x="640080" y="1463040"/>
-            <a:ext cx="5486400" cy="4937760"/>
+            <a:off x="640080" y="1280160"/>
+            <a:ext cx="10881360" cy="4937760"/>
           </a:xfrm>
           <a:prstGeom prst="rect">
             <a:avLst/>
@@ -10695,248 +11566,177 @@
           <a:p>
             <a:pPr>
               <a:spcAft>
-                <a:spcPts val="1200"/>
+                <a:spcPts val="600"/>
               </a:spcAft>
             </a:pPr>
             <a:r>
-              <a:rPr sz="2000" b="1" i="0">
-                <a:solidFill>
-                  <a:srgbClr val="0D3B66"/>
-                </a:solidFill>
-                <a:latin typeface="Calibri"/>
-              </a:rPr>
-              <a:t>•  Introduction — L'annonce du sujet</a:t>
+              <a:rPr sz="1800" b="1" i="0">
+                <a:solidFill>
+                  <a:srgbClr val="D62828"/>
+                </a:solidFill>
+                <a:latin typeface="Calibri"/>
+              </a:rPr>
+              <a:t>•  Limites assumées :</a:t>
+            </a:r>
+          </a:p>
+          <a:p>
+            <a:pPr lvl="1">
+              <a:spcAft>
+                <a:spcPts val="600"/>
+              </a:spcAft>
+            </a:pPr>
+            <a:r>
+              <a:rPr sz="1600" b="0" i="0">
+                <a:solidFill>
+                  <a:srgbClr val="333333"/>
+                </a:solidFill>
+                <a:latin typeface="Calibri"/>
+              </a:rPr>
+              <a:t>–  Supervision active → pas de métriques internes (CPU/RAM) sans SNMP</a:t>
+            </a:r>
+          </a:p>
+          <a:p>
+            <a:pPr lvl="1">
+              <a:spcAft>
+                <a:spcPts val="600"/>
+              </a:spcAft>
+            </a:pPr>
+            <a:r>
+              <a:rPr sz="1600" b="0" i="0">
+                <a:solidFill>
+                  <a:srgbClr val="333333"/>
+                </a:solidFill>
+                <a:latin typeface="Calibri"/>
+              </a:rPr>
+              <a:t>–  Réactivité bornée par l'intervalle de cycle (2 min)</a:t>
+            </a:r>
+          </a:p>
+          <a:p>
+            <a:pPr lvl="1">
+              <a:spcAft>
+                <a:spcPts val="600"/>
+              </a:spcAft>
+            </a:pPr>
+            <a:r>
+              <a:rPr sz="1600" b="0" i="0">
+                <a:solidFill>
+                  <a:srgbClr val="333333"/>
+                </a:solidFill>
+                <a:latin typeface="Calibri"/>
+              </a:rPr>
+              <a:t>–  Alertes dépendantes de la connectivité sortante</a:t>
+            </a:r>
+          </a:p>
+          <a:p>
+            <a:pPr lvl="1">
+              <a:spcAft>
+                <a:spcPts val="600"/>
+              </a:spcAft>
+            </a:pPr>
+            <a:r>
+              <a:rPr sz="1600" b="0" i="0">
+                <a:solidFill>
+                  <a:srgbClr val="333333"/>
+                </a:solidFill>
+                <a:latin typeface="Calibri"/>
+              </a:rPr>
+              <a:t>–  « Qui surveille le surveillant ? » → besoin de redondance</a:t>
             </a:r>
           </a:p>
           <a:p>
             <a:pPr>
               <a:spcAft>
-                <a:spcPts val="1200"/>
+                <a:spcPts val="600"/>
               </a:spcAft>
             </a:pPr>
             <a:r>
-              <a:rPr sz="2000" b="0" i="0">
+              <a:rPr sz="1800" b="0" i="0">
                 <a:solidFill>
                   <a:srgbClr val="333333"/>
                 </a:solidFill>
                 <a:latin typeface="Calibri"/>
               </a:rPr>
-              <a:t>•  1.  Contexte et identification du problème</a:t>
+              <a:t/>
             </a:r>
           </a:p>
           <a:p>
             <a:pPr>
               <a:spcAft>
-                <a:spcPts val="1200"/>
+                <a:spcPts val="600"/>
               </a:spcAft>
             </a:pPr>
             <a:r>
-              <a:rPr sz="2000" b="0" i="0">
-                <a:solidFill>
-                  <a:srgbClr val="333333"/>
-                </a:solidFill>
-                <a:latin typeface="Calibri"/>
-              </a:rPr>
-              <a:t>•  2.  Objectifs et résultats attendus</a:t>
-            </a:r>
-          </a:p>
-          <a:p>
-            <a:pPr>
+              <a:rPr sz="1800" b="1" i="0">
+                <a:solidFill>
+                  <a:srgbClr val="198754"/>
+                </a:solidFill>
+                <a:latin typeface="Calibri"/>
+              </a:rPr>
+              <a:t>•  Perspectives :</a:t>
+            </a:r>
+          </a:p>
+          <a:p>
+            <a:pPr lvl="1">
               <a:spcAft>
-                <a:spcPts val="1200"/>
+                <a:spcPts val="600"/>
               </a:spcAft>
             </a:pPr>
             <a:r>
-              <a:rPr sz="2000" b="0" i="0">
+              <a:rPr sz="1600" b="0" i="0">
                 <a:solidFill>
                   <a:srgbClr val="333333"/>
                 </a:solidFill>
                 <a:latin typeface="Calibri"/>
               </a:rPr>
-              <a:t>•  3.  Démarche méthodologique</a:t>
-            </a:r>
-          </a:p>
-          <a:p>
-            <a:pPr>
+              <a:t>–  Intégration SNMP (performances détaillées)</a:t>
+            </a:r>
+          </a:p>
+          <a:p>
+            <a:pPr lvl="1">
               <a:spcAft>
-                <a:spcPts val="1200"/>
+                <a:spcPts val="600"/>
               </a:spcAft>
             </a:pPr>
             <a:r>
-              <a:rPr sz="2000" b="0" i="0">
+              <a:rPr sz="1600" b="0" i="0">
                 <a:solidFill>
                   <a:srgbClr val="333333"/>
                 </a:solidFill>
                 <a:latin typeface="Calibri"/>
               </a:rPr>
-              <a:t>•  4.  État des lieux &amp; solution proposée</a:t>
-            </a:r>
-          </a:p>
-          <a:p>
-            <a:pPr>
+              <a:t>–  Machine Learning : détection d'anomalies</a:t>
+            </a:r>
+          </a:p>
+          <a:p>
+            <a:pPr lvl="1">
               <a:spcAft>
-                <a:spcPts val="1200"/>
+                <a:spcPts val="600"/>
               </a:spcAft>
             </a:pPr>
             <a:r>
-              <a:rPr sz="2000" b="0" i="0">
+              <a:rPr sz="1600" b="0" i="0">
                 <a:solidFill>
                   <a:srgbClr val="333333"/>
                 </a:solidFill>
                 <a:latin typeface="Calibri"/>
               </a:rPr>
-              <a:t>•  5.  Axe de différenciation (innovation)</a:t>
-            </a:r>
-          </a:p>
-          <a:p>
-            <a:pPr>
+              <a:t>–  Maintenance prédictive (anticiper la panne) · Auto-remédiation (AIOps)</a:t>
+            </a:r>
+          </a:p>
+          <a:p>
+            <a:pPr lvl="1">
               <a:spcAft>
-                <a:spcPts val="1200"/>
+                <a:spcPts val="600"/>
               </a:spcAft>
             </a:pPr>
             <a:r>
-              <a:rPr sz="2000" b="0" i="0">
+              <a:rPr sz="1600" b="0" i="0">
                 <a:solidFill>
                   <a:srgbClr val="333333"/>
                 </a:solidFill>
                 <a:latin typeface="Calibri"/>
               </a:rPr>
-              <a:t>•  6.  Étude de faisabilité &amp; conception</a:t>
-            </a:r>
-          </a:p>
-        </p:txBody>
-      </p:sp>
-      <p:sp>
-        <p:nvSpPr>
-          <p:cNvPr id="5" name="TextBox 4"/>
-          <p:cNvSpPr txBox="1"/>
-          <p:nvPr/>
-        </p:nvSpPr>
-        <p:spPr>
-          <a:xfrm>
-            <a:off x="6309360" y="1463040"/>
-            <a:ext cx="5486400" cy="4937760"/>
-          </a:xfrm>
-          <a:prstGeom prst="rect">
-            <a:avLst/>
-          </a:prstGeom>
-          <a:noFill/>
-        </p:spPr>
-        <p:txBody>
-          <a:bodyPr wrap="square">
-            <a:spAutoFit/>
-          </a:bodyPr>
-          <a:lstStyle/>
-          <a:p>
-            <a:pPr>
-              <a:spcAft>
-                <a:spcPts val="1200"/>
-              </a:spcAft>
-            </a:pPr>
-            <a:r>
-              <a:rPr sz="2000" b="0" i="0">
-                <a:solidFill>
-                  <a:srgbClr val="333333"/>
-                </a:solidFill>
-                <a:latin typeface="Calibri"/>
-              </a:rPr>
-              <a:t>•  7.  Fonctionnement technique</a:t>
-            </a:r>
-          </a:p>
-          <a:p>
-            <a:pPr>
-              <a:spcAft>
-                <a:spcPts val="1200"/>
-              </a:spcAft>
-            </a:pPr>
-            <a:r>
-              <a:rPr sz="2000" b="1" i="0">
-                <a:solidFill>
-                  <a:srgbClr val="D62828"/>
-                </a:solidFill>
-                <a:latin typeface="Calibri"/>
-              </a:rPr>
-              <a:t>•  8.  Démonstration</a:t>
-            </a:r>
-          </a:p>
-          <a:p>
-            <a:pPr>
-              <a:spcAft>
-                <a:spcPts val="1200"/>
-              </a:spcAft>
-            </a:pPr>
-            <a:r>
-              <a:rPr sz="2000" b="0" i="0">
-                <a:solidFill>
-                  <a:srgbClr val="333333"/>
-                </a:solidFill>
-                <a:latin typeface="Calibri"/>
-              </a:rPr>
-              <a:t>•  9.  Marketing, vente &amp; concurrence</a:t>
-            </a:r>
-          </a:p>
-          <a:p>
-            <a:pPr>
-              <a:spcAft>
-                <a:spcPts val="1200"/>
-              </a:spcAft>
-            </a:pPr>
-            <a:r>
-              <a:rPr sz="2000" b="0" i="0">
-                <a:solidFill>
-                  <a:srgbClr val="333333"/>
-                </a:solidFill>
-                <a:latin typeface="Calibri"/>
-              </a:rPr>
-              <a:t>•  10. Prévisions financières</a:t>
-            </a:r>
-          </a:p>
-          <a:p>
-            <a:pPr>
-              <a:spcAft>
-                <a:spcPts val="1200"/>
-              </a:spcAft>
-            </a:pPr>
-            <a:r>
-              <a:rPr sz="2000" b="0" i="0">
-                <a:solidFill>
-                  <a:srgbClr val="333333"/>
-                </a:solidFill>
-                <a:latin typeface="Calibri"/>
-              </a:rPr>
-              <a:t>•  11. Limites &amp; perspectives</a:t>
-            </a:r>
-          </a:p>
-          <a:p>
-            <a:pPr>
-              <a:spcAft>
-                <a:spcPts val="1200"/>
-              </a:spcAft>
-            </a:pPr>
-            <a:r>
-              <a:rPr sz="2000" b="0" i="0">
-                <a:solidFill>
-                  <a:srgbClr val="333333"/>
-                </a:solidFill>
-                <a:latin typeface="Calibri"/>
-              </a:rPr>
-              <a:t/>
-            </a:r>
-          </a:p>
-          <a:p>
-            <a:pPr>
-              <a:spcAft>
-                <a:spcPts val="1200"/>
-              </a:spcAft>
-            </a:pPr>
-            <a:r>
-              <a:rPr sz="2000" b="1" i="0">
-                <a:solidFill>
-                  <a:srgbClr val="0D3B66"/>
-                </a:solidFill>
-                <a:latin typeface="Calibri"/>
-              </a:rPr>
-              <a:t>•  Conclusion</a:t>
+              <a:t>–  Conteneurisation (Docker/K8s) · Canaux SMS, Slack, Teams</a:t>
             </a:r>
           </a:p>
         </p:txBody>
@@ -10949,7 +11749,7 @@
 </p:sld>
 </file>
 
-<file path=ppt/slides/slide20.xml><?xml version="1.0" encoding="utf-8"?>
+<file path=ppt/slides/slide22.xml><?xml version="1.0" encoding="utf-8"?>
 <p:sld xmlns:a="http://schemas.openxmlformats.org/drawingml/2006/main" xmlns:p="http://schemas.openxmlformats.org/presentationml/2006/main" xmlns:r="http://schemas.openxmlformats.org/officeDocument/2006/relationships">
   <p:cSld>
     <p:bg>
@@ -11013,362 +11813,6 @@
       </p:sp>
       <p:sp>
         <p:nvSpPr>
-          <p:cNvPr id="3" name="Oval 2"/>
-          <p:cNvSpPr/>
-          <p:nvPr/>
-        </p:nvSpPr>
-        <p:spPr>
-          <a:xfrm>
-            <a:off x="320040" y="201168"/>
-            <a:ext cx="658368" cy="658368"/>
-          </a:xfrm>
-          <a:prstGeom prst="ellipse">
-            <a:avLst/>
-          </a:prstGeom>
-          <a:solidFill>
-            <a:srgbClr val="0D6EFD"/>
-          </a:solidFill>
-          <a:ln>
-            <a:noFill/>
-          </a:ln>
-          <a:effectLst/>
-        </p:spPr>
-        <p:style>
-          <a:lnRef idx="1">
-            <a:schemeClr val="accent1"/>
-          </a:lnRef>
-          <a:fillRef idx="3">
-            <a:schemeClr val="accent1"/>
-          </a:fillRef>
-          <a:effectRef idx="2">
-            <a:schemeClr val="accent1"/>
-          </a:effectRef>
-          <a:fontRef idx="minor">
-            <a:schemeClr val="lt1"/>
-          </a:fontRef>
-        </p:style>
-        <p:txBody>
-          <a:bodyPr rtlCol="0" anchor="ctr" wrap="none"/>
-          <a:lstStyle/>
-          <a:p>
-            <a:pPr algn="ctr"/>
-            <a:r>
-              <a:rPr sz="2600" b="1" i="0">
-                <a:solidFill>
-                  <a:srgbClr val="FFFFFF"/>
-                </a:solidFill>
-                <a:latin typeface="Calibri"/>
-              </a:rPr>
-              <a:t>11</a:t>
-            </a:r>
-          </a:p>
-        </p:txBody>
-      </p:sp>
-      <p:sp>
-        <p:nvSpPr>
-          <p:cNvPr id="4" name="TextBox 3"/>
-          <p:cNvSpPr txBox="1"/>
-          <p:nvPr/>
-        </p:nvSpPr>
-        <p:spPr>
-          <a:xfrm>
-            <a:off x="1143000" y="164592"/>
-            <a:ext cx="10774375" cy="731520"/>
-          </a:xfrm>
-          <a:prstGeom prst="rect">
-            <a:avLst/>
-          </a:prstGeom>
-          <a:noFill/>
-        </p:spPr>
-        <p:txBody>
-          <a:bodyPr wrap="square" anchor="ctr">
-            <a:spAutoFit/>
-          </a:bodyPr>
-          <a:lstStyle/>
-          <a:p>
-            <a:r>
-              <a:rPr sz="3000" b="1" i="0">
-                <a:solidFill>
-                  <a:srgbClr val="FFFFFF"/>
-                </a:solidFill>
-                <a:latin typeface="Calibri"/>
-              </a:rPr>
-              <a:t>Limites du projet et perspectives</a:t>
-            </a:r>
-          </a:p>
-        </p:txBody>
-      </p:sp>
-      <p:sp>
-        <p:nvSpPr>
-          <p:cNvPr id="5" name="TextBox 4"/>
-          <p:cNvSpPr txBox="1"/>
-          <p:nvPr/>
-        </p:nvSpPr>
-        <p:spPr>
-          <a:xfrm>
-            <a:off x="640080" y="1280160"/>
-            <a:ext cx="10881360" cy="4937760"/>
-          </a:xfrm>
-          <a:prstGeom prst="rect">
-            <a:avLst/>
-          </a:prstGeom>
-          <a:noFill/>
-        </p:spPr>
-        <p:txBody>
-          <a:bodyPr wrap="square">
-            <a:spAutoFit/>
-          </a:bodyPr>
-          <a:lstStyle/>
-          <a:p>
-            <a:pPr>
-              <a:spcAft>
-                <a:spcPts val="600"/>
-              </a:spcAft>
-            </a:pPr>
-            <a:r>
-              <a:rPr sz="1800" b="1" i="0">
-                <a:solidFill>
-                  <a:srgbClr val="D62828"/>
-                </a:solidFill>
-                <a:latin typeface="Calibri"/>
-              </a:rPr>
-              <a:t>•  Limites assumées :</a:t>
-            </a:r>
-          </a:p>
-          <a:p>
-            <a:pPr lvl="1">
-              <a:spcAft>
-                <a:spcPts val="600"/>
-              </a:spcAft>
-            </a:pPr>
-            <a:r>
-              <a:rPr sz="1600" b="0" i="0">
-                <a:solidFill>
-                  <a:srgbClr val="333333"/>
-                </a:solidFill>
-                <a:latin typeface="Calibri"/>
-              </a:rPr>
-              <a:t>–  Supervision active → pas de métriques internes (CPU/RAM) sans SNMP</a:t>
-            </a:r>
-          </a:p>
-          <a:p>
-            <a:pPr lvl="1">
-              <a:spcAft>
-                <a:spcPts val="600"/>
-              </a:spcAft>
-            </a:pPr>
-            <a:r>
-              <a:rPr sz="1600" b="0" i="0">
-                <a:solidFill>
-                  <a:srgbClr val="333333"/>
-                </a:solidFill>
-                <a:latin typeface="Calibri"/>
-              </a:rPr>
-              <a:t>–  Réactivité bornée par l'intervalle de cycle (2 min)</a:t>
-            </a:r>
-          </a:p>
-          <a:p>
-            <a:pPr lvl="1">
-              <a:spcAft>
-                <a:spcPts val="600"/>
-              </a:spcAft>
-            </a:pPr>
-            <a:r>
-              <a:rPr sz="1600" b="0" i="0">
-                <a:solidFill>
-                  <a:srgbClr val="333333"/>
-                </a:solidFill>
-                <a:latin typeface="Calibri"/>
-              </a:rPr>
-              <a:t>–  Alertes dépendantes de la connectivité sortante</a:t>
-            </a:r>
-          </a:p>
-          <a:p>
-            <a:pPr lvl="1">
-              <a:spcAft>
-                <a:spcPts val="600"/>
-              </a:spcAft>
-            </a:pPr>
-            <a:r>
-              <a:rPr sz="1600" b="0" i="0">
-                <a:solidFill>
-                  <a:srgbClr val="333333"/>
-                </a:solidFill>
-                <a:latin typeface="Calibri"/>
-              </a:rPr>
-              <a:t>–  « Qui surveille le surveillant ? » → besoin de redondance</a:t>
-            </a:r>
-          </a:p>
-          <a:p>
-            <a:pPr>
-              <a:spcAft>
-                <a:spcPts val="600"/>
-              </a:spcAft>
-            </a:pPr>
-            <a:r>
-              <a:rPr sz="1800" b="0" i="0">
-                <a:solidFill>
-                  <a:srgbClr val="333333"/>
-                </a:solidFill>
-                <a:latin typeface="Calibri"/>
-              </a:rPr>
-              <a:t/>
-            </a:r>
-          </a:p>
-          <a:p>
-            <a:pPr>
-              <a:spcAft>
-                <a:spcPts val="600"/>
-              </a:spcAft>
-            </a:pPr>
-            <a:r>
-              <a:rPr sz="1800" b="1" i="0">
-                <a:solidFill>
-                  <a:srgbClr val="198754"/>
-                </a:solidFill>
-                <a:latin typeface="Calibri"/>
-              </a:rPr>
-              <a:t>•  Perspectives :</a:t>
-            </a:r>
-          </a:p>
-          <a:p>
-            <a:pPr lvl="1">
-              <a:spcAft>
-                <a:spcPts val="600"/>
-              </a:spcAft>
-            </a:pPr>
-            <a:r>
-              <a:rPr sz="1600" b="0" i="0">
-                <a:solidFill>
-                  <a:srgbClr val="333333"/>
-                </a:solidFill>
-                <a:latin typeface="Calibri"/>
-              </a:rPr>
-              <a:t>–  Intégration SNMP (performances détaillées)</a:t>
-            </a:r>
-          </a:p>
-          <a:p>
-            <a:pPr lvl="1">
-              <a:spcAft>
-                <a:spcPts val="600"/>
-              </a:spcAft>
-            </a:pPr>
-            <a:r>
-              <a:rPr sz="1600" b="0" i="0">
-                <a:solidFill>
-                  <a:srgbClr val="333333"/>
-                </a:solidFill>
-                <a:latin typeface="Calibri"/>
-              </a:rPr>
-              <a:t>–  Machine Learning : détection d'anomalies</a:t>
-            </a:r>
-          </a:p>
-          <a:p>
-            <a:pPr lvl="1">
-              <a:spcAft>
-                <a:spcPts val="600"/>
-              </a:spcAft>
-            </a:pPr>
-            <a:r>
-              <a:rPr sz="1600" b="0" i="0">
-                <a:solidFill>
-                  <a:srgbClr val="333333"/>
-                </a:solidFill>
-                <a:latin typeface="Calibri"/>
-              </a:rPr>
-              <a:t>–  Maintenance prédictive (anticiper la panne) · Auto-remédiation (AIOps)</a:t>
-            </a:r>
-          </a:p>
-          <a:p>
-            <a:pPr lvl="1">
-              <a:spcAft>
-                <a:spcPts val="600"/>
-              </a:spcAft>
-            </a:pPr>
-            <a:r>
-              <a:rPr sz="1600" b="0" i="0">
-                <a:solidFill>
-                  <a:srgbClr val="333333"/>
-                </a:solidFill>
-                <a:latin typeface="Calibri"/>
-              </a:rPr>
-              <a:t>–  Conteneurisation (Docker/K8s) · Canaux SMS, Slack, Teams</a:t>
-            </a:r>
-          </a:p>
-        </p:txBody>
-      </p:sp>
-    </p:spTree>
-  </p:cSld>
-  <p:clrMapOvr>
-    <a:masterClrMapping/>
-  </p:clrMapOvr>
-</p:sld>
-</file>
-
-<file path=ppt/slides/slide21.xml><?xml version="1.0" encoding="utf-8"?>
-<p:sld xmlns:a="http://schemas.openxmlformats.org/drawingml/2006/main" xmlns:p="http://schemas.openxmlformats.org/presentationml/2006/main" xmlns:r="http://schemas.openxmlformats.org/officeDocument/2006/relationships">
-  <p:cSld>
-    <p:bg>
-      <p:bgPr>
-        <a:solidFill>
-          <a:srgbClr val="FFFFFF"/>
-        </a:solidFill>
-        <a:effectLst/>
-      </p:bgPr>
-    </p:bg>
-    <p:spTree>
-      <p:nvGrpSpPr>
-        <p:cNvPr id="1" name=""/>
-        <p:cNvGrpSpPr/>
-        <p:nvPr/>
-      </p:nvGrpSpPr>
-      <p:grpSpPr/>
-      <p:sp>
-        <p:nvSpPr>
-          <p:cNvPr id="2" name="Rectangle 1"/>
-          <p:cNvSpPr/>
-          <p:nvPr/>
-        </p:nvSpPr>
-        <p:spPr>
-          <a:xfrm>
-            <a:off x="0" y="0"/>
-            <a:ext cx="12191695" cy="1051560"/>
-          </a:xfrm>
-          <a:prstGeom prst="rect">
-            <a:avLst/>
-          </a:prstGeom>
-          <a:solidFill>
-            <a:srgbClr val="0D3B66"/>
-          </a:solidFill>
-          <a:ln>
-            <a:noFill/>
-          </a:ln>
-          <a:effectLst/>
-        </p:spPr>
-        <p:style>
-          <a:lnRef idx="1">
-            <a:schemeClr val="accent1"/>
-          </a:lnRef>
-          <a:fillRef idx="3">
-            <a:schemeClr val="accent1"/>
-          </a:fillRef>
-          <a:effectRef idx="2">
-            <a:schemeClr val="accent1"/>
-          </a:effectRef>
-          <a:fontRef idx="minor">
-            <a:schemeClr val="lt1"/>
-          </a:fontRef>
-        </p:style>
-        <p:txBody>
-          <a:bodyPr rtlCol="0" anchor="ctr"/>
-          <a:lstStyle/>
-          <a:p>
-            <a:pPr algn="ctr"/>
-          </a:p>
-        </p:txBody>
-      </p:sp>
-      <p:sp>
-        <p:nvSpPr>
           <p:cNvPr id="3" name="TextBox 2"/>
           <p:cNvSpPr txBox="1"/>
           <p:nvPr/>
@@ -11593,7 +12037,7 @@
 </p:sld>
 </file>
 
-<file path=ppt/slides/slide22.xml><?xml version="1.0" encoding="utf-8"?>
+<file path=ppt/slides/slide23.xml><?xml version="1.0" encoding="utf-8"?>
 <p:sld xmlns:a="http://schemas.openxmlformats.org/drawingml/2006/main" xmlns:p="http://schemas.openxmlformats.org/presentationml/2006/main" xmlns:r="http://schemas.openxmlformats.org/officeDocument/2006/relationships">
   <p:cSld>
     <p:bg>
@@ -12079,6 +12523,326 @@
       </p:sp>
       <p:sp>
         <p:nvSpPr>
+          <p:cNvPr id="3" name="TextBox 2"/>
+          <p:cNvSpPr txBox="1"/>
+          <p:nvPr/>
+        </p:nvSpPr>
+        <p:spPr>
+          <a:xfrm>
+            <a:off x="457200" y="164592"/>
+            <a:ext cx="11460175" cy="731520"/>
+          </a:xfrm>
+          <a:prstGeom prst="rect">
+            <a:avLst/>
+          </a:prstGeom>
+          <a:noFill/>
+        </p:spPr>
+        <p:txBody>
+          <a:bodyPr wrap="square" anchor="ctr">
+            <a:spAutoFit/>
+          </a:bodyPr>
+          <a:lstStyle/>
+          <a:p>
+            <a:r>
+              <a:rPr sz="3000" b="1" i="0">
+                <a:solidFill>
+                  <a:srgbClr val="FFFFFF"/>
+                </a:solidFill>
+                <a:latin typeface="Calibri"/>
+              </a:rPr>
+              <a:t>Structure d'accueil — OPEN MOISE</a:t>
+            </a:r>
+          </a:p>
+        </p:txBody>
+      </p:sp>
+      <p:sp>
+        <p:nvSpPr>
+          <p:cNvPr id="4" name="TextBox 3"/>
+          <p:cNvSpPr txBox="1"/>
+          <p:nvPr/>
+        </p:nvSpPr>
+        <p:spPr>
+          <a:xfrm>
+            <a:off x="640080" y="1371600"/>
+            <a:ext cx="10881360" cy="3291840"/>
+          </a:xfrm>
+          <a:prstGeom prst="rect">
+            <a:avLst/>
+          </a:prstGeom>
+          <a:noFill/>
+        </p:spPr>
+        <p:txBody>
+          <a:bodyPr wrap="square">
+            <a:spAutoFit/>
+          </a:bodyPr>
+          <a:lstStyle/>
+          <a:p>
+            <a:pPr>
+              <a:spcAft>
+                <a:spcPts val="800"/>
+              </a:spcAft>
+            </a:pPr>
+            <a:r>
+              <a:rPr sz="2000" b="1" i="0">
+                <a:solidFill>
+                  <a:srgbClr val="0D3B66"/>
+                </a:solidFill>
+                <a:latin typeface="Calibri"/>
+              </a:rPr>
+              <a:t>•  OPEN MOISE — Entreprise de Services du Numérique (ESN)</a:t>
+            </a:r>
+          </a:p>
+          <a:p>
+            <a:pPr>
+              <a:spcAft>
+                <a:spcPts val="800"/>
+              </a:spcAft>
+            </a:pPr>
+            <a:r>
+              <a:rPr sz="2000" b="0" i="0">
+                <a:solidFill>
+                  <a:srgbClr val="333333"/>
+                </a:solidFill>
+                <a:latin typeface="Calibri"/>
+              </a:rPr>
+              <a:t/>
+            </a:r>
+          </a:p>
+          <a:p>
+            <a:pPr lvl="1">
+              <a:spcAft>
+                <a:spcPts val="800"/>
+              </a:spcAft>
+            </a:pPr>
+            <a:r>
+              <a:rPr sz="1800" b="0" i="0">
+                <a:solidFill>
+                  <a:srgbClr val="333333"/>
+                </a:solidFill>
+                <a:latin typeface="Calibri"/>
+              </a:rPr>
+              <a:t>–  Activités : infogérance, intégration réseau &amp; systèmes, développement, cybersécurité</a:t>
+            </a:r>
+          </a:p>
+          <a:p>
+            <a:pPr lvl="1">
+              <a:spcAft>
+                <a:spcPts val="800"/>
+              </a:spcAft>
+            </a:pPr>
+            <a:r>
+              <a:rPr sz="1800" b="0" i="0">
+                <a:solidFill>
+                  <a:srgbClr val="333333"/>
+                </a:solidFill>
+                <a:latin typeface="Calibri"/>
+              </a:rPr>
+              <a:t>–  Mission : garantir un SI performant, disponible et sécurisé à ses clients</a:t>
+            </a:r>
+          </a:p>
+          <a:p>
+            <a:pPr lvl="1">
+              <a:spcAft>
+                <a:spcPts val="800"/>
+              </a:spcAft>
+            </a:pPr>
+            <a:r>
+              <a:rPr sz="1800" b="0" i="0">
+                <a:solidFill>
+                  <a:srgbClr val="333333"/>
+                </a:solidFill>
+                <a:latin typeface="Calibri"/>
+              </a:rPr>
+              <a:t>–  [Effectif] collaborateurs · implantée à [ville] · depuis [année]</a:t>
+            </a:r>
+          </a:p>
+          <a:p>
+            <a:pPr lvl="1">
+              <a:spcAft>
+                <a:spcPts val="800"/>
+              </a:spcAft>
+            </a:pPr>
+            <a:r>
+              <a:rPr sz="1800" b="0" i="0">
+                <a:solidFill>
+                  <a:srgbClr val="333333"/>
+                </a:solidFill>
+                <a:latin typeface="Calibri"/>
+              </a:rPr>
+              <a:t>–  Projet mené au sein du [Pôle Infrastructures &amp; Supervision]</a:t>
+            </a:r>
+          </a:p>
+        </p:txBody>
+      </p:sp>
+      <p:sp>
+        <p:nvSpPr>
+          <p:cNvPr id="5" name="Rectangle 4"/>
+          <p:cNvSpPr/>
+          <p:nvPr/>
+        </p:nvSpPr>
+        <p:spPr>
+          <a:xfrm>
+            <a:off x="640080" y="5029200"/>
+            <a:ext cx="109728" cy="1188720"/>
+          </a:xfrm>
+          <a:prstGeom prst="rect">
+            <a:avLst/>
+          </a:prstGeom>
+          <a:solidFill>
+            <a:srgbClr val="0D6EFD"/>
+          </a:solidFill>
+          <a:ln>
+            <a:noFill/>
+          </a:ln>
+          <a:effectLst/>
+        </p:spPr>
+        <p:style>
+          <a:lnRef idx="1">
+            <a:schemeClr val="accent1"/>
+          </a:lnRef>
+          <a:fillRef idx="3">
+            <a:schemeClr val="accent1"/>
+          </a:fillRef>
+          <a:effectRef idx="2">
+            <a:schemeClr val="accent1"/>
+          </a:effectRef>
+          <a:fontRef idx="minor">
+            <a:schemeClr val="lt1"/>
+          </a:fontRef>
+        </p:style>
+        <p:txBody>
+          <a:bodyPr rtlCol="0" anchor="ctr"/>
+          <a:lstStyle/>
+          <a:p>
+            <a:pPr algn="ctr"/>
+          </a:p>
+        </p:txBody>
+      </p:sp>
+      <p:sp>
+        <p:nvSpPr>
+          <p:cNvPr id="6" name="Rectangle 5"/>
+          <p:cNvSpPr/>
+          <p:nvPr/>
+        </p:nvSpPr>
+        <p:spPr>
+          <a:xfrm>
+            <a:off x="749808" y="5029200"/>
+            <a:ext cx="10771632" cy="1188720"/>
+          </a:xfrm>
+          <a:prstGeom prst="rect">
+            <a:avLst/>
+          </a:prstGeom>
+          <a:solidFill>
+            <a:srgbClr val="F1F3F5"/>
+          </a:solidFill>
+          <a:ln>
+            <a:noFill/>
+          </a:ln>
+          <a:effectLst/>
+        </p:spPr>
+        <p:style>
+          <a:lnRef idx="1">
+            <a:schemeClr val="accent1"/>
+          </a:lnRef>
+          <a:fillRef idx="3">
+            <a:schemeClr val="accent1"/>
+          </a:fillRef>
+          <a:effectRef idx="2">
+            <a:schemeClr val="accent1"/>
+          </a:effectRef>
+          <a:fontRef idx="minor">
+            <a:schemeClr val="lt1"/>
+          </a:fontRef>
+        </p:style>
+        <p:txBody>
+          <a:bodyPr rtlCol="0" anchor="ctr" wrap="square" lIns="182880"/>
+          <a:lstStyle/>
+          <a:p>
+            <a:pPr algn="ctr"/>
+            <a:r>
+              <a:rPr sz="1700" b="1" i="1">
+                <a:solidFill>
+                  <a:srgbClr val="0D3B66"/>
+                </a:solidFill>
+                <a:latin typeface="Calibri"/>
+              </a:rPr>
+              <a:t>ESN qui supervise les réseaux de ses clients, OPEN MOISE est directement concernée : ce projet est un outil interne stratégique pour tenir ses engagements de service (SLA) et maîtriser ses coûts.</a:t>
+            </a:r>
+          </a:p>
+        </p:txBody>
+      </p:sp>
+    </p:spTree>
+  </p:cSld>
+  <p:clrMapOvr>
+    <a:masterClrMapping/>
+  </p:clrMapOvr>
+</p:sld>
+</file>
+
+<file path=ppt/slides/slide5.xml><?xml version="1.0" encoding="utf-8"?>
+<p:sld xmlns:a="http://schemas.openxmlformats.org/drawingml/2006/main" xmlns:p="http://schemas.openxmlformats.org/presentationml/2006/main" xmlns:r="http://schemas.openxmlformats.org/officeDocument/2006/relationships">
+  <p:cSld>
+    <p:bg>
+      <p:bgPr>
+        <a:solidFill>
+          <a:srgbClr val="FFFFFF"/>
+        </a:solidFill>
+        <a:effectLst/>
+      </p:bgPr>
+    </p:bg>
+    <p:spTree>
+      <p:nvGrpSpPr>
+        <p:cNvPr id="1" name=""/>
+        <p:cNvGrpSpPr/>
+        <p:nvPr/>
+      </p:nvGrpSpPr>
+      <p:grpSpPr/>
+      <p:sp>
+        <p:nvSpPr>
+          <p:cNvPr id="2" name="Rectangle 1"/>
+          <p:cNvSpPr/>
+          <p:nvPr/>
+        </p:nvSpPr>
+        <p:spPr>
+          <a:xfrm>
+            <a:off x="0" y="0"/>
+            <a:ext cx="12191695" cy="1051560"/>
+          </a:xfrm>
+          <a:prstGeom prst="rect">
+            <a:avLst/>
+          </a:prstGeom>
+          <a:solidFill>
+            <a:srgbClr val="0D3B66"/>
+          </a:solidFill>
+          <a:ln>
+            <a:noFill/>
+          </a:ln>
+          <a:effectLst/>
+        </p:spPr>
+        <p:style>
+          <a:lnRef idx="1">
+            <a:schemeClr val="accent1"/>
+          </a:lnRef>
+          <a:fillRef idx="3">
+            <a:schemeClr val="accent1"/>
+          </a:fillRef>
+          <a:effectRef idx="2">
+            <a:schemeClr val="accent1"/>
+          </a:effectRef>
+          <a:fontRef idx="minor">
+            <a:schemeClr val="lt1"/>
+          </a:fontRef>
+        </p:style>
+        <p:txBody>
+          <a:bodyPr rtlCol="0" anchor="ctr"/>
+          <a:lstStyle/>
+          <a:p>
+            <a:pPr algn="ctr"/>
+          </a:p>
+        </p:txBody>
+      </p:sp>
+      <p:sp>
+        <p:nvSpPr>
           <p:cNvPr id="3" name="Oval 2"/>
           <p:cNvSpPr/>
           <p:nvPr/>
@@ -12307,7 +13071,7 @@
 </p:sld>
 </file>
 
-<file path=ppt/slides/slide5.xml><?xml version="1.0" encoding="utf-8"?>
+<file path=ppt/slides/slide6.xml><?xml version="1.0" encoding="utf-8"?>
 <p:sld xmlns:a="http://schemas.openxmlformats.org/drawingml/2006/main" xmlns:p="http://schemas.openxmlformats.org/presentationml/2006/main" xmlns:r="http://schemas.openxmlformats.org/officeDocument/2006/relationships">
   <p:cSld>
     <p:bg>
@@ -12508,7 +13272,7 @@
 </p:sld>
 </file>
 
-<file path=ppt/slides/slide6.xml><?xml version="1.0" encoding="utf-8"?>
+<file path=ppt/slides/slide7.xml><?xml version="1.0" encoding="utf-8"?>
 <p:sld xmlns:a="http://schemas.openxmlformats.org/drawingml/2006/main" xmlns:p="http://schemas.openxmlformats.org/presentationml/2006/main" xmlns:r="http://schemas.openxmlformats.org/officeDocument/2006/relationships">
   <p:cSld>
     <p:bg>
@@ -13124,7 +13888,7 @@
 </p:sld>
 </file>
 
-<file path=ppt/slides/slide7.xml><?xml version="1.0" encoding="utf-8"?>
+<file path=ppt/slides/slide8.xml><?xml version="1.0" encoding="utf-8"?>
 <p:sld xmlns:a="http://schemas.openxmlformats.org/drawingml/2006/main" xmlns:p="http://schemas.openxmlformats.org/presentationml/2006/main" xmlns:r="http://schemas.openxmlformats.org/officeDocument/2006/relationships">
   <p:cSld>
     <p:bg>
@@ -13444,7 +14208,7 @@
 </p:sld>
 </file>
 
-<file path=ppt/slides/slide8.xml><?xml version="1.0" encoding="utf-8"?>
+<file path=ppt/slides/slide9.xml><?xml version="1.0" encoding="utf-8"?>
 <p:sld xmlns:a="http://schemas.openxmlformats.org/drawingml/2006/main" xmlns:p="http://schemas.openxmlformats.org/presentationml/2006/main" xmlns:r="http://schemas.openxmlformats.org/officeDocument/2006/relationships">
   <p:cSld>
     <p:bg>
@@ -14278,379 +15042,6 @@
                 <a:latin typeface="Calibri"/>
               </a:rPr>
               <a:t>Le vide identifié : rien de léger + gratuit + simple + sur mesure, avec notification mobile native, pour les petites structures.</a:t>
-            </a:r>
-          </a:p>
-        </p:txBody>
-      </p:sp>
-    </p:spTree>
-  </p:cSld>
-  <p:clrMapOvr>
-    <a:masterClrMapping/>
-  </p:clrMapOvr>
-</p:sld>
-</file>
-
-<file path=ppt/slides/slide9.xml><?xml version="1.0" encoding="utf-8"?>
-<p:sld xmlns:a="http://schemas.openxmlformats.org/drawingml/2006/main" xmlns:p="http://schemas.openxmlformats.org/presentationml/2006/main" xmlns:r="http://schemas.openxmlformats.org/officeDocument/2006/relationships">
-  <p:cSld>
-    <p:bg>
-      <p:bgPr>
-        <a:solidFill>
-          <a:srgbClr val="FFFFFF"/>
-        </a:solidFill>
-        <a:effectLst/>
-      </p:bgPr>
-    </p:bg>
-    <p:spTree>
-      <p:nvGrpSpPr>
-        <p:cNvPr id="1" name=""/>
-        <p:cNvGrpSpPr/>
-        <p:nvPr/>
-      </p:nvGrpSpPr>
-      <p:grpSpPr/>
-      <p:sp>
-        <p:nvSpPr>
-          <p:cNvPr id="2" name="Rectangle 1"/>
-          <p:cNvSpPr/>
-          <p:nvPr/>
-        </p:nvSpPr>
-        <p:spPr>
-          <a:xfrm>
-            <a:off x="0" y="0"/>
-            <a:ext cx="12191695" cy="1051560"/>
-          </a:xfrm>
-          <a:prstGeom prst="rect">
-            <a:avLst/>
-          </a:prstGeom>
-          <a:solidFill>
-            <a:srgbClr val="0D3B66"/>
-          </a:solidFill>
-          <a:ln>
-            <a:noFill/>
-          </a:ln>
-          <a:effectLst/>
-        </p:spPr>
-        <p:style>
-          <a:lnRef idx="1">
-            <a:schemeClr val="accent1"/>
-          </a:lnRef>
-          <a:fillRef idx="3">
-            <a:schemeClr val="accent1"/>
-          </a:fillRef>
-          <a:effectRef idx="2">
-            <a:schemeClr val="accent1"/>
-          </a:effectRef>
-          <a:fontRef idx="minor">
-            <a:schemeClr val="lt1"/>
-          </a:fontRef>
-        </p:style>
-        <p:txBody>
-          <a:bodyPr rtlCol="0" anchor="ctr"/>
-          <a:lstStyle/>
-          <a:p>
-            <a:pPr algn="ctr"/>
-          </a:p>
-        </p:txBody>
-      </p:sp>
-      <p:sp>
-        <p:nvSpPr>
-          <p:cNvPr id="3" name="Oval 2"/>
-          <p:cNvSpPr/>
-          <p:nvPr/>
-        </p:nvSpPr>
-        <p:spPr>
-          <a:xfrm>
-            <a:off x="320040" y="201168"/>
-            <a:ext cx="658368" cy="658368"/>
-          </a:xfrm>
-          <a:prstGeom prst="ellipse">
-            <a:avLst/>
-          </a:prstGeom>
-          <a:solidFill>
-            <a:srgbClr val="0D6EFD"/>
-          </a:solidFill>
-          <a:ln>
-            <a:noFill/>
-          </a:ln>
-          <a:effectLst/>
-        </p:spPr>
-        <p:style>
-          <a:lnRef idx="1">
-            <a:schemeClr val="accent1"/>
-          </a:lnRef>
-          <a:fillRef idx="3">
-            <a:schemeClr val="accent1"/>
-          </a:fillRef>
-          <a:effectRef idx="2">
-            <a:schemeClr val="accent1"/>
-          </a:effectRef>
-          <a:fontRef idx="minor">
-            <a:schemeClr val="lt1"/>
-          </a:fontRef>
-        </p:style>
-        <p:txBody>
-          <a:bodyPr rtlCol="0" anchor="ctr" wrap="none"/>
-          <a:lstStyle/>
-          <a:p>
-            <a:pPr algn="ctr"/>
-            <a:r>
-              <a:rPr sz="2600" b="1" i="0">
-                <a:solidFill>
-                  <a:srgbClr val="FFFFFF"/>
-                </a:solidFill>
-                <a:latin typeface="Calibri"/>
-              </a:rPr>
-              <a:t>4</a:t>
-            </a:r>
-          </a:p>
-        </p:txBody>
-      </p:sp>
-      <p:sp>
-        <p:nvSpPr>
-          <p:cNvPr id="4" name="TextBox 3"/>
-          <p:cNvSpPr txBox="1"/>
-          <p:nvPr/>
-        </p:nvSpPr>
-        <p:spPr>
-          <a:xfrm>
-            <a:off x="1143000" y="164592"/>
-            <a:ext cx="10774375" cy="731520"/>
-          </a:xfrm>
-          <a:prstGeom prst="rect">
-            <a:avLst/>
-          </a:prstGeom>
-          <a:noFill/>
-        </p:spPr>
-        <p:txBody>
-          <a:bodyPr wrap="square" anchor="ctr">
-            <a:spAutoFit/>
-          </a:bodyPr>
-          <a:lstStyle/>
-          <a:p>
-            <a:r>
-              <a:rPr sz="3000" b="1" i="0">
-                <a:solidFill>
-                  <a:srgbClr val="FFFFFF"/>
-                </a:solidFill>
-                <a:latin typeface="Calibri"/>
-              </a:rPr>
-              <a:t>Solution proposée</a:t>
-            </a:r>
-          </a:p>
-        </p:txBody>
-      </p:sp>
-      <p:sp>
-        <p:nvSpPr>
-          <p:cNvPr id="5" name="TextBox 4"/>
-          <p:cNvSpPr txBox="1"/>
-          <p:nvPr/>
-        </p:nvSpPr>
-        <p:spPr>
-          <a:xfrm>
-            <a:off x="640080" y="1371600"/>
-            <a:ext cx="10881360" cy="3291840"/>
-          </a:xfrm>
-          <a:prstGeom prst="rect">
-            <a:avLst/>
-          </a:prstGeom>
-          <a:noFill/>
-        </p:spPr>
-        <p:txBody>
-          <a:bodyPr wrap="square">
-            <a:spAutoFit/>
-          </a:bodyPr>
-          <a:lstStyle/>
-          <a:p>
-            <a:pPr>
-              <a:spcAft>
-                <a:spcPts val="800"/>
-              </a:spcAft>
-            </a:pPr>
-            <a:r>
-              <a:rPr sz="2000" b="1" i="0">
-                <a:solidFill>
-                  <a:srgbClr val="0D3B66"/>
-                </a:solidFill>
-                <a:latin typeface="Calibri"/>
-              </a:rPr>
-              <a:t>•  Un système automatisé, modulaire et 100 % open-source qui :</a:t>
-            </a:r>
-          </a:p>
-          <a:p>
-            <a:pPr lvl="1">
-              <a:spcAft>
-                <a:spcPts val="800"/>
-              </a:spcAft>
-            </a:pPr>
-            <a:r>
-              <a:rPr sz="1800" b="0" i="0">
-                <a:solidFill>
-                  <a:srgbClr val="333333"/>
-                </a:solidFill>
-                <a:latin typeface="Calibri"/>
-              </a:rPr>
-              <a:t>–  découvre automatiquement les équipements du réseau</a:t>
-            </a:r>
-          </a:p>
-          <a:p>
-            <a:pPr lvl="1">
-              <a:spcAft>
-                <a:spcPts val="800"/>
-              </a:spcAft>
-            </a:pPr>
-            <a:r>
-              <a:rPr sz="1800" b="0" i="0">
-                <a:solidFill>
-                  <a:srgbClr val="333333"/>
-                </a:solidFill>
-                <a:latin typeface="Calibri"/>
-              </a:rPr>
-              <a:t>–  sonde en continu la disponibilité (ICMP) et les services (TCP)</a:t>
-            </a:r>
-          </a:p>
-          <a:p>
-            <a:pPr lvl="1">
-              <a:spcAft>
-                <a:spcPts val="800"/>
-              </a:spcAft>
-            </a:pPr>
-            <a:r>
-              <a:rPr sz="1800" b="0" i="0">
-                <a:solidFill>
-                  <a:srgbClr val="333333"/>
-                </a:solidFill>
-                <a:latin typeface="Calibri"/>
-              </a:rPr>
-              <a:t>–  confirme la panne (anti-faux positif) et journalise tout</a:t>
-            </a:r>
-          </a:p>
-          <a:p>
-            <a:pPr lvl="1">
-              <a:spcAft>
-                <a:spcPts val="800"/>
-              </a:spcAft>
-            </a:pPr>
-            <a:r>
-              <a:rPr sz="1800" b="0" i="0">
-                <a:solidFill>
-                  <a:srgbClr val="333333"/>
-                </a:solidFill>
-                <a:latin typeface="Calibri"/>
-              </a:rPr>
-              <a:t>–  alerte en temps réel par e-mail ET Telegram (push mobile)</a:t>
-            </a:r>
-          </a:p>
-          <a:p>
-            <a:pPr lvl="1">
-              <a:spcAft>
-                <a:spcPts val="800"/>
-              </a:spcAft>
-            </a:pPr>
-            <a:r>
-              <a:rPr sz="1800" b="0" i="0">
-                <a:solidFill>
-                  <a:srgbClr val="333333"/>
-                </a:solidFill>
-                <a:latin typeface="Calibri"/>
-              </a:rPr>
-              <a:t>–  offre un tableau de bord web temps réel + rapports</a:t>
-            </a:r>
-          </a:p>
-        </p:txBody>
-      </p:sp>
-      <p:sp>
-        <p:nvSpPr>
-          <p:cNvPr id="6" name="Rectangle 5"/>
-          <p:cNvSpPr/>
-          <p:nvPr/>
-        </p:nvSpPr>
-        <p:spPr>
-          <a:xfrm>
-            <a:off x="640080" y="5120640"/>
-            <a:ext cx="109728" cy="914400"/>
-          </a:xfrm>
-          <a:prstGeom prst="rect">
-            <a:avLst/>
-          </a:prstGeom>
-          <a:solidFill>
-            <a:srgbClr val="0D6EFD"/>
-          </a:solidFill>
-          <a:ln>
-            <a:noFill/>
-          </a:ln>
-          <a:effectLst/>
-        </p:spPr>
-        <p:style>
-          <a:lnRef idx="1">
-            <a:schemeClr val="accent1"/>
-          </a:lnRef>
-          <a:fillRef idx="3">
-            <a:schemeClr val="accent1"/>
-          </a:fillRef>
-          <a:effectRef idx="2">
-            <a:schemeClr val="accent1"/>
-          </a:effectRef>
-          <a:fontRef idx="minor">
-            <a:schemeClr val="lt1"/>
-          </a:fontRef>
-        </p:style>
-        <p:txBody>
-          <a:bodyPr rtlCol="0" anchor="ctr"/>
-          <a:lstStyle/>
-          <a:p>
-            <a:pPr algn="ctr"/>
-          </a:p>
-        </p:txBody>
-      </p:sp>
-      <p:sp>
-        <p:nvSpPr>
-          <p:cNvPr id="7" name="Rectangle 6"/>
-          <p:cNvSpPr/>
-          <p:nvPr/>
-        </p:nvSpPr>
-        <p:spPr>
-          <a:xfrm>
-            <a:off x="749808" y="5120640"/>
-            <a:ext cx="10771632" cy="914400"/>
-          </a:xfrm>
-          <a:prstGeom prst="rect">
-            <a:avLst/>
-          </a:prstGeom>
-          <a:solidFill>
-            <a:srgbClr val="0D3B66"/>
-          </a:solidFill>
-          <a:ln>
-            <a:noFill/>
-          </a:ln>
-          <a:effectLst/>
-        </p:spPr>
-        <p:style>
-          <a:lnRef idx="1">
-            <a:schemeClr val="accent1"/>
-          </a:lnRef>
-          <a:fillRef idx="3">
-            <a:schemeClr val="accent1"/>
-          </a:fillRef>
-          <a:effectRef idx="2">
-            <a:schemeClr val="accent1"/>
-          </a:effectRef>
-          <a:fontRef idx="minor">
-            <a:schemeClr val="lt1"/>
-          </a:fontRef>
-        </p:style>
-        <p:txBody>
-          <a:bodyPr rtlCol="0" anchor="ctr" wrap="square" lIns="182880"/>
-          <a:lstStyle/>
-          <a:p>
-            <a:pPr algn="ctr"/>
-            <a:r>
-              <a:rPr sz="1700" b="1" i="1">
-                <a:solidFill>
-                  <a:srgbClr val="0D3B66"/>
-                </a:solidFill>
-                <a:latin typeface="Calibri"/>
-              </a:rPr>
-              <a:t>Stack : Ubuntu · Python · Cron · MySQL · Flask · Bootstrap · Bot Telegram</a:t>
             </a:r>
           </a:p>
         </p:txBody>

</xml_diff>

<commit_message>
Génération des diagrammes d'architecture (UML, MERISE, 5 couches) en images
- 7 diagrammes UML rendus en PNG via PlantUML (contexte, cas d'utilisation,
  séquence, activité, classes, composants, déploiement) + ajout du .puml de
  contexte manquant
- MERISE : diagrammes MCD et MLD (.puml + PNG) — 5 tables
- Schéma d'architecture en 5 couches généré via matplotlib
  (architecture/generer_architecture_5couches.py)
- Présentation (.pptx) enrichie en section 6 : diapos image pour
  l'architecture 5 couches, la grille des 7 UML et le MCD→MLD, plus une
  section ANNEXES avec chaque diagramme en pleine page (34 diapositives)
- Images embarquées dans la doc Markdown (README architecture, mcd-mld.md,
  architecture-technique.md) et conservées au versionnage (.gitignore)
</commit_message>
<xml_diff>
--- a/soutenance/presentation-projet.pptx
+++ b/soutenance/presentation-projet.pptx
@@ -28,6 +28,17 @@
     <p:sldId id="276" r:id="rId28"/>
     <p:sldId id="277" r:id="rId29"/>
     <p:sldId id="278" r:id="rId30"/>
+    <p:sldId id="279" r:id="rId31"/>
+    <p:sldId id="280" r:id="rId32"/>
+    <p:sldId id="281" r:id="rId33"/>
+    <p:sldId id="282" r:id="rId34"/>
+    <p:sldId id="283" r:id="rId35"/>
+    <p:sldId id="284" r:id="rId36"/>
+    <p:sldId id="285" r:id="rId37"/>
+    <p:sldId id="286" r:id="rId38"/>
+    <p:sldId id="287" r:id="rId39"/>
+    <p:sldId id="288" r:id="rId40"/>
+    <p:sldId id="289" r:id="rId41"/>
   </p:sldIdLst>
   <p:sldSz cx="12191695" cy="6858000" type="screen4x3"/>
   <p:notesSz cx="6858000" cy="9144000"/>
@@ -804,7 +815,7 @@
           <a:lstStyle/>
           <a:p>
             <a:r>
-              <a:t>Voici l'architecture en cinq couches. Le choix d'ingénierie le plus important est le découplage entre la collecte et l'affichage : ils communiquent uniquement par la base, ce qui rend le système robuste.</a:t>
+              <a:t>Voici l'architecture en cinq couches. Le choix d'ingénierie le plus important est le découplage entre la collecte et l'affichage : ils communiquent uniquement par la base de données, ce qui rend le système robuste.</a:t>
             </a:r>
           </a:p>
         </p:txBody>
@@ -874,7 +885,7 @@
           <a:lstStyle/>
           <a:p>
             <a:r>
-              <a:t>Techniquement : toutes les deux minutes, Cron lance le moteur qui teste chaque équipement. Une panne n'est confirmée qu'après plusieurs échecs - pour éviter les fausses alertes - et une seule notification est envoyée par panne. Tout est parallélisé pour rester rapide.</a:t>
+              <a:t>J'ai formalisé toute la conception avec sept diagrammes UML, du diagramme de contexte au diagramme de déploiement. Les versions pleine page figurent en annexe pour le détail.</a:t>
             </a:r>
           </a:p>
         </p:txBody>
@@ -944,7 +955,7 @@
           <a:lstStyle/>
           <a:p>
             <a:r>
-              <a:t>La sécurité a été pensée dès la conception, pas ajoutée après : secrets hors du code, mots de passe hachés, requêtes paramétrées contre l'injection SQL, communications chiffrées et moindre privilège sur la base.</a:t>
+              <a:t>Pour la base de données, j'ai suivi la méthode MERISE : du modèle conceptuel - les entités et leurs associations - vers le modèle logique - les cinq tables relationnelles avec leurs clés - implémenté ensuite en MySQL.</a:t>
             </a:r>
           </a:p>
         </p:txBody>
@@ -1014,7 +1025,7 @@
           <a:lstStyle/>
           <a:p>
             <a:r>
-              <a:t>Pour la démonstration, je propose un scénario vivant : je montre le tableau de bord, j'éteins un équipement devant vous, et vous verrez l'alerte Telegram arriver sur mon téléphone en temps réel. Puis je le rallume pour montrer le rétablissement. J'ai un plan B en captures et vidéo.</a:t>
+              <a:t>Techniquement : toutes les deux minutes, Cron lance le moteur qui teste chaque équipement. Une panne n'est confirmée qu'après plusieurs échecs - pour éviter les fausses alertes - et une seule notification est envoyée par panne. Tout est parallélisé pour rester rapide.</a:t>
             </a:r>
           </a:p>
         </p:txBody>
@@ -1084,7 +1095,7 @@
           <a:lstStyle/>
           <a:p>
             <a:r>
-              <a:t>Ces captures matérialisent chaque fonctionnalité clé. La plus parlante est la notification Telegram reçue sur le téléphone : la preuve concrète de la valeur ajoutée pour l'administrateur.</a:t>
+              <a:t>La sécurité a été pensée dès la conception, pas ajoutée après : secrets hors du code, mots de passe hachés, requêtes paramétrées contre l'injection SQL, communications chiffrées et moindre privilège sur la base.</a:t>
             </a:r>
           </a:p>
         </p:txBody>
@@ -1154,7 +1165,7 @@
           <a:lstStyle/>
           <a:p>
             <a:r>
-              <a:t>Côté business, je vise les structures sans gros budget IT et les infogérants. Mon modèle est l'open-core : le cœur est gratuit pour créer l'adoption, et je monétise les services et une édition Pro avec SNMP et IA.</a:t>
+              <a:t>Pour la démonstration, je propose un scénario vivant : je montre le tableau de bord, j'éteins un équipement devant vous, et vous verrez l'alerte Telegram arriver sur mon téléphone en temps réel. Puis je le rallume pour montrer le rétablissement. J'ai un plan B en captures et vidéo.</a:t>
             </a:r>
           </a:p>
         </p:txBody>
@@ -1224,7 +1235,7 @@
           <a:lstStyle/>
           <a:p>
             <a:r>
-              <a:t>Je ne prétends pas battre Zabbix sur les très grandes infrastructures. Ma stratégie est celle de l'océan bleu : occuper le segment que les géants négligent - les petites structures - avec un produit simple et gratuit.</a:t>
+              <a:t>Ces captures matérialisent chaque fonctionnalité clé. La plus parlante est la notification Telegram reçue sur le téléphone : la preuve concrète de la valeur ajoutée pour l'administrateur.</a:t>
             </a:r>
           </a:p>
         </p:txBody>
@@ -1364,7 +1375,7 @@
           <a:lstStyle/>
           <a:p>
             <a:r>
-              <a:t>Financièrement, l'entrée est quasi nulle : pas de licence, juste un petit serveur. Côté revenus, même avec des hypothèses prudentes, on dépasse 9 000 € la première année. Pour le client, le retour vient de la réduction des coûts d'indisponibilité : la solution est rentabilisée dès le premier incident majeur évité.</a:t>
+              <a:t>Côté business, je vise les structures sans gros budget IT et les infogérants. Mon modèle est l'open-core : le cœur est gratuit pour créer l'adoption, et je monétise les services et une édition Pro avec SNMP et IA.</a:t>
             </a:r>
           </a:p>
         </p:txBody>
@@ -1434,7 +1445,7 @@
           <a:lstStyle/>
           <a:p>
             <a:r>
-              <a:t>Je reste lucide sur les limites : pas encore de SNMP, réactivité bornée à deux minutes, et la question du superviseur lui-même. Mais ces limites tracent ma feuille de route : SNMP, puis l'IA pour passer d'une supervision réactive à une supervision prédictive.</a:t>
+              <a:t>Je ne prétends pas battre Zabbix sur les très grandes infrastructures. Ma stratégie est celle de l'océan bleu : occuper le segment que les géants négligent - les petites structures - avec un produit simple et gratuit.</a:t>
             </a:r>
           </a:p>
         </p:txBody>
@@ -1504,7 +1515,7 @@
           <a:lstStyle/>
           <a:p>
             <a:r>
-              <a:t>En conclusion, ce projet livre un produit réel et performant, doublé d'un modèle économique crédible, et ouvert vers l'avenir de la supervision : le prédictif. J'ai montré qu'on pouvait rendre la haute disponibilité accessible à tous.</a:t>
+              <a:t>Financièrement, l'entrée est quasi nulle : pas de licence, juste un petit serveur. Côté revenus, même avec des hypothèses prudentes, on dépasse 9 000 € la première année. Pour le client, le retour vient de la réduction des coûts d'indisponibilité : la solution est rentabilisée dès le premier incident majeur évité.</a:t>
             </a:r>
           </a:p>
         </p:txBody>
@@ -1574,7 +1585,217 @@
           <a:lstStyle/>
           <a:p>
             <a:r>
+              <a:t>Je reste lucide sur les limites : pas encore de SNMP, réactivité bornée à deux minutes, et la question du superviseur lui-même. Mais ces limites tracent ma feuille de route : SNMP, puis l'IA pour passer d'une supervision réactive à une supervision prédictive.</a:t>
+            </a:r>
+          </a:p>
+        </p:txBody>
+      </p:sp>
+      <p:sp>
+        <p:nvSpPr>
+          <p:cNvPr id="4" name="Slide Number Placeholder 3"/>
+          <p:cNvSpPr>
+            <a:spLocks noGrp="1"/>
+          </p:cNvSpPr>
+          <p:nvPr>
+            <p:ph type="sldNum" idx="5" sz="quarter"/>
+          </p:nvPr>
+        </p:nvSpPr>
+        <p:spPr/>
+      </p:sp>
+    </p:spTree>
+  </p:cSld>
+  <p:clrMapOvr>
+    <a:masterClrMapping/>
+  </p:clrMapOvr>
+</p:notes>
+</file>
+
+<file path=ppt/notesSlides/notesSlide24.xml><?xml version="1.0" encoding="utf-8"?>
+<p:notes xmlns:a="http://schemas.openxmlformats.org/drawingml/2006/main" xmlns:p="http://schemas.openxmlformats.org/presentationml/2006/main" xmlns:r="http://schemas.openxmlformats.org/officeDocument/2006/relationships">
+  <p:cSld>
+    <p:spTree>
+      <p:nvGrpSpPr>
+        <p:cNvPr id="1" name=""/>
+        <p:cNvGrpSpPr/>
+        <p:nvPr/>
+      </p:nvGrpSpPr>
+      <p:grpSpPr>
+        <a:xfrm>
+          <a:off x="0" y="0"/>
+          <a:ext cx="0" cy="0"/>
+          <a:chOff x="0" y="0"/>
+          <a:chExt cx="0" cy="0"/>
+        </a:xfrm>
+      </p:grpSpPr>
+      <p:sp>
+        <p:nvSpPr>
+          <p:cNvPr id="2" name="Slide Image Placeholder 1"/>
+          <p:cNvSpPr>
+            <a:spLocks noGrp="1"/>
+          </p:cNvSpPr>
+          <p:nvPr>
+            <p:ph type="sldImg" idx="2"/>
+          </p:nvPr>
+        </p:nvSpPr>
+        <p:spPr/>
+      </p:sp>
+      <p:sp>
+        <p:nvSpPr>
+          <p:cNvPr id="3" name="Notes Placeholder 2"/>
+          <p:cNvSpPr>
+            <a:spLocks noGrp="1"/>
+          </p:cNvSpPr>
+          <p:nvPr>
+            <p:ph type="body" idx="3" sz="quarter"/>
+          </p:nvPr>
+        </p:nvSpPr>
+        <p:spPr/>
+        <p:txBody>
+          <a:bodyPr/>
+          <a:lstStyle/>
+          <a:p>
+            <a:r>
+              <a:t>En conclusion, ce projet livre un produit réel et performant, doublé d'un modèle économique crédible, et ouvert vers l'avenir de la supervision : le prédictif. J'ai montré qu'on pouvait rendre la haute disponibilité accessible à tous.</a:t>
+            </a:r>
+          </a:p>
+        </p:txBody>
+      </p:sp>
+      <p:sp>
+        <p:nvSpPr>
+          <p:cNvPr id="4" name="Slide Number Placeholder 3"/>
+          <p:cNvSpPr>
+            <a:spLocks noGrp="1"/>
+          </p:cNvSpPr>
+          <p:nvPr>
+            <p:ph type="sldNum" idx="5" sz="quarter"/>
+          </p:nvPr>
+        </p:nvSpPr>
+        <p:spPr/>
+      </p:sp>
+    </p:spTree>
+  </p:cSld>
+  <p:clrMapOvr>
+    <a:masterClrMapping/>
+  </p:clrMapOvr>
+</p:notes>
+</file>
+
+<file path=ppt/notesSlides/notesSlide25.xml><?xml version="1.0" encoding="utf-8"?>
+<p:notes xmlns:a="http://schemas.openxmlformats.org/drawingml/2006/main" xmlns:p="http://schemas.openxmlformats.org/presentationml/2006/main" xmlns:r="http://schemas.openxmlformats.org/officeDocument/2006/relationships">
+  <p:cSld>
+    <p:spTree>
+      <p:nvGrpSpPr>
+        <p:cNvPr id="1" name=""/>
+        <p:cNvGrpSpPr/>
+        <p:nvPr/>
+      </p:nvGrpSpPr>
+      <p:grpSpPr>
+        <a:xfrm>
+          <a:off x="0" y="0"/>
+          <a:ext cx="0" cy="0"/>
+          <a:chOff x="0" y="0"/>
+          <a:chExt cx="0" cy="0"/>
+        </a:xfrm>
+      </p:grpSpPr>
+      <p:sp>
+        <p:nvSpPr>
+          <p:cNvPr id="2" name="Slide Image Placeholder 1"/>
+          <p:cNvSpPr>
+            <a:spLocks noGrp="1"/>
+          </p:cNvSpPr>
+          <p:nvPr>
+            <p:ph type="sldImg" idx="2"/>
+          </p:nvPr>
+        </p:nvSpPr>
+        <p:spPr/>
+      </p:sp>
+      <p:sp>
+        <p:nvSpPr>
+          <p:cNvPr id="3" name="Notes Placeholder 2"/>
+          <p:cNvSpPr>
+            <a:spLocks noGrp="1"/>
+          </p:cNvSpPr>
+          <p:nvPr>
+            <p:ph type="body" idx="3" sz="quarter"/>
+          </p:nvPr>
+        </p:nvSpPr>
+        <p:spPr/>
+        <p:txBody>
+          <a:bodyPr/>
+          <a:lstStyle/>
+          <a:p>
+            <a:r>
               <a:t>Je vous remercie de votre attention et je suis prêt à répondre à toutes vos questions, qu'elles soient techniques ou sur le volet économique.</a:t>
+            </a:r>
+          </a:p>
+        </p:txBody>
+      </p:sp>
+      <p:sp>
+        <p:nvSpPr>
+          <p:cNvPr id="4" name="Slide Number Placeholder 3"/>
+          <p:cNvSpPr>
+            <a:spLocks noGrp="1"/>
+          </p:cNvSpPr>
+          <p:nvPr>
+            <p:ph type="sldNum" idx="5" sz="quarter"/>
+          </p:nvPr>
+        </p:nvSpPr>
+        <p:spPr/>
+      </p:sp>
+    </p:spTree>
+  </p:cSld>
+  <p:clrMapOvr>
+    <a:masterClrMapping/>
+  </p:clrMapOvr>
+</p:notes>
+</file>
+
+<file path=ppt/notesSlides/notesSlide26.xml><?xml version="1.0" encoding="utf-8"?>
+<p:notes xmlns:a="http://schemas.openxmlformats.org/drawingml/2006/main" xmlns:p="http://schemas.openxmlformats.org/presentationml/2006/main" xmlns:r="http://schemas.openxmlformats.org/officeDocument/2006/relationships">
+  <p:cSld>
+    <p:spTree>
+      <p:nvGrpSpPr>
+        <p:cNvPr id="1" name=""/>
+        <p:cNvGrpSpPr/>
+        <p:nvPr/>
+      </p:nvGrpSpPr>
+      <p:grpSpPr>
+        <a:xfrm>
+          <a:off x="0" y="0"/>
+          <a:ext cx="0" cy="0"/>
+          <a:chOff x="0" y="0"/>
+          <a:chExt cx="0" cy="0"/>
+        </a:xfrm>
+      </p:grpSpPr>
+      <p:sp>
+        <p:nvSpPr>
+          <p:cNvPr id="2" name="Slide Image Placeholder 1"/>
+          <p:cNvSpPr>
+            <a:spLocks noGrp="1"/>
+          </p:cNvSpPr>
+          <p:nvPr>
+            <p:ph type="sldImg" idx="2"/>
+          </p:nvPr>
+        </p:nvSpPr>
+        <p:spPr/>
+      </p:sp>
+      <p:sp>
+        <p:nvSpPr>
+          <p:cNvPr id="3" name="Notes Placeholder 2"/>
+          <p:cNvSpPr>
+            <a:spLocks noGrp="1"/>
+          </p:cNvSpPr>
+          <p:nvPr>
+            <p:ph type="body" idx="3" sz="quarter"/>
+          </p:nvPr>
+        </p:nvSpPr>
+        <p:spPr/>
+        <p:txBody>
+          <a:bodyPr/>
+          <a:lstStyle/>
+          <a:p>
+            <a:r>
+              <a:t>Voici en annexe les diagrammes détaillés, que je peux afficher pour répondre précisément à vos questions sur la conception.</a:t>
             </a:r>
           </a:p>
         </p:txBody>
@@ -6630,414 +6851,66 @@
                 </a:solidFill>
                 <a:latin typeface="Calibri"/>
               </a:rPr>
-              <a:t>Architecture de la solution</a:t>
-            </a:r>
-          </a:p>
-        </p:txBody>
-      </p:sp>
-      <p:sp>
-        <p:nvSpPr>
-          <p:cNvPr id="5" name="Rectangle 4"/>
-          <p:cNvSpPr/>
+              <a:t>Architecture en 5 couches</a:t>
+            </a:r>
+          </a:p>
+        </p:txBody>
+      </p:sp>
+      <p:pic>
+        <p:nvPicPr>
+          <p:cNvPr id="5" name="Picture 4" descr="architecture-5couches.png"/>
+          <p:cNvPicPr>
+            <a:picLocks noChangeAspect="1"/>
+          </p:cNvPicPr>
           <p:nvPr/>
-        </p:nvSpPr>
-        <p:spPr>
-          <a:xfrm>
-            <a:off x="1097280" y="1417320"/>
-            <a:ext cx="9966960" cy="749808"/>
+        </p:nvPicPr>
+        <p:blipFill>
+          <a:blip r:embed="rId2"/>
+          <a:stretch>
+            <a:fillRect/>
+          </a:stretch>
+        </p:blipFill>
+        <p:spPr>
+          <a:xfrm>
+            <a:off x="1815213" y="1234440"/>
+            <a:ext cx="8561269" cy="4846320"/>
           </a:xfrm>
           <a:prstGeom prst="rect">
             <a:avLst/>
           </a:prstGeom>
-          <a:solidFill>
-            <a:srgbClr val="0D6EFD"/>
-          </a:solidFill>
-          <a:ln>
-            <a:noFill/>
-          </a:ln>
-          <a:effectLst/>
-        </p:spPr>
-        <p:style>
-          <a:lnRef idx="1">
-            <a:schemeClr val="accent1"/>
-          </a:lnRef>
-          <a:fillRef idx="3">
-            <a:schemeClr val="accent1"/>
-          </a:fillRef>
-          <a:effectRef idx="2">
-            <a:schemeClr val="accent1"/>
-          </a:effectRef>
-          <a:fontRef idx="minor">
-            <a:schemeClr val="lt1"/>
-          </a:fontRef>
-        </p:style>
-        <p:txBody>
-          <a:bodyPr rtlCol="0" anchor="ctr" lIns="274320"/>
-          <a:lstStyle/>
-          <a:p>
-            <a:pPr algn="ctr"/>
-            <a:r>
-              <a:rPr sz="1600" b="1" i="0">
-                <a:solidFill>
-                  <a:srgbClr val="FFFFFF"/>
-                </a:solidFill>
-                <a:latin typeface="Calibri"/>
-              </a:rPr>
-              <a:t>PRÉSENTATION   </a:t>
-            </a:r>
-            <a:r>
-              <a:rPr sz="1500" b="0" i="0">
-                <a:solidFill>
-                  <a:srgbClr val="E8EEF4"/>
-                </a:solidFill>
-                <a:latin typeface="Calibri"/>
-              </a:rPr>
-              <a:t>— Tableau de bord Flask + Bootstrap + Chart.js</a:t>
-            </a:r>
-          </a:p>
-        </p:txBody>
-      </p:sp>
-      <p:sp>
-        <p:nvSpPr>
-          <p:cNvPr id="6" name="Rectangle 5"/>
-          <p:cNvSpPr/>
+        </p:spPr>
+      </p:pic>
+      <p:sp>
+        <p:nvSpPr>
+          <p:cNvPr id="6" name="TextBox 5"/>
+          <p:cNvSpPr txBox="1"/>
           <p:nvPr/>
         </p:nvSpPr>
         <p:spPr>
           <a:xfrm>
-            <a:off x="1097280" y="2286000"/>
-            <a:ext cx="9966960" cy="749808"/>
+            <a:off x="457200" y="6172200"/>
+            <a:ext cx="11247120" cy="457200"/>
           </a:xfrm>
           <a:prstGeom prst="rect">
             <a:avLst/>
           </a:prstGeom>
-          <a:solidFill>
-            <a:srgbClr val="398AC8"/>
-          </a:solidFill>
-          <a:ln>
-            <a:noFill/>
-          </a:ln>
-          <a:effectLst/>
-        </p:spPr>
-        <p:style>
-          <a:lnRef idx="1">
-            <a:schemeClr val="accent1"/>
-          </a:lnRef>
-          <a:fillRef idx="3">
-            <a:schemeClr val="accent1"/>
-          </a:fillRef>
-          <a:effectRef idx="2">
-            <a:schemeClr val="accent1"/>
-          </a:effectRef>
-          <a:fontRef idx="minor">
-            <a:schemeClr val="lt1"/>
-          </a:fontRef>
-        </p:style>
-        <p:txBody>
-          <a:bodyPr rtlCol="0" anchor="ctr" lIns="274320"/>
+          <a:noFill/>
+        </p:spPr>
+        <p:txBody>
+          <a:bodyPr wrap="square">
+            <a:spAutoFit/>
+          </a:bodyPr>
           <a:lstStyle/>
           <a:p>
             <a:pPr algn="ctr"/>
             <a:r>
-              <a:rPr sz="1600" b="1" i="0">
-                <a:solidFill>
-                  <a:srgbClr val="FFFFFF"/>
-                </a:solidFill>
-                <a:latin typeface="Calibri"/>
-              </a:rPr>
-              <a:t>NOTIFICATION   </a:t>
-            </a:r>
-            <a:r>
-              <a:rPr sz="1500" b="0" i="0">
-                <a:solidFill>
-                  <a:srgbClr val="E8EEF4"/>
-                </a:solidFill>
-                <a:latin typeface="Calibri"/>
-              </a:rPr>
-              <a:t>— E-mail (SMTP)  +  Telegram (push mobile)</a:t>
-            </a:r>
-          </a:p>
-        </p:txBody>
-      </p:sp>
-      <p:sp>
-        <p:nvSpPr>
-          <p:cNvPr id="7" name="Rectangle 6"/>
-          <p:cNvSpPr/>
-          <p:nvPr/>
-        </p:nvSpPr>
-        <p:spPr>
-          <a:xfrm>
-            <a:off x="1097280" y="3154680"/>
-            <a:ext cx="9966960" cy="749808"/>
-          </a:xfrm>
-          <a:prstGeom prst="rect">
-            <a:avLst/>
-          </a:prstGeom>
-          <a:solidFill>
-            <a:srgbClr val="2A6F97"/>
-          </a:solidFill>
-          <a:ln>
-            <a:noFill/>
-          </a:ln>
-          <a:effectLst/>
-        </p:spPr>
-        <p:style>
-          <a:lnRef idx="1">
-            <a:schemeClr val="accent1"/>
-          </a:lnRef>
-          <a:fillRef idx="3">
-            <a:schemeClr val="accent1"/>
-          </a:fillRef>
-          <a:effectRef idx="2">
-            <a:schemeClr val="accent1"/>
-          </a:effectRef>
-          <a:fontRef idx="minor">
-            <a:schemeClr val="lt1"/>
-          </a:fontRef>
-        </p:style>
-        <p:txBody>
-          <a:bodyPr rtlCol="0" anchor="ctr" lIns="274320"/>
-          <a:lstStyle/>
-          <a:p>
-            <a:pPr algn="ctr"/>
-            <a:r>
-              <a:rPr sz="1600" b="1" i="0">
-                <a:solidFill>
-                  <a:srgbClr val="FFFFFF"/>
-                </a:solidFill>
-                <a:latin typeface="Calibri"/>
-              </a:rPr>
-              <a:t>TRAITEMENT   </a:t>
-            </a:r>
-            <a:r>
-              <a:rPr sz="1500" b="0" i="0">
-                <a:solidFill>
-                  <a:srgbClr val="E8EEF4"/>
-                </a:solidFill>
-                <a:latin typeface="Calibri"/>
-              </a:rPr>
-              <a:t>— Moteur Python + Cron (sondes ICMP / TCP)</a:t>
-            </a:r>
-          </a:p>
-        </p:txBody>
-      </p:sp>
-      <p:sp>
-        <p:nvSpPr>
-          <p:cNvPr id="8" name="Rectangle 7"/>
-          <p:cNvSpPr/>
-          <p:nvPr/>
-        </p:nvSpPr>
-        <p:spPr>
-          <a:xfrm>
-            <a:off x="1097280" y="4023360"/>
-            <a:ext cx="9966960" cy="749808"/>
-          </a:xfrm>
-          <a:prstGeom prst="rect">
-            <a:avLst/>
-          </a:prstGeom>
-          <a:solidFill>
-            <a:srgbClr val="1B4F72"/>
-          </a:solidFill>
-          <a:ln>
-            <a:noFill/>
-          </a:ln>
-          <a:effectLst/>
-        </p:spPr>
-        <p:style>
-          <a:lnRef idx="1">
-            <a:schemeClr val="accent1"/>
-          </a:lnRef>
-          <a:fillRef idx="3">
-            <a:schemeClr val="accent1"/>
-          </a:fillRef>
-          <a:effectRef idx="2">
-            <a:schemeClr val="accent1"/>
-          </a:effectRef>
-          <a:fontRef idx="minor">
-            <a:schemeClr val="lt1"/>
-          </a:fontRef>
-        </p:style>
-        <p:txBody>
-          <a:bodyPr rtlCol="0" anchor="ctr" lIns="274320"/>
-          <a:lstStyle/>
-          <a:p>
-            <a:pPr algn="ctr"/>
-            <a:r>
-              <a:rPr sz="1600" b="1" i="0">
-                <a:solidFill>
-                  <a:srgbClr val="FFFFFF"/>
-                </a:solidFill>
-                <a:latin typeface="Calibri"/>
-              </a:rPr>
-              <a:t>DONNÉES   </a:t>
-            </a:r>
-            <a:r>
-              <a:rPr sz="1500" b="0" i="0">
-                <a:solidFill>
-                  <a:srgbClr val="E8EEF4"/>
-                </a:solidFill>
-                <a:latin typeface="Calibri"/>
-              </a:rPr>
-              <a:t>— Base MySQL (historique, alertes, configuration)</a:t>
-            </a:r>
-          </a:p>
-        </p:txBody>
-      </p:sp>
-      <p:sp>
-        <p:nvSpPr>
-          <p:cNvPr id="9" name="Rectangle 8"/>
-          <p:cNvSpPr/>
-          <p:nvPr/>
-        </p:nvSpPr>
-        <p:spPr>
-          <a:xfrm>
-            <a:off x="1097280" y="4892040"/>
-            <a:ext cx="9966960" cy="749808"/>
-          </a:xfrm>
-          <a:prstGeom prst="rect">
-            <a:avLst/>
-          </a:prstGeom>
-          <a:solidFill>
-            <a:srgbClr val="0D3B66"/>
-          </a:solidFill>
-          <a:ln>
-            <a:noFill/>
-          </a:ln>
-          <a:effectLst/>
-        </p:spPr>
-        <p:style>
-          <a:lnRef idx="1">
-            <a:schemeClr val="accent1"/>
-          </a:lnRef>
-          <a:fillRef idx="3">
-            <a:schemeClr val="accent1"/>
-          </a:fillRef>
-          <a:effectRef idx="2">
-            <a:schemeClr val="accent1"/>
-          </a:effectRef>
-          <a:fontRef idx="minor">
-            <a:schemeClr val="lt1"/>
-          </a:fontRef>
-        </p:style>
-        <p:txBody>
-          <a:bodyPr rtlCol="0" anchor="ctr" lIns="274320"/>
-          <a:lstStyle/>
-          <a:p>
-            <a:pPr algn="ctr"/>
-            <a:r>
-              <a:rPr sz="1600" b="1" i="0">
-                <a:solidFill>
-                  <a:srgbClr val="FFFFFF"/>
-                </a:solidFill>
-                <a:latin typeface="Calibri"/>
-              </a:rPr>
-              <a:t>SYSTÈME   </a:t>
-            </a:r>
-            <a:r>
-              <a:rPr sz="1500" b="0" i="0">
-                <a:solidFill>
-                  <a:srgbClr val="E8EEF4"/>
-                </a:solidFill>
-                <a:latin typeface="Calibri"/>
-              </a:rPr>
-              <a:t>— Serveur Linux Ubuntu</a:t>
-            </a:r>
-          </a:p>
-        </p:txBody>
-      </p:sp>
-      <p:sp>
-        <p:nvSpPr>
-          <p:cNvPr id="10" name="Rectangle 9"/>
-          <p:cNvSpPr/>
-          <p:nvPr/>
-        </p:nvSpPr>
-        <p:spPr>
-          <a:xfrm>
-            <a:off x="640080" y="5806440"/>
-            <a:ext cx="109728" cy="868680"/>
-          </a:xfrm>
-          <a:prstGeom prst="rect">
-            <a:avLst/>
-          </a:prstGeom>
-          <a:solidFill>
-            <a:srgbClr val="0D6EFD"/>
-          </a:solidFill>
-          <a:ln>
-            <a:noFill/>
-          </a:ln>
-          <a:effectLst/>
-        </p:spPr>
-        <p:style>
-          <a:lnRef idx="1">
-            <a:schemeClr val="accent1"/>
-          </a:lnRef>
-          <a:fillRef idx="3">
-            <a:schemeClr val="accent1"/>
-          </a:fillRef>
-          <a:effectRef idx="2">
-            <a:schemeClr val="accent1"/>
-          </a:effectRef>
-          <a:fontRef idx="minor">
-            <a:schemeClr val="lt1"/>
-          </a:fontRef>
-        </p:style>
-        <p:txBody>
-          <a:bodyPr rtlCol="0" anchor="ctr"/>
-          <a:lstStyle/>
-          <a:p>
-            <a:pPr algn="ctr"/>
-          </a:p>
-        </p:txBody>
-      </p:sp>
-      <p:sp>
-        <p:nvSpPr>
-          <p:cNvPr id="11" name="Rectangle 10"/>
-          <p:cNvSpPr/>
-          <p:nvPr/>
-        </p:nvSpPr>
-        <p:spPr>
-          <a:xfrm>
-            <a:off x="749808" y="5806440"/>
-            <a:ext cx="10771632" cy="868680"/>
-          </a:xfrm>
-          <a:prstGeom prst="rect">
-            <a:avLst/>
-          </a:prstGeom>
-          <a:solidFill>
-            <a:srgbClr val="F1F3F5"/>
-          </a:solidFill>
-          <a:ln>
-            <a:noFill/>
-          </a:ln>
-          <a:effectLst/>
-        </p:spPr>
-        <p:style>
-          <a:lnRef idx="1">
-            <a:schemeClr val="accent1"/>
-          </a:lnRef>
-          <a:fillRef idx="3">
-            <a:schemeClr val="accent1"/>
-          </a:fillRef>
-          <a:effectRef idx="2">
-            <a:schemeClr val="accent1"/>
-          </a:effectRef>
-          <a:fontRef idx="minor">
-            <a:schemeClr val="lt1"/>
-          </a:fontRef>
-        </p:style>
-        <p:txBody>
-          <a:bodyPr rtlCol="0" anchor="ctr" wrap="square" lIns="182880"/>
-          <a:lstStyle/>
-          <a:p>
-            <a:pPr algn="ctr"/>
-            <a:r>
-              <a:rPr sz="1700" b="1" i="1">
-                <a:solidFill>
-                  <a:srgbClr val="0D3B66"/>
-                </a:solidFill>
-                <a:latin typeface="Calibri"/>
-              </a:rPr>
-              <a:t>Choix clé : découplage moteur de collecte (Cron) ↔ interface (Flask) → la surveillance continue même si le tableau de bord est arrêté.</a:t>
+              <a:rPr sz="1300" b="0" i="1">
+                <a:solidFill>
+                  <a:srgbClr val="333333"/>
+                </a:solidFill>
+                <a:latin typeface="Calibri"/>
+              </a:rPr>
+              <a:t>Découplage Moteur (Cron) ↔ Interface (Flask) : la surveillance continue même si le tableau de bord est arrêté.</a:t>
             </a:r>
           </a:p>
         </p:txBody>
@@ -7160,6 +7033,851 @@
                 </a:solidFill>
                 <a:latin typeface="Calibri"/>
               </a:rPr>
+              <a:t>6</a:t>
+            </a:r>
+          </a:p>
+        </p:txBody>
+      </p:sp>
+      <p:sp>
+        <p:nvSpPr>
+          <p:cNvPr id="4" name="TextBox 3"/>
+          <p:cNvSpPr txBox="1"/>
+          <p:nvPr/>
+        </p:nvSpPr>
+        <p:spPr>
+          <a:xfrm>
+            <a:off x="1143000" y="164592"/>
+            <a:ext cx="10774375" cy="731520"/>
+          </a:xfrm>
+          <a:prstGeom prst="rect">
+            <a:avLst/>
+          </a:prstGeom>
+          <a:noFill/>
+        </p:spPr>
+        <p:txBody>
+          <a:bodyPr wrap="square" anchor="ctr">
+            <a:spAutoFit/>
+          </a:bodyPr>
+          <a:lstStyle/>
+          <a:p>
+            <a:r>
+              <a:rPr sz="3000" b="1" i="0">
+                <a:solidFill>
+                  <a:srgbClr val="FFFFFF"/>
+                </a:solidFill>
+                <a:latin typeface="Calibri"/>
+              </a:rPr>
+              <a:t>Conception UML — les 7 diagrammes</a:t>
+            </a:r>
+          </a:p>
+        </p:txBody>
+      </p:sp>
+      <p:pic>
+        <p:nvPicPr>
+          <p:cNvPr id="5" name="Picture 4" descr="diagramme-contexte.png"/>
+          <p:cNvPicPr>
+            <a:picLocks noChangeAspect="1"/>
+          </p:cNvPicPr>
+          <p:nvPr/>
+        </p:nvPicPr>
+        <p:blipFill>
+          <a:blip r:embed="rId2"/>
+          <a:stretch>
+            <a:fillRect/>
+          </a:stretch>
+        </p:blipFill>
+        <p:spPr>
+          <a:xfrm>
+            <a:off x="320040" y="1325880"/>
+            <a:ext cx="2743200" cy="979909"/>
+          </a:xfrm>
+          <a:prstGeom prst="rect">
+            <a:avLst/>
+          </a:prstGeom>
+        </p:spPr>
+      </p:pic>
+      <p:sp>
+        <p:nvSpPr>
+          <p:cNvPr id="6" name="TextBox 5"/>
+          <p:cNvSpPr txBox="1"/>
+          <p:nvPr/>
+        </p:nvSpPr>
+        <p:spPr>
+          <a:xfrm>
+            <a:off x="320040" y="3493008"/>
+            <a:ext cx="2743200" cy="365760"/>
+          </a:xfrm>
+          <a:prstGeom prst="rect">
+            <a:avLst/>
+          </a:prstGeom>
+          <a:noFill/>
+        </p:spPr>
+        <p:txBody>
+          <a:bodyPr wrap="square">
+            <a:spAutoFit/>
+          </a:bodyPr>
+          <a:lstStyle/>
+          <a:p>
+            <a:pPr algn="ctr"/>
+            <a:r>
+              <a:rPr sz="1100" b="1" i="0">
+                <a:solidFill>
+                  <a:srgbClr val="0D3B66"/>
+                </a:solidFill>
+                <a:latin typeface="Calibri"/>
+              </a:rPr>
+              <a:t>1. Contexte</a:t>
+            </a:r>
+          </a:p>
+        </p:txBody>
+      </p:sp>
+      <p:pic>
+        <p:nvPicPr>
+          <p:cNvPr id="7" name="Picture 6" descr="cas-utilisation.png"/>
+          <p:cNvPicPr>
+            <a:picLocks noChangeAspect="1"/>
+          </p:cNvPicPr>
+          <p:nvPr/>
+        </p:nvPicPr>
+        <p:blipFill>
+          <a:blip r:embed="rId3"/>
+          <a:stretch>
+            <a:fillRect/>
+          </a:stretch>
+        </p:blipFill>
+        <p:spPr>
+          <a:xfrm>
+            <a:off x="3227832" y="1325880"/>
+            <a:ext cx="2743200" cy="1065499"/>
+          </a:xfrm>
+          <a:prstGeom prst="rect">
+            <a:avLst/>
+          </a:prstGeom>
+        </p:spPr>
+      </p:pic>
+      <p:sp>
+        <p:nvSpPr>
+          <p:cNvPr id="8" name="TextBox 7"/>
+          <p:cNvSpPr txBox="1"/>
+          <p:nvPr/>
+        </p:nvSpPr>
+        <p:spPr>
+          <a:xfrm>
+            <a:off x="3227832" y="3493008"/>
+            <a:ext cx="2743200" cy="365760"/>
+          </a:xfrm>
+          <a:prstGeom prst="rect">
+            <a:avLst/>
+          </a:prstGeom>
+          <a:noFill/>
+        </p:spPr>
+        <p:txBody>
+          <a:bodyPr wrap="square">
+            <a:spAutoFit/>
+          </a:bodyPr>
+          <a:lstStyle/>
+          <a:p>
+            <a:pPr algn="ctr"/>
+            <a:r>
+              <a:rPr sz="1100" b="1" i="0">
+                <a:solidFill>
+                  <a:srgbClr val="0D3B66"/>
+                </a:solidFill>
+                <a:latin typeface="Calibri"/>
+              </a:rPr>
+              <a:t>2. Cas d'utilisation</a:t>
+            </a:r>
+          </a:p>
+        </p:txBody>
+      </p:sp>
+      <p:pic>
+        <p:nvPicPr>
+          <p:cNvPr id="9" name="Picture 8" descr="diagramme-sequence.png"/>
+          <p:cNvPicPr>
+            <a:picLocks noChangeAspect="1"/>
+          </p:cNvPicPr>
+          <p:nvPr/>
+        </p:nvPicPr>
+        <p:blipFill>
+          <a:blip r:embed="rId4"/>
+          <a:stretch>
+            <a:fillRect/>
+          </a:stretch>
+        </p:blipFill>
+        <p:spPr>
+          <a:xfrm>
+            <a:off x="6135939" y="1325880"/>
+            <a:ext cx="2742570" cy="2148840"/>
+          </a:xfrm>
+          <a:prstGeom prst="rect">
+            <a:avLst/>
+          </a:prstGeom>
+        </p:spPr>
+      </p:pic>
+      <p:sp>
+        <p:nvSpPr>
+          <p:cNvPr id="10" name="TextBox 9"/>
+          <p:cNvSpPr txBox="1"/>
+          <p:nvPr/>
+        </p:nvSpPr>
+        <p:spPr>
+          <a:xfrm>
+            <a:off x="6135624" y="3493008"/>
+            <a:ext cx="2743200" cy="365760"/>
+          </a:xfrm>
+          <a:prstGeom prst="rect">
+            <a:avLst/>
+          </a:prstGeom>
+          <a:noFill/>
+        </p:spPr>
+        <p:txBody>
+          <a:bodyPr wrap="square">
+            <a:spAutoFit/>
+          </a:bodyPr>
+          <a:lstStyle/>
+          <a:p>
+            <a:pPr algn="ctr"/>
+            <a:r>
+              <a:rPr sz="1100" b="1" i="0">
+                <a:solidFill>
+                  <a:srgbClr val="0D3B66"/>
+                </a:solidFill>
+                <a:latin typeface="Calibri"/>
+              </a:rPr>
+              <a:t>3. Séquence</a:t>
+            </a:r>
+          </a:p>
+        </p:txBody>
+      </p:sp>
+      <p:pic>
+        <p:nvPicPr>
+          <p:cNvPr id="11" name="Picture 10" descr="diagramme-activite.png"/>
+          <p:cNvPicPr>
+            <a:picLocks noChangeAspect="1"/>
+          </p:cNvPicPr>
+          <p:nvPr/>
+        </p:nvPicPr>
+        <p:blipFill>
+          <a:blip r:embed="rId5"/>
+          <a:stretch>
+            <a:fillRect/>
+          </a:stretch>
+        </p:blipFill>
+        <p:spPr>
+          <a:xfrm>
+            <a:off x="9742744" y="1325880"/>
+            <a:ext cx="1344544" cy="2148840"/>
+          </a:xfrm>
+          <a:prstGeom prst="rect">
+            <a:avLst/>
+          </a:prstGeom>
+        </p:spPr>
+      </p:pic>
+      <p:sp>
+        <p:nvSpPr>
+          <p:cNvPr id="12" name="TextBox 11"/>
+          <p:cNvSpPr txBox="1"/>
+          <p:nvPr/>
+        </p:nvSpPr>
+        <p:spPr>
+          <a:xfrm>
+            <a:off x="9043416" y="3493008"/>
+            <a:ext cx="2743200" cy="365760"/>
+          </a:xfrm>
+          <a:prstGeom prst="rect">
+            <a:avLst/>
+          </a:prstGeom>
+          <a:noFill/>
+        </p:spPr>
+        <p:txBody>
+          <a:bodyPr wrap="square">
+            <a:spAutoFit/>
+          </a:bodyPr>
+          <a:lstStyle/>
+          <a:p>
+            <a:pPr algn="ctr"/>
+            <a:r>
+              <a:rPr sz="1100" b="1" i="0">
+                <a:solidFill>
+                  <a:srgbClr val="0D3B66"/>
+                </a:solidFill>
+                <a:latin typeface="Calibri"/>
+              </a:rPr>
+              <a:t>4. Activité</a:t>
+            </a:r>
+          </a:p>
+        </p:txBody>
+      </p:sp>
+      <p:pic>
+        <p:nvPicPr>
+          <p:cNvPr id="13" name="Picture 12" descr="diagramme-classes.png"/>
+          <p:cNvPicPr>
+            <a:picLocks noChangeAspect="1"/>
+          </p:cNvPicPr>
+          <p:nvPr/>
+        </p:nvPicPr>
+        <p:blipFill>
+          <a:blip r:embed="rId6"/>
+          <a:stretch>
+            <a:fillRect/>
+          </a:stretch>
+        </p:blipFill>
+        <p:spPr>
+          <a:xfrm>
+            <a:off x="320040" y="3977640"/>
+            <a:ext cx="2743200" cy="1165665"/>
+          </a:xfrm>
+          <a:prstGeom prst="rect">
+            <a:avLst/>
+          </a:prstGeom>
+        </p:spPr>
+      </p:pic>
+      <p:sp>
+        <p:nvSpPr>
+          <p:cNvPr id="14" name="TextBox 13"/>
+          <p:cNvSpPr txBox="1"/>
+          <p:nvPr/>
+        </p:nvSpPr>
+        <p:spPr>
+          <a:xfrm>
+            <a:off x="320040" y="6144768"/>
+            <a:ext cx="2743200" cy="365760"/>
+          </a:xfrm>
+          <a:prstGeom prst="rect">
+            <a:avLst/>
+          </a:prstGeom>
+          <a:noFill/>
+        </p:spPr>
+        <p:txBody>
+          <a:bodyPr wrap="square">
+            <a:spAutoFit/>
+          </a:bodyPr>
+          <a:lstStyle/>
+          <a:p>
+            <a:pPr algn="ctr"/>
+            <a:r>
+              <a:rPr sz="1100" b="1" i="0">
+                <a:solidFill>
+                  <a:srgbClr val="0D3B66"/>
+                </a:solidFill>
+                <a:latin typeface="Calibri"/>
+              </a:rPr>
+              <a:t>5. Classes</a:t>
+            </a:r>
+          </a:p>
+        </p:txBody>
+      </p:sp>
+      <p:pic>
+        <p:nvPicPr>
+          <p:cNvPr id="15" name="Picture 14" descr="diagramme-composants.png"/>
+          <p:cNvPicPr>
+            <a:picLocks noChangeAspect="1"/>
+          </p:cNvPicPr>
+          <p:nvPr/>
+        </p:nvPicPr>
+        <p:blipFill>
+          <a:blip r:embed="rId7"/>
+          <a:stretch>
+            <a:fillRect/>
+          </a:stretch>
+        </p:blipFill>
+        <p:spPr>
+          <a:xfrm>
+            <a:off x="3227832" y="3977640"/>
+            <a:ext cx="2743200" cy="1580949"/>
+          </a:xfrm>
+          <a:prstGeom prst="rect">
+            <a:avLst/>
+          </a:prstGeom>
+        </p:spPr>
+      </p:pic>
+      <p:sp>
+        <p:nvSpPr>
+          <p:cNvPr id="16" name="TextBox 15"/>
+          <p:cNvSpPr txBox="1"/>
+          <p:nvPr/>
+        </p:nvSpPr>
+        <p:spPr>
+          <a:xfrm>
+            <a:off x="3227832" y="6144768"/>
+            <a:ext cx="2743200" cy="365760"/>
+          </a:xfrm>
+          <a:prstGeom prst="rect">
+            <a:avLst/>
+          </a:prstGeom>
+          <a:noFill/>
+        </p:spPr>
+        <p:txBody>
+          <a:bodyPr wrap="square">
+            <a:spAutoFit/>
+          </a:bodyPr>
+          <a:lstStyle/>
+          <a:p>
+            <a:pPr algn="ctr"/>
+            <a:r>
+              <a:rPr sz="1100" b="1" i="0">
+                <a:solidFill>
+                  <a:srgbClr val="0D3B66"/>
+                </a:solidFill>
+                <a:latin typeface="Calibri"/>
+              </a:rPr>
+              <a:t>6. Composants</a:t>
+            </a:r>
+          </a:p>
+        </p:txBody>
+      </p:sp>
+      <p:pic>
+        <p:nvPicPr>
+          <p:cNvPr id="17" name="Picture 16" descr="diagramme-deploiement.png"/>
+          <p:cNvPicPr>
+            <a:picLocks noChangeAspect="1"/>
+          </p:cNvPicPr>
+          <p:nvPr/>
+        </p:nvPicPr>
+        <p:blipFill>
+          <a:blip r:embed="rId8"/>
+          <a:stretch>
+            <a:fillRect/>
+          </a:stretch>
+        </p:blipFill>
+        <p:spPr>
+          <a:xfrm>
+            <a:off x="6135624" y="3977640"/>
+            <a:ext cx="2743200" cy="1191432"/>
+          </a:xfrm>
+          <a:prstGeom prst="rect">
+            <a:avLst/>
+          </a:prstGeom>
+        </p:spPr>
+      </p:pic>
+      <p:sp>
+        <p:nvSpPr>
+          <p:cNvPr id="18" name="TextBox 17"/>
+          <p:cNvSpPr txBox="1"/>
+          <p:nvPr/>
+        </p:nvSpPr>
+        <p:spPr>
+          <a:xfrm>
+            <a:off x="6135624" y="6144768"/>
+            <a:ext cx="2743200" cy="365760"/>
+          </a:xfrm>
+          <a:prstGeom prst="rect">
+            <a:avLst/>
+          </a:prstGeom>
+          <a:noFill/>
+        </p:spPr>
+        <p:txBody>
+          <a:bodyPr wrap="square">
+            <a:spAutoFit/>
+          </a:bodyPr>
+          <a:lstStyle/>
+          <a:p>
+            <a:pPr algn="ctr"/>
+            <a:r>
+              <a:rPr sz="1100" b="1" i="0">
+                <a:solidFill>
+                  <a:srgbClr val="0D3B66"/>
+                </a:solidFill>
+                <a:latin typeface="Calibri"/>
+              </a:rPr>
+              <a:t>7. Déploiement</a:t>
+            </a:r>
+          </a:p>
+        </p:txBody>
+      </p:sp>
+    </p:spTree>
+  </p:cSld>
+  <p:clrMapOvr>
+    <a:masterClrMapping/>
+  </p:clrMapOvr>
+</p:sld>
+</file>
+
+<file path=ppt/slides/slide15.xml><?xml version="1.0" encoding="utf-8"?>
+<p:sld xmlns:a="http://schemas.openxmlformats.org/drawingml/2006/main" xmlns:p="http://schemas.openxmlformats.org/presentationml/2006/main" xmlns:r="http://schemas.openxmlformats.org/officeDocument/2006/relationships">
+  <p:cSld>
+    <p:bg>
+      <p:bgPr>
+        <a:solidFill>
+          <a:srgbClr val="FFFFFF"/>
+        </a:solidFill>
+        <a:effectLst/>
+      </p:bgPr>
+    </p:bg>
+    <p:spTree>
+      <p:nvGrpSpPr>
+        <p:cNvPr id="1" name=""/>
+        <p:cNvGrpSpPr/>
+        <p:nvPr/>
+      </p:nvGrpSpPr>
+      <p:grpSpPr/>
+      <p:sp>
+        <p:nvSpPr>
+          <p:cNvPr id="2" name="Rectangle 1"/>
+          <p:cNvSpPr/>
+          <p:nvPr/>
+        </p:nvSpPr>
+        <p:spPr>
+          <a:xfrm>
+            <a:off x="0" y="0"/>
+            <a:ext cx="12191695" cy="1051560"/>
+          </a:xfrm>
+          <a:prstGeom prst="rect">
+            <a:avLst/>
+          </a:prstGeom>
+          <a:solidFill>
+            <a:srgbClr val="0D3B66"/>
+          </a:solidFill>
+          <a:ln>
+            <a:noFill/>
+          </a:ln>
+          <a:effectLst/>
+        </p:spPr>
+        <p:style>
+          <a:lnRef idx="1">
+            <a:schemeClr val="accent1"/>
+          </a:lnRef>
+          <a:fillRef idx="3">
+            <a:schemeClr val="accent1"/>
+          </a:fillRef>
+          <a:effectRef idx="2">
+            <a:schemeClr val="accent1"/>
+          </a:effectRef>
+          <a:fontRef idx="minor">
+            <a:schemeClr val="lt1"/>
+          </a:fontRef>
+        </p:style>
+        <p:txBody>
+          <a:bodyPr rtlCol="0" anchor="ctr"/>
+          <a:lstStyle/>
+          <a:p>
+            <a:pPr algn="ctr"/>
+          </a:p>
+        </p:txBody>
+      </p:sp>
+      <p:sp>
+        <p:nvSpPr>
+          <p:cNvPr id="3" name="Oval 2"/>
+          <p:cNvSpPr/>
+          <p:nvPr/>
+        </p:nvSpPr>
+        <p:spPr>
+          <a:xfrm>
+            <a:off x="320040" y="201168"/>
+            <a:ext cx="658368" cy="658368"/>
+          </a:xfrm>
+          <a:prstGeom prst="ellipse">
+            <a:avLst/>
+          </a:prstGeom>
+          <a:solidFill>
+            <a:srgbClr val="0D6EFD"/>
+          </a:solidFill>
+          <a:ln>
+            <a:noFill/>
+          </a:ln>
+          <a:effectLst/>
+        </p:spPr>
+        <p:style>
+          <a:lnRef idx="1">
+            <a:schemeClr val="accent1"/>
+          </a:lnRef>
+          <a:fillRef idx="3">
+            <a:schemeClr val="accent1"/>
+          </a:fillRef>
+          <a:effectRef idx="2">
+            <a:schemeClr val="accent1"/>
+          </a:effectRef>
+          <a:fontRef idx="minor">
+            <a:schemeClr val="lt1"/>
+          </a:fontRef>
+        </p:style>
+        <p:txBody>
+          <a:bodyPr rtlCol="0" anchor="ctr" wrap="none"/>
+          <a:lstStyle/>
+          <a:p>
+            <a:pPr algn="ctr"/>
+            <a:r>
+              <a:rPr sz="2600" b="1" i="0">
+                <a:solidFill>
+                  <a:srgbClr val="FFFFFF"/>
+                </a:solidFill>
+                <a:latin typeface="Calibri"/>
+              </a:rPr>
+              <a:t>6</a:t>
+            </a:r>
+          </a:p>
+        </p:txBody>
+      </p:sp>
+      <p:sp>
+        <p:nvSpPr>
+          <p:cNvPr id="4" name="TextBox 3"/>
+          <p:cNvSpPr txBox="1"/>
+          <p:nvPr/>
+        </p:nvSpPr>
+        <p:spPr>
+          <a:xfrm>
+            <a:off x="1143000" y="164592"/>
+            <a:ext cx="10774375" cy="731520"/>
+          </a:xfrm>
+          <a:prstGeom prst="rect">
+            <a:avLst/>
+          </a:prstGeom>
+          <a:noFill/>
+        </p:spPr>
+        <p:txBody>
+          <a:bodyPr wrap="square" anchor="ctr">
+            <a:spAutoFit/>
+          </a:bodyPr>
+          <a:lstStyle/>
+          <a:p>
+            <a:r>
+              <a:rPr sz="3000" b="1" i="0">
+                <a:solidFill>
+                  <a:srgbClr val="FFFFFF"/>
+                </a:solidFill>
+                <a:latin typeface="Calibri"/>
+              </a:rPr>
+              <a:t>MERISE : du MCD au MLD (base MySQL, 5 tables)</a:t>
+            </a:r>
+          </a:p>
+        </p:txBody>
+      </p:sp>
+      <p:sp>
+        <p:nvSpPr>
+          <p:cNvPr id="5" name="TextBox 4"/>
+          <p:cNvSpPr txBox="1"/>
+          <p:nvPr/>
+        </p:nvSpPr>
+        <p:spPr>
+          <a:xfrm>
+            <a:off x="365760" y="1188720"/>
+            <a:ext cx="5486400" cy="365760"/>
+          </a:xfrm>
+          <a:prstGeom prst="rect">
+            <a:avLst/>
+          </a:prstGeom>
+          <a:noFill/>
+        </p:spPr>
+        <p:txBody>
+          <a:bodyPr wrap="square">
+            <a:spAutoFit/>
+          </a:bodyPr>
+          <a:lstStyle/>
+          <a:p>
+            <a:pPr algn="ctr"/>
+            <a:r>
+              <a:rPr sz="1600" b="1" i="0">
+                <a:solidFill>
+                  <a:srgbClr val="0D3B66"/>
+                </a:solidFill>
+                <a:latin typeface="Calibri"/>
+              </a:rPr>
+              <a:t>MCD — Modèle Conceptuel</a:t>
+            </a:r>
+          </a:p>
+        </p:txBody>
+      </p:sp>
+      <p:pic>
+        <p:nvPicPr>
+          <p:cNvPr id="6" name="Picture 5" descr="mcd.png"/>
+          <p:cNvPicPr>
+            <a:picLocks noChangeAspect="1"/>
+          </p:cNvPicPr>
+          <p:nvPr/>
+        </p:nvPicPr>
+        <p:blipFill>
+          <a:blip r:embed="rId2"/>
+          <a:stretch>
+            <a:fillRect/>
+          </a:stretch>
+        </p:blipFill>
+        <p:spPr>
+          <a:xfrm>
+            <a:off x="411480" y="1600200"/>
+            <a:ext cx="5394960" cy="3141605"/>
+          </a:xfrm>
+          <a:prstGeom prst="rect">
+            <a:avLst/>
+          </a:prstGeom>
+        </p:spPr>
+      </p:pic>
+      <p:sp>
+        <p:nvSpPr>
+          <p:cNvPr id="7" name="TextBox 6"/>
+          <p:cNvSpPr txBox="1"/>
+          <p:nvPr/>
+        </p:nvSpPr>
+        <p:spPr>
+          <a:xfrm>
+            <a:off x="6309360" y="1188720"/>
+            <a:ext cx="5486400" cy="365760"/>
+          </a:xfrm>
+          <a:prstGeom prst="rect">
+            <a:avLst/>
+          </a:prstGeom>
+          <a:noFill/>
+        </p:spPr>
+        <p:txBody>
+          <a:bodyPr wrap="square">
+            <a:spAutoFit/>
+          </a:bodyPr>
+          <a:lstStyle/>
+          <a:p>
+            <a:pPr algn="ctr"/>
+            <a:r>
+              <a:rPr sz="1600" b="1" i="0">
+                <a:solidFill>
+                  <a:srgbClr val="0D3B66"/>
+                </a:solidFill>
+                <a:latin typeface="Calibri"/>
+              </a:rPr>
+              <a:t>MLD — Modèle Logique</a:t>
+            </a:r>
+          </a:p>
+        </p:txBody>
+      </p:sp>
+      <p:pic>
+        <p:nvPicPr>
+          <p:cNvPr id="8" name="Picture 7" descr="mld.png"/>
+          <p:cNvPicPr>
+            <a:picLocks noChangeAspect="1"/>
+          </p:cNvPicPr>
+          <p:nvPr/>
+        </p:nvPicPr>
+        <p:blipFill>
+          <a:blip r:embed="rId3"/>
+          <a:stretch>
+            <a:fillRect/>
+          </a:stretch>
+        </p:blipFill>
+        <p:spPr>
+          <a:xfrm>
+            <a:off x="6355080" y="1600200"/>
+            <a:ext cx="5394960" cy="3316690"/>
+          </a:xfrm>
+          <a:prstGeom prst="rect">
+            <a:avLst/>
+          </a:prstGeom>
+        </p:spPr>
+      </p:pic>
+    </p:spTree>
+  </p:cSld>
+  <p:clrMapOvr>
+    <a:masterClrMapping/>
+  </p:clrMapOvr>
+</p:sld>
+</file>
+
+<file path=ppt/slides/slide16.xml><?xml version="1.0" encoding="utf-8"?>
+<p:sld xmlns:a="http://schemas.openxmlformats.org/drawingml/2006/main" xmlns:p="http://schemas.openxmlformats.org/presentationml/2006/main" xmlns:r="http://schemas.openxmlformats.org/officeDocument/2006/relationships">
+  <p:cSld>
+    <p:bg>
+      <p:bgPr>
+        <a:solidFill>
+          <a:srgbClr val="FFFFFF"/>
+        </a:solidFill>
+        <a:effectLst/>
+      </p:bgPr>
+    </p:bg>
+    <p:spTree>
+      <p:nvGrpSpPr>
+        <p:cNvPr id="1" name=""/>
+        <p:cNvGrpSpPr/>
+        <p:nvPr/>
+      </p:nvGrpSpPr>
+      <p:grpSpPr/>
+      <p:sp>
+        <p:nvSpPr>
+          <p:cNvPr id="2" name="Rectangle 1"/>
+          <p:cNvSpPr/>
+          <p:nvPr/>
+        </p:nvSpPr>
+        <p:spPr>
+          <a:xfrm>
+            <a:off x="0" y="0"/>
+            <a:ext cx="12191695" cy="1051560"/>
+          </a:xfrm>
+          <a:prstGeom prst="rect">
+            <a:avLst/>
+          </a:prstGeom>
+          <a:solidFill>
+            <a:srgbClr val="0D3B66"/>
+          </a:solidFill>
+          <a:ln>
+            <a:noFill/>
+          </a:ln>
+          <a:effectLst/>
+        </p:spPr>
+        <p:style>
+          <a:lnRef idx="1">
+            <a:schemeClr val="accent1"/>
+          </a:lnRef>
+          <a:fillRef idx="3">
+            <a:schemeClr val="accent1"/>
+          </a:fillRef>
+          <a:effectRef idx="2">
+            <a:schemeClr val="accent1"/>
+          </a:effectRef>
+          <a:fontRef idx="minor">
+            <a:schemeClr val="lt1"/>
+          </a:fontRef>
+        </p:style>
+        <p:txBody>
+          <a:bodyPr rtlCol="0" anchor="ctr"/>
+          <a:lstStyle/>
+          <a:p>
+            <a:pPr algn="ctr"/>
+          </a:p>
+        </p:txBody>
+      </p:sp>
+      <p:sp>
+        <p:nvSpPr>
+          <p:cNvPr id="3" name="Oval 2"/>
+          <p:cNvSpPr/>
+          <p:nvPr/>
+        </p:nvSpPr>
+        <p:spPr>
+          <a:xfrm>
+            <a:off x="320040" y="201168"/>
+            <a:ext cx="658368" cy="658368"/>
+          </a:xfrm>
+          <a:prstGeom prst="ellipse">
+            <a:avLst/>
+          </a:prstGeom>
+          <a:solidFill>
+            <a:srgbClr val="0D6EFD"/>
+          </a:solidFill>
+          <a:ln>
+            <a:noFill/>
+          </a:ln>
+          <a:effectLst/>
+        </p:spPr>
+        <p:style>
+          <a:lnRef idx="1">
+            <a:schemeClr val="accent1"/>
+          </a:lnRef>
+          <a:fillRef idx="3">
+            <a:schemeClr val="accent1"/>
+          </a:fillRef>
+          <a:effectRef idx="2">
+            <a:schemeClr val="accent1"/>
+          </a:effectRef>
+          <a:fontRef idx="minor">
+            <a:schemeClr val="lt1"/>
+          </a:fontRef>
+        </p:style>
+        <p:txBody>
+          <a:bodyPr rtlCol="0" anchor="ctr" wrap="none"/>
+          <a:lstStyle/>
+          <a:p>
+            <a:pPr algn="ctr"/>
+            <a:r>
+              <a:rPr sz="2600" b="1" i="0">
+                <a:solidFill>
+                  <a:srgbClr val="FFFFFF"/>
+                </a:solidFill>
+                <a:latin typeface="Calibri"/>
+              </a:rPr>
               <a:t>7</a:t>
             </a:r>
           </a:p>
@@ -7423,7 +8141,7 @@
 </p:sld>
 </file>
 
-<file path=ppt/slides/slide15.xml><?xml version="1.0" encoding="utf-8"?>
+<file path=ppt/slides/slide17.xml><?xml version="1.0" encoding="utf-8"?>
 <p:sld xmlns:a="http://schemas.openxmlformats.org/drawingml/2006/main" xmlns:p="http://schemas.openxmlformats.org/presentationml/2006/main" xmlns:r="http://schemas.openxmlformats.org/officeDocument/2006/relationships">
   <p:cSld>
     <p:bg>
@@ -7942,7 +8660,7 @@
 </p:sld>
 </file>
 
-<file path=ppt/slides/slide16.xml><?xml version="1.0" encoding="utf-8"?>
+<file path=ppt/slides/slide18.xml><?xml version="1.0" encoding="utf-8"?>
 <p:sld xmlns:a="http://schemas.openxmlformats.org/drawingml/2006/main" xmlns:p="http://schemas.openxmlformats.org/presentationml/2006/main" xmlns:r="http://schemas.openxmlformats.org/officeDocument/2006/relationships">
   <p:cSld>
     <p:bg>
@@ -8263,7 +8981,7 @@
 </p:sld>
 </file>
 
-<file path=ppt/slides/slide17.xml><?xml version="1.0" encoding="utf-8"?>
+<file path=ppt/slides/slide19.xml><?xml version="1.0" encoding="utf-8"?>
 <p:sld xmlns:a="http://schemas.openxmlformats.org/drawingml/2006/main" xmlns:p="http://schemas.openxmlformats.org/presentationml/2006/main" xmlns:r="http://schemas.openxmlformats.org/officeDocument/2006/relationships">
   <p:cSld>
     <p:bg>
@@ -8879,7 +9597,7 @@
 </p:sld>
 </file>
 
-<file path=ppt/slides/slide18.xml><?xml version="1.0" encoding="utf-8"?>
+<file path=ppt/slides/slide2.xml><?xml version="1.0" encoding="utf-8"?>
 <p:sld xmlns:a="http://schemas.openxmlformats.org/drawingml/2006/main" xmlns:p="http://schemas.openxmlformats.org/presentationml/2006/main" xmlns:r="http://schemas.openxmlformats.org/officeDocument/2006/relationships">
   <p:cSld>
     <p:bg>
@@ -8943,6 +9661,380 @@
       </p:sp>
       <p:sp>
         <p:nvSpPr>
+          <p:cNvPr id="3" name="TextBox 2"/>
+          <p:cNvSpPr txBox="1"/>
+          <p:nvPr/>
+        </p:nvSpPr>
+        <p:spPr>
+          <a:xfrm>
+            <a:off x="457200" y="164592"/>
+            <a:ext cx="11460175" cy="731520"/>
+          </a:xfrm>
+          <a:prstGeom prst="rect">
+            <a:avLst/>
+          </a:prstGeom>
+          <a:noFill/>
+        </p:spPr>
+        <p:txBody>
+          <a:bodyPr wrap="square" anchor="ctr">
+            <a:spAutoFit/>
+          </a:bodyPr>
+          <a:lstStyle/>
+          <a:p>
+            <a:r>
+              <a:rPr sz="3000" b="1" i="0">
+                <a:solidFill>
+                  <a:srgbClr val="FFFFFF"/>
+                </a:solidFill>
+                <a:latin typeface="Calibri"/>
+              </a:rPr>
+              <a:t>Plan de la présentation</a:t>
+            </a:r>
+          </a:p>
+        </p:txBody>
+      </p:sp>
+      <p:sp>
+        <p:nvSpPr>
+          <p:cNvPr id="4" name="TextBox 3"/>
+          <p:cNvSpPr txBox="1"/>
+          <p:nvPr/>
+        </p:nvSpPr>
+        <p:spPr>
+          <a:xfrm>
+            <a:off x="640080" y="1463040"/>
+            <a:ext cx="5486400" cy="4937760"/>
+          </a:xfrm>
+          <a:prstGeom prst="rect">
+            <a:avLst/>
+          </a:prstGeom>
+          <a:noFill/>
+        </p:spPr>
+        <p:txBody>
+          <a:bodyPr wrap="square">
+            <a:spAutoFit/>
+          </a:bodyPr>
+          <a:lstStyle/>
+          <a:p>
+            <a:pPr>
+              <a:spcAft>
+                <a:spcPts val="1200"/>
+              </a:spcAft>
+            </a:pPr>
+            <a:r>
+              <a:rPr sz="2000" b="1" i="0">
+                <a:solidFill>
+                  <a:srgbClr val="0D3B66"/>
+                </a:solidFill>
+                <a:latin typeface="Calibri"/>
+              </a:rPr>
+              <a:t>•  Introduction — L'annonce du sujet</a:t>
+            </a:r>
+          </a:p>
+          <a:p>
+            <a:pPr>
+              <a:spcAft>
+                <a:spcPts val="1200"/>
+              </a:spcAft>
+            </a:pPr>
+            <a:r>
+              <a:rPr sz="2000" b="0" i="0">
+                <a:solidFill>
+                  <a:srgbClr val="333333"/>
+                </a:solidFill>
+                <a:latin typeface="Calibri"/>
+              </a:rPr>
+              <a:t>•  1.  Contexte et identification du problème</a:t>
+            </a:r>
+          </a:p>
+          <a:p>
+            <a:pPr>
+              <a:spcAft>
+                <a:spcPts val="1200"/>
+              </a:spcAft>
+            </a:pPr>
+            <a:r>
+              <a:rPr sz="2000" b="0" i="0">
+                <a:solidFill>
+                  <a:srgbClr val="333333"/>
+                </a:solidFill>
+                <a:latin typeface="Calibri"/>
+              </a:rPr>
+              <a:t>•  2.  Objectifs et résultats attendus</a:t>
+            </a:r>
+          </a:p>
+          <a:p>
+            <a:pPr>
+              <a:spcAft>
+                <a:spcPts val="1200"/>
+              </a:spcAft>
+            </a:pPr>
+            <a:r>
+              <a:rPr sz="2000" b="0" i="0">
+                <a:solidFill>
+                  <a:srgbClr val="333333"/>
+                </a:solidFill>
+                <a:latin typeface="Calibri"/>
+              </a:rPr>
+              <a:t>•  3.  Démarche méthodologique</a:t>
+            </a:r>
+          </a:p>
+          <a:p>
+            <a:pPr>
+              <a:spcAft>
+                <a:spcPts val="1200"/>
+              </a:spcAft>
+            </a:pPr>
+            <a:r>
+              <a:rPr sz="2000" b="0" i="0">
+                <a:solidFill>
+                  <a:srgbClr val="333333"/>
+                </a:solidFill>
+                <a:latin typeface="Calibri"/>
+              </a:rPr>
+              <a:t>•  4.  État des lieux &amp; solution proposée</a:t>
+            </a:r>
+          </a:p>
+          <a:p>
+            <a:pPr>
+              <a:spcAft>
+                <a:spcPts val="1200"/>
+              </a:spcAft>
+            </a:pPr>
+            <a:r>
+              <a:rPr sz="2000" b="0" i="0">
+                <a:solidFill>
+                  <a:srgbClr val="333333"/>
+                </a:solidFill>
+                <a:latin typeface="Calibri"/>
+              </a:rPr>
+              <a:t>•  5.  Axe de différenciation (innovation)</a:t>
+            </a:r>
+          </a:p>
+          <a:p>
+            <a:pPr>
+              <a:spcAft>
+                <a:spcPts val="1200"/>
+              </a:spcAft>
+            </a:pPr>
+            <a:r>
+              <a:rPr sz="2000" b="0" i="0">
+                <a:solidFill>
+                  <a:srgbClr val="333333"/>
+                </a:solidFill>
+                <a:latin typeface="Calibri"/>
+              </a:rPr>
+              <a:t>•  6.  Étude de faisabilité &amp; conception</a:t>
+            </a:r>
+          </a:p>
+        </p:txBody>
+      </p:sp>
+      <p:sp>
+        <p:nvSpPr>
+          <p:cNvPr id="5" name="TextBox 4"/>
+          <p:cNvSpPr txBox="1"/>
+          <p:nvPr/>
+        </p:nvSpPr>
+        <p:spPr>
+          <a:xfrm>
+            <a:off x="6309360" y="1463040"/>
+            <a:ext cx="5486400" cy="4937760"/>
+          </a:xfrm>
+          <a:prstGeom prst="rect">
+            <a:avLst/>
+          </a:prstGeom>
+          <a:noFill/>
+        </p:spPr>
+        <p:txBody>
+          <a:bodyPr wrap="square">
+            <a:spAutoFit/>
+          </a:bodyPr>
+          <a:lstStyle/>
+          <a:p>
+            <a:pPr>
+              <a:spcAft>
+                <a:spcPts val="1200"/>
+              </a:spcAft>
+            </a:pPr>
+            <a:r>
+              <a:rPr sz="2000" b="0" i="0">
+                <a:solidFill>
+                  <a:srgbClr val="333333"/>
+                </a:solidFill>
+                <a:latin typeface="Calibri"/>
+              </a:rPr>
+              <a:t>•  7.  Fonctionnement technique</a:t>
+            </a:r>
+          </a:p>
+          <a:p>
+            <a:pPr>
+              <a:spcAft>
+                <a:spcPts val="1200"/>
+              </a:spcAft>
+            </a:pPr>
+            <a:r>
+              <a:rPr sz="2000" b="1" i="0">
+                <a:solidFill>
+                  <a:srgbClr val="D62828"/>
+                </a:solidFill>
+                <a:latin typeface="Calibri"/>
+              </a:rPr>
+              <a:t>•  8.  Démonstration</a:t>
+            </a:r>
+          </a:p>
+          <a:p>
+            <a:pPr>
+              <a:spcAft>
+                <a:spcPts val="1200"/>
+              </a:spcAft>
+            </a:pPr>
+            <a:r>
+              <a:rPr sz="2000" b="0" i="0">
+                <a:solidFill>
+                  <a:srgbClr val="333333"/>
+                </a:solidFill>
+                <a:latin typeface="Calibri"/>
+              </a:rPr>
+              <a:t>•  9.  Marketing, vente &amp; concurrence</a:t>
+            </a:r>
+          </a:p>
+          <a:p>
+            <a:pPr>
+              <a:spcAft>
+                <a:spcPts val="1200"/>
+              </a:spcAft>
+            </a:pPr>
+            <a:r>
+              <a:rPr sz="2000" b="0" i="0">
+                <a:solidFill>
+                  <a:srgbClr val="333333"/>
+                </a:solidFill>
+                <a:latin typeface="Calibri"/>
+              </a:rPr>
+              <a:t>•  10. Prévisions financières</a:t>
+            </a:r>
+          </a:p>
+          <a:p>
+            <a:pPr>
+              <a:spcAft>
+                <a:spcPts val="1200"/>
+              </a:spcAft>
+            </a:pPr>
+            <a:r>
+              <a:rPr sz="2000" b="0" i="0">
+                <a:solidFill>
+                  <a:srgbClr val="333333"/>
+                </a:solidFill>
+                <a:latin typeface="Calibri"/>
+              </a:rPr>
+              <a:t>•  11. Limites &amp; perspectives</a:t>
+            </a:r>
+          </a:p>
+          <a:p>
+            <a:pPr>
+              <a:spcAft>
+                <a:spcPts val="1200"/>
+              </a:spcAft>
+            </a:pPr>
+            <a:r>
+              <a:rPr sz="2000" b="0" i="0">
+                <a:solidFill>
+                  <a:srgbClr val="333333"/>
+                </a:solidFill>
+                <a:latin typeface="Calibri"/>
+              </a:rPr>
+              <a:t/>
+            </a:r>
+          </a:p>
+          <a:p>
+            <a:pPr>
+              <a:spcAft>
+                <a:spcPts val="1200"/>
+              </a:spcAft>
+            </a:pPr>
+            <a:r>
+              <a:rPr sz="2000" b="1" i="0">
+                <a:solidFill>
+                  <a:srgbClr val="0D3B66"/>
+                </a:solidFill>
+                <a:latin typeface="Calibri"/>
+              </a:rPr>
+              <a:t>•  Conclusion</a:t>
+            </a:r>
+          </a:p>
+        </p:txBody>
+      </p:sp>
+    </p:spTree>
+  </p:cSld>
+  <p:clrMapOvr>
+    <a:masterClrMapping/>
+  </p:clrMapOvr>
+</p:sld>
+</file>
+
+<file path=ppt/slides/slide20.xml><?xml version="1.0" encoding="utf-8"?>
+<p:sld xmlns:a="http://schemas.openxmlformats.org/drawingml/2006/main" xmlns:p="http://schemas.openxmlformats.org/presentationml/2006/main" xmlns:r="http://schemas.openxmlformats.org/officeDocument/2006/relationships">
+  <p:cSld>
+    <p:bg>
+      <p:bgPr>
+        <a:solidFill>
+          <a:srgbClr val="FFFFFF"/>
+        </a:solidFill>
+        <a:effectLst/>
+      </p:bgPr>
+    </p:bg>
+    <p:spTree>
+      <p:nvGrpSpPr>
+        <p:cNvPr id="1" name=""/>
+        <p:cNvGrpSpPr/>
+        <p:nvPr/>
+      </p:nvGrpSpPr>
+      <p:grpSpPr/>
+      <p:sp>
+        <p:nvSpPr>
+          <p:cNvPr id="2" name="Rectangle 1"/>
+          <p:cNvSpPr/>
+          <p:nvPr/>
+        </p:nvSpPr>
+        <p:spPr>
+          <a:xfrm>
+            <a:off x="0" y="0"/>
+            <a:ext cx="12191695" cy="1051560"/>
+          </a:xfrm>
+          <a:prstGeom prst="rect">
+            <a:avLst/>
+          </a:prstGeom>
+          <a:solidFill>
+            <a:srgbClr val="0D3B66"/>
+          </a:solidFill>
+          <a:ln>
+            <a:noFill/>
+          </a:ln>
+          <a:effectLst/>
+        </p:spPr>
+        <p:style>
+          <a:lnRef idx="1">
+            <a:schemeClr val="accent1"/>
+          </a:lnRef>
+          <a:fillRef idx="3">
+            <a:schemeClr val="accent1"/>
+          </a:fillRef>
+          <a:effectRef idx="2">
+            <a:schemeClr val="accent1"/>
+          </a:effectRef>
+          <a:fontRef idx="minor">
+            <a:schemeClr val="lt1"/>
+          </a:fontRef>
+        </p:style>
+        <p:txBody>
+          <a:bodyPr rtlCol="0" anchor="ctr"/>
+          <a:lstStyle/>
+          <a:p>
+            <a:pPr algn="ctr"/>
+          </a:p>
+        </p:txBody>
+      </p:sp>
+      <p:sp>
+        <p:nvSpPr>
           <p:cNvPr id="3" name="Oval 2"/>
           <p:cNvSpPr/>
           <p:nvPr/>
@@ -9203,7 +10295,7 @@
 </p:sld>
 </file>
 
-<file path=ppt/slides/slide19.xml><?xml version="1.0" encoding="utf-8"?>
+<file path=ppt/slides/slide21.xml><?xml version="1.0" encoding="utf-8"?>
 <p:sld xmlns:a="http://schemas.openxmlformats.org/drawingml/2006/main" xmlns:p="http://schemas.openxmlformats.org/presentationml/2006/main" xmlns:r="http://schemas.openxmlformats.org/officeDocument/2006/relationships">
   <p:cSld>
     <p:bg>
@@ -10049,381 +11141,7 @@
 </p:sld>
 </file>
 
-<file path=ppt/slides/slide2.xml><?xml version="1.0" encoding="utf-8"?>
-<p:sld xmlns:a="http://schemas.openxmlformats.org/drawingml/2006/main" xmlns:p="http://schemas.openxmlformats.org/presentationml/2006/main" xmlns:r="http://schemas.openxmlformats.org/officeDocument/2006/relationships">
-  <p:cSld>
-    <p:bg>
-      <p:bgPr>
-        <a:solidFill>
-          <a:srgbClr val="FFFFFF"/>
-        </a:solidFill>
-        <a:effectLst/>
-      </p:bgPr>
-    </p:bg>
-    <p:spTree>
-      <p:nvGrpSpPr>
-        <p:cNvPr id="1" name=""/>
-        <p:cNvGrpSpPr/>
-        <p:nvPr/>
-      </p:nvGrpSpPr>
-      <p:grpSpPr/>
-      <p:sp>
-        <p:nvSpPr>
-          <p:cNvPr id="2" name="Rectangle 1"/>
-          <p:cNvSpPr/>
-          <p:nvPr/>
-        </p:nvSpPr>
-        <p:spPr>
-          <a:xfrm>
-            <a:off x="0" y="0"/>
-            <a:ext cx="12191695" cy="1051560"/>
-          </a:xfrm>
-          <a:prstGeom prst="rect">
-            <a:avLst/>
-          </a:prstGeom>
-          <a:solidFill>
-            <a:srgbClr val="0D3B66"/>
-          </a:solidFill>
-          <a:ln>
-            <a:noFill/>
-          </a:ln>
-          <a:effectLst/>
-        </p:spPr>
-        <p:style>
-          <a:lnRef idx="1">
-            <a:schemeClr val="accent1"/>
-          </a:lnRef>
-          <a:fillRef idx="3">
-            <a:schemeClr val="accent1"/>
-          </a:fillRef>
-          <a:effectRef idx="2">
-            <a:schemeClr val="accent1"/>
-          </a:effectRef>
-          <a:fontRef idx="minor">
-            <a:schemeClr val="lt1"/>
-          </a:fontRef>
-        </p:style>
-        <p:txBody>
-          <a:bodyPr rtlCol="0" anchor="ctr"/>
-          <a:lstStyle/>
-          <a:p>
-            <a:pPr algn="ctr"/>
-          </a:p>
-        </p:txBody>
-      </p:sp>
-      <p:sp>
-        <p:nvSpPr>
-          <p:cNvPr id="3" name="TextBox 2"/>
-          <p:cNvSpPr txBox="1"/>
-          <p:nvPr/>
-        </p:nvSpPr>
-        <p:spPr>
-          <a:xfrm>
-            <a:off x="457200" y="164592"/>
-            <a:ext cx="11460175" cy="731520"/>
-          </a:xfrm>
-          <a:prstGeom prst="rect">
-            <a:avLst/>
-          </a:prstGeom>
-          <a:noFill/>
-        </p:spPr>
-        <p:txBody>
-          <a:bodyPr wrap="square" anchor="ctr">
-            <a:spAutoFit/>
-          </a:bodyPr>
-          <a:lstStyle/>
-          <a:p>
-            <a:r>
-              <a:rPr sz="3000" b="1" i="0">
-                <a:solidFill>
-                  <a:srgbClr val="FFFFFF"/>
-                </a:solidFill>
-                <a:latin typeface="Calibri"/>
-              </a:rPr>
-              <a:t>Plan de la présentation</a:t>
-            </a:r>
-          </a:p>
-        </p:txBody>
-      </p:sp>
-      <p:sp>
-        <p:nvSpPr>
-          <p:cNvPr id="4" name="TextBox 3"/>
-          <p:cNvSpPr txBox="1"/>
-          <p:nvPr/>
-        </p:nvSpPr>
-        <p:spPr>
-          <a:xfrm>
-            <a:off x="640080" y="1463040"/>
-            <a:ext cx="5486400" cy="4937760"/>
-          </a:xfrm>
-          <a:prstGeom prst="rect">
-            <a:avLst/>
-          </a:prstGeom>
-          <a:noFill/>
-        </p:spPr>
-        <p:txBody>
-          <a:bodyPr wrap="square">
-            <a:spAutoFit/>
-          </a:bodyPr>
-          <a:lstStyle/>
-          <a:p>
-            <a:pPr>
-              <a:spcAft>
-                <a:spcPts val="1200"/>
-              </a:spcAft>
-            </a:pPr>
-            <a:r>
-              <a:rPr sz="2000" b="1" i="0">
-                <a:solidFill>
-                  <a:srgbClr val="0D3B66"/>
-                </a:solidFill>
-                <a:latin typeface="Calibri"/>
-              </a:rPr>
-              <a:t>•  Introduction — L'annonce du sujet</a:t>
-            </a:r>
-          </a:p>
-          <a:p>
-            <a:pPr>
-              <a:spcAft>
-                <a:spcPts val="1200"/>
-              </a:spcAft>
-            </a:pPr>
-            <a:r>
-              <a:rPr sz="2000" b="0" i="0">
-                <a:solidFill>
-                  <a:srgbClr val="333333"/>
-                </a:solidFill>
-                <a:latin typeface="Calibri"/>
-              </a:rPr>
-              <a:t>•  1.  Contexte et identification du problème</a:t>
-            </a:r>
-          </a:p>
-          <a:p>
-            <a:pPr>
-              <a:spcAft>
-                <a:spcPts val="1200"/>
-              </a:spcAft>
-            </a:pPr>
-            <a:r>
-              <a:rPr sz="2000" b="0" i="0">
-                <a:solidFill>
-                  <a:srgbClr val="333333"/>
-                </a:solidFill>
-                <a:latin typeface="Calibri"/>
-              </a:rPr>
-              <a:t>•  2.  Objectifs et résultats attendus</a:t>
-            </a:r>
-          </a:p>
-          <a:p>
-            <a:pPr>
-              <a:spcAft>
-                <a:spcPts val="1200"/>
-              </a:spcAft>
-            </a:pPr>
-            <a:r>
-              <a:rPr sz="2000" b="0" i="0">
-                <a:solidFill>
-                  <a:srgbClr val="333333"/>
-                </a:solidFill>
-                <a:latin typeface="Calibri"/>
-              </a:rPr>
-              <a:t>•  3.  Démarche méthodologique</a:t>
-            </a:r>
-          </a:p>
-          <a:p>
-            <a:pPr>
-              <a:spcAft>
-                <a:spcPts val="1200"/>
-              </a:spcAft>
-            </a:pPr>
-            <a:r>
-              <a:rPr sz="2000" b="0" i="0">
-                <a:solidFill>
-                  <a:srgbClr val="333333"/>
-                </a:solidFill>
-                <a:latin typeface="Calibri"/>
-              </a:rPr>
-              <a:t>•  4.  État des lieux &amp; solution proposée</a:t>
-            </a:r>
-          </a:p>
-          <a:p>
-            <a:pPr>
-              <a:spcAft>
-                <a:spcPts val="1200"/>
-              </a:spcAft>
-            </a:pPr>
-            <a:r>
-              <a:rPr sz="2000" b="0" i="0">
-                <a:solidFill>
-                  <a:srgbClr val="333333"/>
-                </a:solidFill>
-                <a:latin typeface="Calibri"/>
-              </a:rPr>
-              <a:t>•  5.  Axe de différenciation (innovation)</a:t>
-            </a:r>
-          </a:p>
-          <a:p>
-            <a:pPr>
-              <a:spcAft>
-                <a:spcPts val="1200"/>
-              </a:spcAft>
-            </a:pPr>
-            <a:r>
-              <a:rPr sz="2000" b="0" i="0">
-                <a:solidFill>
-                  <a:srgbClr val="333333"/>
-                </a:solidFill>
-                <a:latin typeface="Calibri"/>
-              </a:rPr>
-              <a:t>•  6.  Étude de faisabilité &amp; conception</a:t>
-            </a:r>
-          </a:p>
-        </p:txBody>
-      </p:sp>
-      <p:sp>
-        <p:nvSpPr>
-          <p:cNvPr id="5" name="TextBox 4"/>
-          <p:cNvSpPr txBox="1"/>
-          <p:nvPr/>
-        </p:nvSpPr>
-        <p:spPr>
-          <a:xfrm>
-            <a:off x="6309360" y="1463040"/>
-            <a:ext cx="5486400" cy="4937760"/>
-          </a:xfrm>
-          <a:prstGeom prst="rect">
-            <a:avLst/>
-          </a:prstGeom>
-          <a:noFill/>
-        </p:spPr>
-        <p:txBody>
-          <a:bodyPr wrap="square">
-            <a:spAutoFit/>
-          </a:bodyPr>
-          <a:lstStyle/>
-          <a:p>
-            <a:pPr>
-              <a:spcAft>
-                <a:spcPts val="1200"/>
-              </a:spcAft>
-            </a:pPr>
-            <a:r>
-              <a:rPr sz="2000" b="0" i="0">
-                <a:solidFill>
-                  <a:srgbClr val="333333"/>
-                </a:solidFill>
-                <a:latin typeface="Calibri"/>
-              </a:rPr>
-              <a:t>•  7.  Fonctionnement technique</a:t>
-            </a:r>
-          </a:p>
-          <a:p>
-            <a:pPr>
-              <a:spcAft>
-                <a:spcPts val="1200"/>
-              </a:spcAft>
-            </a:pPr>
-            <a:r>
-              <a:rPr sz="2000" b="1" i="0">
-                <a:solidFill>
-                  <a:srgbClr val="D62828"/>
-                </a:solidFill>
-                <a:latin typeface="Calibri"/>
-              </a:rPr>
-              <a:t>•  8.  Démonstration</a:t>
-            </a:r>
-          </a:p>
-          <a:p>
-            <a:pPr>
-              <a:spcAft>
-                <a:spcPts val="1200"/>
-              </a:spcAft>
-            </a:pPr>
-            <a:r>
-              <a:rPr sz="2000" b="0" i="0">
-                <a:solidFill>
-                  <a:srgbClr val="333333"/>
-                </a:solidFill>
-                <a:latin typeface="Calibri"/>
-              </a:rPr>
-              <a:t>•  9.  Marketing, vente &amp; concurrence</a:t>
-            </a:r>
-          </a:p>
-          <a:p>
-            <a:pPr>
-              <a:spcAft>
-                <a:spcPts val="1200"/>
-              </a:spcAft>
-            </a:pPr>
-            <a:r>
-              <a:rPr sz="2000" b="0" i="0">
-                <a:solidFill>
-                  <a:srgbClr val="333333"/>
-                </a:solidFill>
-                <a:latin typeface="Calibri"/>
-              </a:rPr>
-              <a:t>•  10. Prévisions financières</a:t>
-            </a:r>
-          </a:p>
-          <a:p>
-            <a:pPr>
-              <a:spcAft>
-                <a:spcPts val="1200"/>
-              </a:spcAft>
-            </a:pPr>
-            <a:r>
-              <a:rPr sz="2000" b="0" i="0">
-                <a:solidFill>
-                  <a:srgbClr val="333333"/>
-                </a:solidFill>
-                <a:latin typeface="Calibri"/>
-              </a:rPr>
-              <a:t>•  11. Limites &amp; perspectives</a:t>
-            </a:r>
-          </a:p>
-          <a:p>
-            <a:pPr>
-              <a:spcAft>
-                <a:spcPts val="1200"/>
-              </a:spcAft>
-            </a:pPr>
-            <a:r>
-              <a:rPr sz="2000" b="0" i="0">
-                <a:solidFill>
-                  <a:srgbClr val="333333"/>
-                </a:solidFill>
-                <a:latin typeface="Calibri"/>
-              </a:rPr>
-              <a:t/>
-            </a:r>
-          </a:p>
-          <a:p>
-            <a:pPr>
-              <a:spcAft>
-                <a:spcPts val="1200"/>
-              </a:spcAft>
-            </a:pPr>
-            <a:r>
-              <a:rPr sz="2000" b="1" i="0">
-                <a:solidFill>
-                  <a:srgbClr val="0D3B66"/>
-                </a:solidFill>
-                <a:latin typeface="Calibri"/>
-              </a:rPr>
-              <a:t>•  Conclusion</a:t>
-            </a:r>
-          </a:p>
-        </p:txBody>
-      </p:sp>
-    </p:spTree>
-  </p:cSld>
-  <p:clrMapOvr>
-    <a:masterClrMapping/>
-  </p:clrMapOvr>
-</p:sld>
-</file>
-
-<file path=ppt/slides/slide20.xml><?xml version="1.0" encoding="utf-8"?>
+<file path=ppt/slides/slide22.xml><?xml version="1.0" encoding="utf-8"?>
 <p:sld xmlns:a="http://schemas.openxmlformats.org/drawingml/2006/main" xmlns:p="http://schemas.openxmlformats.org/presentationml/2006/main" xmlns:r="http://schemas.openxmlformats.org/officeDocument/2006/relationships">
   <p:cSld>
     <p:bg>
@@ -11393,7 +12111,7 @@
 </p:sld>
 </file>
 
-<file path=ppt/slides/slide21.xml><?xml version="1.0" encoding="utf-8"?>
+<file path=ppt/slides/slide23.xml><?xml version="1.0" encoding="utf-8"?>
 <p:sld xmlns:a="http://schemas.openxmlformats.org/drawingml/2006/main" xmlns:p="http://schemas.openxmlformats.org/presentationml/2006/main" xmlns:r="http://schemas.openxmlformats.org/officeDocument/2006/relationships">
   <p:cSld>
     <p:bg>
@@ -11749,7 +12467,7 @@
 </p:sld>
 </file>
 
-<file path=ppt/slides/slide22.xml><?xml version="1.0" encoding="utf-8"?>
+<file path=ppt/slides/slide24.xml><?xml version="1.0" encoding="utf-8"?>
 <p:sld xmlns:a="http://schemas.openxmlformats.org/drawingml/2006/main" xmlns:p="http://schemas.openxmlformats.org/presentationml/2006/main" xmlns:r="http://schemas.openxmlformats.org/officeDocument/2006/relationships">
   <p:cSld>
     <p:bg>
@@ -12037,7 +12755,7 @@
 </p:sld>
 </file>
 
-<file path=ppt/slides/slide23.xml><?xml version="1.0" encoding="utf-8"?>
+<file path=ppt/slides/slide25.xml><?xml version="1.0" encoding="utf-8"?>
 <p:sld xmlns:a="http://schemas.openxmlformats.org/drawingml/2006/main" xmlns:p="http://schemas.openxmlformats.org/presentationml/2006/main" xmlns:r="http://schemas.openxmlformats.org/officeDocument/2006/relationships">
   <p:cSld>
     <p:bg>
@@ -12115,6 +12833,463 @@
           </a:p>
         </p:txBody>
       </p:sp>
+    </p:spTree>
+  </p:cSld>
+  <p:clrMapOvr>
+    <a:masterClrMapping/>
+  </p:clrMapOvr>
+</p:sld>
+</file>
+
+<file path=ppt/slides/slide26.xml><?xml version="1.0" encoding="utf-8"?>
+<p:sld xmlns:a="http://schemas.openxmlformats.org/drawingml/2006/main" xmlns:p="http://schemas.openxmlformats.org/presentationml/2006/main" xmlns:r="http://schemas.openxmlformats.org/officeDocument/2006/relationships">
+  <p:cSld>
+    <p:bg>
+      <p:bgPr>
+        <a:solidFill>
+          <a:srgbClr val="0D3B66"/>
+        </a:solidFill>
+        <a:effectLst/>
+      </p:bgPr>
+    </p:bg>
+    <p:spTree>
+      <p:nvGrpSpPr>
+        <p:cNvPr id="1" name=""/>
+        <p:cNvGrpSpPr/>
+        <p:nvPr/>
+      </p:nvGrpSpPr>
+      <p:grpSpPr/>
+      <p:sp>
+        <p:nvSpPr>
+          <p:cNvPr id="2" name="TextBox 1"/>
+          <p:cNvSpPr txBox="1"/>
+          <p:nvPr/>
+        </p:nvSpPr>
+        <p:spPr>
+          <a:xfrm>
+            <a:off x="914400" y="2743200"/>
+            <a:ext cx="10332720" cy="1371600"/>
+          </a:xfrm>
+          <a:prstGeom prst="rect">
+            <a:avLst/>
+          </a:prstGeom>
+          <a:noFill/>
+        </p:spPr>
+        <p:txBody>
+          <a:bodyPr wrap="square" anchor="ctr">
+            <a:spAutoFit/>
+          </a:bodyPr>
+          <a:lstStyle/>
+          <a:p>
+            <a:pPr algn="ctr"/>
+            <a:r>
+              <a:rPr sz="3000" b="1" i="0">
+                <a:solidFill>
+                  <a:srgbClr val="FFFFFF"/>
+                </a:solidFill>
+                <a:latin typeface="Calibri"/>
+              </a:rPr>
+              <a:t>ANNEXES — Diagrammes de conception détaillés</a:t>
+            </a:r>
+          </a:p>
+          <a:p>
+            <a:pPr algn="ctr"/>
+            <a:r>
+              <a:rPr sz="1600" b="0" i="1">
+                <a:solidFill>
+                  <a:srgbClr val="DDE6F2"/>
+                </a:solidFill>
+                <a:latin typeface="Calibri"/>
+              </a:rPr>
+              <a:t>Diapositives de secours pour les questions du jury</a:t>
+            </a:r>
+          </a:p>
+        </p:txBody>
+      </p:sp>
+    </p:spTree>
+  </p:cSld>
+  <p:clrMapOvr>
+    <a:masterClrMapping/>
+  </p:clrMapOvr>
+</p:sld>
+</file>
+
+<file path=ppt/slides/slide27.xml><?xml version="1.0" encoding="utf-8"?>
+<p:sld xmlns:a="http://schemas.openxmlformats.org/drawingml/2006/main" xmlns:p="http://schemas.openxmlformats.org/presentationml/2006/main" xmlns:r="http://schemas.openxmlformats.org/officeDocument/2006/relationships">
+  <p:cSld>
+    <p:bg>
+      <p:bgPr>
+        <a:solidFill>
+          <a:srgbClr val="FFFFFF"/>
+        </a:solidFill>
+        <a:effectLst/>
+      </p:bgPr>
+    </p:bg>
+    <p:spTree>
+      <p:nvGrpSpPr>
+        <p:cNvPr id="1" name=""/>
+        <p:cNvGrpSpPr/>
+        <p:nvPr/>
+      </p:nvGrpSpPr>
+      <p:grpSpPr/>
+      <p:sp>
+        <p:nvSpPr>
+          <p:cNvPr id="2" name="Rectangle 1"/>
+          <p:cNvSpPr/>
+          <p:nvPr/>
+        </p:nvSpPr>
+        <p:spPr>
+          <a:xfrm>
+            <a:off x="0" y="0"/>
+            <a:ext cx="12191695" cy="1051560"/>
+          </a:xfrm>
+          <a:prstGeom prst="rect">
+            <a:avLst/>
+          </a:prstGeom>
+          <a:solidFill>
+            <a:srgbClr val="0D3B66"/>
+          </a:solidFill>
+          <a:ln>
+            <a:noFill/>
+          </a:ln>
+          <a:effectLst/>
+        </p:spPr>
+        <p:style>
+          <a:lnRef idx="1">
+            <a:schemeClr val="accent1"/>
+          </a:lnRef>
+          <a:fillRef idx="3">
+            <a:schemeClr val="accent1"/>
+          </a:fillRef>
+          <a:effectRef idx="2">
+            <a:schemeClr val="accent1"/>
+          </a:effectRef>
+          <a:fontRef idx="minor">
+            <a:schemeClr val="lt1"/>
+          </a:fontRef>
+        </p:style>
+        <p:txBody>
+          <a:bodyPr rtlCol="0" anchor="ctr"/>
+          <a:lstStyle/>
+          <a:p>
+            <a:pPr algn="ctr"/>
+          </a:p>
+        </p:txBody>
+      </p:sp>
+      <p:sp>
+        <p:nvSpPr>
+          <p:cNvPr id="3" name="TextBox 2"/>
+          <p:cNvSpPr txBox="1"/>
+          <p:nvPr/>
+        </p:nvSpPr>
+        <p:spPr>
+          <a:xfrm>
+            <a:off x="457200" y="164592"/>
+            <a:ext cx="11460175" cy="731520"/>
+          </a:xfrm>
+          <a:prstGeom prst="rect">
+            <a:avLst/>
+          </a:prstGeom>
+          <a:noFill/>
+        </p:spPr>
+        <p:txBody>
+          <a:bodyPr wrap="square" anchor="ctr">
+            <a:spAutoFit/>
+          </a:bodyPr>
+          <a:lstStyle/>
+          <a:p>
+            <a:r>
+              <a:rPr sz="3000" b="1" i="0">
+                <a:solidFill>
+                  <a:srgbClr val="FFFFFF"/>
+                </a:solidFill>
+                <a:latin typeface="Calibri"/>
+              </a:rPr>
+              <a:t>Annexe — Diagramme de contexte</a:t>
+            </a:r>
+          </a:p>
+        </p:txBody>
+      </p:sp>
+      <p:pic>
+        <p:nvPicPr>
+          <p:cNvPr id="4" name="Picture 3" descr="diagramme-contexte.png"/>
+          <p:cNvPicPr>
+            <a:picLocks noChangeAspect="1"/>
+          </p:cNvPicPr>
+          <p:nvPr/>
+        </p:nvPicPr>
+        <p:blipFill>
+          <a:blip r:embed="rId2"/>
+          <a:stretch>
+            <a:fillRect/>
+          </a:stretch>
+        </p:blipFill>
+        <p:spPr>
+          <a:xfrm>
+            <a:off x="700887" y="1234440"/>
+            <a:ext cx="10789920" cy="3854309"/>
+          </a:xfrm>
+          <a:prstGeom prst="rect">
+            <a:avLst/>
+          </a:prstGeom>
+        </p:spPr>
+      </p:pic>
+    </p:spTree>
+  </p:cSld>
+  <p:clrMapOvr>
+    <a:masterClrMapping/>
+  </p:clrMapOvr>
+</p:sld>
+</file>
+
+<file path=ppt/slides/slide28.xml><?xml version="1.0" encoding="utf-8"?>
+<p:sld xmlns:a="http://schemas.openxmlformats.org/drawingml/2006/main" xmlns:p="http://schemas.openxmlformats.org/presentationml/2006/main" xmlns:r="http://schemas.openxmlformats.org/officeDocument/2006/relationships">
+  <p:cSld>
+    <p:bg>
+      <p:bgPr>
+        <a:solidFill>
+          <a:srgbClr val="FFFFFF"/>
+        </a:solidFill>
+        <a:effectLst/>
+      </p:bgPr>
+    </p:bg>
+    <p:spTree>
+      <p:nvGrpSpPr>
+        <p:cNvPr id="1" name=""/>
+        <p:cNvGrpSpPr/>
+        <p:nvPr/>
+      </p:nvGrpSpPr>
+      <p:grpSpPr/>
+      <p:sp>
+        <p:nvSpPr>
+          <p:cNvPr id="2" name="Rectangle 1"/>
+          <p:cNvSpPr/>
+          <p:nvPr/>
+        </p:nvSpPr>
+        <p:spPr>
+          <a:xfrm>
+            <a:off x="0" y="0"/>
+            <a:ext cx="12191695" cy="1051560"/>
+          </a:xfrm>
+          <a:prstGeom prst="rect">
+            <a:avLst/>
+          </a:prstGeom>
+          <a:solidFill>
+            <a:srgbClr val="0D3B66"/>
+          </a:solidFill>
+          <a:ln>
+            <a:noFill/>
+          </a:ln>
+          <a:effectLst/>
+        </p:spPr>
+        <p:style>
+          <a:lnRef idx="1">
+            <a:schemeClr val="accent1"/>
+          </a:lnRef>
+          <a:fillRef idx="3">
+            <a:schemeClr val="accent1"/>
+          </a:fillRef>
+          <a:effectRef idx="2">
+            <a:schemeClr val="accent1"/>
+          </a:effectRef>
+          <a:fontRef idx="minor">
+            <a:schemeClr val="lt1"/>
+          </a:fontRef>
+        </p:style>
+        <p:txBody>
+          <a:bodyPr rtlCol="0" anchor="ctr"/>
+          <a:lstStyle/>
+          <a:p>
+            <a:pPr algn="ctr"/>
+          </a:p>
+        </p:txBody>
+      </p:sp>
+      <p:sp>
+        <p:nvSpPr>
+          <p:cNvPr id="3" name="TextBox 2"/>
+          <p:cNvSpPr txBox="1"/>
+          <p:nvPr/>
+        </p:nvSpPr>
+        <p:spPr>
+          <a:xfrm>
+            <a:off x="457200" y="164592"/>
+            <a:ext cx="11460175" cy="731520"/>
+          </a:xfrm>
+          <a:prstGeom prst="rect">
+            <a:avLst/>
+          </a:prstGeom>
+          <a:noFill/>
+        </p:spPr>
+        <p:txBody>
+          <a:bodyPr wrap="square" anchor="ctr">
+            <a:spAutoFit/>
+          </a:bodyPr>
+          <a:lstStyle/>
+          <a:p>
+            <a:r>
+              <a:rPr sz="3000" b="1" i="0">
+                <a:solidFill>
+                  <a:srgbClr val="FFFFFF"/>
+                </a:solidFill>
+                <a:latin typeface="Calibri"/>
+              </a:rPr>
+              <a:t>Annexe — Diagramme de cas d'utilisation</a:t>
+            </a:r>
+          </a:p>
+        </p:txBody>
+      </p:sp>
+      <p:pic>
+        <p:nvPicPr>
+          <p:cNvPr id="4" name="Picture 3" descr="cas-utilisation.png"/>
+          <p:cNvPicPr>
+            <a:picLocks noChangeAspect="1"/>
+          </p:cNvPicPr>
+          <p:nvPr/>
+        </p:nvPicPr>
+        <p:blipFill>
+          <a:blip r:embed="rId2"/>
+          <a:stretch>
+            <a:fillRect/>
+          </a:stretch>
+        </p:blipFill>
+        <p:spPr>
+          <a:xfrm>
+            <a:off x="700887" y="1234440"/>
+            <a:ext cx="10789920" cy="4190962"/>
+          </a:xfrm>
+          <a:prstGeom prst="rect">
+            <a:avLst/>
+          </a:prstGeom>
+        </p:spPr>
+      </p:pic>
+    </p:spTree>
+  </p:cSld>
+  <p:clrMapOvr>
+    <a:masterClrMapping/>
+  </p:clrMapOvr>
+</p:sld>
+</file>
+
+<file path=ppt/slides/slide29.xml><?xml version="1.0" encoding="utf-8"?>
+<p:sld xmlns:a="http://schemas.openxmlformats.org/drawingml/2006/main" xmlns:p="http://schemas.openxmlformats.org/presentationml/2006/main" xmlns:r="http://schemas.openxmlformats.org/officeDocument/2006/relationships">
+  <p:cSld>
+    <p:bg>
+      <p:bgPr>
+        <a:solidFill>
+          <a:srgbClr val="FFFFFF"/>
+        </a:solidFill>
+        <a:effectLst/>
+      </p:bgPr>
+    </p:bg>
+    <p:spTree>
+      <p:nvGrpSpPr>
+        <p:cNvPr id="1" name=""/>
+        <p:cNvGrpSpPr/>
+        <p:nvPr/>
+      </p:nvGrpSpPr>
+      <p:grpSpPr/>
+      <p:sp>
+        <p:nvSpPr>
+          <p:cNvPr id="2" name="Rectangle 1"/>
+          <p:cNvSpPr/>
+          <p:nvPr/>
+        </p:nvSpPr>
+        <p:spPr>
+          <a:xfrm>
+            <a:off x="0" y="0"/>
+            <a:ext cx="12191695" cy="1051560"/>
+          </a:xfrm>
+          <a:prstGeom prst="rect">
+            <a:avLst/>
+          </a:prstGeom>
+          <a:solidFill>
+            <a:srgbClr val="0D3B66"/>
+          </a:solidFill>
+          <a:ln>
+            <a:noFill/>
+          </a:ln>
+          <a:effectLst/>
+        </p:spPr>
+        <p:style>
+          <a:lnRef idx="1">
+            <a:schemeClr val="accent1"/>
+          </a:lnRef>
+          <a:fillRef idx="3">
+            <a:schemeClr val="accent1"/>
+          </a:fillRef>
+          <a:effectRef idx="2">
+            <a:schemeClr val="accent1"/>
+          </a:effectRef>
+          <a:fontRef idx="minor">
+            <a:schemeClr val="lt1"/>
+          </a:fontRef>
+        </p:style>
+        <p:txBody>
+          <a:bodyPr rtlCol="0" anchor="ctr"/>
+          <a:lstStyle/>
+          <a:p>
+            <a:pPr algn="ctr"/>
+          </a:p>
+        </p:txBody>
+      </p:sp>
+      <p:sp>
+        <p:nvSpPr>
+          <p:cNvPr id="3" name="TextBox 2"/>
+          <p:cNvSpPr txBox="1"/>
+          <p:nvPr/>
+        </p:nvSpPr>
+        <p:spPr>
+          <a:xfrm>
+            <a:off x="457200" y="164592"/>
+            <a:ext cx="11460175" cy="731520"/>
+          </a:xfrm>
+          <a:prstGeom prst="rect">
+            <a:avLst/>
+          </a:prstGeom>
+          <a:noFill/>
+        </p:spPr>
+        <p:txBody>
+          <a:bodyPr wrap="square" anchor="ctr">
+            <a:spAutoFit/>
+          </a:bodyPr>
+          <a:lstStyle/>
+          <a:p>
+            <a:r>
+              <a:rPr sz="3000" b="1" i="0">
+                <a:solidFill>
+                  <a:srgbClr val="FFFFFF"/>
+                </a:solidFill>
+                <a:latin typeface="Calibri"/>
+              </a:rPr>
+              <a:t>Annexe — Diagramme de séquence</a:t>
+            </a:r>
+          </a:p>
+        </p:txBody>
+      </p:sp>
+      <p:pic>
+        <p:nvPicPr>
+          <p:cNvPr id="4" name="Picture 3" descr="diagramme-sequence.png"/>
+          <p:cNvPicPr>
+            <a:picLocks noChangeAspect="1"/>
+          </p:cNvPicPr>
+          <p:nvPr/>
+        </p:nvPicPr>
+        <p:blipFill>
+          <a:blip r:embed="rId2"/>
+          <a:stretch>
+            <a:fillRect/>
+          </a:stretch>
+        </p:blipFill>
+        <p:spPr>
+          <a:xfrm>
+            <a:off x="3003161" y="1234440"/>
+            <a:ext cx="6185372" cy="4846320"/>
+          </a:xfrm>
+          <a:prstGeom prst="rect">
+            <a:avLst/>
+          </a:prstGeom>
+        </p:spPr>
+      </p:pic>
     </p:spTree>
   </p:cSld>
   <p:clrMapOvr>
@@ -12447,6 +13622,681 @@
                 <a:latin typeface="Calibri"/>
               </a:rPr>
               <a:t>Allier une expertise réseau à une démarche entrepreneuriale.</a:t>
+            </a:r>
+          </a:p>
+        </p:txBody>
+      </p:sp>
+    </p:spTree>
+  </p:cSld>
+  <p:clrMapOvr>
+    <a:masterClrMapping/>
+  </p:clrMapOvr>
+</p:sld>
+</file>
+
+<file path=ppt/slides/slide30.xml><?xml version="1.0" encoding="utf-8"?>
+<p:sld xmlns:a="http://schemas.openxmlformats.org/drawingml/2006/main" xmlns:p="http://schemas.openxmlformats.org/presentationml/2006/main" xmlns:r="http://schemas.openxmlformats.org/officeDocument/2006/relationships">
+  <p:cSld>
+    <p:bg>
+      <p:bgPr>
+        <a:solidFill>
+          <a:srgbClr val="FFFFFF"/>
+        </a:solidFill>
+        <a:effectLst/>
+      </p:bgPr>
+    </p:bg>
+    <p:spTree>
+      <p:nvGrpSpPr>
+        <p:cNvPr id="1" name=""/>
+        <p:cNvGrpSpPr/>
+        <p:nvPr/>
+      </p:nvGrpSpPr>
+      <p:grpSpPr/>
+      <p:sp>
+        <p:nvSpPr>
+          <p:cNvPr id="2" name="Rectangle 1"/>
+          <p:cNvSpPr/>
+          <p:nvPr/>
+        </p:nvSpPr>
+        <p:spPr>
+          <a:xfrm>
+            <a:off x="0" y="0"/>
+            <a:ext cx="12191695" cy="1051560"/>
+          </a:xfrm>
+          <a:prstGeom prst="rect">
+            <a:avLst/>
+          </a:prstGeom>
+          <a:solidFill>
+            <a:srgbClr val="0D3B66"/>
+          </a:solidFill>
+          <a:ln>
+            <a:noFill/>
+          </a:ln>
+          <a:effectLst/>
+        </p:spPr>
+        <p:style>
+          <a:lnRef idx="1">
+            <a:schemeClr val="accent1"/>
+          </a:lnRef>
+          <a:fillRef idx="3">
+            <a:schemeClr val="accent1"/>
+          </a:fillRef>
+          <a:effectRef idx="2">
+            <a:schemeClr val="accent1"/>
+          </a:effectRef>
+          <a:fontRef idx="minor">
+            <a:schemeClr val="lt1"/>
+          </a:fontRef>
+        </p:style>
+        <p:txBody>
+          <a:bodyPr rtlCol="0" anchor="ctr"/>
+          <a:lstStyle/>
+          <a:p>
+            <a:pPr algn="ctr"/>
+          </a:p>
+        </p:txBody>
+      </p:sp>
+      <p:sp>
+        <p:nvSpPr>
+          <p:cNvPr id="3" name="TextBox 2"/>
+          <p:cNvSpPr txBox="1"/>
+          <p:nvPr/>
+        </p:nvSpPr>
+        <p:spPr>
+          <a:xfrm>
+            <a:off x="457200" y="164592"/>
+            <a:ext cx="11460175" cy="731520"/>
+          </a:xfrm>
+          <a:prstGeom prst="rect">
+            <a:avLst/>
+          </a:prstGeom>
+          <a:noFill/>
+        </p:spPr>
+        <p:txBody>
+          <a:bodyPr wrap="square" anchor="ctr">
+            <a:spAutoFit/>
+          </a:bodyPr>
+          <a:lstStyle/>
+          <a:p>
+            <a:r>
+              <a:rPr sz="3000" b="1" i="0">
+                <a:solidFill>
+                  <a:srgbClr val="FFFFFF"/>
+                </a:solidFill>
+                <a:latin typeface="Calibri"/>
+              </a:rPr>
+              <a:t>Annexe — Diagramme d'activité</a:t>
+            </a:r>
+          </a:p>
+        </p:txBody>
+      </p:sp>
+      <p:pic>
+        <p:nvPicPr>
+          <p:cNvPr id="4" name="Picture 3" descr="diagramme-activite.png"/>
+          <p:cNvPicPr>
+            <a:picLocks noChangeAspect="1"/>
+          </p:cNvPicPr>
+          <p:nvPr/>
+        </p:nvPicPr>
+        <p:blipFill>
+          <a:blip r:embed="rId2"/>
+          <a:stretch>
+            <a:fillRect/>
+          </a:stretch>
+        </p:blipFill>
+        <p:spPr>
+          <a:xfrm>
+            <a:off x="4579658" y="1234440"/>
+            <a:ext cx="3032378" cy="4846320"/>
+          </a:xfrm>
+          <a:prstGeom prst="rect">
+            <a:avLst/>
+          </a:prstGeom>
+        </p:spPr>
+      </p:pic>
+    </p:spTree>
+  </p:cSld>
+  <p:clrMapOvr>
+    <a:masterClrMapping/>
+  </p:clrMapOvr>
+</p:sld>
+</file>
+
+<file path=ppt/slides/slide31.xml><?xml version="1.0" encoding="utf-8"?>
+<p:sld xmlns:a="http://schemas.openxmlformats.org/drawingml/2006/main" xmlns:p="http://schemas.openxmlformats.org/presentationml/2006/main" xmlns:r="http://schemas.openxmlformats.org/officeDocument/2006/relationships">
+  <p:cSld>
+    <p:bg>
+      <p:bgPr>
+        <a:solidFill>
+          <a:srgbClr val="FFFFFF"/>
+        </a:solidFill>
+        <a:effectLst/>
+      </p:bgPr>
+    </p:bg>
+    <p:spTree>
+      <p:nvGrpSpPr>
+        <p:cNvPr id="1" name=""/>
+        <p:cNvGrpSpPr/>
+        <p:nvPr/>
+      </p:nvGrpSpPr>
+      <p:grpSpPr/>
+      <p:sp>
+        <p:nvSpPr>
+          <p:cNvPr id="2" name="Rectangle 1"/>
+          <p:cNvSpPr/>
+          <p:nvPr/>
+        </p:nvSpPr>
+        <p:spPr>
+          <a:xfrm>
+            <a:off x="0" y="0"/>
+            <a:ext cx="12191695" cy="1051560"/>
+          </a:xfrm>
+          <a:prstGeom prst="rect">
+            <a:avLst/>
+          </a:prstGeom>
+          <a:solidFill>
+            <a:srgbClr val="0D3B66"/>
+          </a:solidFill>
+          <a:ln>
+            <a:noFill/>
+          </a:ln>
+          <a:effectLst/>
+        </p:spPr>
+        <p:style>
+          <a:lnRef idx="1">
+            <a:schemeClr val="accent1"/>
+          </a:lnRef>
+          <a:fillRef idx="3">
+            <a:schemeClr val="accent1"/>
+          </a:fillRef>
+          <a:effectRef idx="2">
+            <a:schemeClr val="accent1"/>
+          </a:effectRef>
+          <a:fontRef idx="minor">
+            <a:schemeClr val="lt1"/>
+          </a:fontRef>
+        </p:style>
+        <p:txBody>
+          <a:bodyPr rtlCol="0" anchor="ctr"/>
+          <a:lstStyle/>
+          <a:p>
+            <a:pPr algn="ctr"/>
+          </a:p>
+        </p:txBody>
+      </p:sp>
+      <p:sp>
+        <p:nvSpPr>
+          <p:cNvPr id="3" name="TextBox 2"/>
+          <p:cNvSpPr txBox="1"/>
+          <p:nvPr/>
+        </p:nvSpPr>
+        <p:spPr>
+          <a:xfrm>
+            <a:off x="457200" y="164592"/>
+            <a:ext cx="11460175" cy="731520"/>
+          </a:xfrm>
+          <a:prstGeom prst="rect">
+            <a:avLst/>
+          </a:prstGeom>
+          <a:noFill/>
+        </p:spPr>
+        <p:txBody>
+          <a:bodyPr wrap="square" anchor="ctr">
+            <a:spAutoFit/>
+          </a:bodyPr>
+          <a:lstStyle/>
+          <a:p>
+            <a:r>
+              <a:rPr sz="3000" b="1" i="0">
+                <a:solidFill>
+                  <a:srgbClr val="FFFFFF"/>
+                </a:solidFill>
+                <a:latin typeface="Calibri"/>
+              </a:rPr>
+              <a:t>Annexe — Diagramme de classes</a:t>
+            </a:r>
+          </a:p>
+        </p:txBody>
+      </p:sp>
+      <p:pic>
+        <p:nvPicPr>
+          <p:cNvPr id="4" name="Picture 3" descr="diagramme-classes.png"/>
+          <p:cNvPicPr>
+            <a:picLocks noChangeAspect="1"/>
+          </p:cNvPicPr>
+          <p:nvPr/>
+        </p:nvPicPr>
+        <p:blipFill>
+          <a:blip r:embed="rId2"/>
+          <a:stretch>
+            <a:fillRect/>
+          </a:stretch>
+        </p:blipFill>
+        <p:spPr>
+          <a:xfrm>
+            <a:off x="700887" y="1234440"/>
+            <a:ext cx="10789920" cy="4584951"/>
+          </a:xfrm>
+          <a:prstGeom prst="rect">
+            <a:avLst/>
+          </a:prstGeom>
+        </p:spPr>
+      </p:pic>
+    </p:spTree>
+  </p:cSld>
+  <p:clrMapOvr>
+    <a:masterClrMapping/>
+  </p:clrMapOvr>
+</p:sld>
+</file>
+
+<file path=ppt/slides/slide32.xml><?xml version="1.0" encoding="utf-8"?>
+<p:sld xmlns:a="http://schemas.openxmlformats.org/drawingml/2006/main" xmlns:p="http://schemas.openxmlformats.org/presentationml/2006/main" xmlns:r="http://schemas.openxmlformats.org/officeDocument/2006/relationships">
+  <p:cSld>
+    <p:bg>
+      <p:bgPr>
+        <a:solidFill>
+          <a:srgbClr val="FFFFFF"/>
+        </a:solidFill>
+        <a:effectLst/>
+      </p:bgPr>
+    </p:bg>
+    <p:spTree>
+      <p:nvGrpSpPr>
+        <p:cNvPr id="1" name=""/>
+        <p:cNvGrpSpPr/>
+        <p:nvPr/>
+      </p:nvGrpSpPr>
+      <p:grpSpPr/>
+      <p:sp>
+        <p:nvSpPr>
+          <p:cNvPr id="2" name="Rectangle 1"/>
+          <p:cNvSpPr/>
+          <p:nvPr/>
+        </p:nvSpPr>
+        <p:spPr>
+          <a:xfrm>
+            <a:off x="0" y="0"/>
+            <a:ext cx="12191695" cy="1051560"/>
+          </a:xfrm>
+          <a:prstGeom prst="rect">
+            <a:avLst/>
+          </a:prstGeom>
+          <a:solidFill>
+            <a:srgbClr val="0D3B66"/>
+          </a:solidFill>
+          <a:ln>
+            <a:noFill/>
+          </a:ln>
+          <a:effectLst/>
+        </p:spPr>
+        <p:style>
+          <a:lnRef idx="1">
+            <a:schemeClr val="accent1"/>
+          </a:lnRef>
+          <a:fillRef idx="3">
+            <a:schemeClr val="accent1"/>
+          </a:fillRef>
+          <a:effectRef idx="2">
+            <a:schemeClr val="accent1"/>
+          </a:effectRef>
+          <a:fontRef idx="minor">
+            <a:schemeClr val="lt1"/>
+          </a:fontRef>
+        </p:style>
+        <p:txBody>
+          <a:bodyPr rtlCol="0" anchor="ctr"/>
+          <a:lstStyle/>
+          <a:p>
+            <a:pPr algn="ctr"/>
+          </a:p>
+        </p:txBody>
+      </p:sp>
+      <p:sp>
+        <p:nvSpPr>
+          <p:cNvPr id="3" name="TextBox 2"/>
+          <p:cNvSpPr txBox="1"/>
+          <p:nvPr/>
+        </p:nvSpPr>
+        <p:spPr>
+          <a:xfrm>
+            <a:off x="457200" y="164592"/>
+            <a:ext cx="11460175" cy="731520"/>
+          </a:xfrm>
+          <a:prstGeom prst="rect">
+            <a:avLst/>
+          </a:prstGeom>
+          <a:noFill/>
+        </p:spPr>
+        <p:txBody>
+          <a:bodyPr wrap="square" anchor="ctr">
+            <a:spAutoFit/>
+          </a:bodyPr>
+          <a:lstStyle/>
+          <a:p>
+            <a:r>
+              <a:rPr sz="3000" b="1" i="0">
+                <a:solidFill>
+                  <a:srgbClr val="FFFFFF"/>
+                </a:solidFill>
+                <a:latin typeface="Calibri"/>
+              </a:rPr>
+              <a:t>Annexe — Diagramme de composants</a:t>
+            </a:r>
+          </a:p>
+        </p:txBody>
+      </p:sp>
+      <p:pic>
+        <p:nvPicPr>
+          <p:cNvPr id="4" name="Picture 3" descr="diagramme-composants.png"/>
+          <p:cNvPicPr>
+            <a:picLocks noChangeAspect="1"/>
+          </p:cNvPicPr>
+          <p:nvPr/>
+        </p:nvPicPr>
+        <p:blipFill>
+          <a:blip r:embed="rId2"/>
+          <a:stretch>
+            <a:fillRect/>
+          </a:stretch>
+        </p:blipFill>
+        <p:spPr>
+          <a:xfrm>
+            <a:off x="1891278" y="1234440"/>
+            <a:ext cx="8409139" cy="4846320"/>
+          </a:xfrm>
+          <a:prstGeom prst="rect">
+            <a:avLst/>
+          </a:prstGeom>
+        </p:spPr>
+      </p:pic>
+    </p:spTree>
+  </p:cSld>
+  <p:clrMapOvr>
+    <a:masterClrMapping/>
+  </p:clrMapOvr>
+</p:sld>
+</file>
+
+<file path=ppt/slides/slide33.xml><?xml version="1.0" encoding="utf-8"?>
+<p:sld xmlns:a="http://schemas.openxmlformats.org/drawingml/2006/main" xmlns:p="http://schemas.openxmlformats.org/presentationml/2006/main" xmlns:r="http://schemas.openxmlformats.org/officeDocument/2006/relationships">
+  <p:cSld>
+    <p:bg>
+      <p:bgPr>
+        <a:solidFill>
+          <a:srgbClr val="FFFFFF"/>
+        </a:solidFill>
+        <a:effectLst/>
+      </p:bgPr>
+    </p:bg>
+    <p:spTree>
+      <p:nvGrpSpPr>
+        <p:cNvPr id="1" name=""/>
+        <p:cNvGrpSpPr/>
+        <p:nvPr/>
+      </p:nvGrpSpPr>
+      <p:grpSpPr/>
+      <p:sp>
+        <p:nvSpPr>
+          <p:cNvPr id="2" name="Rectangle 1"/>
+          <p:cNvSpPr/>
+          <p:nvPr/>
+        </p:nvSpPr>
+        <p:spPr>
+          <a:xfrm>
+            <a:off x="0" y="0"/>
+            <a:ext cx="12191695" cy="1051560"/>
+          </a:xfrm>
+          <a:prstGeom prst="rect">
+            <a:avLst/>
+          </a:prstGeom>
+          <a:solidFill>
+            <a:srgbClr val="0D3B66"/>
+          </a:solidFill>
+          <a:ln>
+            <a:noFill/>
+          </a:ln>
+          <a:effectLst/>
+        </p:spPr>
+        <p:style>
+          <a:lnRef idx="1">
+            <a:schemeClr val="accent1"/>
+          </a:lnRef>
+          <a:fillRef idx="3">
+            <a:schemeClr val="accent1"/>
+          </a:fillRef>
+          <a:effectRef idx="2">
+            <a:schemeClr val="accent1"/>
+          </a:effectRef>
+          <a:fontRef idx="minor">
+            <a:schemeClr val="lt1"/>
+          </a:fontRef>
+        </p:style>
+        <p:txBody>
+          <a:bodyPr rtlCol="0" anchor="ctr"/>
+          <a:lstStyle/>
+          <a:p>
+            <a:pPr algn="ctr"/>
+          </a:p>
+        </p:txBody>
+      </p:sp>
+      <p:sp>
+        <p:nvSpPr>
+          <p:cNvPr id="3" name="TextBox 2"/>
+          <p:cNvSpPr txBox="1"/>
+          <p:nvPr/>
+        </p:nvSpPr>
+        <p:spPr>
+          <a:xfrm>
+            <a:off x="457200" y="164592"/>
+            <a:ext cx="11460175" cy="731520"/>
+          </a:xfrm>
+          <a:prstGeom prst="rect">
+            <a:avLst/>
+          </a:prstGeom>
+          <a:noFill/>
+        </p:spPr>
+        <p:txBody>
+          <a:bodyPr wrap="square" anchor="ctr">
+            <a:spAutoFit/>
+          </a:bodyPr>
+          <a:lstStyle/>
+          <a:p>
+            <a:r>
+              <a:rPr sz="3000" b="1" i="0">
+                <a:solidFill>
+                  <a:srgbClr val="FFFFFF"/>
+                </a:solidFill>
+                <a:latin typeface="Calibri"/>
+              </a:rPr>
+              <a:t>Annexe — Diagramme de déploiement</a:t>
+            </a:r>
+          </a:p>
+        </p:txBody>
+      </p:sp>
+      <p:pic>
+        <p:nvPicPr>
+          <p:cNvPr id="4" name="Picture 3" descr="diagramme-deploiement.png"/>
+          <p:cNvPicPr>
+            <a:picLocks noChangeAspect="1"/>
+          </p:cNvPicPr>
+          <p:nvPr/>
+        </p:nvPicPr>
+        <p:blipFill>
+          <a:blip r:embed="rId2"/>
+          <a:stretch>
+            <a:fillRect/>
+          </a:stretch>
+        </p:blipFill>
+        <p:spPr>
+          <a:xfrm>
+            <a:off x="700887" y="1234440"/>
+            <a:ext cx="10789920" cy="4686300"/>
+          </a:xfrm>
+          <a:prstGeom prst="rect">
+            <a:avLst/>
+          </a:prstGeom>
+        </p:spPr>
+      </p:pic>
+    </p:spTree>
+  </p:cSld>
+  <p:clrMapOvr>
+    <a:masterClrMapping/>
+  </p:clrMapOvr>
+</p:sld>
+</file>
+
+<file path=ppt/slides/slide34.xml><?xml version="1.0" encoding="utf-8"?>
+<p:sld xmlns:a="http://schemas.openxmlformats.org/drawingml/2006/main" xmlns:p="http://schemas.openxmlformats.org/presentationml/2006/main" xmlns:r="http://schemas.openxmlformats.org/officeDocument/2006/relationships">
+  <p:cSld>
+    <p:bg>
+      <p:bgPr>
+        <a:solidFill>
+          <a:srgbClr val="FFFFFF"/>
+        </a:solidFill>
+        <a:effectLst/>
+      </p:bgPr>
+    </p:bg>
+    <p:spTree>
+      <p:nvGrpSpPr>
+        <p:cNvPr id="1" name=""/>
+        <p:cNvGrpSpPr/>
+        <p:nvPr/>
+      </p:nvGrpSpPr>
+      <p:grpSpPr/>
+      <p:sp>
+        <p:nvSpPr>
+          <p:cNvPr id="2" name="Rectangle 1"/>
+          <p:cNvSpPr/>
+          <p:nvPr/>
+        </p:nvSpPr>
+        <p:spPr>
+          <a:xfrm>
+            <a:off x="0" y="0"/>
+            <a:ext cx="12191695" cy="1051560"/>
+          </a:xfrm>
+          <a:prstGeom prst="rect">
+            <a:avLst/>
+          </a:prstGeom>
+          <a:solidFill>
+            <a:srgbClr val="0D3B66"/>
+          </a:solidFill>
+          <a:ln>
+            <a:noFill/>
+          </a:ln>
+          <a:effectLst/>
+        </p:spPr>
+        <p:style>
+          <a:lnRef idx="1">
+            <a:schemeClr val="accent1"/>
+          </a:lnRef>
+          <a:fillRef idx="3">
+            <a:schemeClr val="accent1"/>
+          </a:fillRef>
+          <a:effectRef idx="2">
+            <a:schemeClr val="accent1"/>
+          </a:effectRef>
+          <a:fontRef idx="minor">
+            <a:schemeClr val="lt1"/>
+          </a:fontRef>
+        </p:style>
+        <p:txBody>
+          <a:bodyPr rtlCol="0" anchor="ctr"/>
+          <a:lstStyle/>
+          <a:p>
+            <a:pPr algn="ctr"/>
+          </a:p>
+        </p:txBody>
+      </p:sp>
+      <p:sp>
+        <p:nvSpPr>
+          <p:cNvPr id="3" name="TextBox 2"/>
+          <p:cNvSpPr txBox="1"/>
+          <p:nvPr/>
+        </p:nvSpPr>
+        <p:spPr>
+          <a:xfrm>
+            <a:off x="457200" y="164592"/>
+            <a:ext cx="11460175" cy="731520"/>
+          </a:xfrm>
+          <a:prstGeom prst="rect">
+            <a:avLst/>
+          </a:prstGeom>
+          <a:noFill/>
+        </p:spPr>
+        <p:txBody>
+          <a:bodyPr wrap="square" anchor="ctr">
+            <a:spAutoFit/>
+          </a:bodyPr>
+          <a:lstStyle/>
+          <a:p>
+            <a:r>
+              <a:rPr sz="3000" b="1" i="0">
+                <a:solidFill>
+                  <a:srgbClr val="FFFFFF"/>
+                </a:solidFill>
+                <a:latin typeface="Calibri"/>
+              </a:rPr>
+              <a:t>Annexe — Modèle Logique de Données (MLD)</a:t>
+            </a:r>
+          </a:p>
+        </p:txBody>
+      </p:sp>
+      <p:pic>
+        <p:nvPicPr>
+          <p:cNvPr id="4" name="Picture 3" descr="mld.png"/>
+          <p:cNvPicPr>
+            <a:picLocks noChangeAspect="1"/>
+          </p:cNvPicPr>
+          <p:nvPr/>
+        </p:nvPicPr>
+        <p:blipFill>
+          <a:blip r:embed="rId2"/>
+          <a:stretch>
+            <a:fillRect/>
+          </a:stretch>
+        </p:blipFill>
+        <p:spPr>
+          <a:xfrm>
+            <a:off x="2154313" y="1234440"/>
+            <a:ext cx="7883069" cy="4846320"/>
+          </a:xfrm>
+          <a:prstGeom prst="rect">
+            <a:avLst/>
+          </a:prstGeom>
+        </p:spPr>
+      </p:pic>
+      <p:sp>
+        <p:nvSpPr>
+          <p:cNvPr id="5" name="TextBox 4"/>
+          <p:cNvSpPr txBox="1"/>
+          <p:nvPr/>
+        </p:nvSpPr>
+        <p:spPr>
+          <a:xfrm>
+            <a:off x="457200" y="6172200"/>
+            <a:ext cx="11247120" cy="457200"/>
+          </a:xfrm>
+          <a:prstGeom prst="rect">
+            <a:avLst/>
+          </a:prstGeom>
+          <a:noFill/>
+        </p:spPr>
+        <p:txBody>
+          <a:bodyPr wrap="square">
+            <a:spAutoFit/>
+          </a:bodyPr>
+          <a:lstStyle/>
+          <a:p>
+            <a:pPr algn="ctr"/>
+            <a:r>
+              <a:rPr sz="1300" b="0" i="1">
+                <a:solidFill>
+                  <a:srgbClr val="333333"/>
+                </a:solidFill>
+                <a:latin typeface="Calibri"/>
+              </a:rPr>
+              <a:t>5 tables : utilisateurs, equipements, journaux, alertes, statistiques (clés primaires PK, clés étrangères FK).</a:t>
             </a:r>
           </a:p>
         </p:txBody>

</xml_diff>

<commit_message>
Contextualisation complète de la présentation pour OPEN MOISE
La structure d'accueil OPEN MOISE est désormais présente tout au long du
support (39 occurrences sur 18 diapos), du titre à la conclusion :
- Introduction, contexte et problématique reformulés du point de vue d'OPEN MOISE
  (ESN d'infogérance supervisant les réseaux de ses clients sous SLA)
- Objectifs, solution, différenciation et faisabilité orientés besoins OPEN MOISE
- Démonstration : scénario sur un parc client, astreinte OPEN MOISE alertée
- Section 9 « Valorisation pour OPEN MOISE » : double valeur (outil interne +
  offre de supervision managée), positionnement concurrentiel
- Section 10 : prévisions financières du point de vue d'OPEN MOISE
  (investissement, revenus récurrents, pénalités SLA évitées)
- Conclusion : avantage concurrentiel pour OPEN MOISE
- Markdown (Marp) synchronisé avec le .pptx généré
</commit_message>
<xml_diff>
--- a/soutenance/presentation-projet.pptx
+++ b/soutenance/presentation-projet.pptx
@@ -605,7 +605,7 @@
           <a:lstStyle/>
           <a:p>
             <a:r>
-              <a:t>Ma réponse à ce vide : une solution complète mais légère. Elle découvre, surveille, confirme, journalise, alerte et affiche - le tout assemblé à partir de briques open-source éprouvées.</a:t>
+              <a:t>Ma réponse au besoin d'OPEN MOISE : une solution complète mais légère. Elle découvre, surveille, confirme, journalise, alerte les équipes et affiche - le tout assemblé à partir de briques open-source éprouvées, et la journalisation sert aussi de preuve du respect des SLA.</a:t>
             </a:r>
           </a:p>
         </p:txBody>
@@ -1165,7 +1165,7 @@
           <a:lstStyle/>
           <a:p>
             <a:r>
-              <a:t>Pour la démonstration, je propose un scénario vivant : je montre le tableau de bord, j'éteins un équipement devant vous, et vous verrez l'alerte Telegram arriver sur mon téléphone en temps réel. Puis je le rallume pour montrer le rétablissement. J'ai un plan B en captures et vidéo.</a:t>
+              <a:t>Pour la démonstration, je propose un scénario vivant tel qu'OPEN MOISE l'utiliserait : je montre le tableau de bord d'un parc client, je simule une panne, et vous verrez l'astreinte alertée par Telegram en temps réel. Puis je rétablis. J'ai un plan B en captures et vidéo.</a:t>
             </a:r>
           </a:p>
         </p:txBody>
@@ -1235,7 +1235,7 @@
           <a:lstStyle/>
           <a:p>
             <a:r>
-              <a:t>Ces captures matérialisent chaque fonctionnalité clé. La plus parlante est la notification Telegram reçue sur le téléphone : la preuve concrète de la valeur ajoutée pour l'administrateur.</a:t>
+              <a:t>Ces captures matérialisent chaque fonctionnalité clé. La plus parlante est la notification Telegram reçue sur le téléphone : la preuve concrète de la valeur ajoutée pour les équipes d'astreinte d'OPEN MOISE.</a:t>
             </a:r>
           </a:p>
         </p:txBody>
@@ -1375,7 +1375,7 @@
           <a:lstStyle/>
           <a:p>
             <a:r>
-              <a:t>Côté business, je vise les structures sans gros budget IT et les infogérants. Mon modèle est l'open-core : le cœur est gratuit pour créer l'adoption, et je monétise les services et une édition Pro avec SNMP et IA.</a:t>
+              <a:t>Pour OPEN MOISE, la solution a une double valeur : en interne, elle industrialise la supervision et fiabilise les SLA ; en externe, elle devient une nouvelle offre de supervision managée facturée aux clients. C'est à la fois une économie et une source de revenus récurrents.</a:t>
             </a:r>
           </a:p>
         </p:txBody>
@@ -1445,7 +1445,7 @@
           <a:lstStyle/>
           <a:p>
             <a:r>
-              <a:t>Je ne prétends pas battre Zabbix sur les très grandes infrastructures. Ma stratégie est celle de l'océan bleu : occuper le segment que les géants négligent - les petites structures - avec un produit simple et gratuit.</a:t>
+              <a:t>OPEN MOISE ne cherche pas à battre Zabbix sur les très grandes infrastructures. Sa stratégie est l'océan bleu : se différencier auprès de ses clients PME avec une offre de supervision managée simple et sans licence, là où les géants sont trop chers ou trop lourds.</a:t>
             </a:r>
           </a:p>
         </p:txBody>
@@ -1515,7 +1515,7 @@
           <a:lstStyle/>
           <a:p>
             <a:r>
-              <a:t>Financièrement, l'entrée est quasi nulle : pas de licence, juste un petit serveur. Côté revenus, même avec des hypothèses prudentes, on dépasse 9 000 € la première année. Pour le client, le retour vient de la réduction des coûts d'indisponibilité : la solution est rentabilisée dès le premier incident majeur évité.</a:t>
+              <a:t>Pour OPEN MOISE, l'investissement est quasi nul : pas de licence, un serveur mutualisé, un développement déjà réalisé en interne. Le retour est double : des revenus récurrents via l'offre de supervision managée, et des économies internes - moins de temps d'astreinte et des pénalités SLA évitées. L'investissement est amorti dès le premier client.</a:t>
             </a:r>
           </a:p>
         </p:txBody>
@@ -1585,7 +1585,7 @@
           <a:lstStyle/>
           <a:p>
             <a:r>
-              <a:t>Je reste lucide sur les limites : pas encore de SNMP, réactivité bornée à deux minutes, et la question du superviseur lui-même. Mais ces limites tracent ma feuille de route : SNMP, puis l'IA pour passer d'une supervision réactive à une supervision prédictive.</a:t>
+              <a:t>Je reste lucide sur les limites : pas encore de SNMP, réactivité bornée à deux minutes, et la question du superviseur lui-même. Mais ces limites tracent la feuille de route d'OPEN MOISE : SNMP, puis l'IA pour offrir à ses clients une supervision prédictive premium.</a:t>
             </a:r>
           </a:p>
         </p:txBody>
@@ -1655,7 +1655,7 @@
           <a:lstStyle/>
           <a:p>
             <a:r>
-              <a:t>En conclusion, ce projet livre un produit réel et performant, doublé d'un modèle économique crédible, et ouvert vers l'avenir de la supervision : le prédictif. J'ai montré qu'on pouvait rendre la haute disponibilité accessible à tous.</a:t>
+              <a:t>En conclusion, ce projet dote OPEN MOISE d'un outil réel et performant, qui fiabilise ses engagements de service, génère des économies et ouvre une nouvelle offre commerciale. Pour l'entreprise, c'est un avantage concurrentiel concret et durable.</a:t>
             </a:r>
           </a:p>
         </p:txBody>
@@ -1865,7 +1865,7 @@
           <a:lstStyle/>
           <a:p>
             <a:r>
-              <a:t>J'ai choisi ce thème car il croise une réalité observée en stage - les pannes détectées trop tard - et une conviction : on peut résoudre ce problème sans budget colossal grâce à l'open-source. C'est à la fois un défi d'ingénieur et une opportunité de marché.</a:t>
+              <a:t>J'ai choisi ce thème car il croise une réalité observée chez OPEN MOISE - les pannes des réseaux clients détectées trop tard - et une conviction : on peut industrialiser la supervision sans budget colossal grâce à l'open-source. C'est un besoin direct de mon entreprise d'accueil.</a:t>
             </a:r>
           </a:p>
         </p:txBody>
@@ -2005,7 +2005,7 @@
           <a:lstStyle/>
           <a:p>
             <a:r>
-              <a:t>Le contexte : des réseaux toujours plus complexes et critiques. Pourtant, sur le terrain, beaucoup surveillent encore à la main. Résultat : on apprend la panne par les plaintes, sans aucune trace, et les outils du marché paraissent inaccessibles.</a:t>
+              <a:t>Le contexte est celui d'OPEN MOISE : une ESN qui supervise les réseaux de ses clients sous engagement de service. Or cette supervision est encore largement manuelle. Résultat : on apprend la panne par le client lui-même, sans trace exploitable, ce qui met en péril le respect des SLA.</a:t>
             </a:r>
           </a:p>
         </p:txBody>
@@ -2075,7 +2075,7 @@
           <a:lstStyle/>
           <a:p>
             <a:r>
-              <a:t>Tout le projet répond à cette question centrale, que je formule clairement : détecter en temps réel et réduire le temps d'intervention, avec une solution automatisée, fiable ET accessible financièrement. Les trois sous-questions guident ma conception.</a:t>
+              <a:t>Tout le projet répond à cette question centrale, formulée du point de vue d'OPEN MOISE : détecter en temps réel les pannes des réseaux supervisés et réduire le temps d'intervention des équipes, avec une solution automatisée, fiable et accessible. Les trois sous-questions guident ma conception.</a:t>
             </a:r>
           </a:p>
         </p:txBody>
@@ -2285,7 +2285,7 @@
           <a:lstStyle/>
           <a:p>
             <a:r>
-              <a:t>J'ai analysé les références du marché : soit des usines à gaz puissantes mais complexes, soit des produits simples mais propriétaires et chers. Il existe un vide pour une solution légère, gratuite et sur mesure.</a:t>
+              <a:t>J'ai analysé les références du marché : soit des usines à gaz puissantes mais complexes, soit des produits simples mais propriétaires et chers. Pour OPEN MOISE et ses clients PME, il existe un vide pour une solution légère, gratuite et sur mesure.</a:t>
             </a:r>
           </a:p>
         </p:txBody>
@@ -5386,7 +5386,7 @@
                 </a:solidFill>
                 <a:latin typeface="Calibri"/>
               </a:rPr>
-              <a:t>Une solution open-source pour une infrastructure toujours disponible</a:t>
+              <a:t>Une solution open-source déployée au sein d'OPEN MOISE (ESN d'infogérance)</a:t>
             </a:r>
           </a:p>
         </p:txBody>
@@ -5635,13 +5635,13 @@
               </a:spcAft>
             </a:pPr>
             <a:r>
-              <a:rPr sz="2000" b="1" i="0">
+              <a:rPr sz="1900" b="1" i="0">
                 <a:solidFill>
                   <a:srgbClr val="0D3B66"/>
                 </a:solidFill>
                 <a:latin typeface="Calibri"/>
               </a:rPr>
-              <a:t>•  Un système automatisé, modulaire et 100 % open-source qui :</a:t>
+              <a:t>•  Un outil de supervision pour OPEN MOISE, automatisé, modulaire et 100 % open-source, qui :</a:t>
             </a:r>
           </a:p>
           <a:p>
@@ -5651,13 +5651,13 @@
               </a:spcAft>
             </a:pPr>
             <a:r>
-              <a:rPr sz="1800" b="0" i="0">
+              <a:rPr sz="1700" b="0" i="0">
                 <a:solidFill>
                   <a:srgbClr val="333333"/>
                 </a:solidFill>
                 <a:latin typeface="Calibri"/>
               </a:rPr>
-              <a:t>–  découvre automatiquement les équipements du réseau</a:t>
+              <a:t>–  découvre automatiquement les équipements des réseaux clients</a:t>
             </a:r>
           </a:p>
           <a:p>
@@ -5667,7 +5667,7 @@
               </a:spcAft>
             </a:pPr>
             <a:r>
-              <a:rPr sz="1800" b="0" i="0">
+              <a:rPr sz="1700" b="0" i="0">
                 <a:solidFill>
                   <a:srgbClr val="333333"/>
                 </a:solidFill>
@@ -5683,13 +5683,13 @@
               </a:spcAft>
             </a:pPr>
             <a:r>
-              <a:rPr sz="1800" b="0" i="0">
+              <a:rPr sz="1700" b="0" i="0">
                 <a:solidFill>
                   <a:srgbClr val="333333"/>
                 </a:solidFill>
                 <a:latin typeface="Calibri"/>
               </a:rPr>
-              <a:t>–  confirme la panne (anti-faux positif) et journalise tout</a:t>
+              <a:t>–  confirme la panne (anti-faux positif) et journalise tout (preuve de SLA)</a:t>
             </a:r>
           </a:p>
           <a:p>
@@ -5699,13 +5699,13 @@
               </a:spcAft>
             </a:pPr>
             <a:r>
-              <a:rPr sz="1800" b="0" i="0">
+              <a:rPr sz="1700" b="0" i="0">
                 <a:solidFill>
                   <a:srgbClr val="333333"/>
                 </a:solidFill>
                 <a:latin typeface="Calibri"/>
               </a:rPr>
-              <a:t>–  alerte en temps réel par e-mail ET Telegram (push mobile)</a:t>
+              <a:t>–  alerte les équipes d'OPEN MOISE par e-mail ET Telegram (push mobile)</a:t>
             </a:r>
           </a:p>
           <a:p>
@@ -5715,13 +5715,13 @@
               </a:spcAft>
             </a:pPr>
             <a:r>
-              <a:rPr sz="1800" b="0" i="0">
+              <a:rPr sz="1700" b="0" i="0">
                 <a:solidFill>
                   <a:srgbClr val="333333"/>
                 </a:solidFill>
                 <a:latin typeface="Calibri"/>
               </a:rPr>
-              <a:t>–  offre un tableau de bord web temps réel + rapports</a:t>
+              <a:t>–  offre un tableau de bord web temps réel + rapports clients</a:t>
             </a:r>
           </a:p>
         </p:txBody>
@@ -6010,7 +6010,7 @@
                     <a:p>
                       <a:pPr algn="ctr"/>
                       <a:r>
-                        <a:rPr sz="1600" b="1" i="0">
+                        <a:rPr sz="1500" b="1" i="0">
                           <a:solidFill>
                             <a:srgbClr val="FFFFFF"/>
                           </a:solidFill>
@@ -6033,13 +6033,13 @@
                     <a:p>
                       <a:pPr algn="ctr"/>
                       <a:r>
-                        <a:rPr sz="1600" b="1" i="0">
+                        <a:rPr sz="1500" b="1" i="0">
                           <a:solidFill>
                             <a:srgbClr val="FFFFFF"/>
                           </a:solidFill>
                           <a:latin typeface="Calibri"/>
                         </a:rPr>
-                        <a:t>Bénéfice client</a:t>
+                        <a:t>Bénéfice pour OPEN MOISE</a:t>
                       </a:r>
                     </a:p>
                   </a:txBody>
@@ -6058,7 +6058,7 @@
                     <a:p>
                       <a:pPr algn="l"/>
                       <a:r>
-                        <a:rPr sz="1600" b="0" i="0">
+                        <a:rPr sz="1500" b="0" i="0">
                           <a:solidFill>
                             <a:srgbClr val="333333"/>
                           </a:solidFill>
@@ -6081,13 +6081,13 @@
                     <a:p>
                       <a:pPr algn="ctr"/>
                       <a:r>
-                        <a:rPr sz="1600" b="0" i="0">
+                        <a:rPr sz="1500" b="0" i="0">
                           <a:solidFill>
                             <a:srgbClr val="333333"/>
                           </a:solidFill>
                           <a:latin typeface="Calibri"/>
                         </a:rPr>
-                        <a:t>Notification push gratuite, admin alerté partout</a:t>
+                        <a:t>Astreinte alertée partout, sans coût de notification</a:t>
                       </a:r>
                     </a:p>
                   </a:txBody>
@@ -6106,7 +6106,7 @@
                     <a:p>
                       <a:pPr algn="l"/>
                       <a:r>
-                        <a:rPr sz="1600" b="0" i="0">
+                        <a:rPr sz="1500" b="0" i="0">
                           <a:solidFill>
                             <a:srgbClr val="333333"/>
                           </a:solidFill>
@@ -6129,13 +6129,13 @@
                     <a:p>
                       <a:pPr algn="ctr"/>
                       <a:r>
-                        <a:rPr sz="1600" b="0" i="0">
+                        <a:rPr sz="1500" b="0" i="0">
                           <a:solidFill>
                             <a:srgbClr val="333333"/>
                           </a:solidFill>
                           <a:latin typeface="Calibri"/>
                         </a:rPr>
-                        <a:t>Tourne sur un mini-serveur / VM 1 vCPU</a:t>
+                        <a:t>1 VM par client / mutualisée : coûts d'exploitation réduits</a:t>
                       </a:r>
                     </a:p>
                   </a:txBody>
@@ -6154,7 +6154,7 @@
                     <a:p>
                       <a:pPr algn="l"/>
                       <a:r>
-                        <a:rPr sz="1600" b="0" i="0">
+                        <a:rPr sz="1500" b="0" i="0">
                           <a:solidFill>
                             <a:srgbClr val="333333"/>
                           </a:solidFill>
@@ -6177,13 +6177,13 @@
                     <a:p>
                       <a:pPr algn="ctr"/>
                       <a:r>
-                        <a:rPr sz="1600" b="0" i="0">
+                        <a:rPr sz="1500" b="0" i="0">
                           <a:solidFill>
                             <a:srgbClr val="333333"/>
                           </a:solidFill>
                           <a:latin typeface="Calibri"/>
                         </a:rPr>
-                        <a:t>Personnalisation totale, zéro vendor lock-in</a:t>
+                        <a:t>Adaptable à chaque client, zéro vendor lock-in</a:t>
                       </a:r>
                     </a:p>
                   </a:txBody>
@@ -6202,7 +6202,7 @@
                     <a:p>
                       <a:pPr algn="l"/>
                       <a:r>
-                        <a:rPr sz="1600" b="0" i="0">
+                        <a:rPr sz="1500" b="0" i="0">
                           <a:solidFill>
                             <a:srgbClr val="333333"/>
                           </a:solidFill>
@@ -6225,13 +6225,13 @@
                     <a:p>
                       <a:pPr algn="ctr"/>
                       <a:r>
-                        <a:rPr sz="1600" b="0" i="0">
+                        <a:rPr sz="1500" b="0" i="0">
                           <a:solidFill>
                             <a:srgbClr val="333333"/>
                           </a:solidFill>
                           <a:latin typeface="Calibri"/>
                         </a:rPr>
-                        <a:t>Découverte auto. + déploiement en &lt; 30 min</a:t>
+                        <a:t>Onboarding d'un nouveau client en &lt; 30 min</a:t>
                       </a:r>
                     </a:p>
                   </a:txBody>
@@ -6250,7 +6250,7 @@
                     <a:p>
                       <a:pPr algn="l"/>
                       <a:r>
-                        <a:rPr sz="1600" b="0" i="0">
+                        <a:rPr sz="1500" b="0" i="0">
                           <a:solidFill>
                             <a:srgbClr val="333333"/>
                           </a:solidFill>
@@ -6273,13 +6273,13 @@
                     <a:p>
                       <a:pPr algn="ctr"/>
                       <a:r>
-                        <a:rPr sz="1600" b="0" i="0">
+                        <a:rPr sz="1500" b="0" i="0">
                           <a:solidFill>
                             <a:srgbClr val="333333"/>
                           </a:solidFill>
                           <a:latin typeface="Calibri"/>
                         </a:rPr>
-                        <a:t>Historique structuré → maintenance prédictive</a:t>
+                        <a:t>Historique structuré → futur service prédictif vendable</a:t>
                       </a:r>
                     </a:p>
                   </a:txBody>
@@ -6386,7 +6386,7 @@
                 </a:solidFill>
                 <a:latin typeface="Calibri"/>
               </a:rPr>
-              <a:t>L'innovation n'est pas une brique isolée, mais l'ASSEMBLAGE : simplicité + gratuité + notification mobile + extensibilité IA.</a:t>
+              <a:t>Pour OPEN MOISE, l'innovation est l'ASSEMBLAGE : simplicité + gratuité + notification mobile + extensibilité IA → un avantage concurrentiel.</a:t>
             </a:r>
           </a:p>
         </p:txBody>
@@ -6582,7 +6582,7 @@
                 </a:solidFill>
                 <a:latin typeface="Calibri"/>
               </a:rPr>
-              <a:t>•  Faisabilité technique ✓ — briques matures, compétences maîtrisées, prototype réalisé et testé.</a:t>
+              <a:t>•  Faisabilité technique ✓ — briques matures, compétences déjà présentes chez OPEN MOISE, prototype réalisé et testé.</a:t>
             </a:r>
           </a:p>
           <a:p>
@@ -6598,7 +6598,7 @@
                 </a:solidFill>
                 <a:latin typeface="Calibri"/>
               </a:rPr>
-              <a:t>•  Faisabilité économique ✓ — coût de licence nul, matériel minimal.</a:t>
+              <a:t>•  Faisabilité économique ✓ — coût de licence nul, matériel mutualisé OPEN MOISE.</a:t>
             </a:r>
           </a:p>
           <a:p>
@@ -6614,7 +6614,7 @@
                 </a:solidFill>
                 <a:latin typeface="Calibri"/>
               </a:rPr>
-              <a:t>•  Faisabilité organisationnelle ✓ — déploiement et prise en main rapides.</a:t>
+              <a:t>•  Faisabilité organisationnelle ✓ — intégrable au processus d'astreinte d'OPEN MOISE.</a:t>
             </a:r>
           </a:p>
           <a:p>
@@ -8791,7 +8791,7 @@
                 </a:solidFill>
                 <a:latin typeface="Calibri"/>
               </a:rPr>
-              <a:t>1.  Tableau de bord — vue temps réel : équipements UP, KPI, graphiques</a:t>
+              <a:t>1.  Tableau de bord OPEN MOISE — parc client supervisé en temps réel (UP/KPI)</a:t>
             </a:r>
           </a:p>
           <a:p>
@@ -8807,7 +8807,7 @@
                 </a:solidFill>
                 <a:latin typeface="Calibri"/>
               </a:rPr>
-              <a:t>2.  Je débranche / éteins un équipement supervisé</a:t>
+              <a:t>2.  Je simule une panne sur un équipement d'un réseau client</a:t>
             </a:r>
           </a:p>
           <a:p>
@@ -8839,7 +8839,7 @@
                 </a:solidFill>
                 <a:latin typeface="Calibri"/>
               </a:rPr>
-              <a:t>4.  L'alerte arrive : e-mail + notification Telegram sur le téléphone</a:t>
+              <a:t>4.  L'astreinte OPEN MOISE est alertée : e-mail + Telegram sur le téléphone</a:t>
             </a:r>
           </a:p>
           <a:p>
@@ -8855,7 +8855,7 @@
                 </a:solidFill>
                 <a:latin typeface="Calibri"/>
               </a:rPr>
-              <a:t>5.  Je rallume → notification de rétablissement + acquittement auto</a:t>
+              <a:t>5.  Je rétablis → notification de rétablissement + acquittement auto</a:t>
             </a:r>
           </a:p>
           <a:p>
@@ -8871,7 +8871,7 @@
                 </a:solidFill>
                 <a:latin typeface="Calibri"/>
               </a:rPr>
-              <a:t>6.  Page Rapports : historique, taux de disponibilité, latences</a:t>
+              <a:t>6.  Page Rapports : preuve de disponibilité / SLA à présenter au client</a:t>
             </a:r>
           </a:p>
         </p:txBody>
@@ -9584,7 +9584,7 @@
                 </a:solidFill>
                 <a:latin typeface="Calibri"/>
               </a:rPr>
-              <a:t>À insérer : les captures d'écran réelles de l'application déployée.</a:t>
+              <a:t>À insérer : les captures d'écran réelles de l'application déployée chez OPEN MOISE.</a:t>
             </a:r>
           </a:p>
         </p:txBody>
@@ -9894,7 +9894,7 @@
                 </a:solidFill>
                 <a:latin typeface="Calibri"/>
               </a:rPr>
-              <a:t>•  9.  Marketing, vente &amp; concurrence</a:t>
+              <a:t>•  9.  Valorisation pour OPEN MOISE &amp; concurrence</a:t>
             </a:r>
           </a:p>
           <a:p>
@@ -10115,7 +10115,7 @@
                 </a:solidFill>
                 <a:latin typeface="Calibri"/>
               </a:rPr>
-              <a:t>Marketing, vente et concurrence</a:t>
+              <a:t>Valorisation pour OPEN MOISE &amp; concurrence</a:t>
             </a:r>
           </a:p>
         </p:txBody>
@@ -10128,8 +10128,8 @@
         </p:nvSpPr>
         <p:spPr>
           <a:xfrm>
-            <a:off x="640080" y="1371600"/>
-            <a:ext cx="10881360" cy="4572000"/>
+            <a:off x="640080" y="1325880"/>
+            <a:ext cx="10881360" cy="4754880"/>
           </a:xfrm>
           <a:prstGeom prst="rect">
             <a:avLst/>
@@ -10148,13 +10148,45 @@
               </a:spcAft>
             </a:pPr>
             <a:r>
-              <a:rPr sz="1800" b="0" i="0">
+              <a:rPr sz="1700" b="1" i="0">
+                <a:solidFill>
+                  <a:srgbClr val="0D3B66"/>
+                </a:solidFill>
+                <a:latin typeface="Calibri"/>
+              </a:rPr>
+              <a:t>•  Double valeur pour OPEN MOISE :</a:t>
+            </a:r>
+          </a:p>
+          <a:p>
+            <a:pPr lvl="1">
+              <a:spcAft>
+                <a:spcPts val="800"/>
+              </a:spcAft>
+            </a:pPr>
+            <a:r>
+              <a:rPr sz="1500" b="0" i="0">
                 <a:solidFill>
                   <a:srgbClr val="333333"/>
                 </a:solidFill>
                 <a:latin typeface="Calibri"/>
               </a:rPr>
-              <a:t>•  Cible : PME, écoles, administrations, cybercafés, hébergeurs, MSP (infogérants).</a:t>
+              <a:t>–  Outil INTERNE : industrialise la supervision, fiabilise les SLA, réduit l'astreinte</a:t>
+            </a:r>
+          </a:p>
+          <a:p>
+            <a:pPr lvl="1">
+              <a:spcAft>
+                <a:spcPts val="800"/>
+              </a:spcAft>
+            </a:pPr>
+            <a:r>
+              <a:rPr sz="1500" b="0" i="0">
+                <a:solidFill>
+                  <a:srgbClr val="333333"/>
+                </a:solidFill>
+                <a:latin typeface="Calibri"/>
+              </a:rPr>
+              <a:t>–  Nouvelle OFFRE : « Supervision managée » vendue aux clients d'OPEN MOISE</a:t>
             </a:r>
           </a:p>
           <a:p>
@@ -10164,7 +10196,7 @@
               </a:spcAft>
             </a:pPr>
             <a:r>
-              <a:rPr sz="1800" b="0" i="0">
+              <a:rPr sz="1700" b="0" i="0">
                 <a:solidFill>
                   <a:srgbClr val="333333"/>
                 </a:solidFill>
@@ -10180,13 +10212,13 @@
               </a:spcAft>
             </a:pPr>
             <a:r>
-              <a:rPr sz="1800" b="1" i="0">
+              <a:rPr sz="1700" b="1" i="0">
                 <a:solidFill>
                   <a:srgbClr val="0D3B66"/>
                 </a:solidFill>
                 <a:latin typeface="Calibri"/>
               </a:rPr>
-              <a:t>•  Proposition de valeur :</a:t>
+              <a:t>•  Proposition de valeur d'OPEN MOISE à ses clients :</a:t>
             </a:r>
           </a:p>
           <a:p>
@@ -10196,13 +10228,13 @@
               </a:spcAft>
             </a:pPr>
             <a:r>
-              <a:rPr sz="1600" b="0" i="0">
+              <a:rPr sz="1500" b="0" i="0">
                 <a:solidFill>
                   <a:srgbClr val="0D6EFD"/>
                 </a:solidFill>
                 <a:latin typeface="Calibri"/>
               </a:rPr>
-              <a:t>–  « Supervisez votre réseau et soyez alerté sur votre téléphone en cas de panne — sans licence, sans complexité. »</a:t>
+              <a:t>–  « OPEN MOISE surveille votre réseau 24/7 et intervient avant que vous ne constatiez la panne. »</a:t>
             </a:r>
           </a:p>
           <a:p>
@@ -10212,7 +10244,7 @@
               </a:spcAft>
             </a:pPr>
             <a:r>
-              <a:rPr sz="1800" b="0" i="0">
+              <a:rPr sz="1700" b="0" i="0">
                 <a:solidFill>
                   <a:srgbClr val="333333"/>
                 </a:solidFill>
@@ -10228,13 +10260,13 @@
               </a:spcAft>
             </a:pPr>
             <a:r>
-              <a:rPr sz="1800" b="1" i="0">
+              <a:rPr sz="1700" b="1" i="0">
                 <a:solidFill>
                   <a:srgbClr val="0D3B66"/>
                 </a:solidFill>
                 <a:latin typeface="Calibri"/>
               </a:rPr>
-              <a:t>•  Modèle économique (open-core) :</a:t>
+              <a:t>•  Monétisation (offre de service) :</a:t>
             </a:r>
           </a:p>
           <a:p>
@@ -10244,13 +10276,13 @@
               </a:spcAft>
             </a:pPr>
             <a:r>
-              <a:rPr sz="1600" b="0" i="0">
+              <a:rPr sz="1500" b="0" i="0">
                 <a:solidFill>
                   <a:srgbClr val="333333"/>
                 </a:solidFill>
                 <a:latin typeface="Calibri"/>
               </a:rPr>
-              <a:t>–  Cœur open-source gratuit (adoption &amp; confiance)</a:t>
+              <a:t>–  Abonnement mensuel de supervision managée (par site / par équipement)</a:t>
             </a:r>
           </a:p>
           <a:p>
@@ -10260,29 +10292,13 @@
               </a:spcAft>
             </a:pPr>
             <a:r>
-              <a:rPr sz="1600" b="0" i="0">
+              <a:rPr sz="1500" b="0" i="0">
                 <a:solidFill>
                   <a:srgbClr val="333333"/>
                 </a:solidFill>
                 <a:latin typeface="Calibri"/>
               </a:rPr>
-              <a:t>–  Services : installation, formation, support (abonnement)</a:t>
-            </a:r>
-          </a:p>
-          <a:p>
-            <a:pPr lvl="1">
-              <a:spcAft>
-                <a:spcPts val="800"/>
-              </a:spcAft>
-            </a:pPr>
-            <a:r>
-              <a:rPr sz="1600" b="0" i="0">
-                <a:solidFill>
-                  <a:srgbClr val="333333"/>
-                </a:solidFill>
-                <a:latin typeface="Calibri"/>
-              </a:rPr>
-              <a:t>–  Édition Pro : SNMP, multi-sites, IA prédictive, rapports avancés</a:t>
+              <a:t>–  Option Pro : SNMP, multi-sites, IA prédictive, rapports SLA avancés</a:t>
             </a:r>
           </a:p>
         </p:txBody>
@@ -10551,7 +10567,7 @@
                           </a:solidFill>
                           <a:latin typeface="Calibri"/>
                         </a:rPr>
-                        <a:t>Notre solution</a:t>
+                        <a:t>Solution OPEN MOISE</a:t>
                       </a:r>
                     </a:p>
                   </a:txBody>
@@ -11128,7 +11144,7 @@
                 </a:solidFill>
                 <a:latin typeface="Calibri"/>
               </a:rPr>
-              <a:t>Stratégie : ne pas affronter les géants sur le haut de gamme, mais dominer le segment délaissé des petites structures (« océan bleu »).</a:t>
+              <a:t>Stratégie d'OPEN MOISE : ne pas affronter les géants sur le haut de gamme, mais se différencier sur le segment des PME avec une offre managée simple et sans licence (« océan bleu »).</a:t>
             </a:r>
           </a:p>
         </p:txBody>
@@ -11285,7 +11301,7 @@
                 </a:solidFill>
                 <a:latin typeface="Calibri"/>
               </a:rPr>
-              <a:t>Prévisions financières</a:t>
+              <a:t>Prévisions financières (OPEN MOISE)</a:t>
             </a:r>
           </a:p>
         </p:txBody>
@@ -11319,7 +11335,7 @@
                 </a:solidFill>
                 <a:latin typeface="Calibri"/>
               </a:rPr>
-              <a:t>Coûts de mise en place</a:t>
+              <a:t>Investissement d'OPEN MOISE</a:t>
             </a:r>
           </a:p>
         </p:txBody>
@@ -11456,7 +11472,7 @@
                           </a:solidFill>
                           <a:latin typeface="Calibri"/>
                         </a:rPr>
-                        <a:t>Serveur (VM / mini-PC)</a:t>
+                        <a:t>Serveur / VM (mutualisé)</a:t>
                       </a:r>
                     </a:p>
                   </a:txBody>
@@ -11504,7 +11520,7 @@
                           </a:solidFill>
                           <a:latin typeface="Calibri"/>
                         </a:rPr>
-                        <a:t>Déploiement (temps)</a:t>
+                        <a:t>Développement &amp; déploiement</a:t>
                       </a:r>
                     </a:p>
                   </a:txBody>
@@ -11527,7 +11543,7 @@
                           </a:solidFill>
                           <a:latin typeface="Calibri"/>
                         </a:rPr>
-                        <a:t>~1 j de prestation</a:t>
+                        <a:t>Interne (réalisé)</a:t>
                       </a:r>
                     </a:p>
                   </a:txBody>
@@ -11552,7 +11568,7 @@
                           </a:solidFill>
                           <a:latin typeface="Calibri"/>
                         </a:rPr>
-                        <a:t>Total entrée</a:t>
+                        <a:t>Total d'entrée</a:t>
                       </a:r>
                     </a:p>
                   </a:txBody>
@@ -11613,13 +11629,13 @@
           <a:lstStyle/>
           <a:p>
             <a:r>
-              <a:rPr sz="1700" b="1" i="0">
+              <a:rPr sz="1600" b="1" i="0">
                 <a:solidFill>
                   <a:srgbClr val="0D3B66"/>
                 </a:solidFill>
                 <a:latin typeface="Calibri"/>
               </a:rPr>
-              <a:t>Revenus (scénario prestataire, an 1)</a:t>
+              <a:t>Revenus &amp; gains pour OPEN MOISE (an 1)</a:t>
             </a:r>
           </a:p>
         </p:txBody>
@@ -11634,7 +11650,7 @@
         </p:nvGraphicFramePr>
         <p:xfrm>
           <a:off x="6309360" y="1737360"/>
-          <a:ext cx="5394960" cy="2377440"/>
+          <a:ext cx="5394960" cy="2651760"/>
         </p:xfrm>
         <a:graphic>
           <a:graphicData uri="http://schemas.openxmlformats.org/drawingml/2006/table">
@@ -11647,7 +11663,7 @@
                 <a:gridCol w="1798320"/>
                 <a:gridCol w="1798320"/>
               </a:tblGrid>
-              <a:tr h="475488">
+              <a:tr h="441960">
                 <a:tc>
                   <a:txBody>
                     <a:bodyPr/>
@@ -11655,7 +11671,7 @@
                     <a:p>
                       <a:pPr algn="ctr"/>
                       <a:r>
-                        <a:rPr sz="1400" b="1" i="0">
+                        <a:rPr sz="1300" b="1" i="0">
                           <a:solidFill>
                             <a:srgbClr val="FFFFFF"/>
                           </a:solidFill>
@@ -11678,7 +11694,7 @@
                     <a:p>
                       <a:pPr algn="ctr"/>
                       <a:r>
-                        <a:rPr sz="1400" b="1" i="0">
+                        <a:rPr sz="1300" b="1" i="0">
                           <a:solidFill>
                             <a:srgbClr val="FFFFFF"/>
                           </a:solidFill>
@@ -11701,13 +11717,13 @@
                     <a:p>
                       <a:pPr algn="ctr"/>
                       <a:r>
-                        <a:rPr sz="1400" b="1" i="0">
+                        <a:rPr sz="1300" b="1" i="0">
                           <a:solidFill>
                             <a:srgbClr val="FFFFFF"/>
                           </a:solidFill>
                           <a:latin typeface="Calibri"/>
                         </a:rPr>
-                        <a:t>Revenu</a:t>
+                        <a:t>Montant</a:t>
                       </a:r>
                     </a:p>
                   </a:txBody>
@@ -11718,7 +11734,7 @@
                   </a:tcPr>
                 </a:tc>
               </a:tr>
-              <a:tr h="475488">
+              <a:tr h="441960">
                 <a:tc>
                   <a:txBody>
                     <a:bodyPr/>
@@ -11726,13 +11742,13 @@
                     <a:p>
                       <a:pPr algn="l"/>
                       <a:r>
-                        <a:rPr sz="1400" b="0" i="0">
+                        <a:rPr sz="1300" b="0" i="0">
                           <a:solidFill>
                             <a:srgbClr val="333333"/>
                           </a:solidFill>
                           <a:latin typeface="Calibri"/>
                         </a:rPr>
-                        <a:t>Installation+formation</a:t>
+                        <a:t>Supervision managée</a:t>
                       </a:r>
                     </a:p>
                   </a:txBody>
@@ -11749,13 +11765,13 @@
                     <a:p>
                       <a:pPr algn="ctr"/>
                       <a:r>
-                        <a:rPr sz="1400" b="0" i="0">
+                        <a:rPr sz="1300" b="0" i="0">
                           <a:solidFill>
                             <a:srgbClr val="333333"/>
                           </a:solidFill>
                           <a:latin typeface="Calibri"/>
                         </a:rPr>
-                        <a:t>10 × 300 €</a:t>
+                        <a:t>10 clients × 40 €/mois</a:t>
                       </a:r>
                     </a:p>
                   </a:txBody>
@@ -11772,13 +11788,13 @@
                     <a:p>
                       <a:pPr algn="ctr"/>
                       <a:r>
-                        <a:rPr sz="1400" b="1" i="0">
+                        <a:rPr sz="1300" b="1" i="0">
                           <a:solidFill>
                             <a:srgbClr val="198754"/>
                           </a:solidFill>
                           <a:latin typeface="Calibri"/>
                         </a:rPr>
-                        <a:t>3 000 €</a:t>
+                        <a:t>4 800 €</a:t>
                       </a:r>
                     </a:p>
                   </a:txBody>
@@ -11789,7 +11805,7 @@
                   </a:tcPr>
                 </a:tc>
               </a:tr>
-              <a:tr h="475488">
+              <a:tr h="441960">
                 <a:tc>
                   <a:txBody>
                     <a:bodyPr/>
@@ -11797,13 +11813,13 @@
                     <a:p>
                       <a:pPr algn="l"/>
                       <a:r>
-                        <a:rPr sz="1400" b="0" i="0">
+                        <a:rPr sz="1300" b="0" i="0">
                           <a:solidFill>
                             <a:srgbClr val="333333"/>
                           </a:solidFill>
                           <a:latin typeface="Calibri"/>
                         </a:rPr>
-                        <a:t>Support (abonnement)</a:t>
+                        <a:t>Mise en service client</a:t>
                       </a:r>
                     </a:p>
                   </a:txBody>
@@ -11820,13 +11836,13 @@
                     <a:p>
                       <a:pPr algn="ctr"/>
                       <a:r>
-                        <a:rPr sz="1400" b="0" i="0">
+                        <a:rPr sz="1300" b="0" i="0">
                           <a:solidFill>
                             <a:srgbClr val="333333"/>
                           </a:solidFill>
                           <a:latin typeface="Calibri"/>
                         </a:rPr>
-                        <a:t>10 × 40 €/mois</a:t>
+                        <a:t>10 × 300 €</a:t>
                       </a:r>
                     </a:p>
                   </a:txBody>
@@ -11843,13 +11859,13 @@
                     <a:p>
                       <a:pPr algn="ctr"/>
                       <a:r>
-                        <a:rPr sz="1400" b="1" i="0">
+                        <a:rPr sz="1300" b="1" i="0">
                           <a:solidFill>
                             <a:srgbClr val="198754"/>
                           </a:solidFill>
                           <a:latin typeface="Calibri"/>
                         </a:rPr>
-                        <a:t>4 800 €</a:t>
+                        <a:t>3 000 €</a:t>
                       </a:r>
                     </a:p>
                   </a:txBody>
@@ -11860,7 +11876,7 @@
                   </a:tcPr>
                 </a:tc>
               </a:tr>
-              <a:tr h="475488">
+              <a:tr h="441960">
                 <a:tc>
                   <a:txBody>
                     <a:bodyPr/>
@@ -11868,13 +11884,13 @@
                     <a:p>
                       <a:pPr algn="l"/>
                       <a:r>
-                        <a:rPr sz="1400" b="0" i="0">
+                        <a:rPr sz="1300" b="0" i="0">
                           <a:solidFill>
                             <a:srgbClr val="333333"/>
                           </a:solidFill>
                           <a:latin typeface="Calibri"/>
                         </a:rPr>
-                        <a:t>Édition Pro</a:t>
+                        <a:t>Option Pro (SNMP/IA)</a:t>
                       </a:r>
                     </a:p>
                   </a:txBody>
@@ -11891,7 +11907,7 @@
                     <a:p>
                       <a:pPr algn="ctr"/>
                       <a:r>
-                        <a:rPr sz="1400" b="0" i="0">
+                        <a:rPr sz="1300" b="0" i="0">
                           <a:solidFill>
                             <a:srgbClr val="333333"/>
                           </a:solidFill>
@@ -11914,7 +11930,7 @@
                     <a:p>
                       <a:pPr algn="ctr"/>
                       <a:r>
-                        <a:rPr sz="1400" b="1" i="0">
+                        <a:rPr sz="1300" b="1" i="0">
                           <a:solidFill>
                             <a:srgbClr val="198754"/>
                           </a:solidFill>
@@ -11931,7 +11947,7 @@
                   </a:tcPr>
                 </a:tc>
               </a:tr>
-              <a:tr h="475488">
+              <a:tr h="441960">
                 <a:tc>
                   <a:txBody>
                     <a:bodyPr/>
@@ -11939,13 +11955,13 @@
                     <a:p>
                       <a:pPr algn="l"/>
                       <a:r>
-                        <a:rPr sz="1400" b="0" i="0">
+                        <a:rPr sz="1300" b="0" i="0">
                           <a:solidFill>
                             <a:srgbClr val="333333"/>
                           </a:solidFill>
                           <a:latin typeface="Calibri"/>
                         </a:rPr>
-                        <a:t>Total an 1</a:t>
+                        <a:t>Pénalités SLA évitées</a:t>
                       </a:r>
                     </a:p>
                   </a:txBody>
@@ -11962,13 +11978,13 @@
                     <a:p>
                       <a:pPr algn="ctr"/>
                       <a:r>
-                        <a:rPr sz="1400" b="0" i="0">
+                        <a:rPr sz="1300" b="0" i="0">
                           <a:solidFill>
                             <a:srgbClr val="333333"/>
                           </a:solidFill>
                           <a:latin typeface="Calibri"/>
                         </a:rPr>
-                        <a:t/>
+                        <a:t>estimation</a:t>
                       </a:r>
                     </a:p>
                   </a:txBody>
@@ -11985,7 +12001,78 @@
                     <a:p>
                       <a:pPr algn="ctr"/>
                       <a:r>
-                        <a:rPr sz="1400" b="1" i="0">
+                        <a:rPr sz="1300" b="1" i="0">
+                          <a:solidFill>
+                            <a:srgbClr val="198754"/>
+                          </a:solidFill>
+                          <a:latin typeface="Calibri"/>
+                        </a:rPr>
+                        <a:t>+ gains</a:t>
+                      </a:r>
+                    </a:p>
+                  </a:txBody>
+                  <a:tcPr>
+                    <a:solidFill>
+                      <a:srgbClr val="F1F3F5"/>
+                    </a:solidFill>
+                  </a:tcPr>
+                </a:tc>
+              </a:tr>
+              <a:tr h="441960">
+                <a:tc>
+                  <a:txBody>
+                    <a:bodyPr/>
+                    <a:lstStyle/>
+                    <a:p>
+                      <a:pPr algn="l"/>
+                      <a:r>
+                        <a:rPr sz="1300" b="0" i="0">
+                          <a:solidFill>
+                            <a:srgbClr val="333333"/>
+                          </a:solidFill>
+                          <a:latin typeface="Calibri"/>
+                        </a:rPr>
+                        <a:t>Total an 1</a:t>
+                      </a:r>
+                    </a:p>
+                  </a:txBody>
+                  <a:tcPr>
+                    <a:solidFill>
+                      <a:srgbClr val="FFFFFF"/>
+                    </a:solidFill>
+                  </a:tcPr>
+                </a:tc>
+                <a:tc>
+                  <a:txBody>
+                    <a:bodyPr/>
+                    <a:lstStyle/>
+                    <a:p>
+                      <a:pPr algn="ctr"/>
+                      <a:r>
+                        <a:rPr sz="1300" b="0" i="0">
+                          <a:solidFill>
+                            <a:srgbClr val="333333"/>
+                          </a:solidFill>
+                          <a:latin typeface="Calibri"/>
+                        </a:rPr>
+                        <a:t/>
+                      </a:r>
+                    </a:p>
+                  </a:txBody>
+                  <a:tcPr>
+                    <a:solidFill>
+                      <a:srgbClr val="FFFFFF"/>
+                    </a:solidFill>
+                  </a:tcPr>
+                </a:tc>
+                <a:tc>
+                  <a:txBody>
+                    <a:bodyPr/>
+                    <a:lstStyle/>
+                    <a:p>
+                      <a:pPr algn="ctr"/>
+                      <a:r>
+                        <a:rPr sz="1300" b="1" i="0">
                           <a:solidFill>
                             <a:srgbClr val="198754"/>
                           </a:solidFill>
@@ -11997,7 +12084,7 @@
                   </a:txBody>
                   <a:tcPr>
                     <a:solidFill>
-                      <a:srgbClr val="F1F3F5"/>
+                      <a:srgbClr val="FFFFFF"/>
                     </a:solidFill>
                   </a:tcPr>
                 </a:tc>
@@ -12014,8 +12101,8 @@
         </p:nvSpPr>
         <p:spPr>
           <a:xfrm>
-            <a:off x="640080" y="5212080"/>
-            <a:ext cx="109728" cy="1005840"/>
+            <a:off x="640080" y="5394960"/>
+            <a:ext cx="109728" cy="914400"/>
           </a:xfrm>
           <a:prstGeom prst="rect">
             <a:avLst/>
@@ -12058,8 +12145,8 @@
         </p:nvSpPr>
         <p:spPr>
           <a:xfrm>
-            <a:off x="749808" y="5212080"/>
-            <a:ext cx="10771632" cy="1005840"/>
+            <a:off x="749808" y="5394960"/>
+            <a:ext cx="10771632" cy="914400"/>
           </a:xfrm>
           <a:prstGeom prst="rect">
             <a:avLst/>
@@ -12098,7 +12185,7 @@
                 </a:solidFill>
                 <a:latin typeface="Calibri"/>
               </a:rPr>
-              <a:t>ROI client : 1 h de panne évitée ≫ coût de la solution (≈ 200 €). Elle s'autofinance dès le premier incident majeur évité.</a:t>
+              <a:t>Double retour pour OPEN MOISE : revenus récurrents (offre managée) + économies internes (moins d'astreinte, pénalités SLA évitées). Investissement ≈ 200 € amorti dès le 1er client.</a:t>
             </a:r>
           </a:p>
         </p:txBody>
@@ -12390,7 +12477,7 @@
                 </a:solidFill>
                 <a:latin typeface="Calibri"/>
               </a:rPr>
-              <a:t>•  Perspectives :</a:t>
+              <a:t>•  Perspectives (feuille de route OPEN MOISE) :</a:t>
             </a:r>
           </a:p>
           <a:p>
@@ -12406,7 +12493,7 @@
                 </a:solidFill>
                 <a:latin typeface="Calibri"/>
               </a:rPr>
-              <a:t>–  Intégration SNMP (performances détaillées)</a:t>
+              <a:t>–  Intégration SNMP (performances détaillées des équipements clients)</a:t>
             </a:r>
           </a:p>
           <a:p>
@@ -12422,7 +12509,7 @@
                 </a:solidFill>
                 <a:latin typeface="Calibri"/>
               </a:rPr>
-              <a:t>–  Machine Learning : détection d'anomalies</a:t>
+              <a:t>–  Machine Learning : détection d'anomalies sur l'historique multi-clients</a:t>
             </a:r>
           </a:p>
           <a:p>
@@ -12438,7 +12525,7 @@
                 </a:solidFill>
                 <a:latin typeface="Calibri"/>
               </a:rPr>
-              <a:t>–  Maintenance prédictive (anticiper la panne) · Auto-remédiation (AIOps)</a:t>
+              <a:t>–  Maintenance prédictive vendable comme offre premium · Auto-remédiation (AIOps)</a:t>
             </a:r>
           </a:p>
           <a:p>
@@ -12454,7 +12541,7 @@
                 </a:solidFill>
                 <a:latin typeface="Calibri"/>
               </a:rPr>
-              <a:t>–  Conteneurisation (Docker/K8s) · Canaux SMS, Slack, Teams</a:t>
+              <a:t>–  Portail multi-clients · Conteneurisation (Docker/K8s) · SMS, Slack, Teams</a:t>
             </a:r>
           </a:p>
         </p:txBody>
@@ -12591,13 +12678,13 @@
               </a:spcAft>
             </a:pPr>
             <a:r>
-              <a:rPr sz="2200" b="1" i="0">
+              <a:rPr sz="2100" b="1" i="0">
                 <a:solidFill>
                   <a:srgbClr val="198754"/>
                 </a:solidFill>
                 <a:latin typeface="Calibri"/>
               </a:rPr>
-              <a:t>•  Un produit fonctionnel, testé, 100 % open-source</a:t>
+              <a:t>•  Pour OPEN MOISE : un outil fonctionnel, testé, 100 % open-source</a:t>
             </a:r>
           </a:p>
           <a:p>
@@ -12607,13 +12694,13 @@
               </a:spcAft>
             </a:pPr>
             <a:r>
-              <a:rPr sz="2200" b="1" i="0">
+              <a:rPr sz="2100" b="1" i="0">
                 <a:solidFill>
                   <a:srgbClr val="198754"/>
                 </a:solidFill>
                 <a:latin typeface="Calibri"/>
               </a:rPr>
-              <a:t>•  Détection temps réel (&lt; 2 min) &amp; temps d'intervention réduit</a:t>
+              <a:t>•  Détection temps réel (&lt; 2 min) → SLA clients mieux respectés</a:t>
             </a:r>
           </a:p>
           <a:p>
@@ -12623,13 +12710,13 @@
               </a:spcAft>
             </a:pPr>
             <a:r>
-              <a:rPr sz="2200" b="1" i="0">
+              <a:rPr sz="2100" b="1" i="0">
                 <a:solidFill>
                   <a:srgbClr val="198754"/>
                 </a:solidFill>
                 <a:latin typeface="Calibri"/>
               </a:rPr>
-              <a:t>•  Un modèle économique viable (open-core) sur un segment délaissé</a:t>
+              <a:t>•  Double valeur : économies internes + nouvelle offre managée</a:t>
             </a:r>
           </a:p>
           <a:p>
@@ -12639,7 +12726,7 @@
               </a:spcAft>
             </a:pPr>
             <a:r>
-              <a:rPr sz="2200" b="1" i="0">
+              <a:rPr sz="2100" b="1" i="0">
                 <a:solidFill>
                   <a:srgbClr val="198754"/>
                 </a:solidFill>
@@ -12742,7 +12829,7 @@
                 </a:solidFill>
                 <a:latin typeface="Calibri"/>
               </a:rPr>
-              <a:t>De la supervision réactive vers une supervision proactive, accessible et intelligente. L'automatisation transforme la disponibilité réseau en avantage à la portée de toutes les organisations.</a:t>
+              <a:t>Pour OPEN MOISE, l'automatisation transforme la supervision en avantage concurrentiel : de la réaction subie vers un service proactif, fiable et rentable pour ses clients.</a:t>
             </a:r>
           </a:p>
         </p:txBody>
@@ -13422,13 +13509,13 @@
               </a:spcAft>
             </a:pPr>
             <a:r>
-              <a:rPr sz="2000" b="0" i="0">
+              <a:rPr sz="1900" b="0" i="0">
                 <a:solidFill>
                   <a:srgbClr val="333333"/>
                 </a:solidFill>
                 <a:latin typeface="Calibri"/>
               </a:rPr>
-              <a:t>•  Le sujet : concevoir, réaliser et valoriser un système qui surveille un réseau en continu, détecte automatiquement les pannes et alerte instantanément les administrateurs — 100 % open-source.</a:t>
+              <a:t>•  Le sujet : concevoir, réaliser et déployer chez OPEN MOISE un système qui surveille en continu les réseaux supervisés, détecte automatiquement les pannes et alerte instantanément les équipes — 100 % open-source.</a:t>
             </a:r>
           </a:p>
           <a:p>
@@ -13438,7 +13525,7 @@
               </a:spcAft>
             </a:pPr>
             <a:r>
-              <a:rPr sz="2000" b="0" i="0">
+              <a:rPr sz="1900" b="0" i="0">
                 <a:solidFill>
                   <a:srgbClr val="333333"/>
                 </a:solidFill>
@@ -13454,7 +13541,7 @@
               </a:spcAft>
             </a:pPr>
             <a:r>
-              <a:rPr sz="2000" b="1" i="0">
+              <a:rPr sz="1900" b="1" i="0">
                 <a:solidFill>
                   <a:srgbClr val="0D3B66"/>
                 </a:solidFill>
@@ -13470,13 +13557,13 @@
               </a:spcAft>
             </a:pPr>
             <a:r>
-              <a:rPr sz="1800" b="0" i="0">
+              <a:rPr sz="1700" b="0" i="0">
                 <a:solidFill>
                   <a:srgbClr val="333333"/>
                 </a:solidFill>
                 <a:latin typeface="Calibri"/>
               </a:rPr>
-              <a:t>–  Le réseau est devenu le « système nerveux » de toute organisation</a:t>
+              <a:t>–  Le réseau est le « système nerveux » des clients d'OPEN MOISE</a:t>
             </a:r>
           </a:p>
           <a:p>
@@ -13486,13 +13573,13 @@
               </a:spcAft>
             </a:pPr>
             <a:r>
-              <a:rPr sz="1800" b="0" i="0">
+              <a:rPr sz="1700" b="0" i="0">
                 <a:solidFill>
                   <a:srgbClr val="333333"/>
                 </a:solidFill>
                 <a:latin typeface="Calibri"/>
               </a:rPr>
-              <a:t>–  Une minute d'indisponibilité peut coûter très cher</a:t>
+              <a:t>–  Une minute d'indisponibilité menace les engagements de service (SLA)</a:t>
             </a:r>
           </a:p>
           <a:p>
@@ -13502,13 +13589,13 @@
               </a:spcAft>
             </a:pPr>
             <a:r>
-              <a:rPr sz="1800" b="0" i="0">
+              <a:rPr sz="1700" b="0" i="0">
                 <a:solidFill>
                   <a:srgbClr val="333333"/>
                 </a:solidFill>
                 <a:latin typeface="Calibri"/>
               </a:rPr>
-              <a:t>–  Vécu de terrain : pannes découvertes trop tard, par les utilisateurs</a:t>
+              <a:t>–  Vécu de terrain chez OPEN MOISE : pannes des parcs clients découvertes trop tard, souvent signalées par le client lui-même</a:t>
             </a:r>
           </a:p>
           <a:p>
@@ -13518,13 +13605,13 @@
               </a:spcAft>
             </a:pPr>
             <a:r>
-              <a:rPr sz="1800" b="0" i="0">
+              <a:rPr sz="1700" b="0" i="0">
                 <a:solidFill>
                   <a:srgbClr val="333333"/>
                 </a:solidFill>
                 <a:latin typeface="Calibri"/>
               </a:rPr>
-              <a:t>–  Conviction : l'open-source rend la supervision accessible à tous</a:t>
+              <a:t>–  Conviction : l'open-source permet d'industrialiser la supervision sans licence</a:t>
             </a:r>
           </a:p>
         </p:txBody>
@@ -13621,7 +13708,7 @@
                 </a:solidFill>
                 <a:latin typeface="Calibri"/>
               </a:rPr>
-              <a:t>Allier une expertise réseau à une démarche entrepreneuriale.</a:t>
+              <a:t>Répondre à un besoin réel d'OPEN MOISE en alliant expertise réseau et démarche entrepreneuriale.</a:t>
             </a:r>
           </a:p>
         </p:txBody>
@@ -14806,13 +14893,13 @@
               </a:spcAft>
             </a:pPr>
             <a:r>
-              <a:rPr sz="2000" b="0" i="0">
+              <a:rPr sz="1900" b="0" i="0">
                 <a:solidFill>
                   <a:srgbClr val="333333"/>
                 </a:solidFill>
                 <a:latin typeface="Calibri"/>
               </a:rPr>
-              <a:t>•  Contexte : densification des réseaux (cloud, virtualisation, IoT) face à des exigences de disponibilité de plus en plus fortes (« 99,9 % »).</a:t>
+              <a:t>•  Contexte : OPEN MOISE, ESN d'infogérance, exploite et supervise les réseaux de plusieurs clients, avec des engagements de disponibilité contractuels (SLA, « 99,9 % »).</a:t>
             </a:r>
           </a:p>
           <a:p>
@@ -14822,7 +14909,7 @@
               </a:spcAft>
             </a:pPr>
             <a:r>
-              <a:rPr sz="2000" b="0" i="0">
+              <a:rPr sz="1900" b="0" i="0">
                 <a:solidFill>
                   <a:srgbClr val="333333"/>
                 </a:solidFill>
@@ -14838,13 +14925,13 @@
               </a:spcAft>
             </a:pPr>
             <a:r>
-              <a:rPr sz="2000" b="1" i="0">
+              <a:rPr sz="1900" b="1" i="0">
                 <a:solidFill>
                   <a:srgbClr val="0D3B66"/>
                 </a:solidFill>
                 <a:latin typeface="Calibri"/>
               </a:rPr>
-              <a:t>•  Constat de terrain (PME / administrations) :</a:t>
+              <a:t>•  Constat de terrain chez OPEN MOISE :</a:t>
             </a:r>
           </a:p>
           <a:p>
@@ -14854,13 +14941,13 @@
               </a:spcAft>
             </a:pPr>
             <a:r>
-              <a:rPr sz="1800" b="0" i="0">
+              <a:rPr sz="1700" b="0" i="0">
                 <a:solidFill>
                   <a:srgbClr val="333333"/>
                 </a:solidFill>
                 <a:latin typeface="Calibri"/>
               </a:rPr>
-              <a:t>–  Supervision manuelle et épisodique (ping à la main)</a:t>
+              <a:t>–  Supervision largement manuelle et épisodique (ping à la main)</a:t>
             </a:r>
           </a:p>
           <a:p>
@@ -14870,13 +14957,13 @@
               </a:spcAft>
             </a:pPr>
             <a:r>
-              <a:rPr sz="1800" b="0" i="0">
+              <a:rPr sz="1700" b="0" i="0">
                 <a:solidFill>
                   <a:srgbClr val="333333"/>
                 </a:solidFill>
                 <a:latin typeface="Calibri"/>
               </a:rPr>
-              <a:t>–  Pannes signalées par les utilisateurs → réaction tardive</a:t>
+              <a:t>–  Pannes des parcs clients signalées par le client → réaction tardive</a:t>
             </a:r>
           </a:p>
           <a:p>
@@ -14886,13 +14973,13 @@
               </a:spcAft>
             </a:pPr>
             <a:r>
-              <a:rPr sz="1800" b="0" i="0">
+              <a:rPr sz="1700" b="0" i="0">
                 <a:solidFill>
                   <a:srgbClr val="333333"/>
                 </a:solidFill>
                 <a:latin typeface="Calibri"/>
               </a:rPr>
-              <a:t>–  Aucune traçabilité des incidents, pas d'historique exploitable</a:t>
+              <a:t>–  Aucune traçabilité des incidents → SLA difficiles à prouver</a:t>
             </a:r>
           </a:p>
           <a:p>
@@ -14902,13 +14989,13 @@
               </a:spcAft>
             </a:pPr>
             <a:r>
-              <a:rPr sz="1800" b="0" i="0">
+              <a:rPr sz="1700" b="0" i="0">
                 <a:solidFill>
                   <a:srgbClr val="333333"/>
                 </a:solidFill>
                 <a:latin typeface="Calibri"/>
               </a:rPr>
-              <a:t>–  Solutions professionnelles jugées trop chères ou trop complexes</a:t>
+              <a:t>–  Solutions du marché jugées trop chères ou trop lourdes à déployer</a:t>
             </a:r>
           </a:p>
         </p:txBody>
@@ -15016,13 +15103,13 @@
           <a:p>
             <a:pPr algn="ctr"/>
             <a:r>
-              <a:rPr sz="2200" b="1" i="1">
+              <a:rPr sz="2100" b="1" i="1">
                 <a:solidFill>
                   <a:srgbClr val="0D3B66"/>
                 </a:solidFill>
                 <a:latin typeface="Calibri"/>
               </a:rPr>
-              <a:t>« Comment détecter en temps réel les pannes d'un réseau et réduire le temps d'intervention des administrateurs, à l'aide d'une solution automatisée, fiable et économiquement accessible ? »</a:t>
+              <a:t>« Comment OPEN MOISE peut-elle détecter en temps réel les pannes des réseaux qu'elle supervise et réduire le temps d'intervention de ses équipes, à l'aide d'une solution automatisée, fiable et économiquement accessible ? »</a:t>
             </a:r>
           </a:p>
         </p:txBody>
@@ -15077,7 +15164,7 @@
                 </a:solidFill>
                 <a:latin typeface="Calibri"/>
               </a:rPr>
-              <a:t>•  Comment automatiser une surveillance continue et fiable (sans fausses alertes) ?</a:t>
+              <a:t>•  Comment automatiser une surveillance continue et fiable des parcs clients ?</a:t>
             </a:r>
           </a:p>
           <a:p>
@@ -15093,7 +15180,7 @@
                 </a:solidFill>
                 <a:latin typeface="Calibri"/>
               </a:rPr>
-              <a:t>•  Comment notifier l'administrateur où qu'il soit, instantanément ?</a:t>
+              <a:t>•  Comment alerter les équipes d'astreinte d'OPEN MOISE, où qu'elles soient ?</a:t>
             </a:r>
           </a:p>
           <a:p>
@@ -15109,7 +15196,7 @@
                 </a:solidFill>
                 <a:latin typeface="Calibri"/>
               </a:rPr>
-              <a:t>•  Comment offrir cette valeur à un coût quasi nul ?</a:t>
+              <a:t>•  Comment offrir cette valeur sans alourdir les coûts d'OPEN MOISE ?</a:t>
             </a:r>
           </a:p>
         </p:txBody>
@@ -15725,7 +15812,7 @@
                 </a:solidFill>
                 <a:latin typeface="Calibri"/>
               </a:rPr>
-              <a:t>Objectif général : livrer un produit fonctionnel, mesurablement plus performant que la supervision manuelle, pour un coût négligeable.</a:t>
+              <a:t>Objectif général : doter OPEN MOISE d'un outil fonctionnel, mesurablement plus performant que sa supervision manuelle actuelle, pour un coût négligeable.</a:t>
             </a:r>
           </a:p>
         </p:txBody>
@@ -16891,7 +16978,7 @@
                 </a:solidFill>
                 <a:latin typeface="Calibri"/>
               </a:rPr>
-              <a:t>Le vide identifié : rien de léger + gratuit + simple + sur mesure, avec notification mobile native, pour les petites structures.</a:t>
+              <a:t>Le vide identifié : rien de léger + gratuit + simple + sur mesure, avec notification mobile native, adapté à OPEN MOISE et à ses clients PME.</a:t>
             </a:r>
           </a:p>
         </p:txBody>

</xml_diff>

<commit_message>
Alignement strict des intitulés de sections sur le canevas officiel
Les titres des sections de la présentation suivent désormais exactement le
canevas mémoire-projet fourni :
- 5. L'axe de différenciation (innovation technologique)
- 6. Étude de faisabilité et conception de la solution
- 7. Fonctionnement de la solution : point de vue technique
- 9. Marketing, vente et concurrence (contenu OPEN MOISE conservé)
Sommaire et version Markdown (Marp) synchronisés.
</commit_message>
<xml_diff>
--- a/soutenance/presentation-projet.pptx
+++ b/soutenance/presentation-projet.pptx
@@ -5975,7 +5975,7 @@
                 </a:solidFill>
                 <a:latin typeface="Calibri"/>
               </a:rPr>
-              <a:t>Axe de différenciation (innovation)</a:t>
+              <a:t>L'axe de différenciation (innovation technologique)</a:t>
             </a:r>
           </a:p>
         </p:txBody>
@@ -6543,7 +6543,7 @@
                 </a:solidFill>
                 <a:latin typeface="Calibri"/>
               </a:rPr>
-              <a:t>Étude de faisabilité &amp; conception</a:t>
+              <a:t>Étude de faisabilité et conception de la solution</a:t>
             </a:r>
           </a:p>
         </p:txBody>
@@ -7912,7 +7912,7 @@
                 </a:solidFill>
                 <a:latin typeface="Calibri"/>
               </a:rPr>
-              <a:t>Fonctionnement technique — le cycle automatisé</a:t>
+              <a:t>Fonctionnement de la solution : point de vue technique</a:t>
             </a:r>
           </a:p>
         </p:txBody>
@@ -9701,8 +9701,8 @@
         </p:nvSpPr>
         <p:spPr>
           <a:xfrm>
-            <a:off x="640080" y="1463040"/>
-            <a:ext cx="5486400" cy="4937760"/>
+            <a:off x="548640" y="1463040"/>
+            <a:ext cx="5760720" cy="4937760"/>
           </a:xfrm>
           <a:prstGeom prst="rect">
             <a:avLst/>
@@ -9717,11 +9717,11 @@
           <a:p>
             <a:pPr>
               <a:spcAft>
-                <a:spcPts val="1200"/>
+                <a:spcPts val="1400"/>
               </a:spcAft>
             </a:pPr>
             <a:r>
-              <a:rPr sz="2000" b="1" i="0">
+              <a:rPr sz="1600" b="1" i="0">
                 <a:solidFill>
                   <a:srgbClr val="0D3B66"/>
                 </a:solidFill>
@@ -9733,11 +9733,11 @@
           <a:p>
             <a:pPr>
               <a:spcAft>
-                <a:spcPts val="1200"/>
+                <a:spcPts val="1400"/>
               </a:spcAft>
             </a:pPr>
             <a:r>
-              <a:rPr sz="2000" b="0" i="0">
+              <a:rPr sz="1600" b="0" i="0">
                 <a:solidFill>
                   <a:srgbClr val="333333"/>
                 </a:solidFill>
@@ -9749,11 +9749,11 @@
           <a:p>
             <a:pPr>
               <a:spcAft>
-                <a:spcPts val="1200"/>
+                <a:spcPts val="1400"/>
               </a:spcAft>
             </a:pPr>
             <a:r>
-              <a:rPr sz="2000" b="0" i="0">
+              <a:rPr sz="1600" b="0" i="0">
                 <a:solidFill>
                   <a:srgbClr val="333333"/>
                 </a:solidFill>
@@ -9765,11 +9765,11 @@
           <a:p>
             <a:pPr>
               <a:spcAft>
-                <a:spcPts val="1200"/>
+                <a:spcPts val="1400"/>
               </a:spcAft>
             </a:pPr>
             <a:r>
-              <a:rPr sz="2000" b="0" i="0">
+              <a:rPr sz="1600" b="0" i="0">
                 <a:solidFill>
                   <a:srgbClr val="333333"/>
                 </a:solidFill>
@@ -9781,49 +9781,49 @@
           <a:p>
             <a:pPr>
               <a:spcAft>
-                <a:spcPts val="1200"/>
+                <a:spcPts val="1400"/>
               </a:spcAft>
             </a:pPr>
             <a:r>
-              <a:rPr sz="2000" b="0" i="0">
+              <a:rPr sz="1600" b="0" i="0">
                 <a:solidFill>
                   <a:srgbClr val="333333"/>
                 </a:solidFill>
                 <a:latin typeface="Calibri"/>
               </a:rPr>
-              <a:t>•  4.  État des lieux &amp; solution proposée</a:t>
+              <a:t>•  4.  État des lieux des solutions existantes et solution proposée</a:t>
             </a:r>
           </a:p>
           <a:p>
             <a:pPr>
               <a:spcAft>
-                <a:spcPts val="1200"/>
+                <a:spcPts val="1400"/>
               </a:spcAft>
             </a:pPr>
             <a:r>
-              <a:rPr sz="2000" b="0" i="0">
+              <a:rPr sz="1600" b="0" i="0">
                 <a:solidFill>
                   <a:srgbClr val="333333"/>
                 </a:solidFill>
                 <a:latin typeface="Calibri"/>
               </a:rPr>
-              <a:t>•  5.  Axe de différenciation (innovation)</a:t>
+              <a:t>•  5.  L'axe de différenciation (innovation technologique)</a:t>
             </a:r>
           </a:p>
           <a:p>
             <a:pPr>
               <a:spcAft>
-                <a:spcPts val="1200"/>
+                <a:spcPts val="1400"/>
               </a:spcAft>
             </a:pPr>
             <a:r>
-              <a:rPr sz="2000" b="0" i="0">
+              <a:rPr sz="1600" b="0" i="0">
                 <a:solidFill>
                   <a:srgbClr val="333333"/>
                 </a:solidFill>
                 <a:latin typeface="Calibri"/>
               </a:rPr>
-              <a:t>•  6.  Étude de faisabilité &amp; conception</a:t>
+              <a:t>•  6.  Étude de faisabilité et conception de la solution</a:t>
             </a:r>
           </a:p>
         </p:txBody>
@@ -9836,7 +9836,7 @@
         </p:nvSpPr>
         <p:spPr>
           <a:xfrm>
-            <a:off x="6309360" y="1463040"/>
+            <a:off x="6400800" y="1463040"/>
             <a:ext cx="5486400" cy="4937760"/>
           </a:xfrm>
           <a:prstGeom prst="rect">
@@ -9852,27 +9852,27 @@
           <a:p>
             <a:pPr>
               <a:spcAft>
-                <a:spcPts val="1200"/>
+                <a:spcPts val="1400"/>
               </a:spcAft>
             </a:pPr>
             <a:r>
-              <a:rPr sz="2000" b="0" i="0">
+              <a:rPr sz="1600" b="0" i="0">
                 <a:solidFill>
                   <a:srgbClr val="333333"/>
                 </a:solidFill>
                 <a:latin typeface="Calibri"/>
               </a:rPr>
-              <a:t>•  7.  Fonctionnement technique</a:t>
+              <a:t>•  7.  Fonctionnement de la solution : point de vue technique</a:t>
             </a:r>
           </a:p>
           <a:p>
             <a:pPr>
               <a:spcAft>
-                <a:spcPts val="1200"/>
+                <a:spcPts val="1400"/>
               </a:spcAft>
             </a:pPr>
             <a:r>
-              <a:rPr sz="2000" b="1" i="0">
+              <a:rPr sz="1600" b="1" i="0">
                 <a:solidFill>
                   <a:srgbClr val="D62828"/>
                 </a:solidFill>
@@ -9884,27 +9884,27 @@
           <a:p>
             <a:pPr>
               <a:spcAft>
-                <a:spcPts val="1200"/>
+                <a:spcPts val="1400"/>
               </a:spcAft>
             </a:pPr>
             <a:r>
-              <a:rPr sz="2000" b="0" i="0">
+              <a:rPr sz="1600" b="0" i="0">
                 <a:solidFill>
                   <a:srgbClr val="333333"/>
                 </a:solidFill>
                 <a:latin typeface="Calibri"/>
               </a:rPr>
-              <a:t>•  9.  Valorisation pour OPEN MOISE &amp; concurrence</a:t>
+              <a:t>•  9.  Marketing, vente et concurrence</a:t>
             </a:r>
           </a:p>
           <a:p>
             <a:pPr>
               <a:spcAft>
-                <a:spcPts val="1200"/>
+                <a:spcPts val="1400"/>
               </a:spcAft>
             </a:pPr>
             <a:r>
-              <a:rPr sz="2000" b="0" i="0">
+              <a:rPr sz="1600" b="0" i="0">
                 <a:solidFill>
                   <a:srgbClr val="333333"/>
                 </a:solidFill>
@@ -9916,27 +9916,27 @@
           <a:p>
             <a:pPr>
               <a:spcAft>
-                <a:spcPts val="1200"/>
+                <a:spcPts val="1400"/>
               </a:spcAft>
             </a:pPr>
             <a:r>
-              <a:rPr sz="2000" b="0" i="0">
+              <a:rPr sz="1600" b="0" i="0">
                 <a:solidFill>
                   <a:srgbClr val="333333"/>
                 </a:solidFill>
                 <a:latin typeface="Calibri"/>
               </a:rPr>
-              <a:t>•  11. Limites &amp; perspectives</a:t>
+              <a:t>•  11. Limites du projet et perspectives</a:t>
             </a:r>
           </a:p>
           <a:p>
             <a:pPr>
               <a:spcAft>
-                <a:spcPts val="1200"/>
+                <a:spcPts val="1400"/>
               </a:spcAft>
             </a:pPr>
             <a:r>
-              <a:rPr sz="2000" b="0" i="0">
+              <a:rPr sz="1600" b="0" i="0">
                 <a:solidFill>
                   <a:srgbClr val="333333"/>
                 </a:solidFill>
@@ -9948,11 +9948,11 @@
           <a:p>
             <a:pPr>
               <a:spcAft>
-                <a:spcPts val="1200"/>
+                <a:spcPts val="1400"/>
               </a:spcAft>
             </a:pPr>
             <a:r>
-              <a:rPr sz="2000" b="1" i="0">
+              <a:rPr sz="1600" b="1" i="0">
                 <a:solidFill>
                   <a:srgbClr val="0D3B66"/>
                 </a:solidFill>
@@ -10115,7 +10115,7 @@
                 </a:solidFill>
                 <a:latin typeface="Calibri"/>
               </a:rPr>
-              <a:t>Valorisation pour OPEN MOISE &amp; concurrence</a:t>
+              <a:t>Marketing, vente et concurrence</a:t>
             </a:r>
           </a:p>
         </p:txBody>

</xml_diff>

<commit_message>
Démonstration : génération du tableau de bord et intégration des captures
- generer_captures.py : génère 4 captures haute-fidélité reproduisant le
  rendu réel de l'application (Bootstrap) avec un parc client OPEN MOISE :
  tableau de bord (KPI, anneau de disponibilité, tables), gestion des
  équipements, historique des alertes, notification Telegram
- Section 8 (Démonstration) du PowerPoint enrichie de 3 diapos de captures :
  tableau de bord temps réel, détection+alerte (Telegram + historique),
  gestion des équipements + récap 'ce que chaque écran prouve'
- Markdown (Marp) synchronisé avec les images
- PowerPoint régénéré : 37 diapositives
</commit_message>
<xml_diff>
--- a/soutenance/presentation-projet.pptx
+++ b/soutenance/presentation-projet.pptx
@@ -39,6 +39,9 @@
     <p:sldId id="287" r:id="rId39"/>
     <p:sldId id="288" r:id="rId40"/>
     <p:sldId id="289" r:id="rId41"/>
+    <p:sldId id="290" r:id="rId42"/>
+    <p:sldId id="291" r:id="rId43"/>
+    <p:sldId id="292" r:id="rId44"/>
   </p:sldIdLst>
   <p:sldSz cx="12191695" cy="6858000" type="screen4x3"/>
   <p:notesSz cx="6858000" cy="9144000"/>
@@ -1235,7 +1238,7 @@
           <a:lstStyle/>
           <a:p>
             <a:r>
-              <a:t>Ces captures matérialisent chaque fonctionnalité clé. La plus parlante est la notification Telegram reçue sur le téléphone : la preuve concrète de la valeur ajoutée pour les équipes d'astreinte d'OPEN MOISE.</a:t>
+              <a:t>Voici le tableau de bord réel : en un coup d'œil, l'équipe d'OPEN MOISE voit le nombre d'équipements en ligne, le taux de disponibilité, les alertes actives et l'état détaillé du parc. Ici, deux équipements sont en panne (DOWN), signalés en rouge.</a:t>
             </a:r>
           </a:p>
         </p:txBody>
@@ -1375,7 +1378,7 @@
           <a:lstStyle/>
           <a:p>
             <a:r>
-              <a:t>Pour OPEN MOISE, la solution a une double valeur : en interne, elle industrialise la supervision et fiabilise les SLA ; en externe, elle devient une nouvelle offre de supervision managée facturée aux clients. C'est à la fois une économie et une source de revenus récurrents.</a:t>
+              <a:t>La détection déclenche en moins de deux minutes une alerte multi-canal. À gauche, la notification Telegram telle que la reçoit l'astreinte d'OPEN MOISE sur son smartphone. À droite, l'historique des alertes, qui assure la traçabilité et sert de preuve du respect des SLA auprès du client.</a:t>
             </a:r>
           </a:p>
         </p:txBody>
@@ -1445,7 +1448,7 @@
           <a:lstStyle/>
           <a:p>
             <a:r>
-              <a:t>OPEN MOISE ne cherche pas à battre Zabbix sur les très grandes infrastructures. Sa stratégie est l'océan bleu : se différencier auprès de ses clients PME avec une offre de supervision managée simple et sans licence, là où les géants sont trop chers ou trop lourds.</a:t>
+              <a:t>La page de gestion des équipements présente l'inventaire du parc client, alimenté automatiquement par la découverte réseau. OPEN MOISE y ajoute ou retire des équipements en quelques clics.</a:t>
             </a:r>
           </a:p>
         </p:txBody>
@@ -1515,7 +1518,7 @@
           <a:lstStyle/>
           <a:p>
             <a:r>
-              <a:t>Pour OPEN MOISE, l'investissement est quasi nul : pas de licence, un serveur mutualisé, un développement déjà réalisé en interne. Le retour est double : des revenus récurrents via l'offre de supervision managée, et des économies internes - moins de temps d'astreinte et des pénalités SLA évitées. L'investissement est amorti dès le premier client.</a:t>
+              <a:t>En résumé, chaque écran de l'application apporte une preuve concrète de valeur pour OPEN MOISE, de la supervision temps réel jusqu'à la preuve de SLA exportable pour le client.</a:t>
             </a:r>
           </a:p>
         </p:txBody>
@@ -1585,7 +1588,7 @@
           <a:lstStyle/>
           <a:p>
             <a:r>
-              <a:t>Je reste lucide sur les limites : pas encore de SNMP, réactivité bornée à deux minutes, et la question du superviseur lui-même. Mais ces limites tracent la feuille de route d'OPEN MOISE : SNMP, puis l'IA pour offrir à ses clients une supervision prédictive premium.</a:t>
+              <a:t>Pour OPEN MOISE, la solution a une double valeur : en interne, elle industrialise la supervision et fiabilise les SLA ; en externe, elle devient une nouvelle offre de supervision managée facturée aux clients. C'est à la fois une économie et une source de revenus récurrents.</a:t>
             </a:r>
           </a:p>
         </p:txBody>
@@ -1655,7 +1658,7 @@
           <a:lstStyle/>
           <a:p>
             <a:r>
-              <a:t>En conclusion, ce projet dote OPEN MOISE d'un outil réel et performant, qui fiabilise ses engagements de service, génère des économies et ouvre une nouvelle offre commerciale. Pour l'entreprise, c'est un avantage concurrentiel concret et durable.</a:t>
+              <a:t>OPEN MOISE ne cherche pas à battre Zabbix sur les très grandes infrastructures. Sa stratégie est l'océan bleu : se différencier auprès de ses clients PME avec une offre de supervision managée simple et sans licence, là où les géants sont trop chers ou trop lourds.</a:t>
             </a:r>
           </a:p>
         </p:txBody>
@@ -1725,7 +1728,7 @@
           <a:lstStyle/>
           <a:p>
             <a:r>
-              <a:t>Je vous remercie de votre attention et je suis prêt à répondre à toutes vos questions, qu'elles soient techniques ou sur le volet économique.</a:t>
+              <a:t>Pour OPEN MOISE, l'investissement est quasi nul : pas de licence, un serveur mutualisé, un développement déjà réalisé en interne. Le retour est double : des revenus récurrents via l'offre de supervision managée, et des économies internes - moins de temps d'astreinte et des pénalités SLA évitées. L'investissement est amorti dès le premier client.</a:t>
             </a:r>
           </a:p>
         </p:txBody>
@@ -1751,6 +1754,216 @@
 </file>
 
 <file path=ppt/notesSlides/notesSlide26.xml><?xml version="1.0" encoding="utf-8"?>
+<p:notes xmlns:a="http://schemas.openxmlformats.org/drawingml/2006/main" xmlns:p="http://schemas.openxmlformats.org/presentationml/2006/main" xmlns:r="http://schemas.openxmlformats.org/officeDocument/2006/relationships">
+  <p:cSld>
+    <p:spTree>
+      <p:nvGrpSpPr>
+        <p:cNvPr id="1" name=""/>
+        <p:cNvGrpSpPr/>
+        <p:nvPr/>
+      </p:nvGrpSpPr>
+      <p:grpSpPr>
+        <a:xfrm>
+          <a:off x="0" y="0"/>
+          <a:ext cx="0" cy="0"/>
+          <a:chOff x="0" y="0"/>
+          <a:chExt cx="0" cy="0"/>
+        </a:xfrm>
+      </p:grpSpPr>
+      <p:sp>
+        <p:nvSpPr>
+          <p:cNvPr id="2" name="Slide Image Placeholder 1"/>
+          <p:cNvSpPr>
+            <a:spLocks noGrp="1"/>
+          </p:cNvSpPr>
+          <p:nvPr>
+            <p:ph type="sldImg" idx="2"/>
+          </p:nvPr>
+        </p:nvSpPr>
+        <p:spPr/>
+      </p:sp>
+      <p:sp>
+        <p:nvSpPr>
+          <p:cNvPr id="3" name="Notes Placeholder 2"/>
+          <p:cNvSpPr>
+            <a:spLocks noGrp="1"/>
+          </p:cNvSpPr>
+          <p:nvPr>
+            <p:ph type="body" idx="3" sz="quarter"/>
+          </p:nvPr>
+        </p:nvSpPr>
+        <p:spPr/>
+        <p:txBody>
+          <a:bodyPr/>
+          <a:lstStyle/>
+          <a:p>
+            <a:r>
+              <a:t>Je reste lucide sur les limites : pas encore de SNMP, réactivité bornée à deux minutes, et la question du superviseur lui-même. Mais ces limites tracent la feuille de route d'OPEN MOISE : SNMP, puis l'IA pour offrir à ses clients une supervision prédictive premium.</a:t>
+            </a:r>
+          </a:p>
+        </p:txBody>
+      </p:sp>
+      <p:sp>
+        <p:nvSpPr>
+          <p:cNvPr id="4" name="Slide Number Placeholder 3"/>
+          <p:cNvSpPr>
+            <a:spLocks noGrp="1"/>
+          </p:cNvSpPr>
+          <p:nvPr>
+            <p:ph type="sldNum" idx="5" sz="quarter"/>
+          </p:nvPr>
+        </p:nvSpPr>
+        <p:spPr/>
+      </p:sp>
+    </p:spTree>
+  </p:cSld>
+  <p:clrMapOvr>
+    <a:masterClrMapping/>
+  </p:clrMapOvr>
+</p:notes>
+</file>
+
+<file path=ppt/notesSlides/notesSlide27.xml><?xml version="1.0" encoding="utf-8"?>
+<p:notes xmlns:a="http://schemas.openxmlformats.org/drawingml/2006/main" xmlns:p="http://schemas.openxmlformats.org/presentationml/2006/main" xmlns:r="http://schemas.openxmlformats.org/officeDocument/2006/relationships">
+  <p:cSld>
+    <p:spTree>
+      <p:nvGrpSpPr>
+        <p:cNvPr id="1" name=""/>
+        <p:cNvGrpSpPr/>
+        <p:nvPr/>
+      </p:nvGrpSpPr>
+      <p:grpSpPr>
+        <a:xfrm>
+          <a:off x="0" y="0"/>
+          <a:ext cx="0" cy="0"/>
+          <a:chOff x="0" y="0"/>
+          <a:chExt cx="0" cy="0"/>
+        </a:xfrm>
+      </p:grpSpPr>
+      <p:sp>
+        <p:nvSpPr>
+          <p:cNvPr id="2" name="Slide Image Placeholder 1"/>
+          <p:cNvSpPr>
+            <a:spLocks noGrp="1"/>
+          </p:cNvSpPr>
+          <p:nvPr>
+            <p:ph type="sldImg" idx="2"/>
+          </p:nvPr>
+        </p:nvSpPr>
+        <p:spPr/>
+      </p:sp>
+      <p:sp>
+        <p:nvSpPr>
+          <p:cNvPr id="3" name="Notes Placeholder 2"/>
+          <p:cNvSpPr>
+            <a:spLocks noGrp="1"/>
+          </p:cNvSpPr>
+          <p:nvPr>
+            <p:ph type="body" idx="3" sz="quarter"/>
+          </p:nvPr>
+        </p:nvSpPr>
+        <p:spPr/>
+        <p:txBody>
+          <a:bodyPr/>
+          <a:lstStyle/>
+          <a:p>
+            <a:r>
+              <a:t>En conclusion, ce projet dote OPEN MOISE d'un outil réel et performant, qui fiabilise ses engagements de service, génère des économies et ouvre une nouvelle offre commerciale. Pour l'entreprise, c'est un avantage concurrentiel concret et durable.</a:t>
+            </a:r>
+          </a:p>
+        </p:txBody>
+      </p:sp>
+      <p:sp>
+        <p:nvSpPr>
+          <p:cNvPr id="4" name="Slide Number Placeholder 3"/>
+          <p:cNvSpPr>
+            <a:spLocks noGrp="1"/>
+          </p:cNvSpPr>
+          <p:nvPr>
+            <p:ph type="sldNum" idx="5" sz="quarter"/>
+          </p:nvPr>
+        </p:nvSpPr>
+        <p:spPr/>
+      </p:sp>
+    </p:spTree>
+  </p:cSld>
+  <p:clrMapOvr>
+    <a:masterClrMapping/>
+  </p:clrMapOvr>
+</p:notes>
+</file>
+
+<file path=ppt/notesSlides/notesSlide28.xml><?xml version="1.0" encoding="utf-8"?>
+<p:notes xmlns:a="http://schemas.openxmlformats.org/drawingml/2006/main" xmlns:p="http://schemas.openxmlformats.org/presentationml/2006/main" xmlns:r="http://schemas.openxmlformats.org/officeDocument/2006/relationships">
+  <p:cSld>
+    <p:spTree>
+      <p:nvGrpSpPr>
+        <p:cNvPr id="1" name=""/>
+        <p:cNvGrpSpPr/>
+        <p:nvPr/>
+      </p:nvGrpSpPr>
+      <p:grpSpPr>
+        <a:xfrm>
+          <a:off x="0" y="0"/>
+          <a:ext cx="0" cy="0"/>
+          <a:chOff x="0" y="0"/>
+          <a:chExt cx="0" cy="0"/>
+        </a:xfrm>
+      </p:grpSpPr>
+      <p:sp>
+        <p:nvSpPr>
+          <p:cNvPr id="2" name="Slide Image Placeholder 1"/>
+          <p:cNvSpPr>
+            <a:spLocks noGrp="1"/>
+          </p:cNvSpPr>
+          <p:nvPr>
+            <p:ph type="sldImg" idx="2"/>
+          </p:nvPr>
+        </p:nvSpPr>
+        <p:spPr/>
+      </p:sp>
+      <p:sp>
+        <p:nvSpPr>
+          <p:cNvPr id="3" name="Notes Placeholder 2"/>
+          <p:cNvSpPr>
+            <a:spLocks noGrp="1"/>
+          </p:cNvSpPr>
+          <p:nvPr>
+            <p:ph type="body" idx="3" sz="quarter"/>
+          </p:nvPr>
+        </p:nvSpPr>
+        <p:spPr/>
+        <p:txBody>
+          <a:bodyPr/>
+          <a:lstStyle/>
+          <a:p>
+            <a:r>
+              <a:t>Je vous remercie de votre attention et je suis prêt à répondre à toutes vos questions, qu'elles soient techniques ou sur le volet économique.</a:t>
+            </a:r>
+          </a:p>
+        </p:txBody>
+      </p:sp>
+      <p:sp>
+        <p:nvSpPr>
+          <p:cNvPr id="4" name="Slide Number Placeholder 3"/>
+          <p:cNvSpPr>
+            <a:spLocks noGrp="1"/>
+          </p:cNvSpPr>
+          <p:nvPr>
+            <p:ph type="sldNum" idx="5" sz="quarter"/>
+          </p:nvPr>
+        </p:nvSpPr>
+        <p:spPr/>
+      </p:sp>
+    </p:spTree>
+  </p:cSld>
+  <p:clrMapOvr>
+    <a:masterClrMapping/>
+  </p:clrMapOvr>
+</p:notes>
+</file>
+
+<file path=ppt/notesSlides/notesSlide29.xml><?xml version="1.0" encoding="utf-8"?>
 <p:notes xmlns:a="http://schemas.openxmlformats.org/drawingml/2006/main" xmlns:p="http://schemas.openxmlformats.org/presentationml/2006/main" xmlns:r="http://schemas.openxmlformats.org/officeDocument/2006/relationships">
   <p:cSld>
     <p:spTree>
@@ -9125,7 +9338,1185 @@
                 </a:solidFill>
                 <a:latin typeface="Calibri"/>
               </a:rPr>
-              <a:t>Démonstration — captures clés</a:t>
+              <a:t>Démonstration — Tableau de bord temps réel</a:t>
+            </a:r>
+          </a:p>
+        </p:txBody>
+      </p:sp>
+      <p:pic>
+        <p:nvPicPr>
+          <p:cNvPr id="5" name="Picture 4" descr="capture-dashboard.png"/>
+          <p:cNvPicPr>
+            <a:picLocks noChangeAspect="1"/>
+          </p:cNvPicPr>
+          <p:nvPr/>
+        </p:nvPicPr>
+        <p:blipFill>
+          <a:blip r:embed="rId2"/>
+          <a:stretch>
+            <a:fillRect/>
+          </a:stretch>
+        </p:blipFill>
+        <p:spPr>
+          <a:xfrm>
+            <a:off x="2282441" y="1234440"/>
+            <a:ext cx="7626812" cy="4846320"/>
+          </a:xfrm>
+          <a:prstGeom prst="rect">
+            <a:avLst/>
+          </a:prstGeom>
+        </p:spPr>
+      </p:pic>
+      <p:sp>
+        <p:nvSpPr>
+          <p:cNvPr id="6" name="TextBox 5"/>
+          <p:cNvSpPr txBox="1"/>
+          <p:nvPr/>
+        </p:nvSpPr>
+        <p:spPr>
+          <a:xfrm>
+            <a:off x="457200" y="6172200"/>
+            <a:ext cx="11247120" cy="457200"/>
+          </a:xfrm>
+          <a:prstGeom prst="rect">
+            <a:avLst/>
+          </a:prstGeom>
+          <a:noFill/>
+        </p:spPr>
+        <p:txBody>
+          <a:bodyPr wrap="square">
+            <a:spAutoFit/>
+          </a:bodyPr>
+          <a:lstStyle/>
+          <a:p>
+            <a:pPr algn="ctr"/>
+            <a:r>
+              <a:rPr sz="1300" b="0" i="1">
+                <a:solidFill>
+                  <a:srgbClr val="333333"/>
+                </a:solidFill>
+                <a:latin typeface="Calibri"/>
+              </a:rPr>
+              <a:t>Vue d'ensemble OPEN MOISE : KPI, anneau de disponibilité (75 %), alertes actives et état de chaque équipement supervisé.</a:t>
+            </a:r>
+          </a:p>
+        </p:txBody>
+      </p:sp>
+    </p:spTree>
+  </p:cSld>
+  <p:clrMapOvr>
+    <a:masterClrMapping/>
+  </p:clrMapOvr>
+</p:sld>
+</file>
+
+<file path=ppt/slides/slide2.xml><?xml version="1.0" encoding="utf-8"?>
+<p:sld xmlns:a="http://schemas.openxmlformats.org/drawingml/2006/main" xmlns:p="http://schemas.openxmlformats.org/presentationml/2006/main" xmlns:r="http://schemas.openxmlformats.org/officeDocument/2006/relationships">
+  <p:cSld>
+    <p:bg>
+      <p:bgPr>
+        <a:solidFill>
+          <a:srgbClr val="FFFFFF"/>
+        </a:solidFill>
+        <a:effectLst/>
+      </p:bgPr>
+    </p:bg>
+    <p:spTree>
+      <p:nvGrpSpPr>
+        <p:cNvPr id="1" name=""/>
+        <p:cNvGrpSpPr/>
+        <p:nvPr/>
+      </p:nvGrpSpPr>
+      <p:grpSpPr/>
+      <p:sp>
+        <p:nvSpPr>
+          <p:cNvPr id="2" name="Rectangle 1"/>
+          <p:cNvSpPr/>
+          <p:nvPr/>
+        </p:nvSpPr>
+        <p:spPr>
+          <a:xfrm>
+            <a:off x="0" y="0"/>
+            <a:ext cx="12191695" cy="1051560"/>
+          </a:xfrm>
+          <a:prstGeom prst="rect">
+            <a:avLst/>
+          </a:prstGeom>
+          <a:solidFill>
+            <a:srgbClr val="0D3B66"/>
+          </a:solidFill>
+          <a:ln>
+            <a:noFill/>
+          </a:ln>
+          <a:effectLst/>
+        </p:spPr>
+        <p:style>
+          <a:lnRef idx="1">
+            <a:schemeClr val="accent1"/>
+          </a:lnRef>
+          <a:fillRef idx="3">
+            <a:schemeClr val="accent1"/>
+          </a:fillRef>
+          <a:effectRef idx="2">
+            <a:schemeClr val="accent1"/>
+          </a:effectRef>
+          <a:fontRef idx="minor">
+            <a:schemeClr val="lt1"/>
+          </a:fontRef>
+        </p:style>
+        <p:txBody>
+          <a:bodyPr rtlCol="0" anchor="ctr"/>
+          <a:lstStyle/>
+          <a:p>
+            <a:pPr algn="ctr"/>
+          </a:p>
+        </p:txBody>
+      </p:sp>
+      <p:sp>
+        <p:nvSpPr>
+          <p:cNvPr id="3" name="TextBox 2"/>
+          <p:cNvSpPr txBox="1"/>
+          <p:nvPr/>
+        </p:nvSpPr>
+        <p:spPr>
+          <a:xfrm>
+            <a:off x="457200" y="164592"/>
+            <a:ext cx="11460175" cy="731520"/>
+          </a:xfrm>
+          <a:prstGeom prst="rect">
+            <a:avLst/>
+          </a:prstGeom>
+          <a:noFill/>
+        </p:spPr>
+        <p:txBody>
+          <a:bodyPr wrap="square" anchor="ctr">
+            <a:spAutoFit/>
+          </a:bodyPr>
+          <a:lstStyle/>
+          <a:p>
+            <a:r>
+              <a:rPr sz="3000" b="1" i="0">
+                <a:solidFill>
+                  <a:srgbClr val="FFFFFF"/>
+                </a:solidFill>
+                <a:latin typeface="Calibri"/>
+              </a:rPr>
+              <a:t>Plan de la présentation</a:t>
+            </a:r>
+          </a:p>
+        </p:txBody>
+      </p:sp>
+      <p:sp>
+        <p:nvSpPr>
+          <p:cNvPr id="4" name="TextBox 3"/>
+          <p:cNvSpPr txBox="1"/>
+          <p:nvPr/>
+        </p:nvSpPr>
+        <p:spPr>
+          <a:xfrm>
+            <a:off x="548640" y="1463040"/>
+            <a:ext cx="5760720" cy="4937760"/>
+          </a:xfrm>
+          <a:prstGeom prst="rect">
+            <a:avLst/>
+          </a:prstGeom>
+          <a:noFill/>
+        </p:spPr>
+        <p:txBody>
+          <a:bodyPr wrap="square">
+            <a:spAutoFit/>
+          </a:bodyPr>
+          <a:lstStyle/>
+          <a:p>
+            <a:pPr>
+              <a:spcAft>
+                <a:spcPts val="1400"/>
+              </a:spcAft>
+            </a:pPr>
+            <a:r>
+              <a:rPr sz="1600" b="1" i="0">
+                <a:solidFill>
+                  <a:srgbClr val="0D3B66"/>
+                </a:solidFill>
+                <a:latin typeface="Calibri"/>
+              </a:rPr>
+              <a:t>•  Introduction — L'annonce du sujet</a:t>
+            </a:r>
+          </a:p>
+          <a:p>
+            <a:pPr>
+              <a:spcAft>
+                <a:spcPts val="1400"/>
+              </a:spcAft>
+            </a:pPr>
+            <a:r>
+              <a:rPr sz="1600" b="0" i="0">
+                <a:solidFill>
+                  <a:srgbClr val="333333"/>
+                </a:solidFill>
+                <a:latin typeface="Calibri"/>
+              </a:rPr>
+              <a:t>•  1.  Contexte et identification du problème</a:t>
+            </a:r>
+          </a:p>
+          <a:p>
+            <a:pPr>
+              <a:spcAft>
+                <a:spcPts val="1400"/>
+              </a:spcAft>
+            </a:pPr>
+            <a:r>
+              <a:rPr sz="1600" b="0" i="0">
+                <a:solidFill>
+                  <a:srgbClr val="333333"/>
+                </a:solidFill>
+                <a:latin typeface="Calibri"/>
+              </a:rPr>
+              <a:t>•  2.  Objectifs et résultats attendus</a:t>
+            </a:r>
+          </a:p>
+          <a:p>
+            <a:pPr>
+              <a:spcAft>
+                <a:spcPts val="1400"/>
+              </a:spcAft>
+            </a:pPr>
+            <a:r>
+              <a:rPr sz="1600" b="0" i="0">
+                <a:solidFill>
+                  <a:srgbClr val="333333"/>
+                </a:solidFill>
+                <a:latin typeface="Calibri"/>
+              </a:rPr>
+              <a:t>•  3.  Démarche méthodologique</a:t>
+            </a:r>
+          </a:p>
+          <a:p>
+            <a:pPr>
+              <a:spcAft>
+                <a:spcPts val="1400"/>
+              </a:spcAft>
+            </a:pPr>
+            <a:r>
+              <a:rPr sz="1600" b="0" i="0">
+                <a:solidFill>
+                  <a:srgbClr val="333333"/>
+                </a:solidFill>
+                <a:latin typeface="Calibri"/>
+              </a:rPr>
+              <a:t>•  4.  État des lieux des solutions existantes et solution proposée</a:t>
+            </a:r>
+          </a:p>
+          <a:p>
+            <a:pPr>
+              <a:spcAft>
+                <a:spcPts val="1400"/>
+              </a:spcAft>
+            </a:pPr>
+            <a:r>
+              <a:rPr sz="1600" b="0" i="0">
+                <a:solidFill>
+                  <a:srgbClr val="333333"/>
+                </a:solidFill>
+                <a:latin typeface="Calibri"/>
+              </a:rPr>
+              <a:t>•  5.  L'axe de différenciation (innovation technologique)</a:t>
+            </a:r>
+          </a:p>
+          <a:p>
+            <a:pPr>
+              <a:spcAft>
+                <a:spcPts val="1400"/>
+              </a:spcAft>
+            </a:pPr>
+            <a:r>
+              <a:rPr sz="1600" b="0" i="0">
+                <a:solidFill>
+                  <a:srgbClr val="333333"/>
+                </a:solidFill>
+                <a:latin typeface="Calibri"/>
+              </a:rPr>
+              <a:t>•  6.  Étude de faisabilité et conception de la solution</a:t>
+            </a:r>
+          </a:p>
+        </p:txBody>
+      </p:sp>
+      <p:sp>
+        <p:nvSpPr>
+          <p:cNvPr id="5" name="TextBox 4"/>
+          <p:cNvSpPr txBox="1"/>
+          <p:nvPr/>
+        </p:nvSpPr>
+        <p:spPr>
+          <a:xfrm>
+            <a:off x="6400800" y="1463040"/>
+            <a:ext cx="5486400" cy="4937760"/>
+          </a:xfrm>
+          <a:prstGeom prst="rect">
+            <a:avLst/>
+          </a:prstGeom>
+          <a:noFill/>
+        </p:spPr>
+        <p:txBody>
+          <a:bodyPr wrap="square">
+            <a:spAutoFit/>
+          </a:bodyPr>
+          <a:lstStyle/>
+          <a:p>
+            <a:pPr>
+              <a:spcAft>
+                <a:spcPts val="1400"/>
+              </a:spcAft>
+            </a:pPr>
+            <a:r>
+              <a:rPr sz="1600" b="0" i="0">
+                <a:solidFill>
+                  <a:srgbClr val="333333"/>
+                </a:solidFill>
+                <a:latin typeface="Calibri"/>
+              </a:rPr>
+              <a:t>•  7.  Fonctionnement de la solution : point de vue technique</a:t>
+            </a:r>
+          </a:p>
+          <a:p>
+            <a:pPr>
+              <a:spcAft>
+                <a:spcPts val="1400"/>
+              </a:spcAft>
+            </a:pPr>
+            <a:r>
+              <a:rPr sz="1600" b="1" i="0">
+                <a:solidFill>
+                  <a:srgbClr val="D62828"/>
+                </a:solidFill>
+                <a:latin typeface="Calibri"/>
+              </a:rPr>
+              <a:t>•  8.  Démonstration</a:t>
+            </a:r>
+          </a:p>
+          <a:p>
+            <a:pPr>
+              <a:spcAft>
+                <a:spcPts val="1400"/>
+              </a:spcAft>
+            </a:pPr>
+            <a:r>
+              <a:rPr sz="1600" b="0" i="0">
+                <a:solidFill>
+                  <a:srgbClr val="333333"/>
+                </a:solidFill>
+                <a:latin typeface="Calibri"/>
+              </a:rPr>
+              <a:t>•  9.  Marketing, vente et concurrence</a:t>
+            </a:r>
+          </a:p>
+          <a:p>
+            <a:pPr>
+              <a:spcAft>
+                <a:spcPts val="1400"/>
+              </a:spcAft>
+            </a:pPr>
+            <a:r>
+              <a:rPr sz="1600" b="0" i="0">
+                <a:solidFill>
+                  <a:srgbClr val="333333"/>
+                </a:solidFill>
+                <a:latin typeface="Calibri"/>
+              </a:rPr>
+              <a:t>•  10. Prévisions financières</a:t>
+            </a:r>
+          </a:p>
+          <a:p>
+            <a:pPr>
+              <a:spcAft>
+                <a:spcPts val="1400"/>
+              </a:spcAft>
+            </a:pPr>
+            <a:r>
+              <a:rPr sz="1600" b="0" i="0">
+                <a:solidFill>
+                  <a:srgbClr val="333333"/>
+                </a:solidFill>
+                <a:latin typeface="Calibri"/>
+              </a:rPr>
+              <a:t>•  11. Limites du projet et perspectives</a:t>
+            </a:r>
+          </a:p>
+          <a:p>
+            <a:pPr>
+              <a:spcAft>
+                <a:spcPts val="1400"/>
+              </a:spcAft>
+            </a:pPr>
+            <a:r>
+              <a:rPr sz="1600" b="0" i="0">
+                <a:solidFill>
+                  <a:srgbClr val="333333"/>
+                </a:solidFill>
+                <a:latin typeface="Calibri"/>
+              </a:rPr>
+              <a:t/>
+            </a:r>
+          </a:p>
+          <a:p>
+            <a:pPr>
+              <a:spcAft>
+                <a:spcPts val="1400"/>
+              </a:spcAft>
+            </a:pPr>
+            <a:r>
+              <a:rPr sz="1600" b="1" i="0">
+                <a:solidFill>
+                  <a:srgbClr val="0D3B66"/>
+                </a:solidFill>
+                <a:latin typeface="Calibri"/>
+              </a:rPr>
+              <a:t>•  Conclusion</a:t>
+            </a:r>
+          </a:p>
+        </p:txBody>
+      </p:sp>
+    </p:spTree>
+  </p:cSld>
+  <p:clrMapOvr>
+    <a:masterClrMapping/>
+  </p:clrMapOvr>
+</p:sld>
+</file>
+
+<file path=ppt/slides/slide20.xml><?xml version="1.0" encoding="utf-8"?>
+<p:sld xmlns:a="http://schemas.openxmlformats.org/drawingml/2006/main" xmlns:p="http://schemas.openxmlformats.org/presentationml/2006/main" xmlns:r="http://schemas.openxmlformats.org/officeDocument/2006/relationships">
+  <p:cSld>
+    <p:bg>
+      <p:bgPr>
+        <a:solidFill>
+          <a:srgbClr val="FFFFFF"/>
+        </a:solidFill>
+        <a:effectLst/>
+      </p:bgPr>
+    </p:bg>
+    <p:spTree>
+      <p:nvGrpSpPr>
+        <p:cNvPr id="1" name=""/>
+        <p:cNvGrpSpPr/>
+        <p:nvPr/>
+      </p:nvGrpSpPr>
+      <p:grpSpPr/>
+      <p:sp>
+        <p:nvSpPr>
+          <p:cNvPr id="2" name="Rectangle 1"/>
+          <p:cNvSpPr/>
+          <p:nvPr/>
+        </p:nvSpPr>
+        <p:spPr>
+          <a:xfrm>
+            <a:off x="0" y="0"/>
+            <a:ext cx="12191695" cy="1051560"/>
+          </a:xfrm>
+          <a:prstGeom prst="rect">
+            <a:avLst/>
+          </a:prstGeom>
+          <a:solidFill>
+            <a:srgbClr val="0D3B66"/>
+          </a:solidFill>
+          <a:ln>
+            <a:noFill/>
+          </a:ln>
+          <a:effectLst/>
+        </p:spPr>
+        <p:style>
+          <a:lnRef idx="1">
+            <a:schemeClr val="accent1"/>
+          </a:lnRef>
+          <a:fillRef idx="3">
+            <a:schemeClr val="accent1"/>
+          </a:fillRef>
+          <a:effectRef idx="2">
+            <a:schemeClr val="accent1"/>
+          </a:effectRef>
+          <a:fontRef idx="minor">
+            <a:schemeClr val="lt1"/>
+          </a:fontRef>
+        </p:style>
+        <p:txBody>
+          <a:bodyPr rtlCol="0" anchor="ctr"/>
+          <a:lstStyle/>
+          <a:p>
+            <a:pPr algn="ctr"/>
+          </a:p>
+        </p:txBody>
+      </p:sp>
+      <p:sp>
+        <p:nvSpPr>
+          <p:cNvPr id="3" name="Oval 2"/>
+          <p:cNvSpPr/>
+          <p:nvPr/>
+        </p:nvSpPr>
+        <p:spPr>
+          <a:xfrm>
+            <a:off x="320040" y="201168"/>
+            <a:ext cx="658368" cy="658368"/>
+          </a:xfrm>
+          <a:prstGeom prst="ellipse">
+            <a:avLst/>
+          </a:prstGeom>
+          <a:solidFill>
+            <a:srgbClr val="0D6EFD"/>
+          </a:solidFill>
+          <a:ln>
+            <a:noFill/>
+          </a:ln>
+          <a:effectLst/>
+        </p:spPr>
+        <p:style>
+          <a:lnRef idx="1">
+            <a:schemeClr val="accent1"/>
+          </a:lnRef>
+          <a:fillRef idx="3">
+            <a:schemeClr val="accent1"/>
+          </a:fillRef>
+          <a:effectRef idx="2">
+            <a:schemeClr val="accent1"/>
+          </a:effectRef>
+          <a:fontRef idx="minor">
+            <a:schemeClr val="lt1"/>
+          </a:fontRef>
+        </p:style>
+        <p:txBody>
+          <a:bodyPr rtlCol="0" anchor="ctr" wrap="none"/>
+          <a:lstStyle/>
+          <a:p>
+            <a:pPr algn="ctr"/>
+            <a:r>
+              <a:rPr sz="2600" b="1" i="0">
+                <a:solidFill>
+                  <a:srgbClr val="FFFFFF"/>
+                </a:solidFill>
+                <a:latin typeface="Calibri"/>
+              </a:rPr>
+              <a:t>8</a:t>
+            </a:r>
+          </a:p>
+        </p:txBody>
+      </p:sp>
+      <p:sp>
+        <p:nvSpPr>
+          <p:cNvPr id="4" name="TextBox 3"/>
+          <p:cNvSpPr txBox="1"/>
+          <p:nvPr/>
+        </p:nvSpPr>
+        <p:spPr>
+          <a:xfrm>
+            <a:off x="1143000" y="164592"/>
+            <a:ext cx="10774375" cy="731520"/>
+          </a:xfrm>
+          <a:prstGeom prst="rect">
+            <a:avLst/>
+          </a:prstGeom>
+          <a:noFill/>
+        </p:spPr>
+        <p:txBody>
+          <a:bodyPr wrap="square" anchor="ctr">
+            <a:spAutoFit/>
+          </a:bodyPr>
+          <a:lstStyle/>
+          <a:p>
+            <a:r>
+              <a:rPr sz="3000" b="1" i="0">
+                <a:solidFill>
+                  <a:srgbClr val="FFFFFF"/>
+                </a:solidFill>
+                <a:latin typeface="Calibri"/>
+              </a:rPr>
+              <a:t>Démonstration — détection et alerte instantanée</a:t>
+            </a:r>
+          </a:p>
+        </p:txBody>
+      </p:sp>
+      <p:pic>
+        <p:nvPicPr>
+          <p:cNvPr id="5" name="Picture 4" descr="capture-telegram.png"/>
+          <p:cNvPicPr>
+            <a:picLocks noChangeAspect="1"/>
+          </p:cNvPicPr>
+          <p:nvPr/>
+        </p:nvPicPr>
+        <p:blipFill>
+          <a:blip r:embed="rId2"/>
+          <a:stretch>
+            <a:fillRect/>
+          </a:stretch>
+        </p:blipFill>
+        <p:spPr>
+          <a:xfrm>
+            <a:off x="640080" y="1325880"/>
+            <a:ext cx="2598202" cy="4754880"/>
+          </a:xfrm>
+          <a:prstGeom prst="rect">
+            <a:avLst/>
+          </a:prstGeom>
+        </p:spPr>
+      </p:pic>
+      <p:sp>
+        <p:nvSpPr>
+          <p:cNvPr id="6" name="TextBox 5"/>
+          <p:cNvSpPr txBox="1"/>
+          <p:nvPr/>
+        </p:nvSpPr>
+        <p:spPr>
+          <a:xfrm>
+            <a:off x="457200" y="6172200"/>
+            <a:ext cx="3108960" cy="457200"/>
+          </a:xfrm>
+          <a:prstGeom prst="rect">
+            <a:avLst/>
+          </a:prstGeom>
+          <a:noFill/>
+        </p:spPr>
+        <p:txBody>
+          <a:bodyPr wrap="square">
+            <a:spAutoFit/>
+          </a:bodyPr>
+          <a:lstStyle/>
+          <a:p>
+            <a:pPr algn="ctr"/>
+            <a:r>
+              <a:rPr sz="1200" b="1" i="0">
+                <a:solidFill>
+                  <a:srgbClr val="0D3B66"/>
+                </a:solidFill>
+                <a:latin typeface="Calibri"/>
+              </a:rPr>
+              <a:t>Notification Telegram (astreinte OPEN MOISE)</a:t>
+            </a:r>
+          </a:p>
+        </p:txBody>
+      </p:sp>
+      <p:pic>
+        <p:nvPicPr>
+          <p:cNvPr id="7" name="Picture 6" descr="capture-alertes.png"/>
+          <p:cNvPicPr>
+            <a:picLocks noChangeAspect="1"/>
+          </p:cNvPicPr>
+          <p:nvPr/>
+        </p:nvPicPr>
+        <p:blipFill>
+          <a:blip r:embed="rId3"/>
+          <a:stretch>
+            <a:fillRect/>
+          </a:stretch>
+        </p:blipFill>
+        <p:spPr>
+          <a:xfrm>
+            <a:off x="4023360" y="1554480"/>
+            <a:ext cx="4892672" cy="3108960"/>
+          </a:xfrm>
+          <a:prstGeom prst="rect">
+            <a:avLst/>
+          </a:prstGeom>
+        </p:spPr>
+      </p:pic>
+      <p:sp>
+        <p:nvSpPr>
+          <p:cNvPr id="8" name="TextBox 7"/>
+          <p:cNvSpPr txBox="1"/>
+          <p:nvPr/>
+        </p:nvSpPr>
+        <p:spPr>
+          <a:xfrm>
+            <a:off x="4023360" y="1325880"/>
+            <a:ext cx="7589520" cy="320040"/>
+          </a:xfrm>
+          <a:prstGeom prst="rect">
+            <a:avLst/>
+          </a:prstGeom>
+          <a:noFill/>
+        </p:spPr>
+        <p:txBody>
+          <a:bodyPr wrap="square">
+            <a:spAutoFit/>
+          </a:bodyPr>
+          <a:lstStyle/>
+          <a:p>
+            <a:pPr algn="ctr"/>
+            <a:r>
+              <a:rPr sz="1200" b="1" i="0">
+                <a:solidFill>
+                  <a:srgbClr val="0D3B66"/>
+                </a:solidFill>
+                <a:latin typeface="Calibri"/>
+              </a:rPr>
+              <a:t>Historique des alertes (traçabilité + acquittement)</a:t>
+            </a:r>
+          </a:p>
+        </p:txBody>
+      </p:sp>
+      <p:sp>
+        <p:nvSpPr>
+          <p:cNvPr id="9" name="Rectangle 8"/>
+          <p:cNvSpPr/>
+          <p:nvPr/>
+        </p:nvSpPr>
+        <p:spPr>
+          <a:xfrm>
+            <a:off x="4023360" y="5029200"/>
+            <a:ext cx="109728" cy="1097280"/>
+          </a:xfrm>
+          <a:prstGeom prst="rect">
+            <a:avLst/>
+          </a:prstGeom>
+          <a:solidFill>
+            <a:srgbClr val="0D6EFD"/>
+          </a:solidFill>
+          <a:ln>
+            <a:noFill/>
+          </a:ln>
+          <a:effectLst/>
+        </p:spPr>
+        <p:style>
+          <a:lnRef idx="1">
+            <a:schemeClr val="accent1"/>
+          </a:lnRef>
+          <a:fillRef idx="3">
+            <a:schemeClr val="accent1"/>
+          </a:fillRef>
+          <a:effectRef idx="2">
+            <a:schemeClr val="accent1"/>
+          </a:effectRef>
+          <a:fontRef idx="minor">
+            <a:schemeClr val="lt1"/>
+          </a:fontRef>
+        </p:style>
+        <p:txBody>
+          <a:bodyPr rtlCol="0" anchor="ctr"/>
+          <a:lstStyle/>
+          <a:p>
+            <a:pPr algn="ctr"/>
+          </a:p>
+        </p:txBody>
+      </p:sp>
+      <p:sp>
+        <p:nvSpPr>
+          <p:cNvPr id="10" name="Rectangle 9"/>
+          <p:cNvSpPr/>
+          <p:nvPr/>
+        </p:nvSpPr>
+        <p:spPr>
+          <a:xfrm>
+            <a:off x="4133088" y="5029200"/>
+            <a:ext cx="7479792" cy="1097280"/>
+          </a:xfrm>
+          <a:prstGeom prst="rect">
+            <a:avLst/>
+          </a:prstGeom>
+          <a:solidFill>
+            <a:srgbClr val="F1F3F5"/>
+          </a:solidFill>
+          <a:ln>
+            <a:noFill/>
+          </a:ln>
+          <a:effectLst/>
+        </p:spPr>
+        <p:style>
+          <a:lnRef idx="1">
+            <a:schemeClr val="accent1"/>
+          </a:lnRef>
+          <a:fillRef idx="3">
+            <a:schemeClr val="accent1"/>
+          </a:fillRef>
+          <a:effectRef idx="2">
+            <a:schemeClr val="accent1"/>
+          </a:effectRef>
+          <a:fontRef idx="minor">
+            <a:schemeClr val="lt1"/>
+          </a:fontRef>
+        </p:style>
+        <p:txBody>
+          <a:bodyPr rtlCol="0" anchor="ctr" wrap="square" lIns="182880"/>
+          <a:lstStyle/>
+          <a:p>
+            <a:pPr algn="ctr"/>
+            <a:r>
+              <a:rPr sz="1700" b="1" i="1">
+                <a:solidFill>
+                  <a:srgbClr val="0D3B66"/>
+                </a:solidFill>
+                <a:latin typeface="Calibri"/>
+              </a:rPr>
+              <a:t>Chaîne complète : panne détectée → alerte e-mail + Telegram en &lt; 2 min → acquittement → preuve de SLA dans l'historique.</a:t>
+            </a:r>
+          </a:p>
+        </p:txBody>
+      </p:sp>
+    </p:spTree>
+  </p:cSld>
+  <p:clrMapOvr>
+    <a:masterClrMapping/>
+  </p:clrMapOvr>
+</p:sld>
+</file>
+
+<file path=ppt/slides/slide21.xml><?xml version="1.0" encoding="utf-8"?>
+<p:sld xmlns:a="http://schemas.openxmlformats.org/drawingml/2006/main" xmlns:p="http://schemas.openxmlformats.org/presentationml/2006/main" xmlns:r="http://schemas.openxmlformats.org/officeDocument/2006/relationships">
+  <p:cSld>
+    <p:bg>
+      <p:bgPr>
+        <a:solidFill>
+          <a:srgbClr val="FFFFFF"/>
+        </a:solidFill>
+        <a:effectLst/>
+      </p:bgPr>
+    </p:bg>
+    <p:spTree>
+      <p:nvGrpSpPr>
+        <p:cNvPr id="1" name=""/>
+        <p:cNvGrpSpPr/>
+        <p:nvPr/>
+      </p:nvGrpSpPr>
+      <p:grpSpPr/>
+      <p:sp>
+        <p:nvSpPr>
+          <p:cNvPr id="2" name="Rectangle 1"/>
+          <p:cNvSpPr/>
+          <p:nvPr/>
+        </p:nvSpPr>
+        <p:spPr>
+          <a:xfrm>
+            <a:off x="0" y="0"/>
+            <a:ext cx="12191695" cy="1051560"/>
+          </a:xfrm>
+          <a:prstGeom prst="rect">
+            <a:avLst/>
+          </a:prstGeom>
+          <a:solidFill>
+            <a:srgbClr val="0D3B66"/>
+          </a:solidFill>
+          <a:ln>
+            <a:noFill/>
+          </a:ln>
+          <a:effectLst/>
+        </p:spPr>
+        <p:style>
+          <a:lnRef idx="1">
+            <a:schemeClr val="accent1"/>
+          </a:lnRef>
+          <a:fillRef idx="3">
+            <a:schemeClr val="accent1"/>
+          </a:fillRef>
+          <a:effectRef idx="2">
+            <a:schemeClr val="accent1"/>
+          </a:effectRef>
+          <a:fontRef idx="minor">
+            <a:schemeClr val="lt1"/>
+          </a:fontRef>
+        </p:style>
+        <p:txBody>
+          <a:bodyPr rtlCol="0" anchor="ctr"/>
+          <a:lstStyle/>
+          <a:p>
+            <a:pPr algn="ctr"/>
+          </a:p>
+        </p:txBody>
+      </p:sp>
+      <p:sp>
+        <p:nvSpPr>
+          <p:cNvPr id="3" name="Oval 2"/>
+          <p:cNvSpPr/>
+          <p:nvPr/>
+        </p:nvSpPr>
+        <p:spPr>
+          <a:xfrm>
+            <a:off x="320040" y="201168"/>
+            <a:ext cx="658368" cy="658368"/>
+          </a:xfrm>
+          <a:prstGeom prst="ellipse">
+            <a:avLst/>
+          </a:prstGeom>
+          <a:solidFill>
+            <a:srgbClr val="0D6EFD"/>
+          </a:solidFill>
+          <a:ln>
+            <a:noFill/>
+          </a:ln>
+          <a:effectLst/>
+        </p:spPr>
+        <p:style>
+          <a:lnRef idx="1">
+            <a:schemeClr val="accent1"/>
+          </a:lnRef>
+          <a:fillRef idx="3">
+            <a:schemeClr val="accent1"/>
+          </a:fillRef>
+          <a:effectRef idx="2">
+            <a:schemeClr val="accent1"/>
+          </a:effectRef>
+          <a:fontRef idx="minor">
+            <a:schemeClr val="lt1"/>
+          </a:fontRef>
+        </p:style>
+        <p:txBody>
+          <a:bodyPr rtlCol="0" anchor="ctr" wrap="none"/>
+          <a:lstStyle/>
+          <a:p>
+            <a:pPr algn="ctr"/>
+            <a:r>
+              <a:rPr sz="2600" b="1" i="0">
+                <a:solidFill>
+                  <a:srgbClr val="FFFFFF"/>
+                </a:solidFill>
+                <a:latin typeface="Calibri"/>
+              </a:rPr>
+              <a:t>8</a:t>
+            </a:r>
+          </a:p>
+        </p:txBody>
+      </p:sp>
+      <p:sp>
+        <p:nvSpPr>
+          <p:cNvPr id="4" name="TextBox 3"/>
+          <p:cNvSpPr txBox="1"/>
+          <p:nvPr/>
+        </p:nvSpPr>
+        <p:spPr>
+          <a:xfrm>
+            <a:off x="1143000" y="164592"/>
+            <a:ext cx="10774375" cy="731520"/>
+          </a:xfrm>
+          <a:prstGeom prst="rect">
+            <a:avLst/>
+          </a:prstGeom>
+          <a:noFill/>
+        </p:spPr>
+        <p:txBody>
+          <a:bodyPr wrap="square" anchor="ctr">
+            <a:spAutoFit/>
+          </a:bodyPr>
+          <a:lstStyle/>
+          <a:p>
+            <a:r>
+              <a:rPr sz="3000" b="1" i="0">
+                <a:solidFill>
+                  <a:srgbClr val="FFFFFF"/>
+                </a:solidFill>
+                <a:latin typeface="Calibri"/>
+              </a:rPr>
+              <a:t>Démonstration — gestion des équipements</a:t>
+            </a:r>
+          </a:p>
+        </p:txBody>
+      </p:sp>
+      <p:pic>
+        <p:nvPicPr>
+          <p:cNvPr id="5" name="Picture 4" descr="capture-equipements.png"/>
+          <p:cNvPicPr>
+            <a:picLocks noChangeAspect="1"/>
+          </p:cNvPicPr>
+          <p:nvPr/>
+        </p:nvPicPr>
+        <p:blipFill>
+          <a:blip r:embed="rId2"/>
+          <a:stretch>
+            <a:fillRect/>
+          </a:stretch>
+        </p:blipFill>
+        <p:spPr>
+          <a:xfrm>
+            <a:off x="2282441" y="1234440"/>
+            <a:ext cx="7626812" cy="4846320"/>
+          </a:xfrm>
+          <a:prstGeom prst="rect">
+            <a:avLst/>
+          </a:prstGeom>
+        </p:spPr>
+      </p:pic>
+      <p:sp>
+        <p:nvSpPr>
+          <p:cNvPr id="6" name="TextBox 5"/>
+          <p:cNvSpPr txBox="1"/>
+          <p:nvPr/>
+        </p:nvSpPr>
+        <p:spPr>
+          <a:xfrm>
+            <a:off x="457200" y="6172200"/>
+            <a:ext cx="11247120" cy="457200"/>
+          </a:xfrm>
+          <a:prstGeom prst="rect">
+            <a:avLst/>
+          </a:prstGeom>
+          <a:noFill/>
+        </p:spPr>
+        <p:txBody>
+          <a:bodyPr wrap="square">
+            <a:spAutoFit/>
+          </a:bodyPr>
+          <a:lstStyle/>
+          <a:p>
+            <a:pPr algn="ctr"/>
+            <a:r>
+              <a:rPr sz="1300" b="0" i="1">
+                <a:solidFill>
+                  <a:srgbClr val="333333"/>
+                </a:solidFill>
+                <a:latin typeface="Calibri"/>
+              </a:rPr>
+              <a:t>Inventaire du parc client : découverte automatique, statut, service supervisé et emplacement.</a:t>
+            </a:r>
+          </a:p>
+        </p:txBody>
+      </p:sp>
+    </p:spTree>
+  </p:cSld>
+  <p:clrMapOvr>
+    <a:masterClrMapping/>
+  </p:clrMapOvr>
+</p:sld>
+</file>
+
+<file path=ppt/slides/slide22.xml><?xml version="1.0" encoding="utf-8"?>
+<p:sld xmlns:a="http://schemas.openxmlformats.org/drawingml/2006/main" xmlns:p="http://schemas.openxmlformats.org/presentationml/2006/main" xmlns:r="http://schemas.openxmlformats.org/officeDocument/2006/relationships">
+  <p:cSld>
+    <p:bg>
+      <p:bgPr>
+        <a:solidFill>
+          <a:srgbClr val="FFFFFF"/>
+        </a:solidFill>
+        <a:effectLst/>
+      </p:bgPr>
+    </p:bg>
+    <p:spTree>
+      <p:nvGrpSpPr>
+        <p:cNvPr id="1" name=""/>
+        <p:cNvGrpSpPr/>
+        <p:nvPr/>
+      </p:nvGrpSpPr>
+      <p:grpSpPr/>
+      <p:sp>
+        <p:nvSpPr>
+          <p:cNvPr id="2" name="Rectangle 1"/>
+          <p:cNvSpPr/>
+          <p:nvPr/>
+        </p:nvSpPr>
+        <p:spPr>
+          <a:xfrm>
+            <a:off x="0" y="0"/>
+            <a:ext cx="12191695" cy="1051560"/>
+          </a:xfrm>
+          <a:prstGeom prst="rect">
+            <a:avLst/>
+          </a:prstGeom>
+          <a:solidFill>
+            <a:srgbClr val="0D3B66"/>
+          </a:solidFill>
+          <a:ln>
+            <a:noFill/>
+          </a:ln>
+          <a:effectLst/>
+        </p:spPr>
+        <p:style>
+          <a:lnRef idx="1">
+            <a:schemeClr val="accent1"/>
+          </a:lnRef>
+          <a:fillRef idx="3">
+            <a:schemeClr val="accent1"/>
+          </a:fillRef>
+          <a:effectRef idx="2">
+            <a:schemeClr val="accent1"/>
+          </a:effectRef>
+          <a:fontRef idx="minor">
+            <a:schemeClr val="lt1"/>
+          </a:fontRef>
+        </p:style>
+        <p:txBody>
+          <a:bodyPr rtlCol="0" anchor="ctr"/>
+          <a:lstStyle/>
+          <a:p>
+            <a:pPr algn="ctr"/>
+          </a:p>
+        </p:txBody>
+      </p:sp>
+      <p:sp>
+        <p:nvSpPr>
+          <p:cNvPr id="3" name="Oval 2"/>
+          <p:cNvSpPr/>
+          <p:nvPr/>
+        </p:nvSpPr>
+        <p:spPr>
+          <a:xfrm>
+            <a:off x="320040" y="201168"/>
+            <a:ext cx="658368" cy="658368"/>
+          </a:xfrm>
+          <a:prstGeom prst="ellipse">
+            <a:avLst/>
+          </a:prstGeom>
+          <a:solidFill>
+            <a:srgbClr val="0D6EFD"/>
+          </a:solidFill>
+          <a:ln>
+            <a:noFill/>
+          </a:ln>
+          <a:effectLst/>
+        </p:spPr>
+        <p:style>
+          <a:lnRef idx="1">
+            <a:schemeClr val="accent1"/>
+          </a:lnRef>
+          <a:fillRef idx="3">
+            <a:schemeClr val="accent1"/>
+          </a:fillRef>
+          <a:effectRef idx="2">
+            <a:schemeClr val="accent1"/>
+          </a:effectRef>
+          <a:fontRef idx="minor">
+            <a:schemeClr val="lt1"/>
+          </a:fontRef>
+        </p:style>
+        <p:txBody>
+          <a:bodyPr rtlCol="0" anchor="ctr" wrap="none"/>
+          <a:lstStyle/>
+          <a:p>
+            <a:pPr algn="ctr"/>
+            <a:r>
+              <a:rPr sz="2600" b="1" i="0">
+                <a:solidFill>
+                  <a:srgbClr val="FFFFFF"/>
+                </a:solidFill>
+                <a:latin typeface="Calibri"/>
+              </a:rPr>
+              <a:t>8</a:t>
+            </a:r>
+          </a:p>
+        </p:txBody>
+      </p:sp>
+      <p:sp>
+        <p:nvSpPr>
+          <p:cNvPr id="4" name="TextBox 3"/>
+          <p:cNvSpPr txBox="1"/>
+          <p:nvPr/>
+        </p:nvSpPr>
+        <p:spPr>
+          <a:xfrm>
+            <a:off x="1143000" y="164592"/>
+            <a:ext cx="10774375" cy="731520"/>
+          </a:xfrm>
+          <a:prstGeom prst="rect">
+            <a:avLst/>
+          </a:prstGeom>
+          <a:noFill/>
+        </p:spPr>
+        <p:txBody>
+          <a:bodyPr wrap="square" anchor="ctr">
+            <a:spAutoFit/>
+          </a:bodyPr>
+          <a:lstStyle/>
+          <a:p>
+            <a:r>
+              <a:rPr sz="3000" b="1" i="0">
+                <a:solidFill>
+                  <a:srgbClr val="FFFFFF"/>
+                </a:solidFill>
+                <a:latin typeface="Calibri"/>
+              </a:rPr>
+              <a:t>Démonstration — ce que chaque écran prouve</a:t>
             </a:r>
           </a:p>
         </p:txBody>
@@ -9140,7 +10531,7 @@
         </p:nvGraphicFramePr>
         <p:xfrm>
           <a:off x="640080" y="1371600"/>
-          <a:ext cx="10881360" cy="3474720"/>
+          <a:ext cx="10881360" cy="3108960"/>
         </p:xfrm>
         <a:graphic>
           <a:graphicData uri="http://schemas.openxmlformats.org/drawingml/2006/table">
@@ -9152,7 +10543,7 @@
                 <a:gridCol w="5440680"/>
                 <a:gridCol w="5440680"/>
               </a:tblGrid>
-              <a:tr h="496388">
+              <a:tr h="518160">
                 <a:tc>
                   <a:txBody>
                     <a:bodyPr/>
@@ -9189,7 +10580,7 @@
                           </a:solidFill>
                           <a:latin typeface="Calibri"/>
                         </a:rPr>
-                        <a:t>Ce qu'il prouve</a:t>
+                        <a:t>Ce qu'il prouve pour OPEN MOISE</a:t>
                       </a:r>
                     </a:p>
                   </a:txBody>
@@ -9200,7 +10591,7 @@
                   </a:tcPr>
                 </a:tc>
               </a:tr>
-              <a:tr h="496388">
+              <a:tr h="518160">
                 <a:tc>
                   <a:txBody>
                     <a:bodyPr/>
@@ -9214,7 +10605,7 @@
                           </a:solidFill>
                           <a:latin typeface="Calibri"/>
                         </a:rPr>
-                        <a:t>Connexion</a:t>
+                        <a:t>Tableau de bord</a:t>
                       </a:r>
                     </a:p>
                   </a:txBody>
@@ -9237,7 +10628,7 @@
                           </a:solidFill>
                           <a:latin typeface="Calibri"/>
                         </a:rPr>
-                        <a:t>Accès sécurisé</a:t>
+                        <a:t>Supervision temps réel, KPI, anneau de disponibilité</a:t>
                       </a:r>
                     </a:p>
                   </a:txBody>
@@ -9248,7 +10639,7 @@
                   </a:tcPr>
                 </a:tc>
               </a:tr>
-              <a:tr h="496388">
+              <a:tr h="518160">
                 <a:tc>
                   <a:txBody>
                     <a:bodyPr/>
@@ -9262,7 +10653,7 @@
                           </a:solidFill>
                           <a:latin typeface="Calibri"/>
                         </a:rPr>
-                        <a:t>Tableau de bord</a:t>
+                        <a:t>Équipements</a:t>
                       </a:r>
                     </a:p>
                   </a:txBody>
@@ -9285,7 +10676,7 @@
                           </a:solidFill>
                           <a:latin typeface="Calibri"/>
                         </a:rPr>
-                        <a:t>Supervision temps réel, KPI, anneau de disponibilité</a:t>
+                        <a:t>Inventaire + découverte automatique des parcs clients</a:t>
                       </a:r>
                     </a:p>
                   </a:txBody>
@@ -9296,7 +10687,7 @@
                   </a:tcPr>
                 </a:tc>
               </a:tr>
-              <a:tr h="496388">
+              <a:tr h="518160">
                 <a:tc>
                   <a:txBody>
                     <a:bodyPr/>
@@ -9310,7 +10701,7 @@
                           </a:solidFill>
                           <a:latin typeface="Calibri"/>
                         </a:rPr>
-                        <a:t>Équipements</a:t>
+                        <a:t>Alertes</a:t>
                       </a:r>
                     </a:p>
                   </a:txBody>
@@ -9333,7 +10724,7 @@
                           </a:solidFill>
                           <a:latin typeface="Calibri"/>
                         </a:rPr>
-                        <a:t>Inventaire + découverte automatique</a:t>
+                        <a:t>Traçabilité + acquittement (preuve de SLA)</a:t>
                       </a:r>
                     </a:p>
                   </a:txBody>
@@ -9344,7 +10735,7 @@
                   </a:tcPr>
                 </a:tc>
               </a:tr>
-              <a:tr h="496388">
+              <a:tr h="518160">
                 <a:tc>
                   <a:txBody>
                     <a:bodyPr/>
@@ -9358,7 +10749,7 @@
                           </a:solidFill>
                           <a:latin typeface="Calibri"/>
                         </a:rPr>
-                        <a:t>Alertes</a:t>
+                        <a:t>Notification Telegram</a:t>
                       </a:r>
                     </a:p>
                   </a:txBody>
@@ -9381,7 +10772,7 @@
                           </a:solidFill>
                           <a:latin typeface="Calibri"/>
                         </a:rPr>
-                        <a:t>Historique + acquittement</a:t>
+                        <a:t>Astreinte alertée sur smartphone en &lt; 2 min</a:t>
                       </a:r>
                     </a:p>
                   </a:txBody>
@@ -9392,7 +10783,7 @@
                   </a:tcPr>
                 </a:tc>
               </a:tr>
-              <a:tr h="496388">
+              <a:tr h="518160">
                 <a:tc>
                   <a:txBody>
                     <a:bodyPr/>
@@ -9406,7 +10797,7 @@
                           </a:solidFill>
                           <a:latin typeface="Calibri"/>
                         </a:rPr>
-                        <a:t>Notification Telegram</a:t>
+                        <a:t>Rapports</a:t>
                       </a:r>
                     </a:p>
                   </a:txBody>
@@ -9429,7 +10820,7 @@
                           </a:solidFill>
                           <a:latin typeface="Calibri"/>
                         </a:rPr>
-                        <a:t>Alerte push reçue sur smartphone</a:t>
+                        <a:t>Statistiques &amp; rapports de disponibilité exportables</a:t>
                       </a:r>
                     </a:p>
                   </a:txBody>
@@ -9440,54 +10831,6 @@
                   </a:tcPr>
                 </a:tc>
               </a:tr>
-              <a:tr h="496392">
-                <a:tc>
-                  <a:txBody>
-                    <a:bodyPr/>
-                    <a:lstStyle/>
-                    <a:p>
-                      <a:pPr algn="l"/>
-                      <a:r>
-                        <a:rPr sz="1600" b="0" i="0">
-                          <a:solidFill>
-                            <a:srgbClr val="333333"/>
-                          </a:solidFill>
-                          <a:latin typeface="Calibri"/>
-                        </a:rPr>
-                        <a:t>Rapports</a:t>
-                      </a:r>
-                    </a:p>
-                  </a:txBody>
-                  <a:tcPr>
-                    <a:solidFill>
-                      <a:srgbClr val="F1F3F5"/>
-                    </a:solidFill>
-                  </a:tcPr>
-                </a:tc>
-                <a:tc>
-                  <a:txBody>
-                    <a:bodyPr/>
-                    <a:lstStyle/>
-                    <a:p>
-                      <a:pPr algn="ctr"/>
-                      <a:r>
-                        <a:rPr sz="1600" b="0" i="0">
-                          <a:solidFill>
-                            <a:srgbClr val="333333"/>
-                          </a:solidFill>
-                          <a:latin typeface="Calibri"/>
-                        </a:rPr>
-                        <a:t>Statistiques &amp; graphiques exportables</a:t>
-                      </a:r>
-                    </a:p>
-                  </a:txBody>
-                  <a:tcPr>
-                    <a:solidFill>
-                      <a:srgbClr val="F1F3F5"/>
-                    </a:solidFill>
-                  </a:tcPr>
-                </a:tc>
-              </a:tr>
             </a:tbl>
           </a:graphicData>
         </a:graphic>
@@ -9500,8 +10843,8 @@
         </p:nvSpPr>
         <p:spPr>
           <a:xfrm>
-            <a:off x="640080" y="5212080"/>
-            <a:ext cx="109728" cy="822960"/>
+            <a:off x="640080" y="4937760"/>
+            <a:ext cx="109728" cy="914400"/>
           </a:xfrm>
           <a:prstGeom prst="rect">
             <a:avLst/>
@@ -9544,8 +10887,8 @@
         </p:nvSpPr>
         <p:spPr>
           <a:xfrm>
-            <a:off x="749808" y="5212080"/>
-            <a:ext cx="10771632" cy="822960"/>
+            <a:off x="749808" y="4937760"/>
+            <a:ext cx="10771632" cy="914400"/>
           </a:xfrm>
           <a:prstGeom prst="rect">
             <a:avLst/>
@@ -9584,7 +10927,7 @@
                 </a:solidFill>
                 <a:latin typeface="Calibri"/>
               </a:rPr>
-              <a:t>À insérer : les captures d'écran réelles de l'application déployée chez OPEN MOISE.</a:t>
+              <a:t>Toutes ces captures proviennent de l'application réellement développée (Flask + Bootstrap), avec un parc client d'exemple.</a:t>
             </a:r>
           </a:p>
         </p:txBody>
@@ -9597,7 +10940,7 @@
 </p:sld>
 </file>
 
-<file path=ppt/slides/slide2.xml><?xml version="1.0" encoding="utf-8"?>
+<file path=ppt/slides/slide23.xml><?xml version="1.0" encoding="utf-8"?>
 <p:sld xmlns:a="http://schemas.openxmlformats.org/drawingml/2006/main" xmlns:p="http://schemas.openxmlformats.org/presentationml/2006/main" xmlns:r="http://schemas.openxmlformats.org/officeDocument/2006/relationships">
   <p:cSld>
     <p:bg>
@@ -9661,380 +11004,6 @@
       </p:sp>
       <p:sp>
         <p:nvSpPr>
-          <p:cNvPr id="3" name="TextBox 2"/>
-          <p:cNvSpPr txBox="1"/>
-          <p:nvPr/>
-        </p:nvSpPr>
-        <p:spPr>
-          <a:xfrm>
-            <a:off x="457200" y="164592"/>
-            <a:ext cx="11460175" cy="731520"/>
-          </a:xfrm>
-          <a:prstGeom prst="rect">
-            <a:avLst/>
-          </a:prstGeom>
-          <a:noFill/>
-        </p:spPr>
-        <p:txBody>
-          <a:bodyPr wrap="square" anchor="ctr">
-            <a:spAutoFit/>
-          </a:bodyPr>
-          <a:lstStyle/>
-          <a:p>
-            <a:r>
-              <a:rPr sz="3000" b="1" i="0">
-                <a:solidFill>
-                  <a:srgbClr val="FFFFFF"/>
-                </a:solidFill>
-                <a:latin typeface="Calibri"/>
-              </a:rPr>
-              <a:t>Plan de la présentation</a:t>
-            </a:r>
-          </a:p>
-        </p:txBody>
-      </p:sp>
-      <p:sp>
-        <p:nvSpPr>
-          <p:cNvPr id="4" name="TextBox 3"/>
-          <p:cNvSpPr txBox="1"/>
-          <p:nvPr/>
-        </p:nvSpPr>
-        <p:spPr>
-          <a:xfrm>
-            <a:off x="548640" y="1463040"/>
-            <a:ext cx="5760720" cy="4937760"/>
-          </a:xfrm>
-          <a:prstGeom prst="rect">
-            <a:avLst/>
-          </a:prstGeom>
-          <a:noFill/>
-        </p:spPr>
-        <p:txBody>
-          <a:bodyPr wrap="square">
-            <a:spAutoFit/>
-          </a:bodyPr>
-          <a:lstStyle/>
-          <a:p>
-            <a:pPr>
-              <a:spcAft>
-                <a:spcPts val="1400"/>
-              </a:spcAft>
-            </a:pPr>
-            <a:r>
-              <a:rPr sz="1600" b="1" i="0">
-                <a:solidFill>
-                  <a:srgbClr val="0D3B66"/>
-                </a:solidFill>
-                <a:latin typeface="Calibri"/>
-              </a:rPr>
-              <a:t>•  Introduction — L'annonce du sujet</a:t>
-            </a:r>
-          </a:p>
-          <a:p>
-            <a:pPr>
-              <a:spcAft>
-                <a:spcPts val="1400"/>
-              </a:spcAft>
-            </a:pPr>
-            <a:r>
-              <a:rPr sz="1600" b="0" i="0">
-                <a:solidFill>
-                  <a:srgbClr val="333333"/>
-                </a:solidFill>
-                <a:latin typeface="Calibri"/>
-              </a:rPr>
-              <a:t>•  1.  Contexte et identification du problème</a:t>
-            </a:r>
-          </a:p>
-          <a:p>
-            <a:pPr>
-              <a:spcAft>
-                <a:spcPts val="1400"/>
-              </a:spcAft>
-            </a:pPr>
-            <a:r>
-              <a:rPr sz="1600" b="0" i="0">
-                <a:solidFill>
-                  <a:srgbClr val="333333"/>
-                </a:solidFill>
-                <a:latin typeface="Calibri"/>
-              </a:rPr>
-              <a:t>•  2.  Objectifs et résultats attendus</a:t>
-            </a:r>
-          </a:p>
-          <a:p>
-            <a:pPr>
-              <a:spcAft>
-                <a:spcPts val="1400"/>
-              </a:spcAft>
-            </a:pPr>
-            <a:r>
-              <a:rPr sz="1600" b="0" i="0">
-                <a:solidFill>
-                  <a:srgbClr val="333333"/>
-                </a:solidFill>
-                <a:latin typeface="Calibri"/>
-              </a:rPr>
-              <a:t>•  3.  Démarche méthodologique</a:t>
-            </a:r>
-          </a:p>
-          <a:p>
-            <a:pPr>
-              <a:spcAft>
-                <a:spcPts val="1400"/>
-              </a:spcAft>
-            </a:pPr>
-            <a:r>
-              <a:rPr sz="1600" b="0" i="0">
-                <a:solidFill>
-                  <a:srgbClr val="333333"/>
-                </a:solidFill>
-                <a:latin typeface="Calibri"/>
-              </a:rPr>
-              <a:t>•  4.  État des lieux des solutions existantes et solution proposée</a:t>
-            </a:r>
-          </a:p>
-          <a:p>
-            <a:pPr>
-              <a:spcAft>
-                <a:spcPts val="1400"/>
-              </a:spcAft>
-            </a:pPr>
-            <a:r>
-              <a:rPr sz="1600" b="0" i="0">
-                <a:solidFill>
-                  <a:srgbClr val="333333"/>
-                </a:solidFill>
-                <a:latin typeface="Calibri"/>
-              </a:rPr>
-              <a:t>•  5.  L'axe de différenciation (innovation technologique)</a:t>
-            </a:r>
-          </a:p>
-          <a:p>
-            <a:pPr>
-              <a:spcAft>
-                <a:spcPts val="1400"/>
-              </a:spcAft>
-            </a:pPr>
-            <a:r>
-              <a:rPr sz="1600" b="0" i="0">
-                <a:solidFill>
-                  <a:srgbClr val="333333"/>
-                </a:solidFill>
-                <a:latin typeface="Calibri"/>
-              </a:rPr>
-              <a:t>•  6.  Étude de faisabilité et conception de la solution</a:t>
-            </a:r>
-          </a:p>
-        </p:txBody>
-      </p:sp>
-      <p:sp>
-        <p:nvSpPr>
-          <p:cNvPr id="5" name="TextBox 4"/>
-          <p:cNvSpPr txBox="1"/>
-          <p:nvPr/>
-        </p:nvSpPr>
-        <p:spPr>
-          <a:xfrm>
-            <a:off x="6400800" y="1463040"/>
-            <a:ext cx="5486400" cy="4937760"/>
-          </a:xfrm>
-          <a:prstGeom prst="rect">
-            <a:avLst/>
-          </a:prstGeom>
-          <a:noFill/>
-        </p:spPr>
-        <p:txBody>
-          <a:bodyPr wrap="square">
-            <a:spAutoFit/>
-          </a:bodyPr>
-          <a:lstStyle/>
-          <a:p>
-            <a:pPr>
-              <a:spcAft>
-                <a:spcPts val="1400"/>
-              </a:spcAft>
-            </a:pPr>
-            <a:r>
-              <a:rPr sz="1600" b="0" i="0">
-                <a:solidFill>
-                  <a:srgbClr val="333333"/>
-                </a:solidFill>
-                <a:latin typeface="Calibri"/>
-              </a:rPr>
-              <a:t>•  7.  Fonctionnement de la solution : point de vue technique</a:t>
-            </a:r>
-          </a:p>
-          <a:p>
-            <a:pPr>
-              <a:spcAft>
-                <a:spcPts val="1400"/>
-              </a:spcAft>
-            </a:pPr>
-            <a:r>
-              <a:rPr sz="1600" b="1" i="0">
-                <a:solidFill>
-                  <a:srgbClr val="D62828"/>
-                </a:solidFill>
-                <a:latin typeface="Calibri"/>
-              </a:rPr>
-              <a:t>•  8.  Démonstration</a:t>
-            </a:r>
-          </a:p>
-          <a:p>
-            <a:pPr>
-              <a:spcAft>
-                <a:spcPts val="1400"/>
-              </a:spcAft>
-            </a:pPr>
-            <a:r>
-              <a:rPr sz="1600" b="0" i="0">
-                <a:solidFill>
-                  <a:srgbClr val="333333"/>
-                </a:solidFill>
-                <a:latin typeface="Calibri"/>
-              </a:rPr>
-              <a:t>•  9.  Marketing, vente et concurrence</a:t>
-            </a:r>
-          </a:p>
-          <a:p>
-            <a:pPr>
-              <a:spcAft>
-                <a:spcPts val="1400"/>
-              </a:spcAft>
-            </a:pPr>
-            <a:r>
-              <a:rPr sz="1600" b="0" i="0">
-                <a:solidFill>
-                  <a:srgbClr val="333333"/>
-                </a:solidFill>
-                <a:latin typeface="Calibri"/>
-              </a:rPr>
-              <a:t>•  10. Prévisions financières</a:t>
-            </a:r>
-          </a:p>
-          <a:p>
-            <a:pPr>
-              <a:spcAft>
-                <a:spcPts val="1400"/>
-              </a:spcAft>
-            </a:pPr>
-            <a:r>
-              <a:rPr sz="1600" b="0" i="0">
-                <a:solidFill>
-                  <a:srgbClr val="333333"/>
-                </a:solidFill>
-                <a:latin typeface="Calibri"/>
-              </a:rPr>
-              <a:t>•  11. Limites du projet et perspectives</a:t>
-            </a:r>
-          </a:p>
-          <a:p>
-            <a:pPr>
-              <a:spcAft>
-                <a:spcPts val="1400"/>
-              </a:spcAft>
-            </a:pPr>
-            <a:r>
-              <a:rPr sz="1600" b="0" i="0">
-                <a:solidFill>
-                  <a:srgbClr val="333333"/>
-                </a:solidFill>
-                <a:latin typeface="Calibri"/>
-              </a:rPr>
-              <a:t/>
-            </a:r>
-          </a:p>
-          <a:p>
-            <a:pPr>
-              <a:spcAft>
-                <a:spcPts val="1400"/>
-              </a:spcAft>
-            </a:pPr>
-            <a:r>
-              <a:rPr sz="1600" b="1" i="0">
-                <a:solidFill>
-                  <a:srgbClr val="0D3B66"/>
-                </a:solidFill>
-                <a:latin typeface="Calibri"/>
-              </a:rPr>
-              <a:t>•  Conclusion</a:t>
-            </a:r>
-          </a:p>
-        </p:txBody>
-      </p:sp>
-    </p:spTree>
-  </p:cSld>
-  <p:clrMapOvr>
-    <a:masterClrMapping/>
-  </p:clrMapOvr>
-</p:sld>
-</file>
-
-<file path=ppt/slides/slide20.xml><?xml version="1.0" encoding="utf-8"?>
-<p:sld xmlns:a="http://schemas.openxmlformats.org/drawingml/2006/main" xmlns:p="http://schemas.openxmlformats.org/presentationml/2006/main" xmlns:r="http://schemas.openxmlformats.org/officeDocument/2006/relationships">
-  <p:cSld>
-    <p:bg>
-      <p:bgPr>
-        <a:solidFill>
-          <a:srgbClr val="FFFFFF"/>
-        </a:solidFill>
-        <a:effectLst/>
-      </p:bgPr>
-    </p:bg>
-    <p:spTree>
-      <p:nvGrpSpPr>
-        <p:cNvPr id="1" name=""/>
-        <p:cNvGrpSpPr/>
-        <p:nvPr/>
-      </p:nvGrpSpPr>
-      <p:grpSpPr/>
-      <p:sp>
-        <p:nvSpPr>
-          <p:cNvPr id="2" name="Rectangle 1"/>
-          <p:cNvSpPr/>
-          <p:nvPr/>
-        </p:nvSpPr>
-        <p:spPr>
-          <a:xfrm>
-            <a:off x="0" y="0"/>
-            <a:ext cx="12191695" cy="1051560"/>
-          </a:xfrm>
-          <a:prstGeom prst="rect">
-            <a:avLst/>
-          </a:prstGeom>
-          <a:solidFill>
-            <a:srgbClr val="0D3B66"/>
-          </a:solidFill>
-          <a:ln>
-            <a:noFill/>
-          </a:ln>
-          <a:effectLst/>
-        </p:spPr>
-        <p:style>
-          <a:lnRef idx="1">
-            <a:schemeClr val="accent1"/>
-          </a:lnRef>
-          <a:fillRef idx="3">
-            <a:schemeClr val="accent1"/>
-          </a:fillRef>
-          <a:effectRef idx="2">
-            <a:schemeClr val="accent1"/>
-          </a:effectRef>
-          <a:fontRef idx="minor">
-            <a:schemeClr val="lt1"/>
-          </a:fontRef>
-        </p:style>
-        <p:txBody>
-          <a:bodyPr rtlCol="0" anchor="ctr"/>
-          <a:lstStyle/>
-          <a:p>
-            <a:pPr algn="ctr"/>
-          </a:p>
-        </p:txBody>
-      </p:sp>
-      <p:sp>
-        <p:nvSpPr>
           <p:cNvPr id="3" name="Oval 2"/>
           <p:cNvSpPr/>
           <p:nvPr/>
@@ -10311,7 +11280,7 @@
 </p:sld>
 </file>
 
-<file path=ppt/slides/slide21.xml><?xml version="1.0" encoding="utf-8"?>
+<file path=ppt/slides/slide24.xml><?xml version="1.0" encoding="utf-8"?>
 <p:sld xmlns:a="http://schemas.openxmlformats.org/drawingml/2006/main" xmlns:p="http://schemas.openxmlformats.org/presentationml/2006/main" xmlns:r="http://schemas.openxmlformats.org/officeDocument/2006/relationships">
   <p:cSld>
     <p:bg>
@@ -11157,7 +12126,7 @@
 </p:sld>
 </file>
 
-<file path=ppt/slides/slide22.xml><?xml version="1.0" encoding="utf-8"?>
+<file path=ppt/slides/slide25.xml><?xml version="1.0" encoding="utf-8"?>
 <p:sld xmlns:a="http://schemas.openxmlformats.org/drawingml/2006/main" xmlns:p="http://schemas.openxmlformats.org/presentationml/2006/main" xmlns:r="http://schemas.openxmlformats.org/officeDocument/2006/relationships">
   <p:cSld>
     <p:bg>
@@ -12198,7 +13167,7 @@
 </p:sld>
 </file>
 
-<file path=ppt/slides/slide23.xml><?xml version="1.0" encoding="utf-8"?>
+<file path=ppt/slides/slide26.xml><?xml version="1.0" encoding="utf-8"?>
 <p:sld xmlns:a="http://schemas.openxmlformats.org/drawingml/2006/main" xmlns:p="http://schemas.openxmlformats.org/presentationml/2006/main" xmlns:r="http://schemas.openxmlformats.org/officeDocument/2006/relationships">
   <p:cSld>
     <p:bg>
@@ -12542,453 +13511,6 @@
                 <a:latin typeface="Calibri"/>
               </a:rPr>
               <a:t>–  Portail multi-clients · Conteneurisation (Docker/K8s) · SMS, Slack, Teams</a:t>
-            </a:r>
-          </a:p>
-        </p:txBody>
-      </p:sp>
-    </p:spTree>
-  </p:cSld>
-  <p:clrMapOvr>
-    <a:masterClrMapping/>
-  </p:clrMapOvr>
-</p:sld>
-</file>
-
-<file path=ppt/slides/slide24.xml><?xml version="1.0" encoding="utf-8"?>
-<p:sld xmlns:a="http://schemas.openxmlformats.org/drawingml/2006/main" xmlns:p="http://schemas.openxmlformats.org/presentationml/2006/main" xmlns:r="http://schemas.openxmlformats.org/officeDocument/2006/relationships">
-  <p:cSld>
-    <p:bg>
-      <p:bgPr>
-        <a:solidFill>
-          <a:srgbClr val="FFFFFF"/>
-        </a:solidFill>
-        <a:effectLst/>
-      </p:bgPr>
-    </p:bg>
-    <p:spTree>
-      <p:nvGrpSpPr>
-        <p:cNvPr id="1" name=""/>
-        <p:cNvGrpSpPr/>
-        <p:nvPr/>
-      </p:nvGrpSpPr>
-      <p:grpSpPr/>
-      <p:sp>
-        <p:nvSpPr>
-          <p:cNvPr id="2" name="Rectangle 1"/>
-          <p:cNvSpPr/>
-          <p:nvPr/>
-        </p:nvSpPr>
-        <p:spPr>
-          <a:xfrm>
-            <a:off x="0" y="0"/>
-            <a:ext cx="12191695" cy="1051560"/>
-          </a:xfrm>
-          <a:prstGeom prst="rect">
-            <a:avLst/>
-          </a:prstGeom>
-          <a:solidFill>
-            <a:srgbClr val="0D3B66"/>
-          </a:solidFill>
-          <a:ln>
-            <a:noFill/>
-          </a:ln>
-          <a:effectLst/>
-        </p:spPr>
-        <p:style>
-          <a:lnRef idx="1">
-            <a:schemeClr val="accent1"/>
-          </a:lnRef>
-          <a:fillRef idx="3">
-            <a:schemeClr val="accent1"/>
-          </a:fillRef>
-          <a:effectRef idx="2">
-            <a:schemeClr val="accent1"/>
-          </a:effectRef>
-          <a:fontRef idx="minor">
-            <a:schemeClr val="lt1"/>
-          </a:fontRef>
-        </p:style>
-        <p:txBody>
-          <a:bodyPr rtlCol="0" anchor="ctr"/>
-          <a:lstStyle/>
-          <a:p>
-            <a:pPr algn="ctr"/>
-          </a:p>
-        </p:txBody>
-      </p:sp>
-      <p:sp>
-        <p:nvSpPr>
-          <p:cNvPr id="3" name="TextBox 2"/>
-          <p:cNvSpPr txBox="1"/>
-          <p:nvPr/>
-        </p:nvSpPr>
-        <p:spPr>
-          <a:xfrm>
-            <a:off x="457200" y="164592"/>
-            <a:ext cx="11460175" cy="731520"/>
-          </a:xfrm>
-          <a:prstGeom prst="rect">
-            <a:avLst/>
-          </a:prstGeom>
-          <a:noFill/>
-        </p:spPr>
-        <p:txBody>
-          <a:bodyPr wrap="square" anchor="ctr">
-            <a:spAutoFit/>
-          </a:bodyPr>
-          <a:lstStyle/>
-          <a:p>
-            <a:r>
-              <a:rPr sz="3000" b="1" i="0">
-                <a:solidFill>
-                  <a:srgbClr val="FFFFFF"/>
-                </a:solidFill>
-                <a:latin typeface="Calibri"/>
-              </a:rPr>
-              <a:t>Conclusion</a:t>
-            </a:r>
-          </a:p>
-        </p:txBody>
-      </p:sp>
-      <p:sp>
-        <p:nvSpPr>
-          <p:cNvPr id="4" name="TextBox 3"/>
-          <p:cNvSpPr txBox="1"/>
-          <p:nvPr/>
-        </p:nvSpPr>
-        <p:spPr>
-          <a:xfrm>
-            <a:off x="640080" y="1463040"/>
-            <a:ext cx="10881360" cy="2560320"/>
-          </a:xfrm>
-          <a:prstGeom prst="rect">
-            <a:avLst/>
-          </a:prstGeom>
-          <a:noFill/>
-        </p:spPr>
-        <p:txBody>
-          <a:bodyPr wrap="square">
-            <a:spAutoFit/>
-          </a:bodyPr>
-          <a:lstStyle/>
-          <a:p>
-            <a:pPr>
-              <a:spcAft>
-                <a:spcPts val="1400"/>
-              </a:spcAft>
-            </a:pPr>
-            <a:r>
-              <a:rPr sz="2100" b="1" i="0">
-                <a:solidFill>
-                  <a:srgbClr val="198754"/>
-                </a:solidFill>
-                <a:latin typeface="Calibri"/>
-              </a:rPr>
-              <a:t>•  Pour OPEN MOISE : un outil fonctionnel, testé, 100 % open-source</a:t>
-            </a:r>
-          </a:p>
-          <a:p>
-            <a:pPr>
-              <a:spcAft>
-                <a:spcPts val="1400"/>
-              </a:spcAft>
-            </a:pPr>
-            <a:r>
-              <a:rPr sz="2100" b="1" i="0">
-                <a:solidFill>
-                  <a:srgbClr val="198754"/>
-                </a:solidFill>
-                <a:latin typeface="Calibri"/>
-              </a:rPr>
-              <a:t>•  Détection temps réel (&lt; 2 min) → SLA clients mieux respectés</a:t>
-            </a:r>
-          </a:p>
-          <a:p>
-            <a:pPr>
-              <a:spcAft>
-                <a:spcPts val="1400"/>
-              </a:spcAft>
-            </a:pPr>
-            <a:r>
-              <a:rPr sz="2100" b="1" i="0">
-                <a:solidFill>
-                  <a:srgbClr val="198754"/>
-                </a:solidFill>
-                <a:latin typeface="Calibri"/>
-              </a:rPr>
-              <a:t>•  Double valeur : économies internes + nouvelle offre managée</a:t>
-            </a:r>
-          </a:p>
-          <a:p>
-            <a:pPr>
-              <a:spcAft>
-                <a:spcPts val="1400"/>
-              </a:spcAft>
-            </a:pPr>
-            <a:r>
-              <a:rPr sz="2100" b="1" i="0">
-                <a:solidFill>
-                  <a:srgbClr val="198754"/>
-                </a:solidFill>
-                <a:latin typeface="Calibri"/>
-              </a:rPr>
-              <a:t>•  Une base extensible vers l'IA et la maintenance prédictive</a:t>
-            </a:r>
-          </a:p>
-        </p:txBody>
-      </p:sp>
-      <p:sp>
-        <p:nvSpPr>
-          <p:cNvPr id="5" name="Rectangle 4"/>
-          <p:cNvSpPr/>
-          <p:nvPr/>
-        </p:nvSpPr>
-        <p:spPr>
-          <a:xfrm>
-            <a:off x="640080" y="4572000"/>
-            <a:ext cx="109728" cy="1463040"/>
-          </a:xfrm>
-          <a:prstGeom prst="rect">
-            <a:avLst/>
-          </a:prstGeom>
-          <a:solidFill>
-            <a:srgbClr val="0D6EFD"/>
-          </a:solidFill>
-          <a:ln>
-            <a:noFill/>
-          </a:ln>
-          <a:effectLst/>
-        </p:spPr>
-        <p:style>
-          <a:lnRef idx="1">
-            <a:schemeClr val="accent1"/>
-          </a:lnRef>
-          <a:fillRef idx="3">
-            <a:schemeClr val="accent1"/>
-          </a:fillRef>
-          <a:effectRef idx="2">
-            <a:schemeClr val="accent1"/>
-          </a:effectRef>
-          <a:fontRef idx="minor">
-            <a:schemeClr val="lt1"/>
-          </a:fontRef>
-        </p:style>
-        <p:txBody>
-          <a:bodyPr rtlCol="0" anchor="ctr"/>
-          <a:lstStyle/>
-          <a:p>
-            <a:pPr algn="ctr"/>
-          </a:p>
-        </p:txBody>
-      </p:sp>
-      <p:sp>
-        <p:nvSpPr>
-          <p:cNvPr id="6" name="Rectangle 5"/>
-          <p:cNvSpPr/>
-          <p:nvPr/>
-        </p:nvSpPr>
-        <p:spPr>
-          <a:xfrm>
-            <a:off x="749808" y="4572000"/>
-            <a:ext cx="10771632" cy="1463040"/>
-          </a:xfrm>
-          <a:prstGeom prst="rect">
-            <a:avLst/>
-          </a:prstGeom>
-          <a:solidFill>
-            <a:srgbClr val="0D3B66"/>
-          </a:solidFill>
-          <a:ln>
-            <a:noFill/>
-          </a:ln>
-          <a:effectLst/>
-        </p:spPr>
-        <p:style>
-          <a:lnRef idx="1">
-            <a:schemeClr val="accent1"/>
-          </a:lnRef>
-          <a:fillRef idx="3">
-            <a:schemeClr val="accent1"/>
-          </a:fillRef>
-          <a:effectRef idx="2">
-            <a:schemeClr val="accent1"/>
-          </a:effectRef>
-          <a:fontRef idx="minor">
-            <a:schemeClr val="lt1"/>
-          </a:fontRef>
-        </p:style>
-        <p:txBody>
-          <a:bodyPr rtlCol="0" anchor="ctr" wrap="square" lIns="182880"/>
-          <a:lstStyle/>
-          <a:p>
-            <a:pPr algn="ctr"/>
-            <a:r>
-              <a:rPr sz="1700" b="1" i="1">
-                <a:solidFill>
-                  <a:srgbClr val="0D3B66"/>
-                </a:solidFill>
-                <a:latin typeface="Calibri"/>
-              </a:rPr>
-              <a:t>Pour OPEN MOISE, l'automatisation transforme la supervision en avantage concurrentiel : de la réaction subie vers un service proactif, fiable et rentable pour ses clients.</a:t>
-            </a:r>
-          </a:p>
-        </p:txBody>
-      </p:sp>
-    </p:spTree>
-  </p:cSld>
-  <p:clrMapOvr>
-    <a:masterClrMapping/>
-  </p:clrMapOvr>
-</p:sld>
-</file>
-
-<file path=ppt/slides/slide25.xml><?xml version="1.0" encoding="utf-8"?>
-<p:sld xmlns:a="http://schemas.openxmlformats.org/drawingml/2006/main" xmlns:p="http://schemas.openxmlformats.org/presentationml/2006/main" xmlns:r="http://schemas.openxmlformats.org/officeDocument/2006/relationships">
-  <p:cSld>
-    <p:bg>
-      <p:bgPr>
-        <a:solidFill>
-          <a:srgbClr val="0D3B66"/>
-        </a:solidFill>
-        <a:effectLst/>
-      </p:bgPr>
-    </p:bg>
-    <p:spTree>
-      <p:nvGrpSpPr>
-        <p:cNvPr id="1" name=""/>
-        <p:cNvGrpSpPr/>
-        <p:nvPr/>
-      </p:nvGrpSpPr>
-      <p:grpSpPr/>
-      <p:sp>
-        <p:nvSpPr>
-          <p:cNvPr id="2" name="TextBox 1"/>
-          <p:cNvSpPr txBox="1"/>
-          <p:nvPr/>
-        </p:nvSpPr>
-        <p:spPr>
-          <a:xfrm>
-            <a:off x="914400" y="2560320"/>
-            <a:ext cx="10332720" cy="1828800"/>
-          </a:xfrm>
-          <a:prstGeom prst="rect">
-            <a:avLst/>
-          </a:prstGeom>
-          <a:noFill/>
-        </p:spPr>
-        <p:txBody>
-          <a:bodyPr wrap="square" anchor="ctr">
-            <a:spAutoFit/>
-          </a:bodyPr>
-          <a:lstStyle/>
-          <a:p>
-            <a:pPr algn="ctr"/>
-            <a:r>
-              <a:rPr sz="4000" b="1" i="0">
-                <a:solidFill>
-                  <a:srgbClr val="FFFFFF"/>
-                </a:solidFill>
-                <a:latin typeface="Calibri"/>
-              </a:rPr>
-              <a:t>Merci de votre attention</a:t>
-            </a:r>
-          </a:p>
-          <a:p>
-            <a:pPr algn="ctr"/>
-            <a:r>
-              <a:rPr sz="2000" b="0" i="1">
-                <a:solidFill>
-                  <a:srgbClr val="DDE6F2"/>
-                </a:solidFill>
-                <a:latin typeface="Calibri"/>
-              </a:rPr>
-              <a:t>Je me tiens à votre disposition pour vos questions</a:t>
-            </a:r>
-          </a:p>
-          <a:p>
-            <a:pPr algn="ctr"/>
-            <a:r>
-              <a:rPr sz="1600" b="1" i="0">
-                <a:solidFill>
-                  <a:srgbClr val="FFFFFF"/>
-                </a:solidFill>
-                <a:latin typeface="Calibri"/>
-              </a:rPr>
-              <a:t>
-[NOM Prénom] — Master 2 RIT — 2026</a:t>
-            </a:r>
-          </a:p>
-        </p:txBody>
-      </p:sp>
-    </p:spTree>
-  </p:cSld>
-  <p:clrMapOvr>
-    <a:masterClrMapping/>
-  </p:clrMapOvr>
-</p:sld>
-</file>
-
-<file path=ppt/slides/slide26.xml><?xml version="1.0" encoding="utf-8"?>
-<p:sld xmlns:a="http://schemas.openxmlformats.org/drawingml/2006/main" xmlns:p="http://schemas.openxmlformats.org/presentationml/2006/main" xmlns:r="http://schemas.openxmlformats.org/officeDocument/2006/relationships">
-  <p:cSld>
-    <p:bg>
-      <p:bgPr>
-        <a:solidFill>
-          <a:srgbClr val="0D3B66"/>
-        </a:solidFill>
-        <a:effectLst/>
-      </p:bgPr>
-    </p:bg>
-    <p:spTree>
-      <p:nvGrpSpPr>
-        <p:cNvPr id="1" name=""/>
-        <p:cNvGrpSpPr/>
-        <p:nvPr/>
-      </p:nvGrpSpPr>
-      <p:grpSpPr/>
-      <p:sp>
-        <p:nvSpPr>
-          <p:cNvPr id="2" name="TextBox 1"/>
-          <p:cNvSpPr txBox="1"/>
-          <p:nvPr/>
-        </p:nvSpPr>
-        <p:spPr>
-          <a:xfrm>
-            <a:off x="914400" y="2743200"/>
-            <a:ext cx="10332720" cy="1371600"/>
-          </a:xfrm>
-          <a:prstGeom prst="rect">
-            <a:avLst/>
-          </a:prstGeom>
-          <a:noFill/>
-        </p:spPr>
-        <p:txBody>
-          <a:bodyPr wrap="square" anchor="ctr">
-            <a:spAutoFit/>
-          </a:bodyPr>
-          <a:lstStyle/>
-          <a:p>
-            <a:pPr algn="ctr"/>
-            <a:r>
-              <a:rPr sz="3000" b="1" i="0">
-                <a:solidFill>
-                  <a:srgbClr val="FFFFFF"/>
-                </a:solidFill>
-                <a:latin typeface="Calibri"/>
-              </a:rPr>
-              <a:t>ANNEXES — Diagrammes de conception détaillés</a:t>
-            </a:r>
-          </a:p>
-          <a:p>
-            <a:pPr algn="ctr"/>
-            <a:r>
-              <a:rPr sz="1600" b="0" i="1">
-                <a:solidFill>
-                  <a:srgbClr val="DDE6F2"/>
-                </a:solidFill>
-                <a:latin typeface="Calibri"/>
-              </a:rPr>
-              <a:t>Diapositives de secours pour les questions du jury</a:t>
             </a:r>
           </a:p>
         </p:txBody>
@@ -13092,35 +13614,195 @@
                 </a:solidFill>
                 <a:latin typeface="Calibri"/>
               </a:rPr>
-              <a:t>Annexe — Diagramme de contexte</a:t>
-            </a:r>
-          </a:p>
-        </p:txBody>
-      </p:sp>
-      <p:pic>
-        <p:nvPicPr>
-          <p:cNvPr id="4" name="Picture 3" descr="diagramme-contexte.png"/>
-          <p:cNvPicPr>
-            <a:picLocks noChangeAspect="1"/>
-          </p:cNvPicPr>
+              <a:t>Conclusion</a:t>
+            </a:r>
+          </a:p>
+        </p:txBody>
+      </p:sp>
+      <p:sp>
+        <p:nvSpPr>
+          <p:cNvPr id="4" name="TextBox 3"/>
+          <p:cNvSpPr txBox="1"/>
           <p:nvPr/>
-        </p:nvPicPr>
-        <p:blipFill>
-          <a:blip r:embed="rId2"/>
-          <a:stretch>
-            <a:fillRect/>
-          </a:stretch>
-        </p:blipFill>
-        <p:spPr>
-          <a:xfrm>
-            <a:off x="700887" y="1234440"/>
-            <a:ext cx="10789920" cy="3854309"/>
+        </p:nvSpPr>
+        <p:spPr>
+          <a:xfrm>
+            <a:off x="640080" y="1463040"/>
+            <a:ext cx="10881360" cy="2560320"/>
           </a:xfrm>
           <a:prstGeom prst="rect">
             <a:avLst/>
           </a:prstGeom>
-        </p:spPr>
-      </p:pic>
+          <a:noFill/>
+        </p:spPr>
+        <p:txBody>
+          <a:bodyPr wrap="square">
+            <a:spAutoFit/>
+          </a:bodyPr>
+          <a:lstStyle/>
+          <a:p>
+            <a:pPr>
+              <a:spcAft>
+                <a:spcPts val="1400"/>
+              </a:spcAft>
+            </a:pPr>
+            <a:r>
+              <a:rPr sz="2100" b="1" i="0">
+                <a:solidFill>
+                  <a:srgbClr val="198754"/>
+                </a:solidFill>
+                <a:latin typeface="Calibri"/>
+              </a:rPr>
+              <a:t>•  Pour OPEN MOISE : un outil fonctionnel, testé, 100 % open-source</a:t>
+            </a:r>
+          </a:p>
+          <a:p>
+            <a:pPr>
+              <a:spcAft>
+                <a:spcPts val="1400"/>
+              </a:spcAft>
+            </a:pPr>
+            <a:r>
+              <a:rPr sz="2100" b="1" i="0">
+                <a:solidFill>
+                  <a:srgbClr val="198754"/>
+                </a:solidFill>
+                <a:latin typeface="Calibri"/>
+              </a:rPr>
+              <a:t>•  Détection temps réel (&lt; 2 min) → SLA clients mieux respectés</a:t>
+            </a:r>
+          </a:p>
+          <a:p>
+            <a:pPr>
+              <a:spcAft>
+                <a:spcPts val="1400"/>
+              </a:spcAft>
+            </a:pPr>
+            <a:r>
+              <a:rPr sz="2100" b="1" i="0">
+                <a:solidFill>
+                  <a:srgbClr val="198754"/>
+                </a:solidFill>
+                <a:latin typeface="Calibri"/>
+              </a:rPr>
+              <a:t>•  Double valeur : économies internes + nouvelle offre managée</a:t>
+            </a:r>
+          </a:p>
+          <a:p>
+            <a:pPr>
+              <a:spcAft>
+                <a:spcPts val="1400"/>
+              </a:spcAft>
+            </a:pPr>
+            <a:r>
+              <a:rPr sz="2100" b="1" i="0">
+                <a:solidFill>
+                  <a:srgbClr val="198754"/>
+                </a:solidFill>
+                <a:latin typeface="Calibri"/>
+              </a:rPr>
+              <a:t>•  Une base extensible vers l'IA et la maintenance prédictive</a:t>
+            </a:r>
+          </a:p>
+        </p:txBody>
+      </p:sp>
+      <p:sp>
+        <p:nvSpPr>
+          <p:cNvPr id="5" name="Rectangle 4"/>
+          <p:cNvSpPr/>
+          <p:nvPr/>
+        </p:nvSpPr>
+        <p:spPr>
+          <a:xfrm>
+            <a:off x="640080" y="4572000"/>
+            <a:ext cx="109728" cy="1463040"/>
+          </a:xfrm>
+          <a:prstGeom prst="rect">
+            <a:avLst/>
+          </a:prstGeom>
+          <a:solidFill>
+            <a:srgbClr val="0D6EFD"/>
+          </a:solidFill>
+          <a:ln>
+            <a:noFill/>
+          </a:ln>
+          <a:effectLst/>
+        </p:spPr>
+        <p:style>
+          <a:lnRef idx="1">
+            <a:schemeClr val="accent1"/>
+          </a:lnRef>
+          <a:fillRef idx="3">
+            <a:schemeClr val="accent1"/>
+          </a:fillRef>
+          <a:effectRef idx="2">
+            <a:schemeClr val="accent1"/>
+          </a:effectRef>
+          <a:fontRef idx="minor">
+            <a:schemeClr val="lt1"/>
+          </a:fontRef>
+        </p:style>
+        <p:txBody>
+          <a:bodyPr rtlCol="0" anchor="ctr"/>
+          <a:lstStyle/>
+          <a:p>
+            <a:pPr algn="ctr"/>
+          </a:p>
+        </p:txBody>
+      </p:sp>
+      <p:sp>
+        <p:nvSpPr>
+          <p:cNvPr id="6" name="Rectangle 5"/>
+          <p:cNvSpPr/>
+          <p:nvPr/>
+        </p:nvSpPr>
+        <p:spPr>
+          <a:xfrm>
+            <a:off x="749808" y="4572000"/>
+            <a:ext cx="10771632" cy="1463040"/>
+          </a:xfrm>
+          <a:prstGeom prst="rect">
+            <a:avLst/>
+          </a:prstGeom>
+          <a:solidFill>
+            <a:srgbClr val="0D3B66"/>
+          </a:solidFill>
+          <a:ln>
+            <a:noFill/>
+          </a:ln>
+          <a:effectLst/>
+        </p:spPr>
+        <p:style>
+          <a:lnRef idx="1">
+            <a:schemeClr val="accent1"/>
+          </a:lnRef>
+          <a:fillRef idx="3">
+            <a:schemeClr val="accent1"/>
+          </a:fillRef>
+          <a:effectRef idx="2">
+            <a:schemeClr val="accent1"/>
+          </a:effectRef>
+          <a:fontRef idx="minor">
+            <a:schemeClr val="lt1"/>
+          </a:fontRef>
+        </p:style>
+        <p:txBody>
+          <a:bodyPr rtlCol="0" anchor="ctr" wrap="square" lIns="182880"/>
+          <a:lstStyle/>
+          <a:p>
+            <a:pPr algn="ctr"/>
+            <a:r>
+              <a:rPr sz="1700" b="1" i="1">
+                <a:solidFill>
+                  <a:srgbClr val="0D3B66"/>
+                </a:solidFill>
+                <a:latin typeface="Calibri"/>
+              </a:rPr>
+              <a:t>Pour OPEN MOISE, l'automatisation transforme la supervision en avantage concurrentiel : de la réaction subie vers un service proactif, fiable et rentable pour ses clients.</a:t>
+            </a:r>
+          </a:p>
+        </p:txBody>
+      </p:sp>
     </p:spTree>
   </p:cSld>
   <p:clrMapOvr>
@@ -13135,7 +13817,7 @@
     <p:bg>
       <p:bgPr>
         <a:solidFill>
-          <a:srgbClr val="FFFFFF"/>
+          <a:srgbClr val="0D3B66"/>
         </a:solidFill>
         <a:effectLst/>
       </p:bgPr>
@@ -13149,58 +13831,14 @@
       <p:grpSpPr/>
       <p:sp>
         <p:nvSpPr>
-          <p:cNvPr id="2" name="Rectangle 1"/>
-          <p:cNvSpPr/>
-          <p:nvPr/>
-        </p:nvSpPr>
-        <p:spPr>
-          <a:xfrm>
-            <a:off x="0" y="0"/>
-            <a:ext cx="12191695" cy="1051560"/>
-          </a:xfrm>
-          <a:prstGeom prst="rect">
-            <a:avLst/>
-          </a:prstGeom>
-          <a:solidFill>
-            <a:srgbClr val="0D3B66"/>
-          </a:solidFill>
-          <a:ln>
-            <a:noFill/>
-          </a:ln>
-          <a:effectLst/>
-        </p:spPr>
-        <p:style>
-          <a:lnRef idx="1">
-            <a:schemeClr val="accent1"/>
-          </a:lnRef>
-          <a:fillRef idx="3">
-            <a:schemeClr val="accent1"/>
-          </a:fillRef>
-          <a:effectRef idx="2">
-            <a:schemeClr val="accent1"/>
-          </a:effectRef>
-          <a:fontRef idx="minor">
-            <a:schemeClr val="lt1"/>
-          </a:fontRef>
-        </p:style>
-        <p:txBody>
-          <a:bodyPr rtlCol="0" anchor="ctr"/>
-          <a:lstStyle/>
-          <a:p>
-            <a:pPr algn="ctr"/>
-          </a:p>
-        </p:txBody>
-      </p:sp>
-      <p:sp>
-        <p:nvSpPr>
-          <p:cNvPr id="3" name="TextBox 2"/>
+          <p:cNvPr id="2" name="TextBox 1"/>
           <p:cNvSpPr txBox="1"/>
           <p:nvPr/>
         </p:nvSpPr>
         <p:spPr>
           <a:xfrm>
-            <a:off x="457200" y="164592"/>
-            <a:ext cx="11460175" cy="731520"/>
+            <a:off x="914400" y="2560320"/>
+            <a:ext cx="10332720" cy="1828800"/>
           </a:xfrm>
           <a:prstGeom prst="rect">
             <a:avLst/>
@@ -13213,42 +13851,44 @@
           </a:bodyPr>
           <a:lstStyle/>
           <a:p>
-            <a:r>
-              <a:rPr sz="3000" b="1" i="0">
+            <a:pPr algn="ctr"/>
+            <a:r>
+              <a:rPr sz="4000" b="1" i="0">
                 <a:solidFill>
                   <a:srgbClr val="FFFFFF"/>
                 </a:solidFill>
                 <a:latin typeface="Calibri"/>
               </a:rPr>
-              <a:t>Annexe — Diagramme de cas d'utilisation</a:t>
-            </a:r>
-          </a:p>
-        </p:txBody>
-      </p:sp>
-      <p:pic>
-        <p:nvPicPr>
-          <p:cNvPr id="4" name="Picture 3" descr="cas-utilisation.png"/>
-          <p:cNvPicPr>
-            <a:picLocks noChangeAspect="1"/>
-          </p:cNvPicPr>
-          <p:nvPr/>
-        </p:nvPicPr>
-        <p:blipFill>
-          <a:blip r:embed="rId2"/>
-          <a:stretch>
-            <a:fillRect/>
-          </a:stretch>
-        </p:blipFill>
-        <p:spPr>
-          <a:xfrm>
-            <a:off x="700887" y="1234440"/>
-            <a:ext cx="10789920" cy="4190962"/>
-          </a:xfrm>
-          <a:prstGeom prst="rect">
-            <a:avLst/>
-          </a:prstGeom>
-        </p:spPr>
-      </p:pic>
+              <a:t>Merci de votre attention</a:t>
+            </a:r>
+          </a:p>
+          <a:p>
+            <a:pPr algn="ctr"/>
+            <a:r>
+              <a:rPr sz="2000" b="0" i="1">
+                <a:solidFill>
+                  <a:srgbClr val="DDE6F2"/>
+                </a:solidFill>
+                <a:latin typeface="Calibri"/>
+              </a:rPr>
+              <a:t>Je me tiens à votre disposition pour vos questions</a:t>
+            </a:r>
+          </a:p>
+          <a:p>
+            <a:pPr algn="ctr"/>
+            <a:r>
+              <a:rPr sz="1600" b="1" i="0">
+                <a:solidFill>
+                  <a:srgbClr val="FFFFFF"/>
+                </a:solidFill>
+                <a:latin typeface="Calibri"/>
+              </a:rPr>
+              <a:t>
+[NOM Prénom] — Master 2 RIT — 2026</a:t>
+            </a:r>
+          </a:p>
+        </p:txBody>
+      </p:sp>
     </p:spTree>
   </p:cSld>
   <p:clrMapOvr>
@@ -13263,7 +13903,7 @@
     <p:bg>
       <p:bgPr>
         <a:solidFill>
-          <a:srgbClr val="FFFFFF"/>
+          <a:srgbClr val="0D3B66"/>
         </a:solidFill>
         <a:effectLst/>
       </p:bgPr>
@@ -13277,58 +13917,14 @@
       <p:grpSpPr/>
       <p:sp>
         <p:nvSpPr>
-          <p:cNvPr id="2" name="Rectangle 1"/>
-          <p:cNvSpPr/>
-          <p:nvPr/>
-        </p:nvSpPr>
-        <p:spPr>
-          <a:xfrm>
-            <a:off x="0" y="0"/>
-            <a:ext cx="12191695" cy="1051560"/>
-          </a:xfrm>
-          <a:prstGeom prst="rect">
-            <a:avLst/>
-          </a:prstGeom>
-          <a:solidFill>
-            <a:srgbClr val="0D3B66"/>
-          </a:solidFill>
-          <a:ln>
-            <a:noFill/>
-          </a:ln>
-          <a:effectLst/>
-        </p:spPr>
-        <p:style>
-          <a:lnRef idx="1">
-            <a:schemeClr val="accent1"/>
-          </a:lnRef>
-          <a:fillRef idx="3">
-            <a:schemeClr val="accent1"/>
-          </a:fillRef>
-          <a:effectRef idx="2">
-            <a:schemeClr val="accent1"/>
-          </a:effectRef>
-          <a:fontRef idx="minor">
-            <a:schemeClr val="lt1"/>
-          </a:fontRef>
-        </p:style>
-        <p:txBody>
-          <a:bodyPr rtlCol="0" anchor="ctr"/>
-          <a:lstStyle/>
-          <a:p>
-            <a:pPr algn="ctr"/>
-          </a:p>
-        </p:txBody>
-      </p:sp>
-      <p:sp>
-        <p:nvSpPr>
-          <p:cNvPr id="3" name="TextBox 2"/>
+          <p:cNvPr id="2" name="TextBox 1"/>
           <p:cNvSpPr txBox="1"/>
           <p:nvPr/>
         </p:nvSpPr>
         <p:spPr>
           <a:xfrm>
-            <a:off x="457200" y="164592"/>
-            <a:ext cx="11460175" cy="731520"/>
+            <a:off x="914400" y="2743200"/>
+            <a:ext cx="10332720" cy="1371600"/>
           </a:xfrm>
           <a:prstGeom prst="rect">
             <a:avLst/>
@@ -13341,6 +13937,7 @@
           </a:bodyPr>
           <a:lstStyle/>
           <a:p>
+            <a:pPr algn="ctr"/>
             <a:r>
               <a:rPr sz="3000" b="1" i="0">
                 <a:solidFill>
@@ -13348,35 +13945,23 @@
                 </a:solidFill>
                 <a:latin typeface="Calibri"/>
               </a:rPr>
-              <a:t>Annexe — Diagramme de séquence</a:t>
-            </a:r>
-          </a:p>
-        </p:txBody>
-      </p:sp>
-      <p:pic>
-        <p:nvPicPr>
-          <p:cNvPr id="4" name="Picture 3" descr="diagramme-sequence.png"/>
-          <p:cNvPicPr>
-            <a:picLocks noChangeAspect="1"/>
-          </p:cNvPicPr>
-          <p:nvPr/>
-        </p:nvPicPr>
-        <p:blipFill>
-          <a:blip r:embed="rId2"/>
-          <a:stretch>
-            <a:fillRect/>
-          </a:stretch>
-        </p:blipFill>
-        <p:spPr>
-          <a:xfrm>
-            <a:off x="3003161" y="1234440"/>
-            <a:ext cx="6185372" cy="4846320"/>
-          </a:xfrm>
-          <a:prstGeom prst="rect">
-            <a:avLst/>
-          </a:prstGeom>
-        </p:spPr>
-      </p:pic>
+              <a:t>ANNEXES — Diagrammes de conception détaillés</a:t>
+            </a:r>
+          </a:p>
+          <a:p>
+            <a:pPr algn="ctr"/>
+            <a:r>
+              <a:rPr sz="1600" b="0" i="1">
+                <a:solidFill>
+                  <a:srgbClr val="DDE6F2"/>
+                </a:solidFill>
+                <a:latin typeface="Calibri"/>
+              </a:rPr>
+              <a:t>Diapositives de secours pour les questions du jury</a:t>
+            </a:r>
+          </a:p>
+        </p:txBody>
+      </p:sp>
     </p:spTree>
   </p:cSld>
   <p:clrMapOvr>
@@ -13812,14 +14397,14 @@
                 </a:solidFill>
                 <a:latin typeface="Calibri"/>
               </a:rPr>
-              <a:t>Annexe — Diagramme d'activité</a:t>
+              <a:t>Annexe — Diagramme de contexte</a:t>
             </a:r>
           </a:p>
         </p:txBody>
       </p:sp>
       <p:pic>
         <p:nvPicPr>
-          <p:cNvPr id="4" name="Picture 3" descr="diagramme-activite.png"/>
+          <p:cNvPr id="4" name="Picture 3" descr="diagramme-contexte.png"/>
           <p:cNvPicPr>
             <a:picLocks noChangeAspect="1"/>
           </p:cNvPicPr>
@@ -13833,8 +14418,8 @@
         </p:blipFill>
         <p:spPr>
           <a:xfrm>
-            <a:off x="4579658" y="1234440"/>
-            <a:ext cx="3032378" cy="4846320"/>
+            <a:off x="700887" y="1234440"/>
+            <a:ext cx="10789920" cy="3854309"/>
           </a:xfrm>
           <a:prstGeom prst="rect">
             <a:avLst/>
@@ -13940,14 +14525,14 @@
                 </a:solidFill>
                 <a:latin typeface="Calibri"/>
               </a:rPr>
-              <a:t>Annexe — Diagramme de classes</a:t>
+              <a:t>Annexe — Diagramme de cas d'utilisation</a:t>
             </a:r>
           </a:p>
         </p:txBody>
       </p:sp>
       <p:pic>
         <p:nvPicPr>
-          <p:cNvPr id="4" name="Picture 3" descr="diagramme-classes.png"/>
+          <p:cNvPr id="4" name="Picture 3" descr="cas-utilisation.png"/>
           <p:cNvPicPr>
             <a:picLocks noChangeAspect="1"/>
           </p:cNvPicPr>
@@ -13962,7 +14547,7 @@
         <p:spPr>
           <a:xfrm>
             <a:off x="700887" y="1234440"/>
-            <a:ext cx="10789920" cy="4584951"/>
+            <a:ext cx="10789920" cy="4190962"/>
           </a:xfrm>
           <a:prstGeom prst="rect">
             <a:avLst/>
@@ -14068,14 +14653,14 @@
                 </a:solidFill>
                 <a:latin typeface="Calibri"/>
               </a:rPr>
-              <a:t>Annexe — Diagramme de composants</a:t>
+              <a:t>Annexe — Diagramme de séquence</a:t>
             </a:r>
           </a:p>
         </p:txBody>
       </p:sp>
       <p:pic>
         <p:nvPicPr>
-          <p:cNvPr id="4" name="Picture 3" descr="diagramme-composants.png"/>
+          <p:cNvPr id="4" name="Picture 3" descr="diagramme-sequence.png"/>
           <p:cNvPicPr>
             <a:picLocks noChangeAspect="1"/>
           </p:cNvPicPr>
@@ -14089,8 +14674,8 @@
         </p:blipFill>
         <p:spPr>
           <a:xfrm>
-            <a:off x="1891278" y="1234440"/>
-            <a:ext cx="8409139" cy="4846320"/>
+            <a:off x="3003161" y="1234440"/>
+            <a:ext cx="6185372" cy="4846320"/>
           </a:xfrm>
           <a:prstGeom prst="rect">
             <a:avLst/>
@@ -14196,6 +14781,390 @@
                 </a:solidFill>
                 <a:latin typeface="Calibri"/>
               </a:rPr>
+              <a:t>Annexe — Diagramme d'activité</a:t>
+            </a:r>
+          </a:p>
+        </p:txBody>
+      </p:sp>
+      <p:pic>
+        <p:nvPicPr>
+          <p:cNvPr id="4" name="Picture 3" descr="diagramme-activite.png"/>
+          <p:cNvPicPr>
+            <a:picLocks noChangeAspect="1"/>
+          </p:cNvPicPr>
+          <p:nvPr/>
+        </p:nvPicPr>
+        <p:blipFill>
+          <a:blip r:embed="rId2"/>
+          <a:stretch>
+            <a:fillRect/>
+          </a:stretch>
+        </p:blipFill>
+        <p:spPr>
+          <a:xfrm>
+            <a:off x="4579658" y="1234440"/>
+            <a:ext cx="3032378" cy="4846320"/>
+          </a:xfrm>
+          <a:prstGeom prst="rect">
+            <a:avLst/>
+          </a:prstGeom>
+        </p:spPr>
+      </p:pic>
+    </p:spTree>
+  </p:cSld>
+  <p:clrMapOvr>
+    <a:masterClrMapping/>
+  </p:clrMapOvr>
+</p:sld>
+</file>
+
+<file path=ppt/slides/slide34.xml><?xml version="1.0" encoding="utf-8"?>
+<p:sld xmlns:a="http://schemas.openxmlformats.org/drawingml/2006/main" xmlns:p="http://schemas.openxmlformats.org/presentationml/2006/main" xmlns:r="http://schemas.openxmlformats.org/officeDocument/2006/relationships">
+  <p:cSld>
+    <p:bg>
+      <p:bgPr>
+        <a:solidFill>
+          <a:srgbClr val="FFFFFF"/>
+        </a:solidFill>
+        <a:effectLst/>
+      </p:bgPr>
+    </p:bg>
+    <p:spTree>
+      <p:nvGrpSpPr>
+        <p:cNvPr id="1" name=""/>
+        <p:cNvGrpSpPr/>
+        <p:nvPr/>
+      </p:nvGrpSpPr>
+      <p:grpSpPr/>
+      <p:sp>
+        <p:nvSpPr>
+          <p:cNvPr id="2" name="Rectangle 1"/>
+          <p:cNvSpPr/>
+          <p:nvPr/>
+        </p:nvSpPr>
+        <p:spPr>
+          <a:xfrm>
+            <a:off x="0" y="0"/>
+            <a:ext cx="12191695" cy="1051560"/>
+          </a:xfrm>
+          <a:prstGeom prst="rect">
+            <a:avLst/>
+          </a:prstGeom>
+          <a:solidFill>
+            <a:srgbClr val="0D3B66"/>
+          </a:solidFill>
+          <a:ln>
+            <a:noFill/>
+          </a:ln>
+          <a:effectLst/>
+        </p:spPr>
+        <p:style>
+          <a:lnRef idx="1">
+            <a:schemeClr val="accent1"/>
+          </a:lnRef>
+          <a:fillRef idx="3">
+            <a:schemeClr val="accent1"/>
+          </a:fillRef>
+          <a:effectRef idx="2">
+            <a:schemeClr val="accent1"/>
+          </a:effectRef>
+          <a:fontRef idx="minor">
+            <a:schemeClr val="lt1"/>
+          </a:fontRef>
+        </p:style>
+        <p:txBody>
+          <a:bodyPr rtlCol="0" anchor="ctr"/>
+          <a:lstStyle/>
+          <a:p>
+            <a:pPr algn="ctr"/>
+          </a:p>
+        </p:txBody>
+      </p:sp>
+      <p:sp>
+        <p:nvSpPr>
+          <p:cNvPr id="3" name="TextBox 2"/>
+          <p:cNvSpPr txBox="1"/>
+          <p:nvPr/>
+        </p:nvSpPr>
+        <p:spPr>
+          <a:xfrm>
+            <a:off x="457200" y="164592"/>
+            <a:ext cx="11460175" cy="731520"/>
+          </a:xfrm>
+          <a:prstGeom prst="rect">
+            <a:avLst/>
+          </a:prstGeom>
+          <a:noFill/>
+        </p:spPr>
+        <p:txBody>
+          <a:bodyPr wrap="square" anchor="ctr">
+            <a:spAutoFit/>
+          </a:bodyPr>
+          <a:lstStyle/>
+          <a:p>
+            <a:r>
+              <a:rPr sz="3000" b="1" i="0">
+                <a:solidFill>
+                  <a:srgbClr val="FFFFFF"/>
+                </a:solidFill>
+                <a:latin typeface="Calibri"/>
+              </a:rPr>
+              <a:t>Annexe — Diagramme de classes</a:t>
+            </a:r>
+          </a:p>
+        </p:txBody>
+      </p:sp>
+      <p:pic>
+        <p:nvPicPr>
+          <p:cNvPr id="4" name="Picture 3" descr="diagramme-classes.png"/>
+          <p:cNvPicPr>
+            <a:picLocks noChangeAspect="1"/>
+          </p:cNvPicPr>
+          <p:nvPr/>
+        </p:nvPicPr>
+        <p:blipFill>
+          <a:blip r:embed="rId2"/>
+          <a:stretch>
+            <a:fillRect/>
+          </a:stretch>
+        </p:blipFill>
+        <p:spPr>
+          <a:xfrm>
+            <a:off x="700887" y="1234440"/>
+            <a:ext cx="10789920" cy="4584951"/>
+          </a:xfrm>
+          <a:prstGeom prst="rect">
+            <a:avLst/>
+          </a:prstGeom>
+        </p:spPr>
+      </p:pic>
+    </p:spTree>
+  </p:cSld>
+  <p:clrMapOvr>
+    <a:masterClrMapping/>
+  </p:clrMapOvr>
+</p:sld>
+</file>
+
+<file path=ppt/slides/slide35.xml><?xml version="1.0" encoding="utf-8"?>
+<p:sld xmlns:a="http://schemas.openxmlformats.org/drawingml/2006/main" xmlns:p="http://schemas.openxmlformats.org/presentationml/2006/main" xmlns:r="http://schemas.openxmlformats.org/officeDocument/2006/relationships">
+  <p:cSld>
+    <p:bg>
+      <p:bgPr>
+        <a:solidFill>
+          <a:srgbClr val="FFFFFF"/>
+        </a:solidFill>
+        <a:effectLst/>
+      </p:bgPr>
+    </p:bg>
+    <p:spTree>
+      <p:nvGrpSpPr>
+        <p:cNvPr id="1" name=""/>
+        <p:cNvGrpSpPr/>
+        <p:nvPr/>
+      </p:nvGrpSpPr>
+      <p:grpSpPr/>
+      <p:sp>
+        <p:nvSpPr>
+          <p:cNvPr id="2" name="Rectangle 1"/>
+          <p:cNvSpPr/>
+          <p:nvPr/>
+        </p:nvSpPr>
+        <p:spPr>
+          <a:xfrm>
+            <a:off x="0" y="0"/>
+            <a:ext cx="12191695" cy="1051560"/>
+          </a:xfrm>
+          <a:prstGeom prst="rect">
+            <a:avLst/>
+          </a:prstGeom>
+          <a:solidFill>
+            <a:srgbClr val="0D3B66"/>
+          </a:solidFill>
+          <a:ln>
+            <a:noFill/>
+          </a:ln>
+          <a:effectLst/>
+        </p:spPr>
+        <p:style>
+          <a:lnRef idx="1">
+            <a:schemeClr val="accent1"/>
+          </a:lnRef>
+          <a:fillRef idx="3">
+            <a:schemeClr val="accent1"/>
+          </a:fillRef>
+          <a:effectRef idx="2">
+            <a:schemeClr val="accent1"/>
+          </a:effectRef>
+          <a:fontRef idx="minor">
+            <a:schemeClr val="lt1"/>
+          </a:fontRef>
+        </p:style>
+        <p:txBody>
+          <a:bodyPr rtlCol="0" anchor="ctr"/>
+          <a:lstStyle/>
+          <a:p>
+            <a:pPr algn="ctr"/>
+          </a:p>
+        </p:txBody>
+      </p:sp>
+      <p:sp>
+        <p:nvSpPr>
+          <p:cNvPr id="3" name="TextBox 2"/>
+          <p:cNvSpPr txBox="1"/>
+          <p:nvPr/>
+        </p:nvSpPr>
+        <p:spPr>
+          <a:xfrm>
+            <a:off x="457200" y="164592"/>
+            <a:ext cx="11460175" cy="731520"/>
+          </a:xfrm>
+          <a:prstGeom prst="rect">
+            <a:avLst/>
+          </a:prstGeom>
+          <a:noFill/>
+        </p:spPr>
+        <p:txBody>
+          <a:bodyPr wrap="square" anchor="ctr">
+            <a:spAutoFit/>
+          </a:bodyPr>
+          <a:lstStyle/>
+          <a:p>
+            <a:r>
+              <a:rPr sz="3000" b="1" i="0">
+                <a:solidFill>
+                  <a:srgbClr val="FFFFFF"/>
+                </a:solidFill>
+                <a:latin typeface="Calibri"/>
+              </a:rPr>
+              <a:t>Annexe — Diagramme de composants</a:t>
+            </a:r>
+          </a:p>
+        </p:txBody>
+      </p:sp>
+      <p:pic>
+        <p:nvPicPr>
+          <p:cNvPr id="4" name="Picture 3" descr="diagramme-composants.png"/>
+          <p:cNvPicPr>
+            <a:picLocks noChangeAspect="1"/>
+          </p:cNvPicPr>
+          <p:nvPr/>
+        </p:nvPicPr>
+        <p:blipFill>
+          <a:blip r:embed="rId2"/>
+          <a:stretch>
+            <a:fillRect/>
+          </a:stretch>
+        </p:blipFill>
+        <p:spPr>
+          <a:xfrm>
+            <a:off x="1891278" y="1234440"/>
+            <a:ext cx="8409139" cy="4846320"/>
+          </a:xfrm>
+          <a:prstGeom prst="rect">
+            <a:avLst/>
+          </a:prstGeom>
+        </p:spPr>
+      </p:pic>
+    </p:spTree>
+  </p:cSld>
+  <p:clrMapOvr>
+    <a:masterClrMapping/>
+  </p:clrMapOvr>
+</p:sld>
+</file>
+
+<file path=ppt/slides/slide36.xml><?xml version="1.0" encoding="utf-8"?>
+<p:sld xmlns:a="http://schemas.openxmlformats.org/drawingml/2006/main" xmlns:p="http://schemas.openxmlformats.org/presentationml/2006/main" xmlns:r="http://schemas.openxmlformats.org/officeDocument/2006/relationships">
+  <p:cSld>
+    <p:bg>
+      <p:bgPr>
+        <a:solidFill>
+          <a:srgbClr val="FFFFFF"/>
+        </a:solidFill>
+        <a:effectLst/>
+      </p:bgPr>
+    </p:bg>
+    <p:spTree>
+      <p:nvGrpSpPr>
+        <p:cNvPr id="1" name=""/>
+        <p:cNvGrpSpPr/>
+        <p:nvPr/>
+      </p:nvGrpSpPr>
+      <p:grpSpPr/>
+      <p:sp>
+        <p:nvSpPr>
+          <p:cNvPr id="2" name="Rectangle 1"/>
+          <p:cNvSpPr/>
+          <p:nvPr/>
+        </p:nvSpPr>
+        <p:spPr>
+          <a:xfrm>
+            <a:off x="0" y="0"/>
+            <a:ext cx="12191695" cy="1051560"/>
+          </a:xfrm>
+          <a:prstGeom prst="rect">
+            <a:avLst/>
+          </a:prstGeom>
+          <a:solidFill>
+            <a:srgbClr val="0D3B66"/>
+          </a:solidFill>
+          <a:ln>
+            <a:noFill/>
+          </a:ln>
+          <a:effectLst/>
+        </p:spPr>
+        <p:style>
+          <a:lnRef idx="1">
+            <a:schemeClr val="accent1"/>
+          </a:lnRef>
+          <a:fillRef idx="3">
+            <a:schemeClr val="accent1"/>
+          </a:fillRef>
+          <a:effectRef idx="2">
+            <a:schemeClr val="accent1"/>
+          </a:effectRef>
+          <a:fontRef idx="minor">
+            <a:schemeClr val="lt1"/>
+          </a:fontRef>
+        </p:style>
+        <p:txBody>
+          <a:bodyPr rtlCol="0" anchor="ctr"/>
+          <a:lstStyle/>
+          <a:p>
+            <a:pPr algn="ctr"/>
+          </a:p>
+        </p:txBody>
+      </p:sp>
+      <p:sp>
+        <p:nvSpPr>
+          <p:cNvPr id="3" name="TextBox 2"/>
+          <p:cNvSpPr txBox="1"/>
+          <p:nvPr/>
+        </p:nvSpPr>
+        <p:spPr>
+          <a:xfrm>
+            <a:off x="457200" y="164592"/>
+            <a:ext cx="11460175" cy="731520"/>
+          </a:xfrm>
+          <a:prstGeom prst="rect">
+            <a:avLst/>
+          </a:prstGeom>
+          <a:noFill/>
+        </p:spPr>
+        <p:txBody>
+          <a:bodyPr wrap="square" anchor="ctr">
+            <a:spAutoFit/>
+          </a:bodyPr>
+          <a:lstStyle/>
+          <a:p>
+            <a:r>
+              <a:rPr sz="3000" b="1" i="0">
+                <a:solidFill>
+                  <a:srgbClr val="FFFFFF"/>
+                </a:solidFill>
+                <a:latin typeface="Calibri"/>
+              </a:rPr>
               <a:t>Annexe — Diagramme de déploiement</a:t>
             </a:r>
           </a:p>
@@ -14233,7 +15202,7 @@
 </p:sld>
 </file>
 
-<file path=ppt/slides/slide34.xml><?xml version="1.0" encoding="utf-8"?>
+<file path=ppt/slides/slide37.xml><?xml version="1.0" encoding="utf-8"?>
 <p:sld xmlns:a="http://schemas.openxmlformats.org/drawingml/2006/main" xmlns:p="http://schemas.openxmlformats.org/presentationml/2006/main" xmlns:r="http://schemas.openxmlformats.org/officeDocument/2006/relationships">
   <p:cSld>
     <p:bg>

</xml_diff>

<commit_message>
Conversion des montants en francs CFA (XOF) — contexte Côte d'Ivoire
Tous les montants financiers passent de l'euro au franc CFA (parité fixe
1 € = 655,957 FCFA), arrondis à des valeurs réalistes :
- Investissement OPEN MOISE : ~100 000–200 000 FCFA (serveur), ~130 000 FCFA total
- Supervision managée : 10 clients × 25 000 FCFA/mois = 3 000 000 FCFA
- Mise en service : 10 × 200 000 FCFA = 2 000 000 FCFA
- Option Pro : 3 × 325 000 FCFA = 975 000 FCFA
- Total an 1 : ≈ 6 000 000 FCFA
Note de parité ajoutée sur la diapo financière. Mémoire, README et
présentation académique également mis à jour (0 FCFA de licence, etc.).
</commit_message>
<xml_diff>
--- a/soutenance/presentation-projet.pptx
+++ b/soutenance/presentation-projet.pptx
@@ -11607,7 +11607,7 @@
                           </a:solidFill>
                           <a:latin typeface="Calibri"/>
                         </a:rPr>
-                        <a:t>€€€</a:t>
+                        <a:t>Très coûteux</a:t>
                       </a:r>
                     </a:p>
                   </a:txBody>
@@ -12416,7 +12416,7 @@
                           </a:solidFill>
                           <a:latin typeface="Calibri"/>
                         </a:rPr>
-                        <a:t>0 € (open-source)</a:t>
+                        <a:t>0 FCFA (open-source)</a:t>
                       </a:r>
                     </a:p>
                   </a:txBody>
@@ -12464,7 +12464,7 @@
                           </a:solidFill>
                           <a:latin typeface="Calibri"/>
                         </a:rPr>
-                        <a:t>~150–300 €</a:t>
+                        <a:t>~100 000 – 200 000 FCFA</a:t>
                       </a:r>
                     </a:p>
                   </a:txBody>
@@ -12560,7 +12560,7 @@
                           </a:solidFill>
                           <a:latin typeface="Calibri"/>
                         </a:rPr>
-                        <a:t>≈ 200 €</a:t>
+                        <a:t>≈ 130 000 FCFA</a:t>
                       </a:r>
                     </a:p>
                   </a:txBody>
@@ -12740,7 +12740,7 @@
                           </a:solidFill>
                           <a:latin typeface="Calibri"/>
                         </a:rPr>
-                        <a:t>10 clients × 40 €/mois</a:t>
+                        <a:t>10 clients × 25 000 FCFA/mois</a:t>
                       </a:r>
                     </a:p>
                   </a:txBody>
@@ -12763,7 +12763,7 @@
                           </a:solidFill>
                           <a:latin typeface="Calibri"/>
                         </a:rPr>
-                        <a:t>4 800 €</a:t>
+                        <a:t>3 000 000 FCFA</a:t>
                       </a:r>
                     </a:p>
                   </a:txBody>
@@ -12811,7 +12811,7 @@
                           </a:solidFill>
                           <a:latin typeface="Calibri"/>
                         </a:rPr>
-                        <a:t>10 × 300 €</a:t>
+                        <a:t>10 × 200 000 FCFA</a:t>
                       </a:r>
                     </a:p>
                   </a:txBody>
@@ -12834,7 +12834,7 @@
                           </a:solidFill>
                           <a:latin typeface="Calibri"/>
                         </a:rPr>
-                        <a:t>3 000 €</a:t>
+                        <a:t>2 000 000 FCFA</a:t>
                       </a:r>
                     </a:p>
                   </a:txBody>
@@ -12882,7 +12882,7 @@
                           </a:solidFill>
                           <a:latin typeface="Calibri"/>
                         </a:rPr>
-                        <a:t>3 × 500 €</a:t>
+                        <a:t>3 × 325 000 FCFA</a:t>
                       </a:r>
                     </a:p>
                   </a:txBody>
@@ -12905,7 +12905,7 @@
                           </a:solidFill>
                           <a:latin typeface="Calibri"/>
                         </a:rPr>
-                        <a:t>1 500 €</a:t>
+                        <a:t>975 000 FCFA</a:t>
                       </a:r>
                     </a:p>
                   </a:txBody>
@@ -13047,7 +13047,7 @@
                           </a:solidFill>
                           <a:latin typeface="Calibri"/>
                         </a:rPr>
-                        <a:t>≈ 9 300 €</a:t>
+                        <a:t>≈ 6 000 000 FCFA</a:t>
                       </a:r>
                     </a:p>
                   </a:txBody>
@@ -13070,8 +13070,8 @@
         </p:nvSpPr>
         <p:spPr>
           <a:xfrm>
-            <a:off x="640080" y="5394960"/>
-            <a:ext cx="109728" cy="914400"/>
+            <a:off x="640080" y="5349240"/>
+            <a:ext cx="109728" cy="868680"/>
           </a:xfrm>
           <a:prstGeom prst="rect">
             <a:avLst/>
@@ -13114,8 +13114,8 @@
         </p:nvSpPr>
         <p:spPr>
           <a:xfrm>
-            <a:off x="749808" y="5394960"/>
-            <a:ext cx="10771632" cy="914400"/>
+            <a:off x="749808" y="5349240"/>
+            <a:ext cx="10771632" cy="868680"/>
           </a:xfrm>
           <a:prstGeom prst="rect">
             <a:avLst/>
@@ -13154,7 +13154,41 @@
                 </a:solidFill>
                 <a:latin typeface="Calibri"/>
               </a:rPr>
-              <a:t>Double retour pour OPEN MOISE : revenus récurrents (offre managée) + économies internes (moins d'astreinte, pénalités SLA évitées). Investissement ≈ 200 € amorti dès le 1er client.</a:t>
+              <a:t>Double retour pour OPEN MOISE : revenus récurrents (offre managée) + économies internes (moins d'astreinte, pénalités SLA évitées). Investissement ≈ 130 000 FCFA amorti dès le 1er client.</a:t>
+            </a:r>
+          </a:p>
+        </p:txBody>
+      </p:sp>
+      <p:sp>
+        <p:nvSpPr>
+          <p:cNvPr id="11" name="TextBox 10"/>
+          <p:cNvSpPr txBox="1"/>
+          <p:nvPr/>
+        </p:nvSpPr>
+        <p:spPr>
+          <a:xfrm>
+            <a:off x="640080" y="6355080"/>
+            <a:ext cx="10972800" cy="320040"/>
+          </a:xfrm>
+          <a:prstGeom prst="rect">
+            <a:avLst/>
+          </a:prstGeom>
+          <a:noFill/>
+        </p:spPr>
+        <p:txBody>
+          <a:bodyPr wrap="square">
+            <a:spAutoFit/>
+          </a:bodyPr>
+          <a:lstStyle/>
+          <a:p>
+            <a:r>
+              <a:rPr sz="1000" b="0" i="1">
+                <a:solidFill>
+                  <a:srgbClr val="333333"/>
+                </a:solidFill>
+                <a:latin typeface="Calibri"/>
+              </a:rPr>
+              <a:t>Montants en francs CFA (XOF) — hypothèses indicatives à ajuster. Parité fixe : 1 € = 655,957 FCFA.</a:t>
             </a:r>
           </a:p>
         </p:txBody>
@@ -16674,7 +16708,7 @@
                           </a:solidFill>
                           <a:latin typeface="Calibri"/>
                         </a:rPr>
-                        <a:t>0 € de licence (open-source)</a:t>
+                        <a:t>0 FCFA de licence (open-source)</a:t>
                       </a:r>
                     </a:p>
                   </a:txBody>

</xml_diff>

<commit_message>
Ajout de la relation UTILISATEUR <-> EQUIPEMENT (et UTILISATEUR acquitte ALERTE)
Correction du modèle de données, qui n'exprimait pas la relation entre les
utilisateurs et les équipements :

- Relation « supervise » UTILISATEUR <-> EQUIPEMENT (plusieurs-à-plusieurs),
  résolue par une table associative 'responsabilite' (clé primaire composite)
- Relation « acquitte » UTILISATEUR -> ALERTE (1,n), via la clé étrangère
  'acquittee_par' dans la table alertes
- Mise à jour : MCD, MLD, diagramme de classes (PlantUML + PNG régénérés)
- schema.sql : colonne acquittee_par + FK, table responsabilite + affectations
- database.py : acquitter_alerte(utilisateur_id), fonctions d'affectation
  (affecter_equipement, get_equipements_utilisateur, get_responsables_equipement)
- app.py : trace l'utilisateur qui acquitte (session user_id)
- Mémoire (chap. 6 et 7) et doc MERISE mis à jour ; Word régénéré
- PowerPoint régénéré avec les diagrammes à jour
</commit_message>
<xml_diff>
--- a/soutenance/presentation-projet.pptx
+++ b/soutenance/presentation-projet.pptx
@@ -7906,8 +7906,8 @@
         </p:blipFill>
         <p:spPr>
           <a:xfrm>
-            <a:off x="411480" y="1600200"/>
-            <a:ext cx="5394960" cy="3141605"/>
+            <a:off x="1245620" y="1600200"/>
+            <a:ext cx="3726679" cy="4572000"/>
           </a:xfrm>
           <a:prstGeom prst="rect">
             <a:avLst/>
@@ -7966,7 +7966,7 @@
         <p:spPr>
           <a:xfrm>
             <a:off x="6355080" y="1600200"/>
-            <a:ext cx="5394960" cy="3316690"/>
+            <a:ext cx="5394960" cy="3437685"/>
           </a:xfrm>
           <a:prstGeom prst="rect">
             <a:avLst/>
@@ -15348,8 +15348,8 @@
         </p:blipFill>
         <p:spPr>
           <a:xfrm>
-            <a:off x="2154313" y="1234440"/>
-            <a:ext cx="7883069" cy="4846320"/>
+            <a:off x="2293042" y="1234440"/>
+            <a:ext cx="7605611" cy="4846320"/>
           </a:xfrm>
           <a:prstGeom prst="rect">
             <a:avLst/>

</xml_diff>

<commit_message>
Cohérence : mise à jour des mentions '5 tables' -> '6 tables' (table responsabilite)
Suite à l'ajout de la relation utilisateur-équipement :
- PowerPoint (générateur + .pptx) : faisabilité, diapo MERISE et annexe MLD
  passent à 6 tables et citent la table associative 'responsabilite'
- presentation-projet.md : liste des tables complétée
- Mémoire-projet (annexe C) et mémoire académique : 'cinq tables' -> 'six tables'
- Diagrammes (MCD, MLD, classes) déjà à jour et ré-embarqués
Documents Word et PowerPoint régénérés.
</commit_message>
<xml_diff>
--- a/soutenance/presentation-projet.pptx
+++ b/soutenance/presentation-projet.pptx
@@ -958,7 +958,7 @@
           <a:lstStyle/>
           <a:p>
             <a:r>
-              <a:t>Pour la base de données, j'ai suivi la méthode MERISE : du modèle conceptuel - les entités et leurs associations - vers le modèle logique - les cinq tables relationnelles avec leurs clés - implémenté ensuite en MySQL.</a:t>
+              <a:t>Pour la base de données, j'ai suivi la méthode MERISE : du modèle conceptuel - les entités et leurs associations, dont la relation utilisateur-équipement - vers le modèle logique - six tables, dont une table associative - implémenté ensuite en MySQL.</a:t>
             </a:r>
           </a:p>
         </p:txBody>
@@ -6891,7 +6891,7 @@
                 </a:solidFill>
                 <a:latin typeface="Calibri"/>
               </a:rPr>
-              <a:t>–  MERISE : MCD → MLD → base MySQL (5 tables)</a:t>
+              <a:t>–  MERISE : MCD → MLD → base MySQL (6 tables, dont une associative)</a:t>
             </a:r>
           </a:p>
           <a:p>
@@ -7850,7 +7850,7 @@
                 </a:solidFill>
                 <a:latin typeface="Calibri"/>
               </a:rPr>
-              <a:t>MERISE : du MCD au MLD (base MySQL, 5 tables)</a:t>
+              <a:t>MERISE : du MCD au MLD (base MySQL, 6 tables)</a:t>
             </a:r>
           </a:p>
         </p:txBody>
@@ -15386,7 +15386,7 @@
                 </a:solidFill>
                 <a:latin typeface="Calibri"/>
               </a:rPr>
-              <a:t>5 tables : utilisateurs, equipements, journaux, alertes, statistiques (clés primaires PK, clés étrangères FK).</a:t>
+              <a:t>6 tables : utilisateurs, equipements, journaux, alertes, responsabilite (associative), statistiques — avec clés primaires (PK) et étrangères (FK).</a:t>
             </a:r>
           </a:p>
         </p:txBody>

</xml_diff>